<commit_message>
Illustrate week 4 lecture and lab opening stories
</commit_message>
<xml_diff>
--- a/lendet/2026-2027/mobile/lectures/ligjerata-04-neon-postgresql-rideshare-2026.pptx
+++ b/lendet/2026-2027/mobile/lectures/ligjerata-04-neon-postgresql-rideshare-2026.pptx
@@ -2,28 +2,28 @@
 <file path=ppt/presentation.xml><?xml version="1.0" encoding="utf-8"?>
 <p:presentation xmlns:p="http://schemas.openxmlformats.org/presentationml/2006/main">
   <p:sldMasterIdLst>
-    <p:sldMasterId xmlns:r="http://schemas.openxmlformats.org/officeDocument/2006/relationships" id="2147483648" r:id="Red10f41f72b34c87"/>
+    <p:sldMasterId xmlns:r="http://schemas.openxmlformats.org/officeDocument/2006/relationships" id="2147483648" r:id="R32f700e982f04b62"/>
   </p:sldMasterIdLst>
   <p:sldIdLst>
-    <p:sldId xmlns:r="http://schemas.openxmlformats.org/officeDocument/2006/relationships" id="256" r:id="R02751c1ce6bf4056"/>
-    <p:sldId xmlns:r="http://schemas.openxmlformats.org/officeDocument/2006/relationships" id="257" r:id="R51a1d8eefdc14fc7"/>
-    <p:sldId xmlns:r="http://schemas.openxmlformats.org/officeDocument/2006/relationships" id="258" r:id="R655ba8d034704801"/>
-    <p:sldId xmlns:r="http://schemas.openxmlformats.org/officeDocument/2006/relationships" id="259" r:id="Rc0771159c9514ade"/>
-    <p:sldId xmlns:r="http://schemas.openxmlformats.org/officeDocument/2006/relationships" id="260" r:id="Rb048703e825949ba"/>
-    <p:sldId xmlns:r="http://schemas.openxmlformats.org/officeDocument/2006/relationships" id="261" r:id="R97a15a779a7e41bf"/>
-    <p:sldId xmlns:r="http://schemas.openxmlformats.org/officeDocument/2006/relationships" id="262" r:id="R767dc16736b745f0"/>
-    <p:sldId xmlns:r="http://schemas.openxmlformats.org/officeDocument/2006/relationships" id="263" r:id="Rbf5b6a2f54f04566"/>
-    <p:sldId xmlns:r="http://schemas.openxmlformats.org/officeDocument/2006/relationships" id="264" r:id="R74a76565449e4558"/>
-    <p:sldId xmlns:r="http://schemas.openxmlformats.org/officeDocument/2006/relationships" id="265" r:id="R4012071585954ec4"/>
-    <p:sldId xmlns:r="http://schemas.openxmlformats.org/officeDocument/2006/relationships" id="266" r:id="R28259617aaa84692"/>
-    <p:sldId xmlns:r="http://schemas.openxmlformats.org/officeDocument/2006/relationships" id="267" r:id="R9a1f3ee6a7ed444e"/>
-    <p:sldId xmlns:r="http://schemas.openxmlformats.org/officeDocument/2006/relationships" id="268" r:id="R77d81c4d17344768"/>
-    <p:sldId xmlns:r="http://schemas.openxmlformats.org/officeDocument/2006/relationships" id="269" r:id="Rbdb7e65e032c44c4"/>
-    <p:sldId xmlns:r="http://schemas.openxmlformats.org/officeDocument/2006/relationships" id="270" r:id="Ra3644680203e4ff6"/>
-    <p:sldId xmlns:r="http://schemas.openxmlformats.org/officeDocument/2006/relationships" id="271" r:id="R15592293385545bf"/>
-    <p:sldId xmlns:r="http://schemas.openxmlformats.org/officeDocument/2006/relationships" id="272" r:id="Rc118d6867f854394"/>
-    <p:sldId xmlns:r="http://schemas.openxmlformats.org/officeDocument/2006/relationships" id="273" r:id="R7b54aaf5e72b4ae7"/>
-    <p:sldId xmlns:r="http://schemas.openxmlformats.org/officeDocument/2006/relationships" id="274" r:id="Re9664f9f47c94da6"/>
+    <p:sldId xmlns:r="http://schemas.openxmlformats.org/officeDocument/2006/relationships" id="256" r:id="R0b58241ca65c4a25"/>
+    <p:sldId xmlns:r="http://schemas.openxmlformats.org/officeDocument/2006/relationships" id="257" r:id="R1b08c80eb2854183"/>
+    <p:sldId xmlns:r="http://schemas.openxmlformats.org/officeDocument/2006/relationships" id="258" r:id="R04221dabb39d48ab"/>
+    <p:sldId xmlns:r="http://schemas.openxmlformats.org/officeDocument/2006/relationships" id="259" r:id="R9579cb5cf91147ab"/>
+    <p:sldId xmlns:r="http://schemas.openxmlformats.org/officeDocument/2006/relationships" id="260" r:id="R68057e8fac5c4adf"/>
+    <p:sldId xmlns:r="http://schemas.openxmlformats.org/officeDocument/2006/relationships" id="261" r:id="Re270c51eb55c4cd3"/>
+    <p:sldId xmlns:r="http://schemas.openxmlformats.org/officeDocument/2006/relationships" id="262" r:id="Ra926b2f054134575"/>
+    <p:sldId xmlns:r="http://schemas.openxmlformats.org/officeDocument/2006/relationships" id="263" r:id="R43da0ced30d34969"/>
+    <p:sldId xmlns:r="http://schemas.openxmlformats.org/officeDocument/2006/relationships" id="264" r:id="R051e3f8fba1f44ff"/>
+    <p:sldId xmlns:r="http://schemas.openxmlformats.org/officeDocument/2006/relationships" id="265" r:id="R9639caeb60ec4bdb"/>
+    <p:sldId xmlns:r="http://schemas.openxmlformats.org/officeDocument/2006/relationships" id="266" r:id="Rdaf5fcf9055c40e3"/>
+    <p:sldId xmlns:r="http://schemas.openxmlformats.org/officeDocument/2006/relationships" id="267" r:id="Rb7f18537419343c1"/>
+    <p:sldId xmlns:r="http://schemas.openxmlformats.org/officeDocument/2006/relationships" id="268" r:id="R54faa88fb0da400f"/>
+    <p:sldId xmlns:r="http://schemas.openxmlformats.org/officeDocument/2006/relationships" id="269" r:id="R0d90b6d7a7b940b0"/>
+    <p:sldId xmlns:r="http://schemas.openxmlformats.org/officeDocument/2006/relationships" id="270" r:id="R124c16c5404a4ef3"/>
+    <p:sldId xmlns:r="http://schemas.openxmlformats.org/officeDocument/2006/relationships" id="271" r:id="R4b6017b86c7a430f"/>
+    <p:sldId xmlns:r="http://schemas.openxmlformats.org/officeDocument/2006/relationships" id="272" r:id="R870c7b9d29244f78"/>
+    <p:sldId xmlns:r="http://schemas.openxmlformats.org/officeDocument/2006/relationships" id="273" r:id="R878a77bad1e34ea8"/>
+    <p:sldId xmlns:r="http://schemas.openxmlformats.org/officeDocument/2006/relationships" id="274" r:id="R549bd33a29c84bc2"/>
   </p:sldIdLst>
   <p:sldSz cx="12192000" cy="6858000"/>
   <p:notesSz cx="6858000" cy="9144000"/>
@@ -68,7 +68,7 @@
   </p:cSld>
   <p:clrMap bg1="lt1" tx1="dk1" bg2="lt2" tx2="dk2" accent1="accent1" accent2="accent2" accent3="accent3" accent4="accent4" accent5="accent5" accent6="accent6" hlink="hlink" folHlink="folHlink"/>
   <p:sldLayoutIdLst>
-    <p:sldLayoutId xmlns:r="http://schemas.openxmlformats.org/officeDocument/2006/relationships" id="2147483649" r:id="R1aa2874493514186"/>
+    <p:sldLayoutId xmlns:r="http://schemas.openxmlformats.org/officeDocument/2006/relationships" id="2147483649" r:id="R74ad0ca9acd54305"/>
   </p:sldLayoutIdLst>
   <p:txStyles>
     <p:titleStyle>
@@ -616,10 +616,10 @@
       </p:grpSpPr>
       <p:sp>
         <p:nvSpPr>
-          <p:cNvPr id="6" name="">
-            <a:extLst xmlns:a="http://schemas.openxmlformats.org/drawingml/2006/main">
-              <a:ext uri="{FF2B5EF4-FFF2-40B4-BE49-F238E27FC236}">
-                <a16:creationId xmlns:a16="http://schemas.microsoft.com/office/drawing/2014/main" id="{469DE57F-28A4-4A59-99DD-012D8CFD1ADA}"/>
+          <p:cNvPr id="7" name="">
+            <a:extLst xmlns:a="http://schemas.openxmlformats.org/drawingml/2006/main">
+              <a:ext uri="{FF2B5EF4-FFF2-40B4-BE49-F238E27FC236}">
+                <a16:creationId xmlns:a16="http://schemas.microsoft.com/office/drawing/2014/main" id="{6064AF25-45BB-47C9-8EF5-E05D74068521}"/>
               </a:ext>
             </a:extLst>
           </p:cNvPr>
@@ -676,7 +676,7 @@
           <p:cNvPr id="2" name="">
             <a:extLst xmlns:a="http://schemas.openxmlformats.org/drawingml/2006/main">
               <a:ext uri="{FF2B5EF4-FFF2-40B4-BE49-F238E27FC236}">
-                <a16:creationId xmlns:a16="http://schemas.microsoft.com/office/drawing/2014/main" id="{FAA5DC9E-6028-47AD-80BD-78696BB11CB9}"/>
+                <a16:creationId xmlns:a16="http://schemas.microsoft.com/office/drawing/2014/main" id="{84C947D0-34F6-41A3-934C-AC377664CC35}"/>
               </a:ext>
             </a:extLst>
           </p:cNvPr>
@@ -730,20 +730,20 @@
       </p:sp>
       <p:pic>
         <p:nvPicPr>
-          <p:cNvPr id="8" name=""/>
+          <p:cNvPr id="9" name=""/>
           <p:cNvPicPr>
             <a:picLocks xmlns:a="http://schemas.openxmlformats.org/drawingml/2006/main" noChangeAspect="1"/>
           </p:cNvPicPr>
           <p:nvPr/>
         </p:nvPicPr>
         <p:blipFill>
-          <a:blip xmlns:r="http://schemas.openxmlformats.org/officeDocument/2006/relationships" xmlns:a="http://schemas.openxmlformats.org/drawingml/2006/main" r:embed="R5ea368866ce94528"/>
+          <a:blip xmlns:r="http://schemas.openxmlformats.org/officeDocument/2006/relationships" xmlns:a="http://schemas.openxmlformats.org/drawingml/2006/main" r:embed="Ra635b39037004be5"/>
           <a:stretch xmlns:a="http://schemas.openxmlformats.org/drawingml/2006/main"/>
         </p:blipFill>
         <p:spPr>
           <a:xfrm xmlns:a="http://schemas.openxmlformats.org/drawingml/2006/main">
-            <a:off x="609600" y="1283203"/>
-            <a:ext cx="1714500" cy="338718"/>
+            <a:off x="10287000" y="925435"/>
+            <a:ext cx="1238250" cy="244630"/>
           </a:xfrm>
           <a:prstGeom xmlns:a="http://schemas.openxmlformats.org/drawingml/2006/main" prst="rect">
             <a:avLst/>
@@ -755,36 +755,36 @@
           <p:cNvPr id="4" name="">
             <a:extLst xmlns:a="http://schemas.openxmlformats.org/drawingml/2006/main">
               <a:ext uri="{FF2B5EF4-FFF2-40B4-BE49-F238E27FC236}">
-                <a16:creationId xmlns:a16="http://schemas.microsoft.com/office/drawing/2014/main" id="{84D57031-B0D4-4B69-9AC6-5A7FAEE358E8}"/>
-              </a:ext>
-            </a:extLst>
-          </p:cNvPr>
-          <p:cNvSpPr>
-            <a:spLocks xmlns:a="http://schemas.openxmlformats.org/drawingml/2006/main" noGrp="1"/>
-          </p:cNvSpPr>
-          <p:nvPr/>
-        </p:nvSpPr>
-        <p:spPr>
-          <a:xfrm xmlns:a="http://schemas.openxmlformats.org/drawingml/2006/main">
-            <a:off x="609600" y="2143125"/>
-            <a:ext cx="10953750" cy="1381125"/>
-          </a:xfrm>
-          <a:prstGeom xmlns:a="http://schemas.openxmlformats.org/drawingml/2006/main" prst="rect">
-            <a:avLst/>
-          </a:prstGeom>
-          <a:noFill xmlns:a="http://schemas.openxmlformats.org/drawingml/2006/main"/>
-          <a:ln xmlns:a="http://schemas.openxmlformats.org/drawingml/2006/main" w="0">
-            <a:noFill/>
-          </a:ln>
-        </p:spPr>
-        <p:txBody>
-          <a:bodyPr xmlns:a="http://schemas.openxmlformats.org/drawingml/2006/main">
-            <a:noAutofit/>
-          </a:bodyPr>
-          <a:lstStyle xmlns:a="http://schemas.openxmlformats.org/drawingml/2006/main"/>
-          <a:p xmlns:a="http://schemas.openxmlformats.org/drawingml/2006/main">
-            <a:pPr>
-              <a:defRPr sz="4350" b="1">
+                <a16:creationId xmlns:a16="http://schemas.microsoft.com/office/drawing/2014/main" id="{1529EFF1-364B-4D09-B31B-4B1DFEC03C2E}"/>
+              </a:ext>
+            </a:extLst>
+          </p:cNvPr>
+          <p:cNvSpPr>
+            <a:spLocks xmlns:a="http://schemas.openxmlformats.org/drawingml/2006/main" noGrp="1"/>
+          </p:cNvSpPr>
+          <p:nvPr/>
+        </p:nvSpPr>
+        <p:spPr>
+          <a:xfrm xmlns:a="http://schemas.openxmlformats.org/drawingml/2006/main">
+            <a:off x="609600" y="857250"/>
+            <a:ext cx="9429750" cy="714375"/>
+          </a:xfrm>
+          <a:prstGeom xmlns:a="http://schemas.openxmlformats.org/drawingml/2006/main" prst="rect">
+            <a:avLst/>
+          </a:prstGeom>
+          <a:noFill xmlns:a="http://schemas.openxmlformats.org/drawingml/2006/main"/>
+          <a:ln xmlns:a="http://schemas.openxmlformats.org/drawingml/2006/main" w="0">
+            <a:noFill/>
+          </a:ln>
+        </p:spPr>
+        <p:txBody>
+          <a:bodyPr xmlns:a="http://schemas.openxmlformats.org/drawingml/2006/main">
+            <a:noAutofit/>
+          </a:bodyPr>
+          <a:lstStyle xmlns:a="http://schemas.openxmlformats.org/drawingml/2006/main"/>
+          <a:p xmlns:a="http://schemas.openxmlformats.org/drawingml/2006/main">
+            <a:pPr>
+              <a:defRPr sz="3300" b="1">
                 <a:solidFill>
                   <a:srgbClr val="FFFFFF"/>
                 </a:solidFill>
@@ -794,7 +794,7 @@
               </a:defRPr>
             </a:pPr>
             <a:r>
-              <a:rPr sz="4350" b="1">
+              <a:rPr sz="3300" b="1">
                 <a:solidFill>
                   <a:srgbClr val="FFFFFF"/>
                 </a:solidFill>
@@ -807,51 +807,73 @@
           </a:p>
         </p:txBody>
       </p:sp>
-      <p:sp>
-        <p:nvSpPr>
-          <p:cNvPr id="5" name="">
-            <a:extLst xmlns:a="http://schemas.openxmlformats.org/drawingml/2006/main">
-              <a:ext uri="{FF2B5EF4-FFF2-40B4-BE49-F238E27FC236}">
-                <a16:creationId xmlns:a16="http://schemas.microsoft.com/office/drawing/2014/main" id="{B98F68E6-3446-4741-BC28-389136C8421F}"/>
-              </a:ext>
-            </a:extLst>
-          </p:cNvPr>
-          <p:cNvSpPr>
-            <a:spLocks xmlns:a="http://schemas.openxmlformats.org/drawingml/2006/main" noGrp="1"/>
-          </p:cNvSpPr>
-          <p:nvPr/>
-        </p:nvSpPr>
-        <p:spPr>
-          <a:xfrm xmlns:a="http://schemas.openxmlformats.org/drawingml/2006/main">
-            <a:off x="609600" y="3810000"/>
-            <a:ext cx="10668000" cy="1714500"/>
-          </a:xfrm>
-          <a:prstGeom xmlns:a="http://schemas.openxmlformats.org/drawingml/2006/main" prst="rect">
-            <a:avLst/>
-          </a:prstGeom>
-          <a:noFill xmlns:a="http://schemas.openxmlformats.org/drawingml/2006/main"/>
-          <a:ln xmlns:a="http://schemas.openxmlformats.org/drawingml/2006/main" w="0">
-            <a:noFill/>
-          </a:ln>
-        </p:spPr>
-        <p:txBody>
-          <a:bodyPr xmlns:a="http://schemas.openxmlformats.org/drawingml/2006/main">
-            <a:noAutofit/>
-          </a:bodyPr>
-          <a:lstStyle xmlns:a="http://schemas.openxmlformats.org/drawingml/2006/main"/>
-          <a:p xmlns:a="http://schemas.openxmlformats.org/drawingml/2006/main">
-            <a:pPr>
-              <a:defRPr sz="2250" b="0">
-                <a:solidFill>
-                  <a:srgbClr val="EAF1FF"/>
-                </a:solidFill>
-                <a:latin typeface="Arial"/>
-                <a:ea typeface="Arial"/>
-                <a:cs typeface="Arial"/>
-              </a:defRPr>
-            </a:pPr>
-            <a:r>
-              <a:rPr sz="2250" b="0">
+      <p:pic>
+        <p:nvPicPr>
+          <p:cNvPr id="11" name=""/>
+          <p:cNvPicPr>
+            <a:picLocks xmlns:a="http://schemas.openxmlformats.org/drawingml/2006/main" noChangeAspect="1"/>
+          </p:cNvPicPr>
+          <p:nvPr/>
+        </p:nvPicPr>
+        <p:blipFill>
+          <a:blip xmlns:r="http://schemas.openxmlformats.org/officeDocument/2006/relationships" xmlns:a="http://schemas.openxmlformats.org/drawingml/2006/main" r:embed="R0ec69f57b29549c1"/>
+          <a:stretch xmlns:a="http://schemas.openxmlformats.org/drawingml/2006/main"/>
+        </p:blipFill>
+        <p:spPr>
+          <a:xfrm xmlns:a="http://schemas.openxmlformats.org/drawingml/2006/main">
+            <a:off x="2659297" y="1666875"/>
+            <a:ext cx="6854356" cy="3857625"/>
+          </a:xfrm>
+          <a:prstGeom xmlns:a="http://schemas.openxmlformats.org/drawingml/2006/main" prst="rect">
+            <a:avLst/>
+          </a:prstGeom>
+        </p:spPr>
+      </p:pic>
+      <p:sp>
+        <p:nvSpPr>
+          <p:cNvPr id="6" name="">
+            <a:extLst xmlns:a="http://schemas.openxmlformats.org/drawingml/2006/main">
+              <a:ext uri="{FF2B5EF4-FFF2-40B4-BE49-F238E27FC236}">
+                <a16:creationId xmlns:a16="http://schemas.microsoft.com/office/drawing/2014/main" id="{C9ABD680-DE0C-45AB-A475-3307236780BF}"/>
+              </a:ext>
+            </a:extLst>
+          </p:cNvPr>
+          <p:cNvSpPr>
+            <a:spLocks xmlns:a="http://schemas.openxmlformats.org/drawingml/2006/main" noGrp="1"/>
+          </p:cNvSpPr>
+          <p:nvPr/>
+        </p:nvSpPr>
+        <p:spPr>
+          <a:xfrm xmlns:a="http://schemas.openxmlformats.org/drawingml/2006/main">
+            <a:off x="609600" y="5667375"/>
+            <a:ext cx="10953750" cy="619125"/>
+          </a:xfrm>
+          <a:prstGeom xmlns:a="http://schemas.openxmlformats.org/drawingml/2006/main" prst="rect">
+            <a:avLst/>
+          </a:prstGeom>
+          <a:noFill xmlns:a="http://schemas.openxmlformats.org/drawingml/2006/main"/>
+          <a:ln xmlns:a="http://schemas.openxmlformats.org/drawingml/2006/main" w="0">
+            <a:noFill/>
+          </a:ln>
+        </p:spPr>
+        <p:txBody>
+          <a:bodyPr xmlns:a="http://schemas.openxmlformats.org/drawingml/2006/main">
+            <a:noAutofit/>
+          </a:bodyPr>
+          <a:lstStyle xmlns:a="http://schemas.openxmlformats.org/drawingml/2006/main"/>
+          <a:p xmlns:a="http://schemas.openxmlformats.org/drawingml/2006/main">
+            <a:pPr>
+              <a:defRPr sz="1725" b="0">
+                <a:solidFill>
+                  <a:srgbClr val="EAF1FF"/>
+                </a:solidFill>
+                <a:latin typeface="Arial"/>
+                <a:ea typeface="Arial"/>
+                <a:cs typeface="Arial"/>
+              </a:defRPr>
+            </a:pPr>
+            <a:r>
+              <a:rPr sz="1725" b="0">
                 <a:solidFill>
                   <a:srgbClr val="EAF1FF"/>
                 </a:solidFill>
@@ -863,23 +885,18 @@
             </a:r>
           </a:p>
           <a:p xmlns:a="http://schemas.openxmlformats.org/drawingml/2006/main">
-            <a:r>
-              <a:t/>
-            </a:r>
-          </a:p>
-          <a:p xmlns:a="http://schemas.openxmlformats.org/drawingml/2006/main">
-            <a:pPr>
-              <a:defRPr sz="2250" b="0">
-                <a:solidFill>
-                  <a:srgbClr val="EAF1FF"/>
-                </a:solidFill>
-                <a:latin typeface="Arial"/>
-                <a:ea typeface="Arial"/>
-                <a:cs typeface="Arial"/>
-              </a:defRPr>
-            </a:pPr>
-            <a:r>
-              <a:rPr sz="2250" b="0">
+            <a:pPr>
+              <a:defRPr sz="1725" b="0">
+                <a:solidFill>
+                  <a:srgbClr val="EAF1FF"/>
+                </a:solidFill>
+                <a:latin typeface="Arial"/>
+                <a:ea typeface="Arial"/>
+                <a:cs typeface="Arial"/>
+              </a:defRPr>
+            </a:pPr>
+            <a:r>
+              <a:rPr sz="1725" b="0">
                 <a:solidFill>
                   <a:srgbClr val="EAF1FF"/>
                 </a:solidFill>
@@ -895,7 +912,7 @@
     </p:spTree>
     <p:extLst>
       <p:ext uri="{BB962C8B-B14F-4D97-AF65-F5344CB8AC3E}">
-        <p14:creationId xmlns:p14="http://schemas.microsoft.com/office/powerpoint/2010/main" val="462074473"/>
+        <p14:creationId xmlns:p14="http://schemas.microsoft.com/office/powerpoint/2010/main" val="1013837018"/>
       </p:ext>
     </p:extLst>
   </p:cSld>
@@ -926,7 +943,7 @@
           <p:cNvPr id="7" name="">
             <a:extLst xmlns:a="http://schemas.openxmlformats.org/drawingml/2006/main">
               <a:ext uri="{FF2B5EF4-FFF2-40B4-BE49-F238E27FC236}">
-                <a16:creationId xmlns:a16="http://schemas.microsoft.com/office/drawing/2014/main" id="{73FA0A3D-8705-4C2D-A331-AA6997D82092}"/>
+                <a16:creationId xmlns:a16="http://schemas.microsoft.com/office/drawing/2014/main" id="{3FBB8C48-CF46-4590-B667-17BADA7F1165}"/>
               </a:ext>
             </a:extLst>
           </p:cNvPr>
@@ -983,7 +1000,7 @@
           <p:cNvPr id="2" name="">
             <a:extLst xmlns:a="http://schemas.openxmlformats.org/drawingml/2006/main">
               <a:ext uri="{FF2B5EF4-FFF2-40B4-BE49-F238E27FC236}">
-                <a16:creationId xmlns:a16="http://schemas.microsoft.com/office/drawing/2014/main" id="{70339DC2-50D4-4A57-877F-E58FAEE6F211}"/>
+                <a16:creationId xmlns:a16="http://schemas.microsoft.com/office/drawing/2014/main" id="{21362C45-9BCE-4C53-9337-FBAB5DEE2587}"/>
               </a:ext>
             </a:extLst>
           </p:cNvPr>
@@ -1040,7 +1057,7 @@
           <p:cNvPr id="3" name="">
             <a:extLst xmlns:a="http://schemas.openxmlformats.org/drawingml/2006/main">
               <a:ext uri="{FF2B5EF4-FFF2-40B4-BE49-F238E27FC236}">
-                <a16:creationId xmlns:a16="http://schemas.microsoft.com/office/drawing/2014/main" id="{DF55B64C-1A52-4EA2-853F-33C306AF7056}"/>
+                <a16:creationId xmlns:a16="http://schemas.microsoft.com/office/drawing/2014/main" id="{1B112E3A-D2E4-47E9-8B30-CFE2B0CF6A73}"/>
               </a:ext>
             </a:extLst>
           </p:cNvPr>
@@ -1097,7 +1114,7 @@
           <p:cNvPr id="4" name="">
             <a:extLst xmlns:a="http://schemas.openxmlformats.org/drawingml/2006/main">
               <a:ext uri="{FF2B5EF4-FFF2-40B4-BE49-F238E27FC236}">
-                <a16:creationId xmlns:a16="http://schemas.microsoft.com/office/drawing/2014/main" id="{0D343599-02AC-433B-8D53-11CAE06D4B94}"/>
+                <a16:creationId xmlns:a16="http://schemas.microsoft.com/office/drawing/2014/main" id="{7C9C2F61-A5A0-4D26-8063-5F2AEE4D484A}"/>
               </a:ext>
             </a:extLst>
           </p:cNvPr>
@@ -1210,7 +1227,7 @@
           <p:cNvPr id="5" name="">
             <a:extLst xmlns:a="http://schemas.openxmlformats.org/drawingml/2006/main">
               <a:ext uri="{FF2B5EF4-FFF2-40B4-BE49-F238E27FC236}">
-                <a16:creationId xmlns:a16="http://schemas.microsoft.com/office/drawing/2014/main" id="{CC18F116-2587-476C-96E1-6C4F3D615C36}"/>
+                <a16:creationId xmlns:a16="http://schemas.microsoft.com/office/drawing/2014/main" id="{E4222ADF-4DC1-4AE7-BA46-1B6EFD121963}"/>
               </a:ext>
             </a:extLst>
           </p:cNvPr>
@@ -1290,7 +1307,7 @@
           <p:cNvPr id="6" name="">
             <a:extLst xmlns:a="http://schemas.openxmlformats.org/drawingml/2006/main">
               <a:ext uri="{FF2B5EF4-FFF2-40B4-BE49-F238E27FC236}">
-                <a16:creationId xmlns:a16="http://schemas.microsoft.com/office/drawing/2014/main" id="{4CB3C0BA-B13F-438F-AF75-20C9DF392C50}"/>
+                <a16:creationId xmlns:a16="http://schemas.microsoft.com/office/drawing/2014/main" id="{D582E342-0644-4559-AAD0-845F11A65A40}"/>
               </a:ext>
             </a:extLst>
           </p:cNvPr>
@@ -1345,7 +1362,7 @@
     </p:spTree>
     <p:extLst>
       <p:ext uri="{BB962C8B-B14F-4D97-AF65-F5344CB8AC3E}">
-        <p14:creationId xmlns:p14="http://schemas.microsoft.com/office/powerpoint/2010/main" val="94911823"/>
+        <p14:creationId xmlns:p14="http://schemas.microsoft.com/office/powerpoint/2010/main" val="43629586"/>
       </p:ext>
     </p:extLst>
   </p:cSld>
@@ -1376,7 +1393,7 @@
           <p:cNvPr id="7" name="">
             <a:extLst xmlns:a="http://schemas.openxmlformats.org/drawingml/2006/main">
               <a:ext uri="{FF2B5EF4-FFF2-40B4-BE49-F238E27FC236}">
-                <a16:creationId xmlns:a16="http://schemas.microsoft.com/office/drawing/2014/main" id="{A52DBE17-3C4E-4D1E-B7F9-22F6084F7614}"/>
+                <a16:creationId xmlns:a16="http://schemas.microsoft.com/office/drawing/2014/main" id="{9223843D-A577-46F0-A853-FEB583FE2A67}"/>
               </a:ext>
             </a:extLst>
           </p:cNvPr>
@@ -1433,7 +1450,7 @@
           <p:cNvPr id="2" name="">
             <a:extLst xmlns:a="http://schemas.openxmlformats.org/drawingml/2006/main">
               <a:ext uri="{FF2B5EF4-FFF2-40B4-BE49-F238E27FC236}">
-                <a16:creationId xmlns:a16="http://schemas.microsoft.com/office/drawing/2014/main" id="{D45ED1BF-EB6F-4159-9713-EA5A0BB876BA}"/>
+                <a16:creationId xmlns:a16="http://schemas.microsoft.com/office/drawing/2014/main" id="{C9020730-60B0-44DD-AA4F-96E9CDDB6DD6}"/>
               </a:ext>
             </a:extLst>
           </p:cNvPr>
@@ -1490,7 +1507,7 @@
           <p:cNvPr id="3" name="">
             <a:extLst xmlns:a="http://schemas.openxmlformats.org/drawingml/2006/main">
               <a:ext uri="{FF2B5EF4-FFF2-40B4-BE49-F238E27FC236}">
-                <a16:creationId xmlns:a16="http://schemas.microsoft.com/office/drawing/2014/main" id="{B94BCDC7-1B9C-45AC-BE5E-EE9C2BE0B4D0}"/>
+                <a16:creationId xmlns:a16="http://schemas.microsoft.com/office/drawing/2014/main" id="{3547F168-C2E8-41E2-A488-74DBED066A3B}"/>
               </a:ext>
             </a:extLst>
           </p:cNvPr>
@@ -1547,7 +1564,7 @@
           <p:cNvPr id="4" name="">
             <a:extLst xmlns:a="http://schemas.openxmlformats.org/drawingml/2006/main">
               <a:ext uri="{FF2B5EF4-FFF2-40B4-BE49-F238E27FC236}">
-                <a16:creationId xmlns:a16="http://schemas.microsoft.com/office/drawing/2014/main" id="{7ECE8E2A-7961-455A-8E55-60316875F1B5}"/>
+                <a16:creationId xmlns:a16="http://schemas.microsoft.com/office/drawing/2014/main" id="{7AA93283-919D-4DAF-809F-372273FEACB4}"/>
               </a:ext>
             </a:extLst>
           </p:cNvPr>
@@ -1660,7 +1677,7 @@
           <p:cNvPr id="5" name="">
             <a:extLst xmlns:a="http://schemas.openxmlformats.org/drawingml/2006/main">
               <a:ext uri="{FF2B5EF4-FFF2-40B4-BE49-F238E27FC236}">
-                <a16:creationId xmlns:a16="http://schemas.microsoft.com/office/drawing/2014/main" id="{253C93ED-D687-4200-8B30-9CDA3D7769AB}"/>
+                <a16:creationId xmlns:a16="http://schemas.microsoft.com/office/drawing/2014/main" id="{52E3A1AD-ECE6-4A73-BB47-96C5D318AEC3}"/>
               </a:ext>
             </a:extLst>
           </p:cNvPr>
@@ -1740,7 +1757,7 @@
           <p:cNvPr id="6" name="">
             <a:extLst xmlns:a="http://schemas.openxmlformats.org/drawingml/2006/main">
               <a:ext uri="{FF2B5EF4-FFF2-40B4-BE49-F238E27FC236}">
-                <a16:creationId xmlns:a16="http://schemas.microsoft.com/office/drawing/2014/main" id="{45F54839-816E-405B-9606-A67B545ECB52}"/>
+                <a16:creationId xmlns:a16="http://schemas.microsoft.com/office/drawing/2014/main" id="{DB4BE686-84DC-4821-B661-72300B7941E8}"/>
               </a:ext>
             </a:extLst>
           </p:cNvPr>
@@ -1795,7 +1812,7 @@
     </p:spTree>
     <p:extLst>
       <p:ext uri="{BB962C8B-B14F-4D97-AF65-F5344CB8AC3E}">
-        <p14:creationId xmlns:p14="http://schemas.microsoft.com/office/powerpoint/2010/main" val="1690741604"/>
+        <p14:creationId xmlns:p14="http://schemas.microsoft.com/office/powerpoint/2010/main" val="313135659"/>
       </p:ext>
     </p:extLst>
   </p:cSld>
@@ -1826,7 +1843,7 @@
           <p:cNvPr id="7" name="">
             <a:extLst xmlns:a="http://schemas.openxmlformats.org/drawingml/2006/main">
               <a:ext uri="{FF2B5EF4-FFF2-40B4-BE49-F238E27FC236}">
-                <a16:creationId xmlns:a16="http://schemas.microsoft.com/office/drawing/2014/main" id="{C8AE000A-DEC9-481F-896B-D88E4914D9CA}"/>
+                <a16:creationId xmlns:a16="http://schemas.microsoft.com/office/drawing/2014/main" id="{20CA51E5-167F-4542-A90B-D9FE7E60E002}"/>
               </a:ext>
             </a:extLst>
           </p:cNvPr>
@@ -1883,7 +1900,7 @@
           <p:cNvPr id="2" name="">
             <a:extLst xmlns:a="http://schemas.openxmlformats.org/drawingml/2006/main">
               <a:ext uri="{FF2B5EF4-FFF2-40B4-BE49-F238E27FC236}">
-                <a16:creationId xmlns:a16="http://schemas.microsoft.com/office/drawing/2014/main" id="{A9187983-A9E2-44AB-874E-F16320FE921E}"/>
+                <a16:creationId xmlns:a16="http://schemas.microsoft.com/office/drawing/2014/main" id="{49F8B9D2-BD7D-4BEB-869B-3DAF46157185}"/>
               </a:ext>
             </a:extLst>
           </p:cNvPr>
@@ -1940,7 +1957,7 @@
           <p:cNvPr id="3" name="">
             <a:extLst xmlns:a="http://schemas.openxmlformats.org/drawingml/2006/main">
               <a:ext uri="{FF2B5EF4-FFF2-40B4-BE49-F238E27FC236}">
-                <a16:creationId xmlns:a16="http://schemas.microsoft.com/office/drawing/2014/main" id="{2CA3EF23-ECF2-4B0F-A1A7-EEFC4D19A22F}"/>
+                <a16:creationId xmlns:a16="http://schemas.microsoft.com/office/drawing/2014/main" id="{649164E0-16A7-4B4B-9964-1CB77EB931FD}"/>
               </a:ext>
             </a:extLst>
           </p:cNvPr>
@@ -1997,7 +2014,7 @@
           <p:cNvPr id="4" name="">
             <a:extLst xmlns:a="http://schemas.openxmlformats.org/drawingml/2006/main">
               <a:ext uri="{FF2B5EF4-FFF2-40B4-BE49-F238E27FC236}">
-                <a16:creationId xmlns:a16="http://schemas.microsoft.com/office/drawing/2014/main" id="{C48EF23A-1DA9-4194-B163-333B68A296EF}"/>
+                <a16:creationId xmlns:a16="http://schemas.microsoft.com/office/drawing/2014/main" id="{4476F3BB-7C15-4A4D-9A69-BF342C69E01F}"/>
               </a:ext>
             </a:extLst>
           </p:cNvPr>
@@ -2110,7 +2127,7 @@
           <p:cNvPr id="5" name="">
             <a:extLst xmlns:a="http://schemas.openxmlformats.org/drawingml/2006/main">
               <a:ext uri="{FF2B5EF4-FFF2-40B4-BE49-F238E27FC236}">
-                <a16:creationId xmlns:a16="http://schemas.microsoft.com/office/drawing/2014/main" id="{1630BC37-AD46-42CF-B6B0-E0BC86DFD3F9}"/>
+                <a16:creationId xmlns:a16="http://schemas.microsoft.com/office/drawing/2014/main" id="{4D447AB7-1ACF-4F1E-A969-0DBADC04709E}"/>
               </a:ext>
             </a:extLst>
           </p:cNvPr>
@@ -2236,7 +2253,7 @@
           <p:cNvPr id="6" name="">
             <a:extLst xmlns:a="http://schemas.openxmlformats.org/drawingml/2006/main">
               <a:ext uri="{FF2B5EF4-FFF2-40B4-BE49-F238E27FC236}">
-                <a16:creationId xmlns:a16="http://schemas.microsoft.com/office/drawing/2014/main" id="{2BAEE0C6-96B6-4768-B9F8-CE00D1D6D95D}"/>
+                <a16:creationId xmlns:a16="http://schemas.microsoft.com/office/drawing/2014/main" id="{A9DD9EA5-1033-4F77-BCE6-E631D5E257F2}"/>
               </a:ext>
             </a:extLst>
           </p:cNvPr>
@@ -2291,7 +2308,7 @@
     </p:spTree>
     <p:extLst>
       <p:ext uri="{BB962C8B-B14F-4D97-AF65-F5344CB8AC3E}">
-        <p14:creationId xmlns:p14="http://schemas.microsoft.com/office/powerpoint/2010/main" val="1707558408"/>
+        <p14:creationId xmlns:p14="http://schemas.microsoft.com/office/powerpoint/2010/main" val="1076910239"/>
       </p:ext>
     </p:extLst>
   </p:cSld>
@@ -2322,7 +2339,7 @@
           <p:cNvPr id="7" name="">
             <a:extLst xmlns:a="http://schemas.openxmlformats.org/drawingml/2006/main">
               <a:ext uri="{FF2B5EF4-FFF2-40B4-BE49-F238E27FC236}">
-                <a16:creationId xmlns:a16="http://schemas.microsoft.com/office/drawing/2014/main" id="{5ECAF356-BFB8-409D-9D4D-DD307F2E8080}"/>
+                <a16:creationId xmlns:a16="http://schemas.microsoft.com/office/drawing/2014/main" id="{06D8C397-2405-4549-93AF-E503ABEEE4FB}"/>
               </a:ext>
             </a:extLst>
           </p:cNvPr>
@@ -2379,7 +2396,7 @@
           <p:cNvPr id="2" name="">
             <a:extLst xmlns:a="http://schemas.openxmlformats.org/drawingml/2006/main">
               <a:ext uri="{FF2B5EF4-FFF2-40B4-BE49-F238E27FC236}">
-                <a16:creationId xmlns:a16="http://schemas.microsoft.com/office/drawing/2014/main" id="{13850777-FE2F-4F7D-BF6D-D1B5842CBC80}"/>
+                <a16:creationId xmlns:a16="http://schemas.microsoft.com/office/drawing/2014/main" id="{55326104-46A3-467A-9A98-75617C2D849C}"/>
               </a:ext>
             </a:extLst>
           </p:cNvPr>
@@ -2436,7 +2453,7 @@
           <p:cNvPr id="3" name="">
             <a:extLst xmlns:a="http://schemas.openxmlformats.org/drawingml/2006/main">
               <a:ext uri="{FF2B5EF4-FFF2-40B4-BE49-F238E27FC236}">
-                <a16:creationId xmlns:a16="http://schemas.microsoft.com/office/drawing/2014/main" id="{13DBF63C-4F0A-4D9F-AAEB-D9A3BECF4C0D}"/>
+                <a16:creationId xmlns:a16="http://schemas.microsoft.com/office/drawing/2014/main" id="{A3510E55-6035-4B2C-B6CF-EAD558752869}"/>
               </a:ext>
             </a:extLst>
           </p:cNvPr>
@@ -2493,7 +2510,7 @@
           <p:cNvPr id="4" name="">
             <a:extLst xmlns:a="http://schemas.openxmlformats.org/drawingml/2006/main">
               <a:ext uri="{FF2B5EF4-FFF2-40B4-BE49-F238E27FC236}">
-                <a16:creationId xmlns:a16="http://schemas.microsoft.com/office/drawing/2014/main" id="{816E3719-A290-42E7-A06B-7AF85D197D0C}"/>
+                <a16:creationId xmlns:a16="http://schemas.microsoft.com/office/drawing/2014/main" id="{715DD66B-B209-42C3-82EE-3DB400AA01F7}"/>
               </a:ext>
             </a:extLst>
           </p:cNvPr>
@@ -2606,7 +2623,7 @@
           <p:cNvPr id="5" name="">
             <a:extLst xmlns:a="http://schemas.openxmlformats.org/drawingml/2006/main">
               <a:ext uri="{FF2B5EF4-FFF2-40B4-BE49-F238E27FC236}">
-                <a16:creationId xmlns:a16="http://schemas.microsoft.com/office/drawing/2014/main" id="{9D470171-5334-4107-B96F-2CD18EF4AB8C}"/>
+                <a16:creationId xmlns:a16="http://schemas.microsoft.com/office/drawing/2014/main" id="{C64FE656-0F18-456F-B8CE-4221C918120C}"/>
               </a:ext>
             </a:extLst>
           </p:cNvPr>
@@ -2663,7 +2680,7 @@
           <p:cNvPr id="6" name="">
             <a:extLst xmlns:a="http://schemas.openxmlformats.org/drawingml/2006/main">
               <a:ext uri="{FF2B5EF4-FFF2-40B4-BE49-F238E27FC236}">
-                <a16:creationId xmlns:a16="http://schemas.microsoft.com/office/drawing/2014/main" id="{B7909C82-A13C-4E13-A20E-53B72F7D9B6E}"/>
+                <a16:creationId xmlns:a16="http://schemas.microsoft.com/office/drawing/2014/main" id="{76D94573-A9CD-4701-9118-CA2558B4B6FA}"/>
               </a:ext>
             </a:extLst>
           </p:cNvPr>
@@ -2718,7 +2735,7 @@
     </p:spTree>
     <p:extLst>
       <p:ext uri="{BB962C8B-B14F-4D97-AF65-F5344CB8AC3E}">
-        <p14:creationId xmlns:p14="http://schemas.microsoft.com/office/powerpoint/2010/main" val="9690115"/>
+        <p14:creationId xmlns:p14="http://schemas.microsoft.com/office/powerpoint/2010/main" val="1597028890"/>
       </p:ext>
     </p:extLst>
   </p:cSld>
@@ -2749,7 +2766,7 @@
           <p:cNvPr id="6" name="">
             <a:extLst xmlns:a="http://schemas.openxmlformats.org/drawingml/2006/main">
               <a:ext uri="{FF2B5EF4-FFF2-40B4-BE49-F238E27FC236}">
-                <a16:creationId xmlns:a16="http://schemas.microsoft.com/office/drawing/2014/main" id="{976510E2-94BA-455C-88B4-814CD3BC3386}"/>
+                <a16:creationId xmlns:a16="http://schemas.microsoft.com/office/drawing/2014/main" id="{7E032EEC-2864-47ED-A12D-FC39880BA67B}"/>
               </a:ext>
             </a:extLst>
           </p:cNvPr>
@@ -2806,7 +2823,7 @@
           <p:cNvPr id="2" name="">
             <a:extLst xmlns:a="http://schemas.openxmlformats.org/drawingml/2006/main">
               <a:ext uri="{FF2B5EF4-FFF2-40B4-BE49-F238E27FC236}">
-                <a16:creationId xmlns:a16="http://schemas.microsoft.com/office/drawing/2014/main" id="{1F736E57-64CB-4840-938B-DA0FFEBC4E8B}"/>
+                <a16:creationId xmlns:a16="http://schemas.microsoft.com/office/drawing/2014/main" id="{84AD6215-793B-4281-8156-8FCD67C3A171}"/>
               </a:ext>
             </a:extLst>
           </p:cNvPr>
@@ -2863,7 +2880,7 @@
           <p:cNvPr id="3" name="">
             <a:extLst xmlns:a="http://schemas.openxmlformats.org/drawingml/2006/main">
               <a:ext uri="{FF2B5EF4-FFF2-40B4-BE49-F238E27FC236}">
-                <a16:creationId xmlns:a16="http://schemas.microsoft.com/office/drawing/2014/main" id="{32184544-E9DC-4F8E-A29E-809336F3FE2D}"/>
+                <a16:creationId xmlns:a16="http://schemas.microsoft.com/office/drawing/2014/main" id="{DE175D9D-0F57-49CB-A50E-122B642ED566}"/>
               </a:ext>
             </a:extLst>
           </p:cNvPr>
@@ -2920,7 +2937,7 @@
           <p:cNvPr id="4" name="">
             <a:extLst xmlns:a="http://schemas.openxmlformats.org/drawingml/2006/main">
               <a:ext uri="{FF2B5EF4-FFF2-40B4-BE49-F238E27FC236}">
-                <a16:creationId xmlns:a16="http://schemas.microsoft.com/office/drawing/2014/main" id="{E523E93E-8D38-41A3-9E2D-36F469BAC293}"/>
+                <a16:creationId xmlns:a16="http://schemas.microsoft.com/office/drawing/2014/main" id="{27D54040-5FFE-45D7-9C0F-DBD6EBE45C8A}"/>
               </a:ext>
             </a:extLst>
           </p:cNvPr>
@@ -3061,7 +3078,7 @@
           <p:cNvPr id="5" name="">
             <a:extLst xmlns:a="http://schemas.openxmlformats.org/drawingml/2006/main">
               <a:ext uri="{FF2B5EF4-FFF2-40B4-BE49-F238E27FC236}">
-                <a16:creationId xmlns:a16="http://schemas.microsoft.com/office/drawing/2014/main" id="{FE439384-5635-407A-AF37-EDAA442A4CF1}"/>
+                <a16:creationId xmlns:a16="http://schemas.microsoft.com/office/drawing/2014/main" id="{E38C9EF5-BDD9-437A-ABFD-E44BC6063B18}"/>
               </a:ext>
             </a:extLst>
           </p:cNvPr>
@@ -3116,7 +3133,7 @@
     </p:spTree>
     <p:extLst>
       <p:ext uri="{BB962C8B-B14F-4D97-AF65-F5344CB8AC3E}">
-        <p14:creationId xmlns:p14="http://schemas.microsoft.com/office/powerpoint/2010/main" val="1208969818"/>
+        <p14:creationId xmlns:p14="http://schemas.microsoft.com/office/powerpoint/2010/main" val="288069148"/>
       </p:ext>
     </p:extLst>
   </p:cSld>
@@ -3147,7 +3164,7 @@
           <p:cNvPr id="7" name="">
             <a:extLst xmlns:a="http://schemas.openxmlformats.org/drawingml/2006/main">
               <a:ext uri="{FF2B5EF4-FFF2-40B4-BE49-F238E27FC236}">
-                <a16:creationId xmlns:a16="http://schemas.microsoft.com/office/drawing/2014/main" id="{65BDED59-4563-4290-A537-EC6043CAAA34}"/>
+                <a16:creationId xmlns:a16="http://schemas.microsoft.com/office/drawing/2014/main" id="{005C0E5B-793F-45FF-A2F1-C9E4952782F8}"/>
               </a:ext>
             </a:extLst>
           </p:cNvPr>
@@ -3204,7 +3221,7 @@
           <p:cNvPr id="2" name="">
             <a:extLst xmlns:a="http://schemas.openxmlformats.org/drawingml/2006/main">
               <a:ext uri="{FF2B5EF4-FFF2-40B4-BE49-F238E27FC236}">
-                <a16:creationId xmlns:a16="http://schemas.microsoft.com/office/drawing/2014/main" id="{A4FCF976-B538-4D41-B884-962E37622655}"/>
+                <a16:creationId xmlns:a16="http://schemas.microsoft.com/office/drawing/2014/main" id="{70AEF83A-E897-4E42-8850-95BC0FBBF834}"/>
               </a:ext>
             </a:extLst>
           </p:cNvPr>
@@ -3261,7 +3278,7 @@
           <p:cNvPr id="3" name="">
             <a:extLst xmlns:a="http://schemas.openxmlformats.org/drawingml/2006/main">
               <a:ext uri="{FF2B5EF4-FFF2-40B4-BE49-F238E27FC236}">
-                <a16:creationId xmlns:a16="http://schemas.microsoft.com/office/drawing/2014/main" id="{52132634-7C9D-4AB7-B946-C77EC6164217}"/>
+                <a16:creationId xmlns:a16="http://schemas.microsoft.com/office/drawing/2014/main" id="{28FE2936-DAFA-449F-AE27-9385502812CE}"/>
               </a:ext>
             </a:extLst>
           </p:cNvPr>
@@ -3318,7 +3335,7 @@
           <p:cNvPr id="4" name="">
             <a:extLst xmlns:a="http://schemas.openxmlformats.org/drawingml/2006/main">
               <a:ext uri="{FF2B5EF4-FFF2-40B4-BE49-F238E27FC236}">
-                <a16:creationId xmlns:a16="http://schemas.microsoft.com/office/drawing/2014/main" id="{23A2508A-4FCE-444F-A029-6E54A88C3B10}"/>
+                <a16:creationId xmlns:a16="http://schemas.microsoft.com/office/drawing/2014/main" id="{E9129264-EA85-494C-B9BC-35C1144B5486}"/>
               </a:ext>
             </a:extLst>
           </p:cNvPr>
@@ -3431,7 +3448,7 @@
           <p:cNvPr id="5" name="">
             <a:extLst xmlns:a="http://schemas.openxmlformats.org/drawingml/2006/main">
               <a:ext uri="{FF2B5EF4-FFF2-40B4-BE49-F238E27FC236}">
-                <a16:creationId xmlns:a16="http://schemas.microsoft.com/office/drawing/2014/main" id="{76A6F169-2C25-4A08-BEED-8C4F676094C9}"/>
+                <a16:creationId xmlns:a16="http://schemas.microsoft.com/office/drawing/2014/main" id="{82A402E8-60E8-41D5-B923-90EF9C5C1CD4}"/>
               </a:ext>
             </a:extLst>
           </p:cNvPr>
@@ -3488,7 +3505,7 @@
           <p:cNvPr id="6" name="">
             <a:extLst xmlns:a="http://schemas.openxmlformats.org/drawingml/2006/main">
               <a:ext uri="{FF2B5EF4-FFF2-40B4-BE49-F238E27FC236}">
-                <a16:creationId xmlns:a16="http://schemas.microsoft.com/office/drawing/2014/main" id="{B3D2185A-D388-4A73-B56E-EB5CF19E2CBF}"/>
+                <a16:creationId xmlns:a16="http://schemas.microsoft.com/office/drawing/2014/main" id="{C2F519D4-B5B6-41A8-BF05-95997C25523E}"/>
               </a:ext>
             </a:extLst>
           </p:cNvPr>
@@ -3543,7 +3560,7 @@
     </p:spTree>
     <p:extLst>
       <p:ext uri="{BB962C8B-B14F-4D97-AF65-F5344CB8AC3E}">
-        <p14:creationId xmlns:p14="http://schemas.microsoft.com/office/powerpoint/2010/main" val="1385442611"/>
+        <p14:creationId xmlns:p14="http://schemas.microsoft.com/office/powerpoint/2010/main" val="262707331"/>
       </p:ext>
     </p:extLst>
   </p:cSld>
@@ -3574,7 +3591,7 @@
           <p:cNvPr id="5" name="">
             <a:extLst xmlns:a="http://schemas.openxmlformats.org/drawingml/2006/main">
               <a:ext uri="{FF2B5EF4-FFF2-40B4-BE49-F238E27FC236}">
-                <a16:creationId xmlns:a16="http://schemas.microsoft.com/office/drawing/2014/main" id="{3A4959D5-2973-488E-A36A-328265D0E9E1}"/>
+                <a16:creationId xmlns:a16="http://schemas.microsoft.com/office/drawing/2014/main" id="{FF41871A-95E6-41B8-8530-95348086C759}"/>
               </a:ext>
             </a:extLst>
           </p:cNvPr>
@@ -3631,7 +3648,7 @@
           <p:cNvPr id="2" name="">
             <a:extLst xmlns:a="http://schemas.openxmlformats.org/drawingml/2006/main">
               <a:ext uri="{FF2B5EF4-FFF2-40B4-BE49-F238E27FC236}">
-                <a16:creationId xmlns:a16="http://schemas.microsoft.com/office/drawing/2014/main" id="{671E69A5-659D-4C67-BEBA-7520843F62C2}"/>
+                <a16:creationId xmlns:a16="http://schemas.microsoft.com/office/drawing/2014/main" id="{D18A79FC-0D48-4863-B962-6D89279A4FF1}"/>
               </a:ext>
             </a:extLst>
           </p:cNvPr>
@@ -3688,7 +3705,7 @@
           <p:cNvPr id="3" name="">
             <a:extLst xmlns:a="http://schemas.openxmlformats.org/drawingml/2006/main">
               <a:ext uri="{FF2B5EF4-FFF2-40B4-BE49-F238E27FC236}">
-                <a16:creationId xmlns:a16="http://schemas.microsoft.com/office/drawing/2014/main" id="{AD79699D-36C2-494E-AB84-10D83741CE6D}"/>
+                <a16:creationId xmlns:a16="http://schemas.microsoft.com/office/drawing/2014/main" id="{347A2F1F-0015-4AA2-8F98-5A483EE8D501}"/>
               </a:ext>
             </a:extLst>
           </p:cNvPr>
@@ -3745,7 +3762,7 @@
           <p:cNvPr id="4" name="">
             <a:extLst xmlns:a="http://schemas.openxmlformats.org/drawingml/2006/main">
               <a:ext uri="{FF2B5EF4-FFF2-40B4-BE49-F238E27FC236}">
-                <a16:creationId xmlns:a16="http://schemas.microsoft.com/office/drawing/2014/main" id="{F94FEC4A-7EBF-48B6-9A6A-23454D86EFB0}"/>
+                <a16:creationId xmlns:a16="http://schemas.microsoft.com/office/drawing/2014/main" id="{9E60EC9A-A9CF-4EB0-8859-2B4481F2F40B}"/>
               </a:ext>
             </a:extLst>
           </p:cNvPr>
@@ -3884,7 +3901,7 @@
     </p:spTree>
     <p:extLst>
       <p:ext uri="{BB962C8B-B14F-4D97-AF65-F5344CB8AC3E}">
-        <p14:creationId xmlns:p14="http://schemas.microsoft.com/office/powerpoint/2010/main" val="695515321"/>
+        <p14:creationId xmlns:p14="http://schemas.microsoft.com/office/powerpoint/2010/main" val="1832751913"/>
       </p:ext>
     </p:extLst>
   </p:cSld>
@@ -3915,7 +3932,7 @@
           <p:cNvPr id="7" name="">
             <a:extLst xmlns:a="http://schemas.openxmlformats.org/drawingml/2006/main">
               <a:ext uri="{FF2B5EF4-FFF2-40B4-BE49-F238E27FC236}">
-                <a16:creationId xmlns:a16="http://schemas.microsoft.com/office/drawing/2014/main" id="{3AE0DCB1-7F7F-447E-9287-6DB00D2751B4}"/>
+                <a16:creationId xmlns:a16="http://schemas.microsoft.com/office/drawing/2014/main" id="{CB99EE05-D039-41BD-A51C-222372CBD2A3}"/>
               </a:ext>
             </a:extLst>
           </p:cNvPr>
@@ -3972,7 +3989,7 @@
           <p:cNvPr id="2" name="">
             <a:extLst xmlns:a="http://schemas.openxmlformats.org/drawingml/2006/main">
               <a:ext uri="{FF2B5EF4-FFF2-40B4-BE49-F238E27FC236}">
-                <a16:creationId xmlns:a16="http://schemas.microsoft.com/office/drawing/2014/main" id="{3E48507C-2448-4498-A222-2C6E4AEC412E}"/>
+                <a16:creationId xmlns:a16="http://schemas.microsoft.com/office/drawing/2014/main" id="{C5D27AF6-268D-4184-9025-8E68F8DD1FBA}"/>
               </a:ext>
             </a:extLst>
           </p:cNvPr>
@@ -4029,7 +4046,7 @@
           <p:cNvPr id="3" name="">
             <a:extLst xmlns:a="http://schemas.openxmlformats.org/drawingml/2006/main">
               <a:ext uri="{FF2B5EF4-FFF2-40B4-BE49-F238E27FC236}">
-                <a16:creationId xmlns:a16="http://schemas.microsoft.com/office/drawing/2014/main" id="{C17B4BE3-2105-4F5C-B9EE-CB0E698FD9AD}"/>
+                <a16:creationId xmlns:a16="http://schemas.microsoft.com/office/drawing/2014/main" id="{84EEC89E-1B20-4F31-9F2A-CE9579EBBB8D}"/>
               </a:ext>
             </a:extLst>
           </p:cNvPr>
@@ -4086,7 +4103,7 @@
           <p:cNvPr id="4" name="">
             <a:extLst xmlns:a="http://schemas.openxmlformats.org/drawingml/2006/main">
               <a:ext uri="{FF2B5EF4-FFF2-40B4-BE49-F238E27FC236}">
-                <a16:creationId xmlns:a16="http://schemas.microsoft.com/office/drawing/2014/main" id="{E25D8ADE-6948-4484-8359-016AB18C9B81}"/>
+                <a16:creationId xmlns:a16="http://schemas.microsoft.com/office/drawing/2014/main" id="{CAC82D99-2AB2-415A-A800-A6E92EAE7415}"/>
               </a:ext>
             </a:extLst>
           </p:cNvPr>
@@ -4171,7 +4188,7 @@
           <p:cNvPr id="5" name="">
             <a:extLst xmlns:a="http://schemas.openxmlformats.org/drawingml/2006/main">
               <a:ext uri="{FF2B5EF4-FFF2-40B4-BE49-F238E27FC236}">
-                <a16:creationId xmlns:a16="http://schemas.microsoft.com/office/drawing/2014/main" id="{32500C41-8809-40B9-AE22-7A0FEAB1A39E}"/>
+                <a16:creationId xmlns:a16="http://schemas.microsoft.com/office/drawing/2014/main" id="{016F8FAC-3B03-450A-826C-75E2718DE3BA}"/>
               </a:ext>
             </a:extLst>
           </p:cNvPr>
@@ -4274,7 +4291,7 @@
           <p:cNvPr id="6" name="">
             <a:extLst xmlns:a="http://schemas.openxmlformats.org/drawingml/2006/main">
               <a:ext uri="{FF2B5EF4-FFF2-40B4-BE49-F238E27FC236}">
-                <a16:creationId xmlns:a16="http://schemas.microsoft.com/office/drawing/2014/main" id="{5843B34A-E740-47E3-BC4D-49F2EE3E2AC9}"/>
+                <a16:creationId xmlns:a16="http://schemas.microsoft.com/office/drawing/2014/main" id="{E43AF9DF-F330-4720-BC81-4A69AC5D99CF}"/>
               </a:ext>
             </a:extLst>
           </p:cNvPr>
@@ -4329,7 +4346,7 @@
     </p:spTree>
     <p:extLst>
       <p:ext uri="{BB962C8B-B14F-4D97-AF65-F5344CB8AC3E}">
-        <p14:creationId xmlns:p14="http://schemas.microsoft.com/office/powerpoint/2010/main" val="1986543754"/>
+        <p14:creationId xmlns:p14="http://schemas.microsoft.com/office/powerpoint/2010/main" val="1893970491"/>
       </p:ext>
     </p:extLst>
   </p:cSld>
@@ -4360,7 +4377,7 @@
           <p:cNvPr id="6" name="">
             <a:extLst xmlns:a="http://schemas.openxmlformats.org/drawingml/2006/main">
               <a:ext uri="{FF2B5EF4-FFF2-40B4-BE49-F238E27FC236}">
-                <a16:creationId xmlns:a16="http://schemas.microsoft.com/office/drawing/2014/main" id="{7F94BDD3-961E-4B94-B425-46ABBBD0FFB6}"/>
+                <a16:creationId xmlns:a16="http://schemas.microsoft.com/office/drawing/2014/main" id="{B9F0533F-BAC2-4AF5-A974-241F2C6F6B8D}"/>
               </a:ext>
             </a:extLst>
           </p:cNvPr>
@@ -4417,7 +4434,7 @@
           <p:cNvPr id="2" name="">
             <a:extLst xmlns:a="http://schemas.openxmlformats.org/drawingml/2006/main">
               <a:ext uri="{FF2B5EF4-FFF2-40B4-BE49-F238E27FC236}">
-                <a16:creationId xmlns:a16="http://schemas.microsoft.com/office/drawing/2014/main" id="{0975FE9C-C713-492D-B1B4-ED96F5438C00}"/>
+                <a16:creationId xmlns:a16="http://schemas.microsoft.com/office/drawing/2014/main" id="{801BBD37-9781-4E35-8432-CAB5C23767E1}"/>
               </a:ext>
             </a:extLst>
           </p:cNvPr>
@@ -4474,7 +4491,7 @@
           <p:cNvPr id="3" name="">
             <a:extLst xmlns:a="http://schemas.openxmlformats.org/drawingml/2006/main">
               <a:ext uri="{FF2B5EF4-FFF2-40B4-BE49-F238E27FC236}">
-                <a16:creationId xmlns:a16="http://schemas.microsoft.com/office/drawing/2014/main" id="{EA75BDA9-3154-4092-BB6A-1F12D3EF7CB1}"/>
+                <a16:creationId xmlns:a16="http://schemas.microsoft.com/office/drawing/2014/main" id="{399CD36E-186A-49DC-A042-1982D63CDC7E}"/>
               </a:ext>
             </a:extLst>
           </p:cNvPr>
@@ -4531,7 +4548,7 @@
           <p:cNvPr id="4" name="">
             <a:extLst xmlns:a="http://schemas.openxmlformats.org/drawingml/2006/main">
               <a:ext uri="{FF2B5EF4-FFF2-40B4-BE49-F238E27FC236}">
-                <a16:creationId xmlns:a16="http://schemas.microsoft.com/office/drawing/2014/main" id="{C9463AA2-7923-4400-8DF7-09A15260F841}"/>
+                <a16:creationId xmlns:a16="http://schemas.microsoft.com/office/drawing/2014/main" id="{495126C5-281B-4D66-B548-D4A549D7AA9A}"/>
               </a:ext>
             </a:extLst>
           </p:cNvPr>
@@ -4672,7 +4689,7 @@
           <p:cNvPr id="5" name="">
             <a:extLst xmlns:a="http://schemas.openxmlformats.org/drawingml/2006/main">
               <a:ext uri="{FF2B5EF4-FFF2-40B4-BE49-F238E27FC236}">
-                <a16:creationId xmlns:a16="http://schemas.microsoft.com/office/drawing/2014/main" id="{39F83FB1-78AC-48CA-8378-27D13F3CD50A}"/>
+                <a16:creationId xmlns:a16="http://schemas.microsoft.com/office/drawing/2014/main" id="{A32898AD-C2EC-41A3-9931-CFF5A653627C}"/>
               </a:ext>
             </a:extLst>
           </p:cNvPr>
@@ -4727,7 +4744,7 @@
     </p:spTree>
     <p:extLst>
       <p:ext uri="{BB962C8B-B14F-4D97-AF65-F5344CB8AC3E}">
-        <p14:creationId xmlns:p14="http://schemas.microsoft.com/office/powerpoint/2010/main" val="1793628779"/>
+        <p14:creationId xmlns:p14="http://schemas.microsoft.com/office/powerpoint/2010/main" val="1573002623"/>
       </p:ext>
     </p:extLst>
   </p:cSld>
@@ -4758,7 +4775,7 @@
           <p:cNvPr id="5" name="">
             <a:extLst xmlns:a="http://schemas.openxmlformats.org/drawingml/2006/main">
               <a:ext uri="{FF2B5EF4-FFF2-40B4-BE49-F238E27FC236}">
-                <a16:creationId xmlns:a16="http://schemas.microsoft.com/office/drawing/2014/main" id="{DD713243-13A6-4770-A771-1787FFEFF892}"/>
+                <a16:creationId xmlns:a16="http://schemas.microsoft.com/office/drawing/2014/main" id="{F051809C-9230-468E-945E-EA844CDE4FFF}"/>
               </a:ext>
             </a:extLst>
           </p:cNvPr>
@@ -4815,7 +4832,7 @@
           <p:cNvPr id="2" name="">
             <a:extLst xmlns:a="http://schemas.openxmlformats.org/drawingml/2006/main">
               <a:ext uri="{FF2B5EF4-FFF2-40B4-BE49-F238E27FC236}">
-                <a16:creationId xmlns:a16="http://schemas.microsoft.com/office/drawing/2014/main" id="{6B8207BB-3CAF-45F0-B161-EA21024EE49D}"/>
+                <a16:creationId xmlns:a16="http://schemas.microsoft.com/office/drawing/2014/main" id="{69E9B0DF-BD85-4E9C-B1F5-DEC3233D8C14}"/>
               </a:ext>
             </a:extLst>
           </p:cNvPr>
@@ -4872,7 +4889,7 @@
           <p:cNvPr id="3" name="">
             <a:extLst xmlns:a="http://schemas.openxmlformats.org/drawingml/2006/main">
               <a:ext uri="{FF2B5EF4-FFF2-40B4-BE49-F238E27FC236}">
-                <a16:creationId xmlns:a16="http://schemas.microsoft.com/office/drawing/2014/main" id="{EC668ABE-50E6-4620-9BCA-F77915D108DC}"/>
+                <a16:creationId xmlns:a16="http://schemas.microsoft.com/office/drawing/2014/main" id="{B5E4A6C5-2E09-4D71-B937-F60E4EFF4196}"/>
               </a:ext>
             </a:extLst>
           </p:cNvPr>
@@ -4929,7 +4946,7 @@
           <p:cNvPr id="4" name="">
             <a:extLst xmlns:a="http://schemas.openxmlformats.org/drawingml/2006/main">
               <a:ext uri="{FF2B5EF4-FFF2-40B4-BE49-F238E27FC236}">
-                <a16:creationId xmlns:a16="http://schemas.microsoft.com/office/drawing/2014/main" id="{CB6DEF09-F085-4A5D-9FBC-2B8EED8A6F99}"/>
+                <a16:creationId xmlns:a16="http://schemas.microsoft.com/office/drawing/2014/main" id="{971F69BD-945C-484D-A6C4-89A52BEFDFDC}"/>
               </a:ext>
             </a:extLst>
           </p:cNvPr>
@@ -5068,7 +5085,7 @@
     </p:spTree>
     <p:extLst>
       <p:ext uri="{BB962C8B-B14F-4D97-AF65-F5344CB8AC3E}">
-        <p14:creationId xmlns:p14="http://schemas.microsoft.com/office/powerpoint/2010/main" val="660974711"/>
+        <p14:creationId xmlns:p14="http://schemas.microsoft.com/office/powerpoint/2010/main" val="2071209131"/>
       </p:ext>
     </p:extLst>
   </p:cSld>
@@ -5099,7 +5116,7 @@
           <p:cNvPr id="6" name="">
             <a:extLst xmlns:a="http://schemas.openxmlformats.org/drawingml/2006/main">
               <a:ext uri="{FF2B5EF4-FFF2-40B4-BE49-F238E27FC236}">
-                <a16:creationId xmlns:a16="http://schemas.microsoft.com/office/drawing/2014/main" id="{8A9F1AC3-1F70-4957-A1B7-A9522F99FA57}"/>
+                <a16:creationId xmlns:a16="http://schemas.microsoft.com/office/drawing/2014/main" id="{E7600D80-EC2B-4612-A924-A22A39999CCE}"/>
               </a:ext>
             </a:extLst>
           </p:cNvPr>
@@ -5156,7 +5173,7 @@
           <p:cNvPr id="2" name="">
             <a:extLst xmlns:a="http://schemas.openxmlformats.org/drawingml/2006/main">
               <a:ext uri="{FF2B5EF4-FFF2-40B4-BE49-F238E27FC236}">
-                <a16:creationId xmlns:a16="http://schemas.microsoft.com/office/drawing/2014/main" id="{83FE155D-FC14-4090-8716-4BF2F3414DA0}"/>
+                <a16:creationId xmlns:a16="http://schemas.microsoft.com/office/drawing/2014/main" id="{0D0C8B76-EEC5-499B-B7A4-88B81B8BF956}"/>
               </a:ext>
             </a:extLst>
           </p:cNvPr>
@@ -5213,7 +5230,7 @@
           <p:cNvPr id="3" name="">
             <a:extLst xmlns:a="http://schemas.openxmlformats.org/drawingml/2006/main">
               <a:ext uri="{FF2B5EF4-FFF2-40B4-BE49-F238E27FC236}">
-                <a16:creationId xmlns:a16="http://schemas.microsoft.com/office/drawing/2014/main" id="{1CF00EAE-566E-4D5F-8BCF-A46FDF39F62C}"/>
+                <a16:creationId xmlns:a16="http://schemas.microsoft.com/office/drawing/2014/main" id="{6304849B-404E-4BBD-B6D5-1D619B7882F3}"/>
               </a:ext>
             </a:extLst>
           </p:cNvPr>
@@ -5270,7 +5287,7 @@
           <p:cNvPr id="4" name="">
             <a:extLst xmlns:a="http://schemas.openxmlformats.org/drawingml/2006/main">
               <a:ext uri="{FF2B5EF4-FFF2-40B4-BE49-F238E27FC236}">
-                <a16:creationId xmlns:a16="http://schemas.microsoft.com/office/drawing/2014/main" id="{B0FCBB11-4A79-4F04-8705-CF755986BE9D}"/>
+                <a16:creationId xmlns:a16="http://schemas.microsoft.com/office/drawing/2014/main" id="{38549393-176D-45DE-938A-C966AFDDB7F4}"/>
               </a:ext>
             </a:extLst>
           </p:cNvPr>
@@ -5383,7 +5400,7 @@
           <p:cNvPr id="5" name="">
             <a:extLst xmlns:a="http://schemas.openxmlformats.org/drawingml/2006/main">
               <a:ext uri="{FF2B5EF4-FFF2-40B4-BE49-F238E27FC236}">
-                <a16:creationId xmlns:a16="http://schemas.microsoft.com/office/drawing/2014/main" id="{209F77C1-01C8-4E67-8F43-408D742985BA}"/>
+                <a16:creationId xmlns:a16="http://schemas.microsoft.com/office/drawing/2014/main" id="{B77BD5C1-C3B8-474D-BAE9-58BDABD6217C}"/>
               </a:ext>
             </a:extLst>
           </p:cNvPr>
@@ -5438,7 +5455,7 @@
     </p:spTree>
     <p:extLst>
       <p:ext uri="{BB962C8B-B14F-4D97-AF65-F5344CB8AC3E}">
-        <p14:creationId xmlns:p14="http://schemas.microsoft.com/office/powerpoint/2010/main" val="571015428"/>
+        <p14:creationId xmlns:p14="http://schemas.microsoft.com/office/powerpoint/2010/main" val="991943503"/>
       </p:ext>
     </p:extLst>
   </p:cSld>
@@ -5469,7 +5486,7 @@
           <p:cNvPr id="6" name="">
             <a:extLst xmlns:a="http://schemas.openxmlformats.org/drawingml/2006/main">
               <a:ext uri="{FF2B5EF4-FFF2-40B4-BE49-F238E27FC236}">
-                <a16:creationId xmlns:a16="http://schemas.microsoft.com/office/drawing/2014/main" id="{ECFAF366-4C37-42A4-8ED3-950C4C34CD09}"/>
+                <a16:creationId xmlns:a16="http://schemas.microsoft.com/office/drawing/2014/main" id="{24A7A570-817F-4813-923F-E470ABE82653}"/>
               </a:ext>
             </a:extLst>
           </p:cNvPr>
@@ -5526,7 +5543,7 @@
           <p:cNvPr id="2" name="">
             <a:extLst xmlns:a="http://schemas.openxmlformats.org/drawingml/2006/main">
               <a:ext uri="{FF2B5EF4-FFF2-40B4-BE49-F238E27FC236}">
-                <a16:creationId xmlns:a16="http://schemas.microsoft.com/office/drawing/2014/main" id="{917A2B1A-FB53-4FE6-8FCD-E9E7D458E672}"/>
+                <a16:creationId xmlns:a16="http://schemas.microsoft.com/office/drawing/2014/main" id="{9C77A48B-3E3E-4EF9-82CF-6074368F2DF5}"/>
               </a:ext>
             </a:extLst>
           </p:cNvPr>
@@ -5583,7 +5600,7 @@
           <p:cNvPr id="3" name="">
             <a:extLst xmlns:a="http://schemas.openxmlformats.org/drawingml/2006/main">
               <a:ext uri="{FF2B5EF4-FFF2-40B4-BE49-F238E27FC236}">
-                <a16:creationId xmlns:a16="http://schemas.microsoft.com/office/drawing/2014/main" id="{B1EC6C21-CD5E-4C3C-A2B5-F0CAE7F63829}"/>
+                <a16:creationId xmlns:a16="http://schemas.microsoft.com/office/drawing/2014/main" id="{021F3AF5-74E0-449E-AB13-215D9425FB54}"/>
               </a:ext>
             </a:extLst>
           </p:cNvPr>
@@ -5640,7 +5657,7 @@
           <p:cNvPr id="4" name="">
             <a:extLst xmlns:a="http://schemas.openxmlformats.org/drawingml/2006/main">
               <a:ext uri="{FF2B5EF4-FFF2-40B4-BE49-F238E27FC236}">
-                <a16:creationId xmlns:a16="http://schemas.microsoft.com/office/drawing/2014/main" id="{F5B85620-4F8F-4F33-936F-ECE33B11C166}"/>
+                <a16:creationId xmlns:a16="http://schemas.microsoft.com/office/drawing/2014/main" id="{A4CEF351-8D75-4548-A9A7-EF95365DC56D}"/>
               </a:ext>
             </a:extLst>
           </p:cNvPr>
@@ -5753,7 +5770,7 @@
           <p:cNvPr id="5" name="">
             <a:extLst xmlns:a="http://schemas.openxmlformats.org/drawingml/2006/main">
               <a:ext uri="{FF2B5EF4-FFF2-40B4-BE49-F238E27FC236}">
-                <a16:creationId xmlns:a16="http://schemas.microsoft.com/office/drawing/2014/main" id="{CFDE30F1-ED48-430C-A695-9847D99A4637}"/>
+                <a16:creationId xmlns:a16="http://schemas.microsoft.com/office/drawing/2014/main" id="{59E3496F-DE82-4500-B606-6FC9185BDB7A}"/>
               </a:ext>
             </a:extLst>
           </p:cNvPr>
@@ -5831,7 +5848,7 @@
     </p:spTree>
     <p:extLst>
       <p:ext uri="{BB962C8B-B14F-4D97-AF65-F5344CB8AC3E}">
-        <p14:creationId xmlns:p14="http://schemas.microsoft.com/office/powerpoint/2010/main" val="1356840658"/>
+        <p14:creationId xmlns:p14="http://schemas.microsoft.com/office/powerpoint/2010/main" val="76419847"/>
       </p:ext>
     </p:extLst>
   </p:cSld>
@@ -5862,7 +5879,7 @@
           <p:cNvPr id="6" name="">
             <a:extLst xmlns:a="http://schemas.openxmlformats.org/drawingml/2006/main">
               <a:ext uri="{FF2B5EF4-FFF2-40B4-BE49-F238E27FC236}">
-                <a16:creationId xmlns:a16="http://schemas.microsoft.com/office/drawing/2014/main" id="{117625FB-81AD-477B-B2B5-31A835E9FC37}"/>
+                <a16:creationId xmlns:a16="http://schemas.microsoft.com/office/drawing/2014/main" id="{044F6874-130F-4748-B8A6-0864B39A1C9B}"/>
               </a:ext>
             </a:extLst>
           </p:cNvPr>
@@ -5919,7 +5936,7 @@
           <p:cNvPr id="2" name="">
             <a:extLst xmlns:a="http://schemas.openxmlformats.org/drawingml/2006/main">
               <a:ext uri="{FF2B5EF4-FFF2-40B4-BE49-F238E27FC236}">
-                <a16:creationId xmlns:a16="http://schemas.microsoft.com/office/drawing/2014/main" id="{9E4B2E48-1C0B-42A7-887C-B623E0F5F2EC}"/>
+                <a16:creationId xmlns:a16="http://schemas.microsoft.com/office/drawing/2014/main" id="{79E11CB0-0F8B-4B40-AA45-552321085873}"/>
               </a:ext>
             </a:extLst>
           </p:cNvPr>
@@ -5976,7 +5993,7 @@
           <p:cNvPr id="3" name="">
             <a:extLst xmlns:a="http://schemas.openxmlformats.org/drawingml/2006/main">
               <a:ext uri="{FF2B5EF4-FFF2-40B4-BE49-F238E27FC236}">
-                <a16:creationId xmlns:a16="http://schemas.microsoft.com/office/drawing/2014/main" id="{271A4929-4629-405B-8C55-8D4A605EADE2}"/>
+                <a16:creationId xmlns:a16="http://schemas.microsoft.com/office/drawing/2014/main" id="{08FB5C11-D550-439C-820F-E4750446E36E}"/>
               </a:ext>
             </a:extLst>
           </p:cNvPr>
@@ -6033,7 +6050,7 @@
           <p:cNvPr id="4" name="">
             <a:extLst xmlns:a="http://schemas.openxmlformats.org/drawingml/2006/main">
               <a:ext uri="{FF2B5EF4-FFF2-40B4-BE49-F238E27FC236}">
-                <a16:creationId xmlns:a16="http://schemas.microsoft.com/office/drawing/2014/main" id="{606286AB-2BED-4CAA-8889-52E9A7E3BA01}"/>
+                <a16:creationId xmlns:a16="http://schemas.microsoft.com/office/drawing/2014/main" id="{F11C9278-B812-4D90-81FF-969402F962EA}"/>
               </a:ext>
             </a:extLst>
           </p:cNvPr>
@@ -6146,7 +6163,7 @@
           <p:cNvPr id="5" name="">
             <a:extLst xmlns:a="http://schemas.openxmlformats.org/drawingml/2006/main">
               <a:ext uri="{FF2B5EF4-FFF2-40B4-BE49-F238E27FC236}">
-                <a16:creationId xmlns:a16="http://schemas.microsoft.com/office/drawing/2014/main" id="{116B5BC2-2B6A-4C26-9DA1-671285E9B0DE}"/>
+                <a16:creationId xmlns:a16="http://schemas.microsoft.com/office/drawing/2014/main" id="{8ABC2A7B-80C7-48E7-8A3A-99327E420003}"/>
               </a:ext>
             </a:extLst>
           </p:cNvPr>
@@ -6201,7 +6218,7 @@
     </p:spTree>
     <p:extLst>
       <p:ext uri="{BB962C8B-B14F-4D97-AF65-F5344CB8AC3E}">
-        <p14:creationId xmlns:p14="http://schemas.microsoft.com/office/powerpoint/2010/main" val="1579195225"/>
+        <p14:creationId xmlns:p14="http://schemas.microsoft.com/office/powerpoint/2010/main" val="1243842282"/>
       </p:ext>
     </p:extLst>
   </p:cSld>
@@ -6232,7 +6249,7 @@
           <p:cNvPr id="7" name="">
             <a:extLst xmlns:a="http://schemas.openxmlformats.org/drawingml/2006/main">
               <a:ext uri="{FF2B5EF4-FFF2-40B4-BE49-F238E27FC236}">
-                <a16:creationId xmlns:a16="http://schemas.microsoft.com/office/drawing/2014/main" id="{214F7132-3239-4666-8EC1-FADF6CB1F745}"/>
+                <a16:creationId xmlns:a16="http://schemas.microsoft.com/office/drawing/2014/main" id="{C382FEA6-32CE-4F82-AC30-EF6C341D29EC}"/>
               </a:ext>
             </a:extLst>
           </p:cNvPr>
@@ -6289,7 +6306,7 @@
           <p:cNvPr id="2" name="">
             <a:extLst xmlns:a="http://schemas.openxmlformats.org/drawingml/2006/main">
               <a:ext uri="{FF2B5EF4-FFF2-40B4-BE49-F238E27FC236}">
-                <a16:creationId xmlns:a16="http://schemas.microsoft.com/office/drawing/2014/main" id="{185C2693-0773-4A8B-B3D7-68906DCBABA1}"/>
+                <a16:creationId xmlns:a16="http://schemas.microsoft.com/office/drawing/2014/main" id="{81328DB9-07DF-414B-9439-1A51994AB994}"/>
               </a:ext>
             </a:extLst>
           </p:cNvPr>
@@ -6346,7 +6363,7 @@
           <p:cNvPr id="3" name="">
             <a:extLst xmlns:a="http://schemas.openxmlformats.org/drawingml/2006/main">
               <a:ext uri="{FF2B5EF4-FFF2-40B4-BE49-F238E27FC236}">
-                <a16:creationId xmlns:a16="http://schemas.microsoft.com/office/drawing/2014/main" id="{63BFB1F4-1CED-480C-BC74-EEE80CEA91C0}"/>
+                <a16:creationId xmlns:a16="http://schemas.microsoft.com/office/drawing/2014/main" id="{3EA7DCD4-FECC-4CEB-8255-1615D50B4B22}"/>
               </a:ext>
             </a:extLst>
           </p:cNvPr>
@@ -6819,7 +6836,7 @@
           <p:cNvPr id="5" name="">
             <a:extLst xmlns:a="http://schemas.openxmlformats.org/drawingml/2006/main">
               <a:ext uri="{FF2B5EF4-FFF2-40B4-BE49-F238E27FC236}">
-                <a16:creationId xmlns:a16="http://schemas.microsoft.com/office/drawing/2014/main" id="{221EC8FC-BA56-4903-B3B8-1A8BC6098A06}"/>
+                <a16:creationId xmlns:a16="http://schemas.microsoft.com/office/drawing/2014/main" id="{4E0EA83A-B5BB-4513-9635-7B87DD718840}"/>
               </a:ext>
             </a:extLst>
           </p:cNvPr>
@@ -6904,7 +6921,7 @@
           <p:cNvPr id="6" name="">
             <a:extLst xmlns:a="http://schemas.openxmlformats.org/drawingml/2006/main">
               <a:ext uri="{FF2B5EF4-FFF2-40B4-BE49-F238E27FC236}">
-                <a16:creationId xmlns:a16="http://schemas.microsoft.com/office/drawing/2014/main" id="{8E7AA664-7765-4BD6-B685-E32A63C42969}"/>
+                <a16:creationId xmlns:a16="http://schemas.microsoft.com/office/drawing/2014/main" id="{F2049937-290E-44AE-9209-C791B1F5C372}"/>
               </a:ext>
             </a:extLst>
           </p:cNvPr>
@@ -6959,7 +6976,7 @@
     </p:spTree>
     <p:extLst>
       <p:ext uri="{BB962C8B-B14F-4D97-AF65-F5344CB8AC3E}">
-        <p14:creationId xmlns:p14="http://schemas.microsoft.com/office/powerpoint/2010/main" val="1613915612"/>
+        <p14:creationId xmlns:p14="http://schemas.microsoft.com/office/powerpoint/2010/main" val="1242275336"/>
       </p:ext>
     </p:extLst>
   </p:cSld>
@@ -6990,7 +7007,7 @@
           <p:cNvPr id="7" name="">
             <a:extLst xmlns:a="http://schemas.openxmlformats.org/drawingml/2006/main">
               <a:ext uri="{FF2B5EF4-FFF2-40B4-BE49-F238E27FC236}">
-                <a16:creationId xmlns:a16="http://schemas.microsoft.com/office/drawing/2014/main" id="{BE5C9490-18E0-4F35-AC66-1AA41B5779C9}"/>
+                <a16:creationId xmlns:a16="http://schemas.microsoft.com/office/drawing/2014/main" id="{E2B4374B-5EEF-45A1-9363-694734D0EBB3}"/>
               </a:ext>
             </a:extLst>
           </p:cNvPr>
@@ -7047,7 +7064,7 @@
           <p:cNvPr id="2" name="">
             <a:extLst xmlns:a="http://schemas.openxmlformats.org/drawingml/2006/main">
               <a:ext uri="{FF2B5EF4-FFF2-40B4-BE49-F238E27FC236}">
-                <a16:creationId xmlns:a16="http://schemas.microsoft.com/office/drawing/2014/main" id="{7D191C11-A5FC-4993-8EBB-8F2AFD1EAFBA}"/>
+                <a16:creationId xmlns:a16="http://schemas.microsoft.com/office/drawing/2014/main" id="{2F9AC65A-CAF8-4DF3-9854-0052A0620D18}"/>
               </a:ext>
             </a:extLst>
           </p:cNvPr>
@@ -7104,7 +7121,7 @@
           <p:cNvPr id="3" name="">
             <a:extLst xmlns:a="http://schemas.openxmlformats.org/drawingml/2006/main">
               <a:ext uri="{FF2B5EF4-FFF2-40B4-BE49-F238E27FC236}">
-                <a16:creationId xmlns:a16="http://schemas.microsoft.com/office/drawing/2014/main" id="{E2056C00-6DEF-4368-9E03-DD0CEF908B8A}"/>
+                <a16:creationId xmlns:a16="http://schemas.microsoft.com/office/drawing/2014/main" id="{8B79825F-4CB1-4E04-B63D-E9F9E37E2602}"/>
               </a:ext>
             </a:extLst>
           </p:cNvPr>
@@ -7161,7 +7178,7 @@
           <p:cNvPr id="4" name="">
             <a:extLst xmlns:a="http://schemas.openxmlformats.org/drawingml/2006/main">
               <a:ext uri="{FF2B5EF4-FFF2-40B4-BE49-F238E27FC236}">
-                <a16:creationId xmlns:a16="http://schemas.microsoft.com/office/drawing/2014/main" id="{607CB899-7811-4E87-8585-B5A47610C6A3}"/>
+                <a16:creationId xmlns:a16="http://schemas.microsoft.com/office/drawing/2014/main" id="{C08212D9-9188-4C36-96E1-C7992564242C}"/>
               </a:ext>
             </a:extLst>
           </p:cNvPr>
@@ -7302,7 +7319,7 @@
           <p:cNvPr id="5" name="">
             <a:extLst xmlns:a="http://schemas.openxmlformats.org/drawingml/2006/main">
               <a:ext uri="{FF2B5EF4-FFF2-40B4-BE49-F238E27FC236}">
-                <a16:creationId xmlns:a16="http://schemas.microsoft.com/office/drawing/2014/main" id="{76673849-AEBD-422E-A971-D8981DD37645}"/>
+                <a16:creationId xmlns:a16="http://schemas.microsoft.com/office/drawing/2014/main" id="{EDA61498-4EB6-4476-AEF7-300C0309C215}"/>
               </a:ext>
             </a:extLst>
           </p:cNvPr>
@@ -7405,7 +7422,7 @@
           <p:cNvPr id="6" name="">
             <a:extLst xmlns:a="http://schemas.openxmlformats.org/drawingml/2006/main">
               <a:ext uri="{FF2B5EF4-FFF2-40B4-BE49-F238E27FC236}">
-                <a16:creationId xmlns:a16="http://schemas.microsoft.com/office/drawing/2014/main" id="{28617E7C-7C15-4847-A4EF-EB04AFD8C995}"/>
+                <a16:creationId xmlns:a16="http://schemas.microsoft.com/office/drawing/2014/main" id="{621BED62-59E4-4375-9AF2-D21CD965847F}"/>
               </a:ext>
             </a:extLst>
           </p:cNvPr>
@@ -7460,7 +7477,7 @@
     </p:spTree>
     <p:extLst>
       <p:ext uri="{BB962C8B-B14F-4D97-AF65-F5344CB8AC3E}">
-        <p14:creationId xmlns:p14="http://schemas.microsoft.com/office/powerpoint/2010/main" val="1863021217"/>
+        <p14:creationId xmlns:p14="http://schemas.microsoft.com/office/powerpoint/2010/main" val="1818488791"/>
       </p:ext>
     </p:extLst>
   </p:cSld>
@@ -7491,7 +7508,7 @@
           <p:cNvPr id="6" name="">
             <a:extLst xmlns:a="http://schemas.openxmlformats.org/drawingml/2006/main">
               <a:ext uri="{FF2B5EF4-FFF2-40B4-BE49-F238E27FC236}">
-                <a16:creationId xmlns:a16="http://schemas.microsoft.com/office/drawing/2014/main" id="{2F082466-18A2-4789-9B65-C191BA2DA1B5}"/>
+                <a16:creationId xmlns:a16="http://schemas.microsoft.com/office/drawing/2014/main" id="{3AD65419-AE2D-47ED-9E30-753BB1718424}"/>
               </a:ext>
             </a:extLst>
           </p:cNvPr>
@@ -7548,7 +7565,7 @@
           <p:cNvPr id="2" name="">
             <a:extLst xmlns:a="http://schemas.openxmlformats.org/drawingml/2006/main">
               <a:ext uri="{FF2B5EF4-FFF2-40B4-BE49-F238E27FC236}">
-                <a16:creationId xmlns:a16="http://schemas.microsoft.com/office/drawing/2014/main" id="{EC1C3973-8B1C-4F8C-8CA7-477040EC2DD0}"/>
+                <a16:creationId xmlns:a16="http://schemas.microsoft.com/office/drawing/2014/main" id="{26768E4B-B51F-4B09-A5F2-9BC960B15745}"/>
               </a:ext>
             </a:extLst>
           </p:cNvPr>
@@ -7605,7 +7622,7 @@
           <p:cNvPr id="3" name="">
             <a:extLst xmlns:a="http://schemas.openxmlformats.org/drawingml/2006/main">
               <a:ext uri="{FF2B5EF4-FFF2-40B4-BE49-F238E27FC236}">
-                <a16:creationId xmlns:a16="http://schemas.microsoft.com/office/drawing/2014/main" id="{4F79B48C-341C-4894-BFD1-13FCAC4DF5C7}"/>
+                <a16:creationId xmlns:a16="http://schemas.microsoft.com/office/drawing/2014/main" id="{DD23FF3D-E33F-4F56-9DA0-E112797AB8B7}"/>
               </a:ext>
             </a:extLst>
           </p:cNvPr>
@@ -7662,7 +7679,7 @@
           <p:cNvPr id="4" name="">
             <a:extLst xmlns:a="http://schemas.openxmlformats.org/drawingml/2006/main">
               <a:ext uri="{FF2B5EF4-FFF2-40B4-BE49-F238E27FC236}">
-                <a16:creationId xmlns:a16="http://schemas.microsoft.com/office/drawing/2014/main" id="{A4E3416F-7D1D-47E3-8333-BBE4C8180C9F}"/>
+                <a16:creationId xmlns:a16="http://schemas.microsoft.com/office/drawing/2014/main" id="{64D62F80-28AB-42F2-8AAC-92825A41366F}"/>
               </a:ext>
             </a:extLst>
           </p:cNvPr>
@@ -7775,7 +7792,7 @@
           <p:cNvPr id="5" name="">
             <a:extLst xmlns:a="http://schemas.openxmlformats.org/drawingml/2006/main">
               <a:ext uri="{FF2B5EF4-FFF2-40B4-BE49-F238E27FC236}">
-                <a16:creationId xmlns:a16="http://schemas.microsoft.com/office/drawing/2014/main" id="{54F3C4D6-1730-4A09-9963-8426680FAE4D}"/>
+                <a16:creationId xmlns:a16="http://schemas.microsoft.com/office/drawing/2014/main" id="{284BAB30-1A34-4875-AAB6-7C6831906B0E}"/>
               </a:ext>
             </a:extLst>
           </p:cNvPr>
@@ -7876,7 +7893,7 @@
     </p:spTree>
     <p:extLst>
       <p:ext uri="{BB962C8B-B14F-4D97-AF65-F5344CB8AC3E}">
-        <p14:creationId xmlns:p14="http://schemas.microsoft.com/office/powerpoint/2010/main" val="1107145885"/>
+        <p14:creationId xmlns:p14="http://schemas.microsoft.com/office/powerpoint/2010/main" val="872823588"/>
       </p:ext>
     </p:extLst>
   </p:cSld>
@@ -7907,7 +7924,7 @@
           <p:cNvPr id="7" name="">
             <a:extLst xmlns:a="http://schemas.openxmlformats.org/drawingml/2006/main">
               <a:ext uri="{FF2B5EF4-FFF2-40B4-BE49-F238E27FC236}">
-                <a16:creationId xmlns:a16="http://schemas.microsoft.com/office/drawing/2014/main" id="{E6E182E0-9B0C-4AE0-8DF6-0F1A7C503BBC}"/>
+                <a16:creationId xmlns:a16="http://schemas.microsoft.com/office/drawing/2014/main" id="{B0AA2F7A-9824-40AC-A440-AB900DA5BD57}"/>
               </a:ext>
             </a:extLst>
           </p:cNvPr>
@@ -7964,7 +7981,7 @@
           <p:cNvPr id="2" name="">
             <a:extLst xmlns:a="http://schemas.openxmlformats.org/drawingml/2006/main">
               <a:ext uri="{FF2B5EF4-FFF2-40B4-BE49-F238E27FC236}">
-                <a16:creationId xmlns:a16="http://schemas.microsoft.com/office/drawing/2014/main" id="{822E6B5D-BBD0-4CC9-B850-47B94676BDA2}"/>
+                <a16:creationId xmlns:a16="http://schemas.microsoft.com/office/drawing/2014/main" id="{8862D0A0-4463-4CA2-9563-6FF88D67315B}"/>
               </a:ext>
             </a:extLst>
           </p:cNvPr>
@@ -8021,7 +8038,7 @@
           <p:cNvPr id="3" name="">
             <a:extLst xmlns:a="http://schemas.openxmlformats.org/drawingml/2006/main">
               <a:ext uri="{FF2B5EF4-FFF2-40B4-BE49-F238E27FC236}">
-                <a16:creationId xmlns:a16="http://schemas.microsoft.com/office/drawing/2014/main" id="{8B64320E-3C5C-432C-8C0F-01C30CEA5AFA}"/>
+                <a16:creationId xmlns:a16="http://schemas.microsoft.com/office/drawing/2014/main" id="{8541FE2F-EE22-42AD-B6B5-5B4BA7335B98}"/>
               </a:ext>
             </a:extLst>
           </p:cNvPr>
@@ -8078,7 +8095,7 @@
           <p:cNvPr id="4" name="">
             <a:extLst xmlns:a="http://schemas.openxmlformats.org/drawingml/2006/main">
               <a:ext uri="{FF2B5EF4-FFF2-40B4-BE49-F238E27FC236}">
-                <a16:creationId xmlns:a16="http://schemas.microsoft.com/office/drawing/2014/main" id="{85FF5EBF-BA07-45DC-850D-EAF9DE41D621}"/>
+                <a16:creationId xmlns:a16="http://schemas.microsoft.com/office/drawing/2014/main" id="{6D737F55-8A28-41BC-9C57-DE5DD8D0214B}"/>
               </a:ext>
             </a:extLst>
           </p:cNvPr>
@@ -8163,7 +8180,7 @@
           <p:cNvPr id="5" name="">
             <a:extLst xmlns:a="http://schemas.openxmlformats.org/drawingml/2006/main">
               <a:ext uri="{FF2B5EF4-FFF2-40B4-BE49-F238E27FC236}">
-                <a16:creationId xmlns:a16="http://schemas.microsoft.com/office/drawing/2014/main" id="{D52E1B69-6653-42A7-BC21-93AD02C81569}"/>
+                <a16:creationId xmlns:a16="http://schemas.microsoft.com/office/drawing/2014/main" id="{2797EC1D-EFE8-4DDF-A250-0E927B1E1937}"/>
               </a:ext>
             </a:extLst>
           </p:cNvPr>
@@ -8266,7 +8283,7 @@
           <p:cNvPr id="6" name="">
             <a:extLst xmlns:a="http://schemas.openxmlformats.org/drawingml/2006/main">
               <a:ext uri="{FF2B5EF4-FFF2-40B4-BE49-F238E27FC236}">
-                <a16:creationId xmlns:a16="http://schemas.microsoft.com/office/drawing/2014/main" id="{90E66305-0F3A-4D97-B2DD-48DDB958DA1C}"/>
+                <a16:creationId xmlns:a16="http://schemas.microsoft.com/office/drawing/2014/main" id="{49C5674A-412F-47AE-9B20-45DF65A388FC}"/>
               </a:ext>
             </a:extLst>
           </p:cNvPr>
@@ -8321,7 +8338,7 @@
     </p:spTree>
     <p:extLst>
       <p:ext uri="{BB962C8B-B14F-4D97-AF65-F5344CB8AC3E}">
-        <p14:creationId xmlns:p14="http://schemas.microsoft.com/office/powerpoint/2010/main" val="1910793661"/>
+        <p14:creationId xmlns:p14="http://schemas.microsoft.com/office/powerpoint/2010/main" val="237674924"/>
       </p:ext>
     </p:extLst>
   </p:cSld>
@@ -8352,7 +8369,7 @@
           <p:cNvPr id="7" name="">
             <a:extLst xmlns:a="http://schemas.openxmlformats.org/drawingml/2006/main">
               <a:ext uri="{FF2B5EF4-FFF2-40B4-BE49-F238E27FC236}">
-                <a16:creationId xmlns:a16="http://schemas.microsoft.com/office/drawing/2014/main" id="{1112F2AF-39B2-4CE1-8DE5-6E4E52BDDCAA}"/>
+                <a16:creationId xmlns:a16="http://schemas.microsoft.com/office/drawing/2014/main" id="{F2002B98-DBEE-47B1-B91E-DC5C5ACA4548}"/>
               </a:ext>
             </a:extLst>
           </p:cNvPr>
@@ -8409,7 +8426,7 @@
           <p:cNvPr id="2" name="">
             <a:extLst xmlns:a="http://schemas.openxmlformats.org/drawingml/2006/main">
               <a:ext uri="{FF2B5EF4-FFF2-40B4-BE49-F238E27FC236}">
-                <a16:creationId xmlns:a16="http://schemas.microsoft.com/office/drawing/2014/main" id="{5A94E7D8-532A-4FE6-AAC8-958524358FE0}"/>
+                <a16:creationId xmlns:a16="http://schemas.microsoft.com/office/drawing/2014/main" id="{8CC93428-7895-4618-9C9F-1E470B3DB88B}"/>
               </a:ext>
             </a:extLst>
           </p:cNvPr>
@@ -8466,7 +8483,7 @@
           <p:cNvPr id="3" name="">
             <a:extLst xmlns:a="http://schemas.openxmlformats.org/drawingml/2006/main">
               <a:ext uri="{FF2B5EF4-FFF2-40B4-BE49-F238E27FC236}">
-                <a16:creationId xmlns:a16="http://schemas.microsoft.com/office/drawing/2014/main" id="{52DE91CB-64B9-40F4-B4DF-BA81BFED6532}"/>
+                <a16:creationId xmlns:a16="http://schemas.microsoft.com/office/drawing/2014/main" id="{A2177AE7-3CF3-430D-BA11-4BECB2352388}"/>
               </a:ext>
             </a:extLst>
           </p:cNvPr>
@@ -8527,7 +8544,7 @@
           <p:nvPr/>
         </p:nvPicPr>
         <p:blipFill>
-          <a:blip xmlns:r="http://schemas.openxmlformats.org/officeDocument/2006/relationships" xmlns:a="http://schemas.openxmlformats.org/drawingml/2006/main" r:embed="Rce4443667a554245"/>
+          <a:blip xmlns:r="http://schemas.openxmlformats.org/officeDocument/2006/relationships" xmlns:a="http://schemas.openxmlformats.org/drawingml/2006/main" r:embed="R99d400a2c64241a8"/>
           <a:stretch xmlns:a="http://schemas.openxmlformats.org/drawingml/2006/main"/>
         </p:blipFill>
         <p:spPr>
@@ -8545,7 +8562,7 @@
           <p:cNvPr id="5" name="">
             <a:extLst xmlns:a="http://schemas.openxmlformats.org/drawingml/2006/main">
               <a:ext uri="{FF2B5EF4-FFF2-40B4-BE49-F238E27FC236}">
-                <a16:creationId xmlns:a16="http://schemas.microsoft.com/office/drawing/2014/main" id="{4AB4E885-E379-40B3-9134-B16F69C18BE6}"/>
+                <a16:creationId xmlns:a16="http://schemas.microsoft.com/office/drawing/2014/main" id="{556E404A-7271-4FF6-91FA-7C02CAA1D86D}"/>
               </a:ext>
             </a:extLst>
           </p:cNvPr>
@@ -8602,7 +8619,7 @@
           <p:cNvPr id="6" name="">
             <a:extLst xmlns:a="http://schemas.openxmlformats.org/drawingml/2006/main">
               <a:ext uri="{FF2B5EF4-FFF2-40B4-BE49-F238E27FC236}">
-                <a16:creationId xmlns:a16="http://schemas.microsoft.com/office/drawing/2014/main" id="{A136CD57-C2CE-4C7D-A96E-64AF0E11D2E0}"/>
+                <a16:creationId xmlns:a16="http://schemas.microsoft.com/office/drawing/2014/main" id="{933D0E42-4DE5-4598-9013-BDFA85FE8B24}"/>
               </a:ext>
             </a:extLst>
           </p:cNvPr>
@@ -8657,7 +8674,7 @@
     </p:spTree>
     <p:extLst>
       <p:ext uri="{BB962C8B-B14F-4D97-AF65-F5344CB8AC3E}">
-        <p14:creationId xmlns:p14="http://schemas.microsoft.com/office/powerpoint/2010/main" val="1403402694"/>
+        <p14:creationId xmlns:p14="http://schemas.microsoft.com/office/powerpoint/2010/main" val="97481855"/>
       </p:ext>
     </p:extLst>
   </p:cSld>

</xml_diff>

<commit_message>
Illustrate week 4 lecture and lab opening stories (#42)
</commit_message>
<xml_diff>
--- a/lendet/2026-2027/mobile/lectures/ligjerata-04-neon-postgresql-rideshare-2026.pptx
+++ b/lendet/2026-2027/mobile/lectures/ligjerata-04-neon-postgresql-rideshare-2026.pptx
@@ -2,28 +2,28 @@
 <file path=ppt/presentation.xml><?xml version="1.0" encoding="utf-8"?>
 <p:presentation xmlns:p="http://schemas.openxmlformats.org/presentationml/2006/main">
   <p:sldMasterIdLst>
-    <p:sldMasterId xmlns:r="http://schemas.openxmlformats.org/officeDocument/2006/relationships" id="2147483648" r:id="Red10f41f72b34c87"/>
+    <p:sldMasterId xmlns:r="http://schemas.openxmlformats.org/officeDocument/2006/relationships" id="2147483648" r:id="R32f700e982f04b62"/>
   </p:sldMasterIdLst>
   <p:sldIdLst>
-    <p:sldId xmlns:r="http://schemas.openxmlformats.org/officeDocument/2006/relationships" id="256" r:id="R02751c1ce6bf4056"/>
-    <p:sldId xmlns:r="http://schemas.openxmlformats.org/officeDocument/2006/relationships" id="257" r:id="R51a1d8eefdc14fc7"/>
-    <p:sldId xmlns:r="http://schemas.openxmlformats.org/officeDocument/2006/relationships" id="258" r:id="R655ba8d034704801"/>
-    <p:sldId xmlns:r="http://schemas.openxmlformats.org/officeDocument/2006/relationships" id="259" r:id="Rc0771159c9514ade"/>
-    <p:sldId xmlns:r="http://schemas.openxmlformats.org/officeDocument/2006/relationships" id="260" r:id="Rb048703e825949ba"/>
-    <p:sldId xmlns:r="http://schemas.openxmlformats.org/officeDocument/2006/relationships" id="261" r:id="R97a15a779a7e41bf"/>
-    <p:sldId xmlns:r="http://schemas.openxmlformats.org/officeDocument/2006/relationships" id="262" r:id="R767dc16736b745f0"/>
-    <p:sldId xmlns:r="http://schemas.openxmlformats.org/officeDocument/2006/relationships" id="263" r:id="Rbf5b6a2f54f04566"/>
-    <p:sldId xmlns:r="http://schemas.openxmlformats.org/officeDocument/2006/relationships" id="264" r:id="R74a76565449e4558"/>
-    <p:sldId xmlns:r="http://schemas.openxmlformats.org/officeDocument/2006/relationships" id="265" r:id="R4012071585954ec4"/>
-    <p:sldId xmlns:r="http://schemas.openxmlformats.org/officeDocument/2006/relationships" id="266" r:id="R28259617aaa84692"/>
-    <p:sldId xmlns:r="http://schemas.openxmlformats.org/officeDocument/2006/relationships" id="267" r:id="R9a1f3ee6a7ed444e"/>
-    <p:sldId xmlns:r="http://schemas.openxmlformats.org/officeDocument/2006/relationships" id="268" r:id="R77d81c4d17344768"/>
-    <p:sldId xmlns:r="http://schemas.openxmlformats.org/officeDocument/2006/relationships" id="269" r:id="Rbdb7e65e032c44c4"/>
-    <p:sldId xmlns:r="http://schemas.openxmlformats.org/officeDocument/2006/relationships" id="270" r:id="Ra3644680203e4ff6"/>
-    <p:sldId xmlns:r="http://schemas.openxmlformats.org/officeDocument/2006/relationships" id="271" r:id="R15592293385545bf"/>
-    <p:sldId xmlns:r="http://schemas.openxmlformats.org/officeDocument/2006/relationships" id="272" r:id="Rc118d6867f854394"/>
-    <p:sldId xmlns:r="http://schemas.openxmlformats.org/officeDocument/2006/relationships" id="273" r:id="R7b54aaf5e72b4ae7"/>
-    <p:sldId xmlns:r="http://schemas.openxmlformats.org/officeDocument/2006/relationships" id="274" r:id="Re9664f9f47c94da6"/>
+    <p:sldId xmlns:r="http://schemas.openxmlformats.org/officeDocument/2006/relationships" id="256" r:id="R0b58241ca65c4a25"/>
+    <p:sldId xmlns:r="http://schemas.openxmlformats.org/officeDocument/2006/relationships" id="257" r:id="R1b08c80eb2854183"/>
+    <p:sldId xmlns:r="http://schemas.openxmlformats.org/officeDocument/2006/relationships" id="258" r:id="R04221dabb39d48ab"/>
+    <p:sldId xmlns:r="http://schemas.openxmlformats.org/officeDocument/2006/relationships" id="259" r:id="R9579cb5cf91147ab"/>
+    <p:sldId xmlns:r="http://schemas.openxmlformats.org/officeDocument/2006/relationships" id="260" r:id="R68057e8fac5c4adf"/>
+    <p:sldId xmlns:r="http://schemas.openxmlformats.org/officeDocument/2006/relationships" id="261" r:id="Re270c51eb55c4cd3"/>
+    <p:sldId xmlns:r="http://schemas.openxmlformats.org/officeDocument/2006/relationships" id="262" r:id="Ra926b2f054134575"/>
+    <p:sldId xmlns:r="http://schemas.openxmlformats.org/officeDocument/2006/relationships" id="263" r:id="R43da0ced30d34969"/>
+    <p:sldId xmlns:r="http://schemas.openxmlformats.org/officeDocument/2006/relationships" id="264" r:id="R051e3f8fba1f44ff"/>
+    <p:sldId xmlns:r="http://schemas.openxmlformats.org/officeDocument/2006/relationships" id="265" r:id="R9639caeb60ec4bdb"/>
+    <p:sldId xmlns:r="http://schemas.openxmlformats.org/officeDocument/2006/relationships" id="266" r:id="Rdaf5fcf9055c40e3"/>
+    <p:sldId xmlns:r="http://schemas.openxmlformats.org/officeDocument/2006/relationships" id="267" r:id="Rb7f18537419343c1"/>
+    <p:sldId xmlns:r="http://schemas.openxmlformats.org/officeDocument/2006/relationships" id="268" r:id="R54faa88fb0da400f"/>
+    <p:sldId xmlns:r="http://schemas.openxmlformats.org/officeDocument/2006/relationships" id="269" r:id="R0d90b6d7a7b940b0"/>
+    <p:sldId xmlns:r="http://schemas.openxmlformats.org/officeDocument/2006/relationships" id="270" r:id="R124c16c5404a4ef3"/>
+    <p:sldId xmlns:r="http://schemas.openxmlformats.org/officeDocument/2006/relationships" id="271" r:id="R4b6017b86c7a430f"/>
+    <p:sldId xmlns:r="http://schemas.openxmlformats.org/officeDocument/2006/relationships" id="272" r:id="R870c7b9d29244f78"/>
+    <p:sldId xmlns:r="http://schemas.openxmlformats.org/officeDocument/2006/relationships" id="273" r:id="R878a77bad1e34ea8"/>
+    <p:sldId xmlns:r="http://schemas.openxmlformats.org/officeDocument/2006/relationships" id="274" r:id="R549bd33a29c84bc2"/>
   </p:sldIdLst>
   <p:sldSz cx="12192000" cy="6858000"/>
   <p:notesSz cx="6858000" cy="9144000"/>
@@ -68,7 +68,7 @@
   </p:cSld>
   <p:clrMap bg1="lt1" tx1="dk1" bg2="lt2" tx2="dk2" accent1="accent1" accent2="accent2" accent3="accent3" accent4="accent4" accent5="accent5" accent6="accent6" hlink="hlink" folHlink="folHlink"/>
   <p:sldLayoutIdLst>
-    <p:sldLayoutId xmlns:r="http://schemas.openxmlformats.org/officeDocument/2006/relationships" id="2147483649" r:id="R1aa2874493514186"/>
+    <p:sldLayoutId xmlns:r="http://schemas.openxmlformats.org/officeDocument/2006/relationships" id="2147483649" r:id="R74ad0ca9acd54305"/>
   </p:sldLayoutIdLst>
   <p:txStyles>
     <p:titleStyle>
@@ -616,10 +616,10 @@
       </p:grpSpPr>
       <p:sp>
         <p:nvSpPr>
-          <p:cNvPr id="6" name="">
-            <a:extLst xmlns:a="http://schemas.openxmlformats.org/drawingml/2006/main">
-              <a:ext uri="{FF2B5EF4-FFF2-40B4-BE49-F238E27FC236}">
-                <a16:creationId xmlns:a16="http://schemas.microsoft.com/office/drawing/2014/main" id="{469DE57F-28A4-4A59-99DD-012D8CFD1ADA}"/>
+          <p:cNvPr id="7" name="">
+            <a:extLst xmlns:a="http://schemas.openxmlformats.org/drawingml/2006/main">
+              <a:ext uri="{FF2B5EF4-FFF2-40B4-BE49-F238E27FC236}">
+                <a16:creationId xmlns:a16="http://schemas.microsoft.com/office/drawing/2014/main" id="{6064AF25-45BB-47C9-8EF5-E05D74068521}"/>
               </a:ext>
             </a:extLst>
           </p:cNvPr>
@@ -676,7 +676,7 @@
           <p:cNvPr id="2" name="">
             <a:extLst xmlns:a="http://schemas.openxmlformats.org/drawingml/2006/main">
               <a:ext uri="{FF2B5EF4-FFF2-40B4-BE49-F238E27FC236}">
-                <a16:creationId xmlns:a16="http://schemas.microsoft.com/office/drawing/2014/main" id="{FAA5DC9E-6028-47AD-80BD-78696BB11CB9}"/>
+                <a16:creationId xmlns:a16="http://schemas.microsoft.com/office/drawing/2014/main" id="{84C947D0-34F6-41A3-934C-AC377664CC35}"/>
               </a:ext>
             </a:extLst>
           </p:cNvPr>
@@ -730,20 +730,20 @@
       </p:sp>
       <p:pic>
         <p:nvPicPr>
-          <p:cNvPr id="8" name=""/>
+          <p:cNvPr id="9" name=""/>
           <p:cNvPicPr>
             <a:picLocks xmlns:a="http://schemas.openxmlformats.org/drawingml/2006/main" noChangeAspect="1"/>
           </p:cNvPicPr>
           <p:nvPr/>
         </p:nvPicPr>
         <p:blipFill>
-          <a:blip xmlns:r="http://schemas.openxmlformats.org/officeDocument/2006/relationships" xmlns:a="http://schemas.openxmlformats.org/drawingml/2006/main" r:embed="R5ea368866ce94528"/>
+          <a:blip xmlns:r="http://schemas.openxmlformats.org/officeDocument/2006/relationships" xmlns:a="http://schemas.openxmlformats.org/drawingml/2006/main" r:embed="Ra635b39037004be5"/>
           <a:stretch xmlns:a="http://schemas.openxmlformats.org/drawingml/2006/main"/>
         </p:blipFill>
         <p:spPr>
           <a:xfrm xmlns:a="http://schemas.openxmlformats.org/drawingml/2006/main">
-            <a:off x="609600" y="1283203"/>
-            <a:ext cx="1714500" cy="338718"/>
+            <a:off x="10287000" y="925435"/>
+            <a:ext cx="1238250" cy="244630"/>
           </a:xfrm>
           <a:prstGeom xmlns:a="http://schemas.openxmlformats.org/drawingml/2006/main" prst="rect">
             <a:avLst/>
@@ -755,36 +755,36 @@
           <p:cNvPr id="4" name="">
             <a:extLst xmlns:a="http://schemas.openxmlformats.org/drawingml/2006/main">
               <a:ext uri="{FF2B5EF4-FFF2-40B4-BE49-F238E27FC236}">
-                <a16:creationId xmlns:a16="http://schemas.microsoft.com/office/drawing/2014/main" id="{84D57031-B0D4-4B69-9AC6-5A7FAEE358E8}"/>
-              </a:ext>
-            </a:extLst>
-          </p:cNvPr>
-          <p:cNvSpPr>
-            <a:spLocks xmlns:a="http://schemas.openxmlformats.org/drawingml/2006/main" noGrp="1"/>
-          </p:cNvSpPr>
-          <p:nvPr/>
-        </p:nvSpPr>
-        <p:spPr>
-          <a:xfrm xmlns:a="http://schemas.openxmlformats.org/drawingml/2006/main">
-            <a:off x="609600" y="2143125"/>
-            <a:ext cx="10953750" cy="1381125"/>
-          </a:xfrm>
-          <a:prstGeom xmlns:a="http://schemas.openxmlformats.org/drawingml/2006/main" prst="rect">
-            <a:avLst/>
-          </a:prstGeom>
-          <a:noFill xmlns:a="http://schemas.openxmlformats.org/drawingml/2006/main"/>
-          <a:ln xmlns:a="http://schemas.openxmlformats.org/drawingml/2006/main" w="0">
-            <a:noFill/>
-          </a:ln>
-        </p:spPr>
-        <p:txBody>
-          <a:bodyPr xmlns:a="http://schemas.openxmlformats.org/drawingml/2006/main">
-            <a:noAutofit/>
-          </a:bodyPr>
-          <a:lstStyle xmlns:a="http://schemas.openxmlformats.org/drawingml/2006/main"/>
-          <a:p xmlns:a="http://schemas.openxmlformats.org/drawingml/2006/main">
-            <a:pPr>
-              <a:defRPr sz="4350" b="1">
+                <a16:creationId xmlns:a16="http://schemas.microsoft.com/office/drawing/2014/main" id="{1529EFF1-364B-4D09-B31B-4B1DFEC03C2E}"/>
+              </a:ext>
+            </a:extLst>
+          </p:cNvPr>
+          <p:cNvSpPr>
+            <a:spLocks xmlns:a="http://schemas.openxmlformats.org/drawingml/2006/main" noGrp="1"/>
+          </p:cNvSpPr>
+          <p:nvPr/>
+        </p:nvSpPr>
+        <p:spPr>
+          <a:xfrm xmlns:a="http://schemas.openxmlformats.org/drawingml/2006/main">
+            <a:off x="609600" y="857250"/>
+            <a:ext cx="9429750" cy="714375"/>
+          </a:xfrm>
+          <a:prstGeom xmlns:a="http://schemas.openxmlformats.org/drawingml/2006/main" prst="rect">
+            <a:avLst/>
+          </a:prstGeom>
+          <a:noFill xmlns:a="http://schemas.openxmlformats.org/drawingml/2006/main"/>
+          <a:ln xmlns:a="http://schemas.openxmlformats.org/drawingml/2006/main" w="0">
+            <a:noFill/>
+          </a:ln>
+        </p:spPr>
+        <p:txBody>
+          <a:bodyPr xmlns:a="http://schemas.openxmlformats.org/drawingml/2006/main">
+            <a:noAutofit/>
+          </a:bodyPr>
+          <a:lstStyle xmlns:a="http://schemas.openxmlformats.org/drawingml/2006/main"/>
+          <a:p xmlns:a="http://schemas.openxmlformats.org/drawingml/2006/main">
+            <a:pPr>
+              <a:defRPr sz="3300" b="1">
                 <a:solidFill>
                   <a:srgbClr val="FFFFFF"/>
                 </a:solidFill>
@@ -794,7 +794,7 @@
               </a:defRPr>
             </a:pPr>
             <a:r>
-              <a:rPr sz="4350" b="1">
+              <a:rPr sz="3300" b="1">
                 <a:solidFill>
                   <a:srgbClr val="FFFFFF"/>
                 </a:solidFill>
@@ -807,51 +807,73 @@
           </a:p>
         </p:txBody>
       </p:sp>
-      <p:sp>
-        <p:nvSpPr>
-          <p:cNvPr id="5" name="">
-            <a:extLst xmlns:a="http://schemas.openxmlformats.org/drawingml/2006/main">
-              <a:ext uri="{FF2B5EF4-FFF2-40B4-BE49-F238E27FC236}">
-                <a16:creationId xmlns:a16="http://schemas.microsoft.com/office/drawing/2014/main" id="{B98F68E6-3446-4741-BC28-389136C8421F}"/>
-              </a:ext>
-            </a:extLst>
-          </p:cNvPr>
-          <p:cNvSpPr>
-            <a:spLocks xmlns:a="http://schemas.openxmlformats.org/drawingml/2006/main" noGrp="1"/>
-          </p:cNvSpPr>
-          <p:nvPr/>
-        </p:nvSpPr>
-        <p:spPr>
-          <a:xfrm xmlns:a="http://schemas.openxmlformats.org/drawingml/2006/main">
-            <a:off x="609600" y="3810000"/>
-            <a:ext cx="10668000" cy="1714500"/>
-          </a:xfrm>
-          <a:prstGeom xmlns:a="http://schemas.openxmlformats.org/drawingml/2006/main" prst="rect">
-            <a:avLst/>
-          </a:prstGeom>
-          <a:noFill xmlns:a="http://schemas.openxmlformats.org/drawingml/2006/main"/>
-          <a:ln xmlns:a="http://schemas.openxmlformats.org/drawingml/2006/main" w="0">
-            <a:noFill/>
-          </a:ln>
-        </p:spPr>
-        <p:txBody>
-          <a:bodyPr xmlns:a="http://schemas.openxmlformats.org/drawingml/2006/main">
-            <a:noAutofit/>
-          </a:bodyPr>
-          <a:lstStyle xmlns:a="http://schemas.openxmlformats.org/drawingml/2006/main"/>
-          <a:p xmlns:a="http://schemas.openxmlformats.org/drawingml/2006/main">
-            <a:pPr>
-              <a:defRPr sz="2250" b="0">
-                <a:solidFill>
-                  <a:srgbClr val="EAF1FF"/>
-                </a:solidFill>
-                <a:latin typeface="Arial"/>
-                <a:ea typeface="Arial"/>
-                <a:cs typeface="Arial"/>
-              </a:defRPr>
-            </a:pPr>
-            <a:r>
-              <a:rPr sz="2250" b="0">
+      <p:pic>
+        <p:nvPicPr>
+          <p:cNvPr id="11" name=""/>
+          <p:cNvPicPr>
+            <a:picLocks xmlns:a="http://schemas.openxmlformats.org/drawingml/2006/main" noChangeAspect="1"/>
+          </p:cNvPicPr>
+          <p:nvPr/>
+        </p:nvPicPr>
+        <p:blipFill>
+          <a:blip xmlns:r="http://schemas.openxmlformats.org/officeDocument/2006/relationships" xmlns:a="http://schemas.openxmlformats.org/drawingml/2006/main" r:embed="R0ec69f57b29549c1"/>
+          <a:stretch xmlns:a="http://schemas.openxmlformats.org/drawingml/2006/main"/>
+        </p:blipFill>
+        <p:spPr>
+          <a:xfrm xmlns:a="http://schemas.openxmlformats.org/drawingml/2006/main">
+            <a:off x="2659297" y="1666875"/>
+            <a:ext cx="6854356" cy="3857625"/>
+          </a:xfrm>
+          <a:prstGeom xmlns:a="http://schemas.openxmlformats.org/drawingml/2006/main" prst="rect">
+            <a:avLst/>
+          </a:prstGeom>
+        </p:spPr>
+      </p:pic>
+      <p:sp>
+        <p:nvSpPr>
+          <p:cNvPr id="6" name="">
+            <a:extLst xmlns:a="http://schemas.openxmlformats.org/drawingml/2006/main">
+              <a:ext uri="{FF2B5EF4-FFF2-40B4-BE49-F238E27FC236}">
+                <a16:creationId xmlns:a16="http://schemas.microsoft.com/office/drawing/2014/main" id="{C9ABD680-DE0C-45AB-A475-3307236780BF}"/>
+              </a:ext>
+            </a:extLst>
+          </p:cNvPr>
+          <p:cNvSpPr>
+            <a:spLocks xmlns:a="http://schemas.openxmlformats.org/drawingml/2006/main" noGrp="1"/>
+          </p:cNvSpPr>
+          <p:nvPr/>
+        </p:nvSpPr>
+        <p:spPr>
+          <a:xfrm xmlns:a="http://schemas.openxmlformats.org/drawingml/2006/main">
+            <a:off x="609600" y="5667375"/>
+            <a:ext cx="10953750" cy="619125"/>
+          </a:xfrm>
+          <a:prstGeom xmlns:a="http://schemas.openxmlformats.org/drawingml/2006/main" prst="rect">
+            <a:avLst/>
+          </a:prstGeom>
+          <a:noFill xmlns:a="http://schemas.openxmlformats.org/drawingml/2006/main"/>
+          <a:ln xmlns:a="http://schemas.openxmlformats.org/drawingml/2006/main" w="0">
+            <a:noFill/>
+          </a:ln>
+        </p:spPr>
+        <p:txBody>
+          <a:bodyPr xmlns:a="http://schemas.openxmlformats.org/drawingml/2006/main">
+            <a:noAutofit/>
+          </a:bodyPr>
+          <a:lstStyle xmlns:a="http://schemas.openxmlformats.org/drawingml/2006/main"/>
+          <a:p xmlns:a="http://schemas.openxmlformats.org/drawingml/2006/main">
+            <a:pPr>
+              <a:defRPr sz="1725" b="0">
+                <a:solidFill>
+                  <a:srgbClr val="EAF1FF"/>
+                </a:solidFill>
+                <a:latin typeface="Arial"/>
+                <a:ea typeface="Arial"/>
+                <a:cs typeface="Arial"/>
+              </a:defRPr>
+            </a:pPr>
+            <a:r>
+              <a:rPr sz="1725" b="0">
                 <a:solidFill>
                   <a:srgbClr val="EAF1FF"/>
                 </a:solidFill>
@@ -863,23 +885,18 @@
             </a:r>
           </a:p>
           <a:p xmlns:a="http://schemas.openxmlformats.org/drawingml/2006/main">
-            <a:r>
-              <a:t/>
-            </a:r>
-          </a:p>
-          <a:p xmlns:a="http://schemas.openxmlformats.org/drawingml/2006/main">
-            <a:pPr>
-              <a:defRPr sz="2250" b="0">
-                <a:solidFill>
-                  <a:srgbClr val="EAF1FF"/>
-                </a:solidFill>
-                <a:latin typeface="Arial"/>
-                <a:ea typeface="Arial"/>
-                <a:cs typeface="Arial"/>
-              </a:defRPr>
-            </a:pPr>
-            <a:r>
-              <a:rPr sz="2250" b="0">
+            <a:pPr>
+              <a:defRPr sz="1725" b="0">
+                <a:solidFill>
+                  <a:srgbClr val="EAF1FF"/>
+                </a:solidFill>
+                <a:latin typeface="Arial"/>
+                <a:ea typeface="Arial"/>
+                <a:cs typeface="Arial"/>
+              </a:defRPr>
+            </a:pPr>
+            <a:r>
+              <a:rPr sz="1725" b="0">
                 <a:solidFill>
                   <a:srgbClr val="EAF1FF"/>
                 </a:solidFill>
@@ -895,7 +912,7 @@
     </p:spTree>
     <p:extLst>
       <p:ext uri="{BB962C8B-B14F-4D97-AF65-F5344CB8AC3E}">
-        <p14:creationId xmlns:p14="http://schemas.microsoft.com/office/powerpoint/2010/main" val="462074473"/>
+        <p14:creationId xmlns:p14="http://schemas.microsoft.com/office/powerpoint/2010/main" val="1013837018"/>
       </p:ext>
     </p:extLst>
   </p:cSld>
@@ -926,7 +943,7 @@
           <p:cNvPr id="7" name="">
             <a:extLst xmlns:a="http://schemas.openxmlformats.org/drawingml/2006/main">
               <a:ext uri="{FF2B5EF4-FFF2-40B4-BE49-F238E27FC236}">
-                <a16:creationId xmlns:a16="http://schemas.microsoft.com/office/drawing/2014/main" id="{73FA0A3D-8705-4C2D-A331-AA6997D82092}"/>
+                <a16:creationId xmlns:a16="http://schemas.microsoft.com/office/drawing/2014/main" id="{3FBB8C48-CF46-4590-B667-17BADA7F1165}"/>
               </a:ext>
             </a:extLst>
           </p:cNvPr>
@@ -983,7 +1000,7 @@
           <p:cNvPr id="2" name="">
             <a:extLst xmlns:a="http://schemas.openxmlformats.org/drawingml/2006/main">
               <a:ext uri="{FF2B5EF4-FFF2-40B4-BE49-F238E27FC236}">
-                <a16:creationId xmlns:a16="http://schemas.microsoft.com/office/drawing/2014/main" id="{70339DC2-50D4-4A57-877F-E58FAEE6F211}"/>
+                <a16:creationId xmlns:a16="http://schemas.microsoft.com/office/drawing/2014/main" id="{21362C45-9BCE-4C53-9337-FBAB5DEE2587}"/>
               </a:ext>
             </a:extLst>
           </p:cNvPr>
@@ -1040,7 +1057,7 @@
           <p:cNvPr id="3" name="">
             <a:extLst xmlns:a="http://schemas.openxmlformats.org/drawingml/2006/main">
               <a:ext uri="{FF2B5EF4-FFF2-40B4-BE49-F238E27FC236}">
-                <a16:creationId xmlns:a16="http://schemas.microsoft.com/office/drawing/2014/main" id="{DF55B64C-1A52-4EA2-853F-33C306AF7056}"/>
+                <a16:creationId xmlns:a16="http://schemas.microsoft.com/office/drawing/2014/main" id="{1B112E3A-D2E4-47E9-8B30-CFE2B0CF6A73}"/>
               </a:ext>
             </a:extLst>
           </p:cNvPr>
@@ -1097,7 +1114,7 @@
           <p:cNvPr id="4" name="">
             <a:extLst xmlns:a="http://schemas.openxmlformats.org/drawingml/2006/main">
               <a:ext uri="{FF2B5EF4-FFF2-40B4-BE49-F238E27FC236}">
-                <a16:creationId xmlns:a16="http://schemas.microsoft.com/office/drawing/2014/main" id="{0D343599-02AC-433B-8D53-11CAE06D4B94}"/>
+                <a16:creationId xmlns:a16="http://schemas.microsoft.com/office/drawing/2014/main" id="{7C9C2F61-A5A0-4D26-8063-5F2AEE4D484A}"/>
               </a:ext>
             </a:extLst>
           </p:cNvPr>
@@ -1210,7 +1227,7 @@
           <p:cNvPr id="5" name="">
             <a:extLst xmlns:a="http://schemas.openxmlformats.org/drawingml/2006/main">
               <a:ext uri="{FF2B5EF4-FFF2-40B4-BE49-F238E27FC236}">
-                <a16:creationId xmlns:a16="http://schemas.microsoft.com/office/drawing/2014/main" id="{CC18F116-2587-476C-96E1-6C4F3D615C36}"/>
+                <a16:creationId xmlns:a16="http://schemas.microsoft.com/office/drawing/2014/main" id="{E4222ADF-4DC1-4AE7-BA46-1B6EFD121963}"/>
               </a:ext>
             </a:extLst>
           </p:cNvPr>
@@ -1290,7 +1307,7 @@
           <p:cNvPr id="6" name="">
             <a:extLst xmlns:a="http://schemas.openxmlformats.org/drawingml/2006/main">
               <a:ext uri="{FF2B5EF4-FFF2-40B4-BE49-F238E27FC236}">
-                <a16:creationId xmlns:a16="http://schemas.microsoft.com/office/drawing/2014/main" id="{4CB3C0BA-B13F-438F-AF75-20C9DF392C50}"/>
+                <a16:creationId xmlns:a16="http://schemas.microsoft.com/office/drawing/2014/main" id="{D582E342-0644-4559-AAD0-845F11A65A40}"/>
               </a:ext>
             </a:extLst>
           </p:cNvPr>
@@ -1345,7 +1362,7 @@
     </p:spTree>
     <p:extLst>
       <p:ext uri="{BB962C8B-B14F-4D97-AF65-F5344CB8AC3E}">
-        <p14:creationId xmlns:p14="http://schemas.microsoft.com/office/powerpoint/2010/main" val="94911823"/>
+        <p14:creationId xmlns:p14="http://schemas.microsoft.com/office/powerpoint/2010/main" val="43629586"/>
       </p:ext>
     </p:extLst>
   </p:cSld>
@@ -1376,7 +1393,7 @@
           <p:cNvPr id="7" name="">
             <a:extLst xmlns:a="http://schemas.openxmlformats.org/drawingml/2006/main">
               <a:ext uri="{FF2B5EF4-FFF2-40B4-BE49-F238E27FC236}">
-                <a16:creationId xmlns:a16="http://schemas.microsoft.com/office/drawing/2014/main" id="{A52DBE17-3C4E-4D1E-B7F9-22F6084F7614}"/>
+                <a16:creationId xmlns:a16="http://schemas.microsoft.com/office/drawing/2014/main" id="{9223843D-A577-46F0-A853-FEB583FE2A67}"/>
               </a:ext>
             </a:extLst>
           </p:cNvPr>
@@ -1433,7 +1450,7 @@
           <p:cNvPr id="2" name="">
             <a:extLst xmlns:a="http://schemas.openxmlformats.org/drawingml/2006/main">
               <a:ext uri="{FF2B5EF4-FFF2-40B4-BE49-F238E27FC236}">
-                <a16:creationId xmlns:a16="http://schemas.microsoft.com/office/drawing/2014/main" id="{D45ED1BF-EB6F-4159-9713-EA5A0BB876BA}"/>
+                <a16:creationId xmlns:a16="http://schemas.microsoft.com/office/drawing/2014/main" id="{C9020730-60B0-44DD-AA4F-96E9CDDB6DD6}"/>
               </a:ext>
             </a:extLst>
           </p:cNvPr>
@@ -1490,7 +1507,7 @@
           <p:cNvPr id="3" name="">
             <a:extLst xmlns:a="http://schemas.openxmlformats.org/drawingml/2006/main">
               <a:ext uri="{FF2B5EF4-FFF2-40B4-BE49-F238E27FC236}">
-                <a16:creationId xmlns:a16="http://schemas.microsoft.com/office/drawing/2014/main" id="{B94BCDC7-1B9C-45AC-BE5E-EE9C2BE0B4D0}"/>
+                <a16:creationId xmlns:a16="http://schemas.microsoft.com/office/drawing/2014/main" id="{3547F168-C2E8-41E2-A488-74DBED066A3B}"/>
               </a:ext>
             </a:extLst>
           </p:cNvPr>
@@ -1547,7 +1564,7 @@
           <p:cNvPr id="4" name="">
             <a:extLst xmlns:a="http://schemas.openxmlformats.org/drawingml/2006/main">
               <a:ext uri="{FF2B5EF4-FFF2-40B4-BE49-F238E27FC236}">
-                <a16:creationId xmlns:a16="http://schemas.microsoft.com/office/drawing/2014/main" id="{7ECE8E2A-7961-455A-8E55-60316875F1B5}"/>
+                <a16:creationId xmlns:a16="http://schemas.microsoft.com/office/drawing/2014/main" id="{7AA93283-919D-4DAF-809F-372273FEACB4}"/>
               </a:ext>
             </a:extLst>
           </p:cNvPr>
@@ -1660,7 +1677,7 @@
           <p:cNvPr id="5" name="">
             <a:extLst xmlns:a="http://schemas.openxmlformats.org/drawingml/2006/main">
               <a:ext uri="{FF2B5EF4-FFF2-40B4-BE49-F238E27FC236}">
-                <a16:creationId xmlns:a16="http://schemas.microsoft.com/office/drawing/2014/main" id="{253C93ED-D687-4200-8B30-9CDA3D7769AB}"/>
+                <a16:creationId xmlns:a16="http://schemas.microsoft.com/office/drawing/2014/main" id="{52E3A1AD-ECE6-4A73-BB47-96C5D318AEC3}"/>
               </a:ext>
             </a:extLst>
           </p:cNvPr>
@@ -1740,7 +1757,7 @@
           <p:cNvPr id="6" name="">
             <a:extLst xmlns:a="http://schemas.openxmlformats.org/drawingml/2006/main">
               <a:ext uri="{FF2B5EF4-FFF2-40B4-BE49-F238E27FC236}">
-                <a16:creationId xmlns:a16="http://schemas.microsoft.com/office/drawing/2014/main" id="{45F54839-816E-405B-9606-A67B545ECB52}"/>
+                <a16:creationId xmlns:a16="http://schemas.microsoft.com/office/drawing/2014/main" id="{DB4BE686-84DC-4821-B661-72300B7941E8}"/>
               </a:ext>
             </a:extLst>
           </p:cNvPr>
@@ -1795,7 +1812,7 @@
     </p:spTree>
     <p:extLst>
       <p:ext uri="{BB962C8B-B14F-4D97-AF65-F5344CB8AC3E}">
-        <p14:creationId xmlns:p14="http://schemas.microsoft.com/office/powerpoint/2010/main" val="1690741604"/>
+        <p14:creationId xmlns:p14="http://schemas.microsoft.com/office/powerpoint/2010/main" val="313135659"/>
       </p:ext>
     </p:extLst>
   </p:cSld>
@@ -1826,7 +1843,7 @@
           <p:cNvPr id="7" name="">
             <a:extLst xmlns:a="http://schemas.openxmlformats.org/drawingml/2006/main">
               <a:ext uri="{FF2B5EF4-FFF2-40B4-BE49-F238E27FC236}">
-                <a16:creationId xmlns:a16="http://schemas.microsoft.com/office/drawing/2014/main" id="{C8AE000A-DEC9-481F-896B-D88E4914D9CA}"/>
+                <a16:creationId xmlns:a16="http://schemas.microsoft.com/office/drawing/2014/main" id="{20CA51E5-167F-4542-A90B-D9FE7E60E002}"/>
               </a:ext>
             </a:extLst>
           </p:cNvPr>
@@ -1883,7 +1900,7 @@
           <p:cNvPr id="2" name="">
             <a:extLst xmlns:a="http://schemas.openxmlformats.org/drawingml/2006/main">
               <a:ext uri="{FF2B5EF4-FFF2-40B4-BE49-F238E27FC236}">
-                <a16:creationId xmlns:a16="http://schemas.microsoft.com/office/drawing/2014/main" id="{A9187983-A9E2-44AB-874E-F16320FE921E}"/>
+                <a16:creationId xmlns:a16="http://schemas.microsoft.com/office/drawing/2014/main" id="{49F8B9D2-BD7D-4BEB-869B-3DAF46157185}"/>
               </a:ext>
             </a:extLst>
           </p:cNvPr>
@@ -1940,7 +1957,7 @@
           <p:cNvPr id="3" name="">
             <a:extLst xmlns:a="http://schemas.openxmlformats.org/drawingml/2006/main">
               <a:ext uri="{FF2B5EF4-FFF2-40B4-BE49-F238E27FC236}">
-                <a16:creationId xmlns:a16="http://schemas.microsoft.com/office/drawing/2014/main" id="{2CA3EF23-ECF2-4B0F-A1A7-EEFC4D19A22F}"/>
+                <a16:creationId xmlns:a16="http://schemas.microsoft.com/office/drawing/2014/main" id="{649164E0-16A7-4B4B-9964-1CB77EB931FD}"/>
               </a:ext>
             </a:extLst>
           </p:cNvPr>
@@ -1997,7 +2014,7 @@
           <p:cNvPr id="4" name="">
             <a:extLst xmlns:a="http://schemas.openxmlformats.org/drawingml/2006/main">
               <a:ext uri="{FF2B5EF4-FFF2-40B4-BE49-F238E27FC236}">
-                <a16:creationId xmlns:a16="http://schemas.microsoft.com/office/drawing/2014/main" id="{C48EF23A-1DA9-4194-B163-333B68A296EF}"/>
+                <a16:creationId xmlns:a16="http://schemas.microsoft.com/office/drawing/2014/main" id="{4476F3BB-7C15-4A4D-9A69-BF342C69E01F}"/>
               </a:ext>
             </a:extLst>
           </p:cNvPr>
@@ -2110,7 +2127,7 @@
           <p:cNvPr id="5" name="">
             <a:extLst xmlns:a="http://schemas.openxmlformats.org/drawingml/2006/main">
               <a:ext uri="{FF2B5EF4-FFF2-40B4-BE49-F238E27FC236}">
-                <a16:creationId xmlns:a16="http://schemas.microsoft.com/office/drawing/2014/main" id="{1630BC37-AD46-42CF-B6B0-E0BC86DFD3F9}"/>
+                <a16:creationId xmlns:a16="http://schemas.microsoft.com/office/drawing/2014/main" id="{4D447AB7-1ACF-4F1E-A969-0DBADC04709E}"/>
               </a:ext>
             </a:extLst>
           </p:cNvPr>
@@ -2236,7 +2253,7 @@
           <p:cNvPr id="6" name="">
             <a:extLst xmlns:a="http://schemas.openxmlformats.org/drawingml/2006/main">
               <a:ext uri="{FF2B5EF4-FFF2-40B4-BE49-F238E27FC236}">
-                <a16:creationId xmlns:a16="http://schemas.microsoft.com/office/drawing/2014/main" id="{2BAEE0C6-96B6-4768-B9F8-CE00D1D6D95D}"/>
+                <a16:creationId xmlns:a16="http://schemas.microsoft.com/office/drawing/2014/main" id="{A9DD9EA5-1033-4F77-BCE6-E631D5E257F2}"/>
               </a:ext>
             </a:extLst>
           </p:cNvPr>
@@ -2291,7 +2308,7 @@
     </p:spTree>
     <p:extLst>
       <p:ext uri="{BB962C8B-B14F-4D97-AF65-F5344CB8AC3E}">
-        <p14:creationId xmlns:p14="http://schemas.microsoft.com/office/powerpoint/2010/main" val="1707558408"/>
+        <p14:creationId xmlns:p14="http://schemas.microsoft.com/office/powerpoint/2010/main" val="1076910239"/>
       </p:ext>
     </p:extLst>
   </p:cSld>
@@ -2322,7 +2339,7 @@
           <p:cNvPr id="7" name="">
             <a:extLst xmlns:a="http://schemas.openxmlformats.org/drawingml/2006/main">
               <a:ext uri="{FF2B5EF4-FFF2-40B4-BE49-F238E27FC236}">
-                <a16:creationId xmlns:a16="http://schemas.microsoft.com/office/drawing/2014/main" id="{5ECAF356-BFB8-409D-9D4D-DD307F2E8080}"/>
+                <a16:creationId xmlns:a16="http://schemas.microsoft.com/office/drawing/2014/main" id="{06D8C397-2405-4549-93AF-E503ABEEE4FB}"/>
               </a:ext>
             </a:extLst>
           </p:cNvPr>
@@ -2379,7 +2396,7 @@
           <p:cNvPr id="2" name="">
             <a:extLst xmlns:a="http://schemas.openxmlformats.org/drawingml/2006/main">
               <a:ext uri="{FF2B5EF4-FFF2-40B4-BE49-F238E27FC236}">
-                <a16:creationId xmlns:a16="http://schemas.microsoft.com/office/drawing/2014/main" id="{13850777-FE2F-4F7D-BF6D-D1B5842CBC80}"/>
+                <a16:creationId xmlns:a16="http://schemas.microsoft.com/office/drawing/2014/main" id="{55326104-46A3-467A-9A98-75617C2D849C}"/>
               </a:ext>
             </a:extLst>
           </p:cNvPr>
@@ -2436,7 +2453,7 @@
           <p:cNvPr id="3" name="">
             <a:extLst xmlns:a="http://schemas.openxmlformats.org/drawingml/2006/main">
               <a:ext uri="{FF2B5EF4-FFF2-40B4-BE49-F238E27FC236}">
-                <a16:creationId xmlns:a16="http://schemas.microsoft.com/office/drawing/2014/main" id="{13DBF63C-4F0A-4D9F-AAEB-D9A3BECF4C0D}"/>
+                <a16:creationId xmlns:a16="http://schemas.microsoft.com/office/drawing/2014/main" id="{A3510E55-6035-4B2C-B6CF-EAD558752869}"/>
               </a:ext>
             </a:extLst>
           </p:cNvPr>
@@ -2493,7 +2510,7 @@
           <p:cNvPr id="4" name="">
             <a:extLst xmlns:a="http://schemas.openxmlformats.org/drawingml/2006/main">
               <a:ext uri="{FF2B5EF4-FFF2-40B4-BE49-F238E27FC236}">
-                <a16:creationId xmlns:a16="http://schemas.microsoft.com/office/drawing/2014/main" id="{816E3719-A290-42E7-A06B-7AF85D197D0C}"/>
+                <a16:creationId xmlns:a16="http://schemas.microsoft.com/office/drawing/2014/main" id="{715DD66B-B209-42C3-82EE-3DB400AA01F7}"/>
               </a:ext>
             </a:extLst>
           </p:cNvPr>
@@ -2606,7 +2623,7 @@
           <p:cNvPr id="5" name="">
             <a:extLst xmlns:a="http://schemas.openxmlformats.org/drawingml/2006/main">
               <a:ext uri="{FF2B5EF4-FFF2-40B4-BE49-F238E27FC236}">
-                <a16:creationId xmlns:a16="http://schemas.microsoft.com/office/drawing/2014/main" id="{9D470171-5334-4107-B96F-2CD18EF4AB8C}"/>
+                <a16:creationId xmlns:a16="http://schemas.microsoft.com/office/drawing/2014/main" id="{C64FE656-0F18-456F-B8CE-4221C918120C}"/>
               </a:ext>
             </a:extLst>
           </p:cNvPr>
@@ -2663,7 +2680,7 @@
           <p:cNvPr id="6" name="">
             <a:extLst xmlns:a="http://schemas.openxmlformats.org/drawingml/2006/main">
               <a:ext uri="{FF2B5EF4-FFF2-40B4-BE49-F238E27FC236}">
-                <a16:creationId xmlns:a16="http://schemas.microsoft.com/office/drawing/2014/main" id="{B7909C82-A13C-4E13-A20E-53B72F7D9B6E}"/>
+                <a16:creationId xmlns:a16="http://schemas.microsoft.com/office/drawing/2014/main" id="{76D94573-A9CD-4701-9118-CA2558B4B6FA}"/>
               </a:ext>
             </a:extLst>
           </p:cNvPr>
@@ -2718,7 +2735,7 @@
     </p:spTree>
     <p:extLst>
       <p:ext uri="{BB962C8B-B14F-4D97-AF65-F5344CB8AC3E}">
-        <p14:creationId xmlns:p14="http://schemas.microsoft.com/office/powerpoint/2010/main" val="9690115"/>
+        <p14:creationId xmlns:p14="http://schemas.microsoft.com/office/powerpoint/2010/main" val="1597028890"/>
       </p:ext>
     </p:extLst>
   </p:cSld>
@@ -2749,7 +2766,7 @@
           <p:cNvPr id="6" name="">
             <a:extLst xmlns:a="http://schemas.openxmlformats.org/drawingml/2006/main">
               <a:ext uri="{FF2B5EF4-FFF2-40B4-BE49-F238E27FC236}">
-                <a16:creationId xmlns:a16="http://schemas.microsoft.com/office/drawing/2014/main" id="{976510E2-94BA-455C-88B4-814CD3BC3386}"/>
+                <a16:creationId xmlns:a16="http://schemas.microsoft.com/office/drawing/2014/main" id="{7E032EEC-2864-47ED-A12D-FC39880BA67B}"/>
               </a:ext>
             </a:extLst>
           </p:cNvPr>
@@ -2806,7 +2823,7 @@
           <p:cNvPr id="2" name="">
             <a:extLst xmlns:a="http://schemas.openxmlformats.org/drawingml/2006/main">
               <a:ext uri="{FF2B5EF4-FFF2-40B4-BE49-F238E27FC236}">
-                <a16:creationId xmlns:a16="http://schemas.microsoft.com/office/drawing/2014/main" id="{1F736E57-64CB-4840-938B-DA0FFEBC4E8B}"/>
+                <a16:creationId xmlns:a16="http://schemas.microsoft.com/office/drawing/2014/main" id="{84AD6215-793B-4281-8156-8FCD67C3A171}"/>
               </a:ext>
             </a:extLst>
           </p:cNvPr>
@@ -2863,7 +2880,7 @@
           <p:cNvPr id="3" name="">
             <a:extLst xmlns:a="http://schemas.openxmlformats.org/drawingml/2006/main">
               <a:ext uri="{FF2B5EF4-FFF2-40B4-BE49-F238E27FC236}">
-                <a16:creationId xmlns:a16="http://schemas.microsoft.com/office/drawing/2014/main" id="{32184544-E9DC-4F8E-A29E-809336F3FE2D}"/>
+                <a16:creationId xmlns:a16="http://schemas.microsoft.com/office/drawing/2014/main" id="{DE175D9D-0F57-49CB-A50E-122B642ED566}"/>
               </a:ext>
             </a:extLst>
           </p:cNvPr>
@@ -2920,7 +2937,7 @@
           <p:cNvPr id="4" name="">
             <a:extLst xmlns:a="http://schemas.openxmlformats.org/drawingml/2006/main">
               <a:ext uri="{FF2B5EF4-FFF2-40B4-BE49-F238E27FC236}">
-                <a16:creationId xmlns:a16="http://schemas.microsoft.com/office/drawing/2014/main" id="{E523E93E-8D38-41A3-9E2D-36F469BAC293}"/>
+                <a16:creationId xmlns:a16="http://schemas.microsoft.com/office/drawing/2014/main" id="{27D54040-5FFE-45D7-9C0F-DBD6EBE45C8A}"/>
               </a:ext>
             </a:extLst>
           </p:cNvPr>
@@ -3061,7 +3078,7 @@
           <p:cNvPr id="5" name="">
             <a:extLst xmlns:a="http://schemas.openxmlformats.org/drawingml/2006/main">
               <a:ext uri="{FF2B5EF4-FFF2-40B4-BE49-F238E27FC236}">
-                <a16:creationId xmlns:a16="http://schemas.microsoft.com/office/drawing/2014/main" id="{FE439384-5635-407A-AF37-EDAA442A4CF1}"/>
+                <a16:creationId xmlns:a16="http://schemas.microsoft.com/office/drawing/2014/main" id="{E38C9EF5-BDD9-437A-ABFD-E44BC6063B18}"/>
               </a:ext>
             </a:extLst>
           </p:cNvPr>
@@ -3116,7 +3133,7 @@
     </p:spTree>
     <p:extLst>
       <p:ext uri="{BB962C8B-B14F-4D97-AF65-F5344CB8AC3E}">
-        <p14:creationId xmlns:p14="http://schemas.microsoft.com/office/powerpoint/2010/main" val="1208969818"/>
+        <p14:creationId xmlns:p14="http://schemas.microsoft.com/office/powerpoint/2010/main" val="288069148"/>
       </p:ext>
     </p:extLst>
   </p:cSld>
@@ -3147,7 +3164,7 @@
           <p:cNvPr id="7" name="">
             <a:extLst xmlns:a="http://schemas.openxmlformats.org/drawingml/2006/main">
               <a:ext uri="{FF2B5EF4-FFF2-40B4-BE49-F238E27FC236}">
-                <a16:creationId xmlns:a16="http://schemas.microsoft.com/office/drawing/2014/main" id="{65BDED59-4563-4290-A537-EC6043CAAA34}"/>
+                <a16:creationId xmlns:a16="http://schemas.microsoft.com/office/drawing/2014/main" id="{005C0E5B-793F-45FF-A2F1-C9E4952782F8}"/>
               </a:ext>
             </a:extLst>
           </p:cNvPr>
@@ -3204,7 +3221,7 @@
           <p:cNvPr id="2" name="">
             <a:extLst xmlns:a="http://schemas.openxmlformats.org/drawingml/2006/main">
               <a:ext uri="{FF2B5EF4-FFF2-40B4-BE49-F238E27FC236}">
-                <a16:creationId xmlns:a16="http://schemas.microsoft.com/office/drawing/2014/main" id="{A4FCF976-B538-4D41-B884-962E37622655}"/>
+                <a16:creationId xmlns:a16="http://schemas.microsoft.com/office/drawing/2014/main" id="{70AEF83A-E897-4E42-8850-95BC0FBBF834}"/>
               </a:ext>
             </a:extLst>
           </p:cNvPr>
@@ -3261,7 +3278,7 @@
           <p:cNvPr id="3" name="">
             <a:extLst xmlns:a="http://schemas.openxmlformats.org/drawingml/2006/main">
               <a:ext uri="{FF2B5EF4-FFF2-40B4-BE49-F238E27FC236}">
-                <a16:creationId xmlns:a16="http://schemas.microsoft.com/office/drawing/2014/main" id="{52132634-7C9D-4AB7-B946-C77EC6164217}"/>
+                <a16:creationId xmlns:a16="http://schemas.microsoft.com/office/drawing/2014/main" id="{28FE2936-DAFA-449F-AE27-9385502812CE}"/>
               </a:ext>
             </a:extLst>
           </p:cNvPr>
@@ -3318,7 +3335,7 @@
           <p:cNvPr id="4" name="">
             <a:extLst xmlns:a="http://schemas.openxmlformats.org/drawingml/2006/main">
               <a:ext uri="{FF2B5EF4-FFF2-40B4-BE49-F238E27FC236}">
-                <a16:creationId xmlns:a16="http://schemas.microsoft.com/office/drawing/2014/main" id="{23A2508A-4FCE-444F-A029-6E54A88C3B10}"/>
+                <a16:creationId xmlns:a16="http://schemas.microsoft.com/office/drawing/2014/main" id="{E9129264-EA85-494C-B9BC-35C1144B5486}"/>
               </a:ext>
             </a:extLst>
           </p:cNvPr>
@@ -3431,7 +3448,7 @@
           <p:cNvPr id="5" name="">
             <a:extLst xmlns:a="http://schemas.openxmlformats.org/drawingml/2006/main">
               <a:ext uri="{FF2B5EF4-FFF2-40B4-BE49-F238E27FC236}">
-                <a16:creationId xmlns:a16="http://schemas.microsoft.com/office/drawing/2014/main" id="{76A6F169-2C25-4A08-BEED-8C4F676094C9}"/>
+                <a16:creationId xmlns:a16="http://schemas.microsoft.com/office/drawing/2014/main" id="{82A402E8-60E8-41D5-B923-90EF9C5C1CD4}"/>
               </a:ext>
             </a:extLst>
           </p:cNvPr>
@@ -3488,7 +3505,7 @@
           <p:cNvPr id="6" name="">
             <a:extLst xmlns:a="http://schemas.openxmlformats.org/drawingml/2006/main">
               <a:ext uri="{FF2B5EF4-FFF2-40B4-BE49-F238E27FC236}">
-                <a16:creationId xmlns:a16="http://schemas.microsoft.com/office/drawing/2014/main" id="{B3D2185A-D388-4A73-B56E-EB5CF19E2CBF}"/>
+                <a16:creationId xmlns:a16="http://schemas.microsoft.com/office/drawing/2014/main" id="{C2F519D4-B5B6-41A8-BF05-95997C25523E}"/>
               </a:ext>
             </a:extLst>
           </p:cNvPr>
@@ -3543,7 +3560,7 @@
     </p:spTree>
     <p:extLst>
       <p:ext uri="{BB962C8B-B14F-4D97-AF65-F5344CB8AC3E}">
-        <p14:creationId xmlns:p14="http://schemas.microsoft.com/office/powerpoint/2010/main" val="1385442611"/>
+        <p14:creationId xmlns:p14="http://schemas.microsoft.com/office/powerpoint/2010/main" val="262707331"/>
       </p:ext>
     </p:extLst>
   </p:cSld>
@@ -3574,7 +3591,7 @@
           <p:cNvPr id="5" name="">
             <a:extLst xmlns:a="http://schemas.openxmlformats.org/drawingml/2006/main">
               <a:ext uri="{FF2B5EF4-FFF2-40B4-BE49-F238E27FC236}">
-                <a16:creationId xmlns:a16="http://schemas.microsoft.com/office/drawing/2014/main" id="{3A4959D5-2973-488E-A36A-328265D0E9E1}"/>
+                <a16:creationId xmlns:a16="http://schemas.microsoft.com/office/drawing/2014/main" id="{FF41871A-95E6-41B8-8530-95348086C759}"/>
               </a:ext>
             </a:extLst>
           </p:cNvPr>
@@ -3631,7 +3648,7 @@
           <p:cNvPr id="2" name="">
             <a:extLst xmlns:a="http://schemas.openxmlformats.org/drawingml/2006/main">
               <a:ext uri="{FF2B5EF4-FFF2-40B4-BE49-F238E27FC236}">
-                <a16:creationId xmlns:a16="http://schemas.microsoft.com/office/drawing/2014/main" id="{671E69A5-659D-4C67-BEBA-7520843F62C2}"/>
+                <a16:creationId xmlns:a16="http://schemas.microsoft.com/office/drawing/2014/main" id="{D18A79FC-0D48-4863-B962-6D89279A4FF1}"/>
               </a:ext>
             </a:extLst>
           </p:cNvPr>
@@ -3688,7 +3705,7 @@
           <p:cNvPr id="3" name="">
             <a:extLst xmlns:a="http://schemas.openxmlformats.org/drawingml/2006/main">
               <a:ext uri="{FF2B5EF4-FFF2-40B4-BE49-F238E27FC236}">
-                <a16:creationId xmlns:a16="http://schemas.microsoft.com/office/drawing/2014/main" id="{AD79699D-36C2-494E-AB84-10D83741CE6D}"/>
+                <a16:creationId xmlns:a16="http://schemas.microsoft.com/office/drawing/2014/main" id="{347A2F1F-0015-4AA2-8F98-5A483EE8D501}"/>
               </a:ext>
             </a:extLst>
           </p:cNvPr>
@@ -3745,7 +3762,7 @@
           <p:cNvPr id="4" name="">
             <a:extLst xmlns:a="http://schemas.openxmlformats.org/drawingml/2006/main">
               <a:ext uri="{FF2B5EF4-FFF2-40B4-BE49-F238E27FC236}">
-                <a16:creationId xmlns:a16="http://schemas.microsoft.com/office/drawing/2014/main" id="{F94FEC4A-7EBF-48B6-9A6A-23454D86EFB0}"/>
+                <a16:creationId xmlns:a16="http://schemas.microsoft.com/office/drawing/2014/main" id="{9E60EC9A-A9CF-4EB0-8859-2B4481F2F40B}"/>
               </a:ext>
             </a:extLst>
           </p:cNvPr>
@@ -3884,7 +3901,7 @@
     </p:spTree>
     <p:extLst>
       <p:ext uri="{BB962C8B-B14F-4D97-AF65-F5344CB8AC3E}">
-        <p14:creationId xmlns:p14="http://schemas.microsoft.com/office/powerpoint/2010/main" val="695515321"/>
+        <p14:creationId xmlns:p14="http://schemas.microsoft.com/office/powerpoint/2010/main" val="1832751913"/>
       </p:ext>
     </p:extLst>
   </p:cSld>
@@ -3915,7 +3932,7 @@
           <p:cNvPr id="7" name="">
             <a:extLst xmlns:a="http://schemas.openxmlformats.org/drawingml/2006/main">
               <a:ext uri="{FF2B5EF4-FFF2-40B4-BE49-F238E27FC236}">
-                <a16:creationId xmlns:a16="http://schemas.microsoft.com/office/drawing/2014/main" id="{3AE0DCB1-7F7F-447E-9287-6DB00D2751B4}"/>
+                <a16:creationId xmlns:a16="http://schemas.microsoft.com/office/drawing/2014/main" id="{CB99EE05-D039-41BD-A51C-222372CBD2A3}"/>
               </a:ext>
             </a:extLst>
           </p:cNvPr>
@@ -3972,7 +3989,7 @@
           <p:cNvPr id="2" name="">
             <a:extLst xmlns:a="http://schemas.openxmlformats.org/drawingml/2006/main">
               <a:ext uri="{FF2B5EF4-FFF2-40B4-BE49-F238E27FC236}">
-                <a16:creationId xmlns:a16="http://schemas.microsoft.com/office/drawing/2014/main" id="{3E48507C-2448-4498-A222-2C6E4AEC412E}"/>
+                <a16:creationId xmlns:a16="http://schemas.microsoft.com/office/drawing/2014/main" id="{C5D27AF6-268D-4184-9025-8E68F8DD1FBA}"/>
               </a:ext>
             </a:extLst>
           </p:cNvPr>
@@ -4029,7 +4046,7 @@
           <p:cNvPr id="3" name="">
             <a:extLst xmlns:a="http://schemas.openxmlformats.org/drawingml/2006/main">
               <a:ext uri="{FF2B5EF4-FFF2-40B4-BE49-F238E27FC236}">
-                <a16:creationId xmlns:a16="http://schemas.microsoft.com/office/drawing/2014/main" id="{C17B4BE3-2105-4F5C-B9EE-CB0E698FD9AD}"/>
+                <a16:creationId xmlns:a16="http://schemas.microsoft.com/office/drawing/2014/main" id="{84EEC89E-1B20-4F31-9F2A-CE9579EBBB8D}"/>
               </a:ext>
             </a:extLst>
           </p:cNvPr>
@@ -4086,7 +4103,7 @@
           <p:cNvPr id="4" name="">
             <a:extLst xmlns:a="http://schemas.openxmlformats.org/drawingml/2006/main">
               <a:ext uri="{FF2B5EF4-FFF2-40B4-BE49-F238E27FC236}">
-                <a16:creationId xmlns:a16="http://schemas.microsoft.com/office/drawing/2014/main" id="{E25D8ADE-6948-4484-8359-016AB18C9B81}"/>
+                <a16:creationId xmlns:a16="http://schemas.microsoft.com/office/drawing/2014/main" id="{CAC82D99-2AB2-415A-A800-A6E92EAE7415}"/>
               </a:ext>
             </a:extLst>
           </p:cNvPr>
@@ -4171,7 +4188,7 @@
           <p:cNvPr id="5" name="">
             <a:extLst xmlns:a="http://schemas.openxmlformats.org/drawingml/2006/main">
               <a:ext uri="{FF2B5EF4-FFF2-40B4-BE49-F238E27FC236}">
-                <a16:creationId xmlns:a16="http://schemas.microsoft.com/office/drawing/2014/main" id="{32500C41-8809-40B9-AE22-7A0FEAB1A39E}"/>
+                <a16:creationId xmlns:a16="http://schemas.microsoft.com/office/drawing/2014/main" id="{016F8FAC-3B03-450A-826C-75E2718DE3BA}"/>
               </a:ext>
             </a:extLst>
           </p:cNvPr>
@@ -4274,7 +4291,7 @@
           <p:cNvPr id="6" name="">
             <a:extLst xmlns:a="http://schemas.openxmlformats.org/drawingml/2006/main">
               <a:ext uri="{FF2B5EF4-FFF2-40B4-BE49-F238E27FC236}">
-                <a16:creationId xmlns:a16="http://schemas.microsoft.com/office/drawing/2014/main" id="{5843B34A-E740-47E3-BC4D-49F2EE3E2AC9}"/>
+                <a16:creationId xmlns:a16="http://schemas.microsoft.com/office/drawing/2014/main" id="{E43AF9DF-F330-4720-BC81-4A69AC5D99CF}"/>
               </a:ext>
             </a:extLst>
           </p:cNvPr>
@@ -4329,7 +4346,7 @@
     </p:spTree>
     <p:extLst>
       <p:ext uri="{BB962C8B-B14F-4D97-AF65-F5344CB8AC3E}">
-        <p14:creationId xmlns:p14="http://schemas.microsoft.com/office/powerpoint/2010/main" val="1986543754"/>
+        <p14:creationId xmlns:p14="http://schemas.microsoft.com/office/powerpoint/2010/main" val="1893970491"/>
       </p:ext>
     </p:extLst>
   </p:cSld>
@@ -4360,7 +4377,7 @@
           <p:cNvPr id="6" name="">
             <a:extLst xmlns:a="http://schemas.openxmlformats.org/drawingml/2006/main">
               <a:ext uri="{FF2B5EF4-FFF2-40B4-BE49-F238E27FC236}">
-                <a16:creationId xmlns:a16="http://schemas.microsoft.com/office/drawing/2014/main" id="{7F94BDD3-961E-4B94-B425-46ABBBD0FFB6}"/>
+                <a16:creationId xmlns:a16="http://schemas.microsoft.com/office/drawing/2014/main" id="{B9F0533F-BAC2-4AF5-A974-241F2C6F6B8D}"/>
               </a:ext>
             </a:extLst>
           </p:cNvPr>
@@ -4417,7 +4434,7 @@
           <p:cNvPr id="2" name="">
             <a:extLst xmlns:a="http://schemas.openxmlformats.org/drawingml/2006/main">
               <a:ext uri="{FF2B5EF4-FFF2-40B4-BE49-F238E27FC236}">
-                <a16:creationId xmlns:a16="http://schemas.microsoft.com/office/drawing/2014/main" id="{0975FE9C-C713-492D-B1B4-ED96F5438C00}"/>
+                <a16:creationId xmlns:a16="http://schemas.microsoft.com/office/drawing/2014/main" id="{801BBD37-9781-4E35-8432-CAB5C23767E1}"/>
               </a:ext>
             </a:extLst>
           </p:cNvPr>
@@ -4474,7 +4491,7 @@
           <p:cNvPr id="3" name="">
             <a:extLst xmlns:a="http://schemas.openxmlformats.org/drawingml/2006/main">
               <a:ext uri="{FF2B5EF4-FFF2-40B4-BE49-F238E27FC236}">
-                <a16:creationId xmlns:a16="http://schemas.microsoft.com/office/drawing/2014/main" id="{EA75BDA9-3154-4092-BB6A-1F12D3EF7CB1}"/>
+                <a16:creationId xmlns:a16="http://schemas.microsoft.com/office/drawing/2014/main" id="{399CD36E-186A-49DC-A042-1982D63CDC7E}"/>
               </a:ext>
             </a:extLst>
           </p:cNvPr>
@@ -4531,7 +4548,7 @@
           <p:cNvPr id="4" name="">
             <a:extLst xmlns:a="http://schemas.openxmlformats.org/drawingml/2006/main">
               <a:ext uri="{FF2B5EF4-FFF2-40B4-BE49-F238E27FC236}">
-                <a16:creationId xmlns:a16="http://schemas.microsoft.com/office/drawing/2014/main" id="{C9463AA2-7923-4400-8DF7-09A15260F841}"/>
+                <a16:creationId xmlns:a16="http://schemas.microsoft.com/office/drawing/2014/main" id="{495126C5-281B-4D66-B548-D4A549D7AA9A}"/>
               </a:ext>
             </a:extLst>
           </p:cNvPr>
@@ -4672,7 +4689,7 @@
           <p:cNvPr id="5" name="">
             <a:extLst xmlns:a="http://schemas.openxmlformats.org/drawingml/2006/main">
               <a:ext uri="{FF2B5EF4-FFF2-40B4-BE49-F238E27FC236}">
-                <a16:creationId xmlns:a16="http://schemas.microsoft.com/office/drawing/2014/main" id="{39F83FB1-78AC-48CA-8378-27D13F3CD50A}"/>
+                <a16:creationId xmlns:a16="http://schemas.microsoft.com/office/drawing/2014/main" id="{A32898AD-C2EC-41A3-9931-CFF5A653627C}"/>
               </a:ext>
             </a:extLst>
           </p:cNvPr>
@@ -4727,7 +4744,7 @@
     </p:spTree>
     <p:extLst>
       <p:ext uri="{BB962C8B-B14F-4D97-AF65-F5344CB8AC3E}">
-        <p14:creationId xmlns:p14="http://schemas.microsoft.com/office/powerpoint/2010/main" val="1793628779"/>
+        <p14:creationId xmlns:p14="http://schemas.microsoft.com/office/powerpoint/2010/main" val="1573002623"/>
       </p:ext>
     </p:extLst>
   </p:cSld>
@@ -4758,7 +4775,7 @@
           <p:cNvPr id="5" name="">
             <a:extLst xmlns:a="http://schemas.openxmlformats.org/drawingml/2006/main">
               <a:ext uri="{FF2B5EF4-FFF2-40B4-BE49-F238E27FC236}">
-                <a16:creationId xmlns:a16="http://schemas.microsoft.com/office/drawing/2014/main" id="{DD713243-13A6-4770-A771-1787FFEFF892}"/>
+                <a16:creationId xmlns:a16="http://schemas.microsoft.com/office/drawing/2014/main" id="{F051809C-9230-468E-945E-EA844CDE4FFF}"/>
               </a:ext>
             </a:extLst>
           </p:cNvPr>
@@ -4815,7 +4832,7 @@
           <p:cNvPr id="2" name="">
             <a:extLst xmlns:a="http://schemas.openxmlformats.org/drawingml/2006/main">
               <a:ext uri="{FF2B5EF4-FFF2-40B4-BE49-F238E27FC236}">
-                <a16:creationId xmlns:a16="http://schemas.microsoft.com/office/drawing/2014/main" id="{6B8207BB-3CAF-45F0-B161-EA21024EE49D}"/>
+                <a16:creationId xmlns:a16="http://schemas.microsoft.com/office/drawing/2014/main" id="{69E9B0DF-BD85-4E9C-B1F5-DEC3233D8C14}"/>
               </a:ext>
             </a:extLst>
           </p:cNvPr>
@@ -4872,7 +4889,7 @@
           <p:cNvPr id="3" name="">
             <a:extLst xmlns:a="http://schemas.openxmlformats.org/drawingml/2006/main">
               <a:ext uri="{FF2B5EF4-FFF2-40B4-BE49-F238E27FC236}">
-                <a16:creationId xmlns:a16="http://schemas.microsoft.com/office/drawing/2014/main" id="{EC668ABE-50E6-4620-9BCA-F77915D108DC}"/>
+                <a16:creationId xmlns:a16="http://schemas.microsoft.com/office/drawing/2014/main" id="{B5E4A6C5-2E09-4D71-B937-F60E4EFF4196}"/>
               </a:ext>
             </a:extLst>
           </p:cNvPr>
@@ -4929,7 +4946,7 @@
           <p:cNvPr id="4" name="">
             <a:extLst xmlns:a="http://schemas.openxmlformats.org/drawingml/2006/main">
               <a:ext uri="{FF2B5EF4-FFF2-40B4-BE49-F238E27FC236}">
-                <a16:creationId xmlns:a16="http://schemas.microsoft.com/office/drawing/2014/main" id="{CB6DEF09-F085-4A5D-9FBC-2B8EED8A6F99}"/>
+                <a16:creationId xmlns:a16="http://schemas.microsoft.com/office/drawing/2014/main" id="{971F69BD-945C-484D-A6C4-89A52BEFDFDC}"/>
               </a:ext>
             </a:extLst>
           </p:cNvPr>
@@ -5068,7 +5085,7 @@
     </p:spTree>
     <p:extLst>
       <p:ext uri="{BB962C8B-B14F-4D97-AF65-F5344CB8AC3E}">
-        <p14:creationId xmlns:p14="http://schemas.microsoft.com/office/powerpoint/2010/main" val="660974711"/>
+        <p14:creationId xmlns:p14="http://schemas.microsoft.com/office/powerpoint/2010/main" val="2071209131"/>
       </p:ext>
     </p:extLst>
   </p:cSld>
@@ -5099,7 +5116,7 @@
           <p:cNvPr id="6" name="">
             <a:extLst xmlns:a="http://schemas.openxmlformats.org/drawingml/2006/main">
               <a:ext uri="{FF2B5EF4-FFF2-40B4-BE49-F238E27FC236}">
-                <a16:creationId xmlns:a16="http://schemas.microsoft.com/office/drawing/2014/main" id="{8A9F1AC3-1F70-4957-A1B7-A9522F99FA57}"/>
+                <a16:creationId xmlns:a16="http://schemas.microsoft.com/office/drawing/2014/main" id="{E7600D80-EC2B-4612-A924-A22A39999CCE}"/>
               </a:ext>
             </a:extLst>
           </p:cNvPr>
@@ -5156,7 +5173,7 @@
           <p:cNvPr id="2" name="">
             <a:extLst xmlns:a="http://schemas.openxmlformats.org/drawingml/2006/main">
               <a:ext uri="{FF2B5EF4-FFF2-40B4-BE49-F238E27FC236}">
-                <a16:creationId xmlns:a16="http://schemas.microsoft.com/office/drawing/2014/main" id="{83FE155D-FC14-4090-8716-4BF2F3414DA0}"/>
+                <a16:creationId xmlns:a16="http://schemas.microsoft.com/office/drawing/2014/main" id="{0D0C8B76-EEC5-499B-B7A4-88B81B8BF956}"/>
               </a:ext>
             </a:extLst>
           </p:cNvPr>
@@ -5213,7 +5230,7 @@
           <p:cNvPr id="3" name="">
             <a:extLst xmlns:a="http://schemas.openxmlformats.org/drawingml/2006/main">
               <a:ext uri="{FF2B5EF4-FFF2-40B4-BE49-F238E27FC236}">
-                <a16:creationId xmlns:a16="http://schemas.microsoft.com/office/drawing/2014/main" id="{1CF00EAE-566E-4D5F-8BCF-A46FDF39F62C}"/>
+                <a16:creationId xmlns:a16="http://schemas.microsoft.com/office/drawing/2014/main" id="{6304849B-404E-4BBD-B6D5-1D619B7882F3}"/>
               </a:ext>
             </a:extLst>
           </p:cNvPr>
@@ -5270,7 +5287,7 @@
           <p:cNvPr id="4" name="">
             <a:extLst xmlns:a="http://schemas.openxmlformats.org/drawingml/2006/main">
               <a:ext uri="{FF2B5EF4-FFF2-40B4-BE49-F238E27FC236}">
-                <a16:creationId xmlns:a16="http://schemas.microsoft.com/office/drawing/2014/main" id="{B0FCBB11-4A79-4F04-8705-CF755986BE9D}"/>
+                <a16:creationId xmlns:a16="http://schemas.microsoft.com/office/drawing/2014/main" id="{38549393-176D-45DE-938A-C966AFDDB7F4}"/>
               </a:ext>
             </a:extLst>
           </p:cNvPr>
@@ -5383,7 +5400,7 @@
           <p:cNvPr id="5" name="">
             <a:extLst xmlns:a="http://schemas.openxmlformats.org/drawingml/2006/main">
               <a:ext uri="{FF2B5EF4-FFF2-40B4-BE49-F238E27FC236}">
-                <a16:creationId xmlns:a16="http://schemas.microsoft.com/office/drawing/2014/main" id="{209F77C1-01C8-4E67-8F43-408D742985BA}"/>
+                <a16:creationId xmlns:a16="http://schemas.microsoft.com/office/drawing/2014/main" id="{B77BD5C1-C3B8-474D-BAE9-58BDABD6217C}"/>
               </a:ext>
             </a:extLst>
           </p:cNvPr>
@@ -5438,7 +5455,7 @@
     </p:spTree>
     <p:extLst>
       <p:ext uri="{BB962C8B-B14F-4D97-AF65-F5344CB8AC3E}">
-        <p14:creationId xmlns:p14="http://schemas.microsoft.com/office/powerpoint/2010/main" val="571015428"/>
+        <p14:creationId xmlns:p14="http://schemas.microsoft.com/office/powerpoint/2010/main" val="991943503"/>
       </p:ext>
     </p:extLst>
   </p:cSld>
@@ -5469,7 +5486,7 @@
           <p:cNvPr id="6" name="">
             <a:extLst xmlns:a="http://schemas.openxmlformats.org/drawingml/2006/main">
               <a:ext uri="{FF2B5EF4-FFF2-40B4-BE49-F238E27FC236}">
-                <a16:creationId xmlns:a16="http://schemas.microsoft.com/office/drawing/2014/main" id="{ECFAF366-4C37-42A4-8ED3-950C4C34CD09}"/>
+                <a16:creationId xmlns:a16="http://schemas.microsoft.com/office/drawing/2014/main" id="{24A7A570-817F-4813-923F-E470ABE82653}"/>
               </a:ext>
             </a:extLst>
           </p:cNvPr>
@@ -5526,7 +5543,7 @@
           <p:cNvPr id="2" name="">
             <a:extLst xmlns:a="http://schemas.openxmlformats.org/drawingml/2006/main">
               <a:ext uri="{FF2B5EF4-FFF2-40B4-BE49-F238E27FC236}">
-                <a16:creationId xmlns:a16="http://schemas.microsoft.com/office/drawing/2014/main" id="{917A2B1A-FB53-4FE6-8FCD-E9E7D458E672}"/>
+                <a16:creationId xmlns:a16="http://schemas.microsoft.com/office/drawing/2014/main" id="{9C77A48B-3E3E-4EF9-82CF-6074368F2DF5}"/>
               </a:ext>
             </a:extLst>
           </p:cNvPr>
@@ -5583,7 +5600,7 @@
           <p:cNvPr id="3" name="">
             <a:extLst xmlns:a="http://schemas.openxmlformats.org/drawingml/2006/main">
               <a:ext uri="{FF2B5EF4-FFF2-40B4-BE49-F238E27FC236}">
-                <a16:creationId xmlns:a16="http://schemas.microsoft.com/office/drawing/2014/main" id="{B1EC6C21-CD5E-4C3C-A2B5-F0CAE7F63829}"/>
+                <a16:creationId xmlns:a16="http://schemas.microsoft.com/office/drawing/2014/main" id="{021F3AF5-74E0-449E-AB13-215D9425FB54}"/>
               </a:ext>
             </a:extLst>
           </p:cNvPr>
@@ -5640,7 +5657,7 @@
           <p:cNvPr id="4" name="">
             <a:extLst xmlns:a="http://schemas.openxmlformats.org/drawingml/2006/main">
               <a:ext uri="{FF2B5EF4-FFF2-40B4-BE49-F238E27FC236}">
-                <a16:creationId xmlns:a16="http://schemas.microsoft.com/office/drawing/2014/main" id="{F5B85620-4F8F-4F33-936F-ECE33B11C166}"/>
+                <a16:creationId xmlns:a16="http://schemas.microsoft.com/office/drawing/2014/main" id="{A4CEF351-8D75-4548-A9A7-EF95365DC56D}"/>
               </a:ext>
             </a:extLst>
           </p:cNvPr>
@@ -5753,7 +5770,7 @@
           <p:cNvPr id="5" name="">
             <a:extLst xmlns:a="http://schemas.openxmlformats.org/drawingml/2006/main">
               <a:ext uri="{FF2B5EF4-FFF2-40B4-BE49-F238E27FC236}">
-                <a16:creationId xmlns:a16="http://schemas.microsoft.com/office/drawing/2014/main" id="{CFDE30F1-ED48-430C-A695-9847D99A4637}"/>
+                <a16:creationId xmlns:a16="http://schemas.microsoft.com/office/drawing/2014/main" id="{59E3496F-DE82-4500-B606-6FC9185BDB7A}"/>
               </a:ext>
             </a:extLst>
           </p:cNvPr>
@@ -5831,7 +5848,7 @@
     </p:spTree>
     <p:extLst>
       <p:ext uri="{BB962C8B-B14F-4D97-AF65-F5344CB8AC3E}">
-        <p14:creationId xmlns:p14="http://schemas.microsoft.com/office/powerpoint/2010/main" val="1356840658"/>
+        <p14:creationId xmlns:p14="http://schemas.microsoft.com/office/powerpoint/2010/main" val="76419847"/>
       </p:ext>
     </p:extLst>
   </p:cSld>
@@ -5862,7 +5879,7 @@
           <p:cNvPr id="6" name="">
             <a:extLst xmlns:a="http://schemas.openxmlformats.org/drawingml/2006/main">
               <a:ext uri="{FF2B5EF4-FFF2-40B4-BE49-F238E27FC236}">
-                <a16:creationId xmlns:a16="http://schemas.microsoft.com/office/drawing/2014/main" id="{117625FB-81AD-477B-B2B5-31A835E9FC37}"/>
+                <a16:creationId xmlns:a16="http://schemas.microsoft.com/office/drawing/2014/main" id="{044F6874-130F-4748-B8A6-0864B39A1C9B}"/>
               </a:ext>
             </a:extLst>
           </p:cNvPr>
@@ -5919,7 +5936,7 @@
           <p:cNvPr id="2" name="">
             <a:extLst xmlns:a="http://schemas.openxmlformats.org/drawingml/2006/main">
               <a:ext uri="{FF2B5EF4-FFF2-40B4-BE49-F238E27FC236}">
-                <a16:creationId xmlns:a16="http://schemas.microsoft.com/office/drawing/2014/main" id="{9E4B2E48-1C0B-42A7-887C-B623E0F5F2EC}"/>
+                <a16:creationId xmlns:a16="http://schemas.microsoft.com/office/drawing/2014/main" id="{79E11CB0-0F8B-4B40-AA45-552321085873}"/>
               </a:ext>
             </a:extLst>
           </p:cNvPr>
@@ -5976,7 +5993,7 @@
           <p:cNvPr id="3" name="">
             <a:extLst xmlns:a="http://schemas.openxmlformats.org/drawingml/2006/main">
               <a:ext uri="{FF2B5EF4-FFF2-40B4-BE49-F238E27FC236}">
-                <a16:creationId xmlns:a16="http://schemas.microsoft.com/office/drawing/2014/main" id="{271A4929-4629-405B-8C55-8D4A605EADE2}"/>
+                <a16:creationId xmlns:a16="http://schemas.microsoft.com/office/drawing/2014/main" id="{08FB5C11-D550-439C-820F-E4750446E36E}"/>
               </a:ext>
             </a:extLst>
           </p:cNvPr>
@@ -6033,7 +6050,7 @@
           <p:cNvPr id="4" name="">
             <a:extLst xmlns:a="http://schemas.openxmlformats.org/drawingml/2006/main">
               <a:ext uri="{FF2B5EF4-FFF2-40B4-BE49-F238E27FC236}">
-                <a16:creationId xmlns:a16="http://schemas.microsoft.com/office/drawing/2014/main" id="{606286AB-2BED-4CAA-8889-52E9A7E3BA01}"/>
+                <a16:creationId xmlns:a16="http://schemas.microsoft.com/office/drawing/2014/main" id="{F11C9278-B812-4D90-81FF-969402F962EA}"/>
               </a:ext>
             </a:extLst>
           </p:cNvPr>
@@ -6146,7 +6163,7 @@
           <p:cNvPr id="5" name="">
             <a:extLst xmlns:a="http://schemas.openxmlformats.org/drawingml/2006/main">
               <a:ext uri="{FF2B5EF4-FFF2-40B4-BE49-F238E27FC236}">
-                <a16:creationId xmlns:a16="http://schemas.microsoft.com/office/drawing/2014/main" id="{116B5BC2-2B6A-4C26-9DA1-671285E9B0DE}"/>
+                <a16:creationId xmlns:a16="http://schemas.microsoft.com/office/drawing/2014/main" id="{8ABC2A7B-80C7-48E7-8A3A-99327E420003}"/>
               </a:ext>
             </a:extLst>
           </p:cNvPr>
@@ -6201,7 +6218,7 @@
     </p:spTree>
     <p:extLst>
       <p:ext uri="{BB962C8B-B14F-4D97-AF65-F5344CB8AC3E}">
-        <p14:creationId xmlns:p14="http://schemas.microsoft.com/office/powerpoint/2010/main" val="1579195225"/>
+        <p14:creationId xmlns:p14="http://schemas.microsoft.com/office/powerpoint/2010/main" val="1243842282"/>
       </p:ext>
     </p:extLst>
   </p:cSld>
@@ -6232,7 +6249,7 @@
           <p:cNvPr id="7" name="">
             <a:extLst xmlns:a="http://schemas.openxmlformats.org/drawingml/2006/main">
               <a:ext uri="{FF2B5EF4-FFF2-40B4-BE49-F238E27FC236}">
-                <a16:creationId xmlns:a16="http://schemas.microsoft.com/office/drawing/2014/main" id="{214F7132-3239-4666-8EC1-FADF6CB1F745}"/>
+                <a16:creationId xmlns:a16="http://schemas.microsoft.com/office/drawing/2014/main" id="{C382FEA6-32CE-4F82-AC30-EF6C341D29EC}"/>
               </a:ext>
             </a:extLst>
           </p:cNvPr>
@@ -6289,7 +6306,7 @@
           <p:cNvPr id="2" name="">
             <a:extLst xmlns:a="http://schemas.openxmlformats.org/drawingml/2006/main">
               <a:ext uri="{FF2B5EF4-FFF2-40B4-BE49-F238E27FC236}">
-                <a16:creationId xmlns:a16="http://schemas.microsoft.com/office/drawing/2014/main" id="{185C2693-0773-4A8B-B3D7-68906DCBABA1}"/>
+                <a16:creationId xmlns:a16="http://schemas.microsoft.com/office/drawing/2014/main" id="{81328DB9-07DF-414B-9439-1A51994AB994}"/>
               </a:ext>
             </a:extLst>
           </p:cNvPr>
@@ -6346,7 +6363,7 @@
           <p:cNvPr id="3" name="">
             <a:extLst xmlns:a="http://schemas.openxmlformats.org/drawingml/2006/main">
               <a:ext uri="{FF2B5EF4-FFF2-40B4-BE49-F238E27FC236}">
-                <a16:creationId xmlns:a16="http://schemas.microsoft.com/office/drawing/2014/main" id="{63BFB1F4-1CED-480C-BC74-EEE80CEA91C0}"/>
+                <a16:creationId xmlns:a16="http://schemas.microsoft.com/office/drawing/2014/main" id="{3EA7DCD4-FECC-4CEB-8255-1615D50B4B22}"/>
               </a:ext>
             </a:extLst>
           </p:cNvPr>
@@ -6819,7 +6836,7 @@
           <p:cNvPr id="5" name="">
             <a:extLst xmlns:a="http://schemas.openxmlformats.org/drawingml/2006/main">
               <a:ext uri="{FF2B5EF4-FFF2-40B4-BE49-F238E27FC236}">
-                <a16:creationId xmlns:a16="http://schemas.microsoft.com/office/drawing/2014/main" id="{221EC8FC-BA56-4903-B3B8-1A8BC6098A06}"/>
+                <a16:creationId xmlns:a16="http://schemas.microsoft.com/office/drawing/2014/main" id="{4E0EA83A-B5BB-4513-9635-7B87DD718840}"/>
               </a:ext>
             </a:extLst>
           </p:cNvPr>
@@ -6904,7 +6921,7 @@
           <p:cNvPr id="6" name="">
             <a:extLst xmlns:a="http://schemas.openxmlformats.org/drawingml/2006/main">
               <a:ext uri="{FF2B5EF4-FFF2-40B4-BE49-F238E27FC236}">
-                <a16:creationId xmlns:a16="http://schemas.microsoft.com/office/drawing/2014/main" id="{8E7AA664-7765-4BD6-B685-E32A63C42969}"/>
+                <a16:creationId xmlns:a16="http://schemas.microsoft.com/office/drawing/2014/main" id="{F2049937-290E-44AE-9209-C791B1F5C372}"/>
               </a:ext>
             </a:extLst>
           </p:cNvPr>
@@ -6959,7 +6976,7 @@
     </p:spTree>
     <p:extLst>
       <p:ext uri="{BB962C8B-B14F-4D97-AF65-F5344CB8AC3E}">
-        <p14:creationId xmlns:p14="http://schemas.microsoft.com/office/powerpoint/2010/main" val="1613915612"/>
+        <p14:creationId xmlns:p14="http://schemas.microsoft.com/office/powerpoint/2010/main" val="1242275336"/>
       </p:ext>
     </p:extLst>
   </p:cSld>
@@ -6990,7 +7007,7 @@
           <p:cNvPr id="7" name="">
             <a:extLst xmlns:a="http://schemas.openxmlformats.org/drawingml/2006/main">
               <a:ext uri="{FF2B5EF4-FFF2-40B4-BE49-F238E27FC236}">
-                <a16:creationId xmlns:a16="http://schemas.microsoft.com/office/drawing/2014/main" id="{BE5C9490-18E0-4F35-AC66-1AA41B5779C9}"/>
+                <a16:creationId xmlns:a16="http://schemas.microsoft.com/office/drawing/2014/main" id="{E2B4374B-5EEF-45A1-9363-694734D0EBB3}"/>
               </a:ext>
             </a:extLst>
           </p:cNvPr>
@@ -7047,7 +7064,7 @@
           <p:cNvPr id="2" name="">
             <a:extLst xmlns:a="http://schemas.openxmlformats.org/drawingml/2006/main">
               <a:ext uri="{FF2B5EF4-FFF2-40B4-BE49-F238E27FC236}">
-                <a16:creationId xmlns:a16="http://schemas.microsoft.com/office/drawing/2014/main" id="{7D191C11-A5FC-4993-8EBB-8F2AFD1EAFBA}"/>
+                <a16:creationId xmlns:a16="http://schemas.microsoft.com/office/drawing/2014/main" id="{2F9AC65A-CAF8-4DF3-9854-0052A0620D18}"/>
               </a:ext>
             </a:extLst>
           </p:cNvPr>
@@ -7104,7 +7121,7 @@
           <p:cNvPr id="3" name="">
             <a:extLst xmlns:a="http://schemas.openxmlformats.org/drawingml/2006/main">
               <a:ext uri="{FF2B5EF4-FFF2-40B4-BE49-F238E27FC236}">
-                <a16:creationId xmlns:a16="http://schemas.microsoft.com/office/drawing/2014/main" id="{E2056C00-6DEF-4368-9E03-DD0CEF908B8A}"/>
+                <a16:creationId xmlns:a16="http://schemas.microsoft.com/office/drawing/2014/main" id="{8B79825F-4CB1-4E04-B63D-E9F9E37E2602}"/>
               </a:ext>
             </a:extLst>
           </p:cNvPr>
@@ -7161,7 +7178,7 @@
           <p:cNvPr id="4" name="">
             <a:extLst xmlns:a="http://schemas.openxmlformats.org/drawingml/2006/main">
               <a:ext uri="{FF2B5EF4-FFF2-40B4-BE49-F238E27FC236}">
-                <a16:creationId xmlns:a16="http://schemas.microsoft.com/office/drawing/2014/main" id="{607CB899-7811-4E87-8585-B5A47610C6A3}"/>
+                <a16:creationId xmlns:a16="http://schemas.microsoft.com/office/drawing/2014/main" id="{C08212D9-9188-4C36-96E1-C7992564242C}"/>
               </a:ext>
             </a:extLst>
           </p:cNvPr>
@@ -7302,7 +7319,7 @@
           <p:cNvPr id="5" name="">
             <a:extLst xmlns:a="http://schemas.openxmlformats.org/drawingml/2006/main">
               <a:ext uri="{FF2B5EF4-FFF2-40B4-BE49-F238E27FC236}">
-                <a16:creationId xmlns:a16="http://schemas.microsoft.com/office/drawing/2014/main" id="{76673849-AEBD-422E-A971-D8981DD37645}"/>
+                <a16:creationId xmlns:a16="http://schemas.microsoft.com/office/drawing/2014/main" id="{EDA61498-4EB6-4476-AEF7-300C0309C215}"/>
               </a:ext>
             </a:extLst>
           </p:cNvPr>
@@ -7405,7 +7422,7 @@
           <p:cNvPr id="6" name="">
             <a:extLst xmlns:a="http://schemas.openxmlformats.org/drawingml/2006/main">
               <a:ext uri="{FF2B5EF4-FFF2-40B4-BE49-F238E27FC236}">
-                <a16:creationId xmlns:a16="http://schemas.microsoft.com/office/drawing/2014/main" id="{28617E7C-7C15-4847-A4EF-EB04AFD8C995}"/>
+                <a16:creationId xmlns:a16="http://schemas.microsoft.com/office/drawing/2014/main" id="{621BED62-59E4-4375-9AF2-D21CD965847F}"/>
               </a:ext>
             </a:extLst>
           </p:cNvPr>
@@ -7460,7 +7477,7 @@
     </p:spTree>
     <p:extLst>
       <p:ext uri="{BB962C8B-B14F-4D97-AF65-F5344CB8AC3E}">
-        <p14:creationId xmlns:p14="http://schemas.microsoft.com/office/powerpoint/2010/main" val="1863021217"/>
+        <p14:creationId xmlns:p14="http://schemas.microsoft.com/office/powerpoint/2010/main" val="1818488791"/>
       </p:ext>
     </p:extLst>
   </p:cSld>
@@ -7491,7 +7508,7 @@
           <p:cNvPr id="6" name="">
             <a:extLst xmlns:a="http://schemas.openxmlformats.org/drawingml/2006/main">
               <a:ext uri="{FF2B5EF4-FFF2-40B4-BE49-F238E27FC236}">
-                <a16:creationId xmlns:a16="http://schemas.microsoft.com/office/drawing/2014/main" id="{2F082466-18A2-4789-9B65-C191BA2DA1B5}"/>
+                <a16:creationId xmlns:a16="http://schemas.microsoft.com/office/drawing/2014/main" id="{3AD65419-AE2D-47ED-9E30-753BB1718424}"/>
               </a:ext>
             </a:extLst>
           </p:cNvPr>
@@ -7548,7 +7565,7 @@
           <p:cNvPr id="2" name="">
             <a:extLst xmlns:a="http://schemas.openxmlformats.org/drawingml/2006/main">
               <a:ext uri="{FF2B5EF4-FFF2-40B4-BE49-F238E27FC236}">
-                <a16:creationId xmlns:a16="http://schemas.microsoft.com/office/drawing/2014/main" id="{EC1C3973-8B1C-4F8C-8CA7-477040EC2DD0}"/>
+                <a16:creationId xmlns:a16="http://schemas.microsoft.com/office/drawing/2014/main" id="{26768E4B-B51F-4B09-A5F2-9BC960B15745}"/>
               </a:ext>
             </a:extLst>
           </p:cNvPr>
@@ -7605,7 +7622,7 @@
           <p:cNvPr id="3" name="">
             <a:extLst xmlns:a="http://schemas.openxmlformats.org/drawingml/2006/main">
               <a:ext uri="{FF2B5EF4-FFF2-40B4-BE49-F238E27FC236}">
-                <a16:creationId xmlns:a16="http://schemas.microsoft.com/office/drawing/2014/main" id="{4F79B48C-341C-4894-BFD1-13FCAC4DF5C7}"/>
+                <a16:creationId xmlns:a16="http://schemas.microsoft.com/office/drawing/2014/main" id="{DD23FF3D-E33F-4F56-9DA0-E112797AB8B7}"/>
               </a:ext>
             </a:extLst>
           </p:cNvPr>
@@ -7662,7 +7679,7 @@
           <p:cNvPr id="4" name="">
             <a:extLst xmlns:a="http://schemas.openxmlformats.org/drawingml/2006/main">
               <a:ext uri="{FF2B5EF4-FFF2-40B4-BE49-F238E27FC236}">
-                <a16:creationId xmlns:a16="http://schemas.microsoft.com/office/drawing/2014/main" id="{A4E3416F-7D1D-47E3-8333-BBE4C8180C9F}"/>
+                <a16:creationId xmlns:a16="http://schemas.microsoft.com/office/drawing/2014/main" id="{64D62F80-28AB-42F2-8AAC-92825A41366F}"/>
               </a:ext>
             </a:extLst>
           </p:cNvPr>
@@ -7775,7 +7792,7 @@
           <p:cNvPr id="5" name="">
             <a:extLst xmlns:a="http://schemas.openxmlformats.org/drawingml/2006/main">
               <a:ext uri="{FF2B5EF4-FFF2-40B4-BE49-F238E27FC236}">
-                <a16:creationId xmlns:a16="http://schemas.microsoft.com/office/drawing/2014/main" id="{54F3C4D6-1730-4A09-9963-8426680FAE4D}"/>
+                <a16:creationId xmlns:a16="http://schemas.microsoft.com/office/drawing/2014/main" id="{284BAB30-1A34-4875-AAB6-7C6831906B0E}"/>
               </a:ext>
             </a:extLst>
           </p:cNvPr>
@@ -7876,7 +7893,7 @@
     </p:spTree>
     <p:extLst>
       <p:ext uri="{BB962C8B-B14F-4D97-AF65-F5344CB8AC3E}">
-        <p14:creationId xmlns:p14="http://schemas.microsoft.com/office/powerpoint/2010/main" val="1107145885"/>
+        <p14:creationId xmlns:p14="http://schemas.microsoft.com/office/powerpoint/2010/main" val="872823588"/>
       </p:ext>
     </p:extLst>
   </p:cSld>
@@ -7907,7 +7924,7 @@
           <p:cNvPr id="7" name="">
             <a:extLst xmlns:a="http://schemas.openxmlformats.org/drawingml/2006/main">
               <a:ext uri="{FF2B5EF4-FFF2-40B4-BE49-F238E27FC236}">
-                <a16:creationId xmlns:a16="http://schemas.microsoft.com/office/drawing/2014/main" id="{E6E182E0-9B0C-4AE0-8DF6-0F1A7C503BBC}"/>
+                <a16:creationId xmlns:a16="http://schemas.microsoft.com/office/drawing/2014/main" id="{B0AA2F7A-9824-40AC-A440-AB900DA5BD57}"/>
               </a:ext>
             </a:extLst>
           </p:cNvPr>
@@ -7964,7 +7981,7 @@
           <p:cNvPr id="2" name="">
             <a:extLst xmlns:a="http://schemas.openxmlformats.org/drawingml/2006/main">
               <a:ext uri="{FF2B5EF4-FFF2-40B4-BE49-F238E27FC236}">
-                <a16:creationId xmlns:a16="http://schemas.microsoft.com/office/drawing/2014/main" id="{822E6B5D-BBD0-4CC9-B850-47B94676BDA2}"/>
+                <a16:creationId xmlns:a16="http://schemas.microsoft.com/office/drawing/2014/main" id="{8862D0A0-4463-4CA2-9563-6FF88D67315B}"/>
               </a:ext>
             </a:extLst>
           </p:cNvPr>
@@ -8021,7 +8038,7 @@
           <p:cNvPr id="3" name="">
             <a:extLst xmlns:a="http://schemas.openxmlformats.org/drawingml/2006/main">
               <a:ext uri="{FF2B5EF4-FFF2-40B4-BE49-F238E27FC236}">
-                <a16:creationId xmlns:a16="http://schemas.microsoft.com/office/drawing/2014/main" id="{8B64320E-3C5C-432C-8C0F-01C30CEA5AFA}"/>
+                <a16:creationId xmlns:a16="http://schemas.microsoft.com/office/drawing/2014/main" id="{8541FE2F-EE22-42AD-B6B5-5B4BA7335B98}"/>
               </a:ext>
             </a:extLst>
           </p:cNvPr>
@@ -8078,7 +8095,7 @@
           <p:cNvPr id="4" name="">
             <a:extLst xmlns:a="http://schemas.openxmlformats.org/drawingml/2006/main">
               <a:ext uri="{FF2B5EF4-FFF2-40B4-BE49-F238E27FC236}">
-                <a16:creationId xmlns:a16="http://schemas.microsoft.com/office/drawing/2014/main" id="{85FF5EBF-BA07-45DC-850D-EAF9DE41D621}"/>
+                <a16:creationId xmlns:a16="http://schemas.microsoft.com/office/drawing/2014/main" id="{6D737F55-8A28-41BC-9C57-DE5DD8D0214B}"/>
               </a:ext>
             </a:extLst>
           </p:cNvPr>
@@ -8163,7 +8180,7 @@
           <p:cNvPr id="5" name="">
             <a:extLst xmlns:a="http://schemas.openxmlformats.org/drawingml/2006/main">
               <a:ext uri="{FF2B5EF4-FFF2-40B4-BE49-F238E27FC236}">
-                <a16:creationId xmlns:a16="http://schemas.microsoft.com/office/drawing/2014/main" id="{D52E1B69-6653-42A7-BC21-93AD02C81569}"/>
+                <a16:creationId xmlns:a16="http://schemas.microsoft.com/office/drawing/2014/main" id="{2797EC1D-EFE8-4DDF-A250-0E927B1E1937}"/>
               </a:ext>
             </a:extLst>
           </p:cNvPr>
@@ -8266,7 +8283,7 @@
           <p:cNvPr id="6" name="">
             <a:extLst xmlns:a="http://schemas.openxmlformats.org/drawingml/2006/main">
               <a:ext uri="{FF2B5EF4-FFF2-40B4-BE49-F238E27FC236}">
-                <a16:creationId xmlns:a16="http://schemas.microsoft.com/office/drawing/2014/main" id="{90E66305-0F3A-4D97-B2DD-48DDB958DA1C}"/>
+                <a16:creationId xmlns:a16="http://schemas.microsoft.com/office/drawing/2014/main" id="{49C5674A-412F-47AE-9B20-45DF65A388FC}"/>
               </a:ext>
             </a:extLst>
           </p:cNvPr>
@@ -8321,7 +8338,7 @@
     </p:spTree>
     <p:extLst>
       <p:ext uri="{BB962C8B-B14F-4D97-AF65-F5344CB8AC3E}">
-        <p14:creationId xmlns:p14="http://schemas.microsoft.com/office/powerpoint/2010/main" val="1910793661"/>
+        <p14:creationId xmlns:p14="http://schemas.microsoft.com/office/powerpoint/2010/main" val="237674924"/>
       </p:ext>
     </p:extLst>
   </p:cSld>
@@ -8352,7 +8369,7 @@
           <p:cNvPr id="7" name="">
             <a:extLst xmlns:a="http://schemas.openxmlformats.org/drawingml/2006/main">
               <a:ext uri="{FF2B5EF4-FFF2-40B4-BE49-F238E27FC236}">
-                <a16:creationId xmlns:a16="http://schemas.microsoft.com/office/drawing/2014/main" id="{1112F2AF-39B2-4CE1-8DE5-6E4E52BDDCAA}"/>
+                <a16:creationId xmlns:a16="http://schemas.microsoft.com/office/drawing/2014/main" id="{F2002B98-DBEE-47B1-B91E-DC5C5ACA4548}"/>
               </a:ext>
             </a:extLst>
           </p:cNvPr>
@@ -8409,7 +8426,7 @@
           <p:cNvPr id="2" name="">
             <a:extLst xmlns:a="http://schemas.openxmlformats.org/drawingml/2006/main">
               <a:ext uri="{FF2B5EF4-FFF2-40B4-BE49-F238E27FC236}">
-                <a16:creationId xmlns:a16="http://schemas.microsoft.com/office/drawing/2014/main" id="{5A94E7D8-532A-4FE6-AAC8-958524358FE0}"/>
+                <a16:creationId xmlns:a16="http://schemas.microsoft.com/office/drawing/2014/main" id="{8CC93428-7895-4618-9C9F-1E470B3DB88B}"/>
               </a:ext>
             </a:extLst>
           </p:cNvPr>
@@ -8466,7 +8483,7 @@
           <p:cNvPr id="3" name="">
             <a:extLst xmlns:a="http://schemas.openxmlformats.org/drawingml/2006/main">
               <a:ext uri="{FF2B5EF4-FFF2-40B4-BE49-F238E27FC236}">
-                <a16:creationId xmlns:a16="http://schemas.microsoft.com/office/drawing/2014/main" id="{52DE91CB-64B9-40F4-B4DF-BA81BFED6532}"/>
+                <a16:creationId xmlns:a16="http://schemas.microsoft.com/office/drawing/2014/main" id="{A2177AE7-3CF3-430D-BA11-4BECB2352388}"/>
               </a:ext>
             </a:extLst>
           </p:cNvPr>
@@ -8527,7 +8544,7 @@
           <p:nvPr/>
         </p:nvPicPr>
         <p:blipFill>
-          <a:blip xmlns:r="http://schemas.openxmlformats.org/officeDocument/2006/relationships" xmlns:a="http://schemas.openxmlformats.org/drawingml/2006/main" r:embed="Rce4443667a554245"/>
+          <a:blip xmlns:r="http://schemas.openxmlformats.org/officeDocument/2006/relationships" xmlns:a="http://schemas.openxmlformats.org/drawingml/2006/main" r:embed="R99d400a2c64241a8"/>
           <a:stretch xmlns:a="http://schemas.openxmlformats.org/drawingml/2006/main"/>
         </p:blipFill>
         <p:spPr>
@@ -8545,7 +8562,7 @@
           <p:cNvPr id="5" name="">
             <a:extLst xmlns:a="http://schemas.openxmlformats.org/drawingml/2006/main">
               <a:ext uri="{FF2B5EF4-FFF2-40B4-BE49-F238E27FC236}">
-                <a16:creationId xmlns:a16="http://schemas.microsoft.com/office/drawing/2014/main" id="{4AB4E885-E379-40B3-9134-B16F69C18BE6}"/>
+                <a16:creationId xmlns:a16="http://schemas.microsoft.com/office/drawing/2014/main" id="{556E404A-7271-4FF6-91FA-7C02CAA1D86D}"/>
               </a:ext>
             </a:extLst>
           </p:cNvPr>
@@ -8602,7 +8619,7 @@
           <p:cNvPr id="6" name="">
             <a:extLst xmlns:a="http://schemas.openxmlformats.org/drawingml/2006/main">
               <a:ext uri="{FF2B5EF4-FFF2-40B4-BE49-F238E27FC236}">
-                <a16:creationId xmlns:a16="http://schemas.microsoft.com/office/drawing/2014/main" id="{A136CD57-C2CE-4C7D-A96E-64AF0E11D2E0}"/>
+                <a16:creationId xmlns:a16="http://schemas.microsoft.com/office/drawing/2014/main" id="{933D0E42-4DE5-4598-9013-BDFA85FE8B24}"/>
               </a:ext>
             </a:extLst>
           </p:cNvPr>
@@ -8657,7 +8674,7 @@
     </p:spTree>
     <p:extLst>
       <p:ext uri="{BB962C8B-B14F-4D97-AF65-F5344CB8AC3E}">
-        <p14:creationId xmlns:p14="http://schemas.microsoft.com/office/powerpoint/2010/main" val="1403402694"/>
+        <p14:creationId xmlns:p14="http://schemas.microsoft.com/office/powerpoint/2010/main" val="97481855"/>
       </p:ext>
     </p:extLst>
   </p:cSld>

</xml_diff>

<commit_message>
Replace week 4 covers with cloud infrastructure diagrams
</commit_message>
<xml_diff>
--- a/lendet/2026-2027/mobile/lectures/ligjerata-04-neon-postgresql-rideshare-2026.pptx
+++ b/lendet/2026-2027/mobile/lectures/ligjerata-04-neon-postgresql-rideshare-2026.pptx
@@ -2,28 +2,28 @@
 <file path=ppt/presentation.xml><?xml version="1.0" encoding="utf-8"?>
 <p:presentation xmlns:p="http://schemas.openxmlformats.org/presentationml/2006/main">
   <p:sldMasterIdLst>
-    <p:sldMasterId xmlns:r="http://schemas.openxmlformats.org/officeDocument/2006/relationships" id="2147483648" r:id="R32f700e982f04b62"/>
+    <p:sldMasterId xmlns:r="http://schemas.openxmlformats.org/officeDocument/2006/relationships" id="2147483648" r:id="R32c6a9eb752d418c"/>
   </p:sldMasterIdLst>
   <p:sldIdLst>
-    <p:sldId xmlns:r="http://schemas.openxmlformats.org/officeDocument/2006/relationships" id="256" r:id="R0b58241ca65c4a25"/>
-    <p:sldId xmlns:r="http://schemas.openxmlformats.org/officeDocument/2006/relationships" id="257" r:id="R1b08c80eb2854183"/>
-    <p:sldId xmlns:r="http://schemas.openxmlformats.org/officeDocument/2006/relationships" id="258" r:id="R04221dabb39d48ab"/>
-    <p:sldId xmlns:r="http://schemas.openxmlformats.org/officeDocument/2006/relationships" id="259" r:id="R9579cb5cf91147ab"/>
-    <p:sldId xmlns:r="http://schemas.openxmlformats.org/officeDocument/2006/relationships" id="260" r:id="R68057e8fac5c4adf"/>
-    <p:sldId xmlns:r="http://schemas.openxmlformats.org/officeDocument/2006/relationships" id="261" r:id="Re270c51eb55c4cd3"/>
-    <p:sldId xmlns:r="http://schemas.openxmlformats.org/officeDocument/2006/relationships" id="262" r:id="Ra926b2f054134575"/>
-    <p:sldId xmlns:r="http://schemas.openxmlformats.org/officeDocument/2006/relationships" id="263" r:id="R43da0ced30d34969"/>
-    <p:sldId xmlns:r="http://schemas.openxmlformats.org/officeDocument/2006/relationships" id="264" r:id="R051e3f8fba1f44ff"/>
-    <p:sldId xmlns:r="http://schemas.openxmlformats.org/officeDocument/2006/relationships" id="265" r:id="R9639caeb60ec4bdb"/>
-    <p:sldId xmlns:r="http://schemas.openxmlformats.org/officeDocument/2006/relationships" id="266" r:id="Rdaf5fcf9055c40e3"/>
-    <p:sldId xmlns:r="http://schemas.openxmlformats.org/officeDocument/2006/relationships" id="267" r:id="Rb7f18537419343c1"/>
-    <p:sldId xmlns:r="http://schemas.openxmlformats.org/officeDocument/2006/relationships" id="268" r:id="R54faa88fb0da400f"/>
-    <p:sldId xmlns:r="http://schemas.openxmlformats.org/officeDocument/2006/relationships" id="269" r:id="R0d90b6d7a7b940b0"/>
-    <p:sldId xmlns:r="http://schemas.openxmlformats.org/officeDocument/2006/relationships" id="270" r:id="R124c16c5404a4ef3"/>
-    <p:sldId xmlns:r="http://schemas.openxmlformats.org/officeDocument/2006/relationships" id="271" r:id="R4b6017b86c7a430f"/>
-    <p:sldId xmlns:r="http://schemas.openxmlformats.org/officeDocument/2006/relationships" id="272" r:id="R870c7b9d29244f78"/>
-    <p:sldId xmlns:r="http://schemas.openxmlformats.org/officeDocument/2006/relationships" id="273" r:id="R878a77bad1e34ea8"/>
-    <p:sldId xmlns:r="http://schemas.openxmlformats.org/officeDocument/2006/relationships" id="274" r:id="R549bd33a29c84bc2"/>
+    <p:sldId xmlns:r="http://schemas.openxmlformats.org/officeDocument/2006/relationships" id="256" r:id="Ra876a60a489f4bc9"/>
+    <p:sldId xmlns:r="http://schemas.openxmlformats.org/officeDocument/2006/relationships" id="257" r:id="R225528af12c04fbc"/>
+    <p:sldId xmlns:r="http://schemas.openxmlformats.org/officeDocument/2006/relationships" id="258" r:id="Rb9528da0e9694116"/>
+    <p:sldId xmlns:r="http://schemas.openxmlformats.org/officeDocument/2006/relationships" id="259" r:id="Re8aca3b46b15401f"/>
+    <p:sldId xmlns:r="http://schemas.openxmlformats.org/officeDocument/2006/relationships" id="260" r:id="R2bd05c2b2ee94015"/>
+    <p:sldId xmlns:r="http://schemas.openxmlformats.org/officeDocument/2006/relationships" id="261" r:id="Rf11bb080a3254ff9"/>
+    <p:sldId xmlns:r="http://schemas.openxmlformats.org/officeDocument/2006/relationships" id="262" r:id="Rf4ebb075ec0b41a3"/>
+    <p:sldId xmlns:r="http://schemas.openxmlformats.org/officeDocument/2006/relationships" id="263" r:id="Rc0be5e9fa4d24ca2"/>
+    <p:sldId xmlns:r="http://schemas.openxmlformats.org/officeDocument/2006/relationships" id="264" r:id="Raa28d02aa4bf4d1b"/>
+    <p:sldId xmlns:r="http://schemas.openxmlformats.org/officeDocument/2006/relationships" id="265" r:id="Rf6dd8d9e2c2c4017"/>
+    <p:sldId xmlns:r="http://schemas.openxmlformats.org/officeDocument/2006/relationships" id="266" r:id="R5a01840c332146a0"/>
+    <p:sldId xmlns:r="http://schemas.openxmlformats.org/officeDocument/2006/relationships" id="267" r:id="R77137f03398e4e14"/>
+    <p:sldId xmlns:r="http://schemas.openxmlformats.org/officeDocument/2006/relationships" id="268" r:id="Rdea3d882bc2445f3"/>
+    <p:sldId xmlns:r="http://schemas.openxmlformats.org/officeDocument/2006/relationships" id="269" r:id="R3d965ea79fbe4b45"/>
+    <p:sldId xmlns:r="http://schemas.openxmlformats.org/officeDocument/2006/relationships" id="270" r:id="R67d24730111e4ccc"/>
+    <p:sldId xmlns:r="http://schemas.openxmlformats.org/officeDocument/2006/relationships" id="271" r:id="R4c82b1a80aef41eb"/>
+    <p:sldId xmlns:r="http://schemas.openxmlformats.org/officeDocument/2006/relationships" id="272" r:id="R0bd03a94435e4390"/>
+    <p:sldId xmlns:r="http://schemas.openxmlformats.org/officeDocument/2006/relationships" id="273" r:id="Ra87217fc09a54fdb"/>
+    <p:sldId xmlns:r="http://schemas.openxmlformats.org/officeDocument/2006/relationships" id="274" r:id="R8708fb9bb89f445c"/>
   </p:sldIdLst>
   <p:sldSz cx="12192000" cy="6858000"/>
   <p:notesSz cx="6858000" cy="9144000"/>
@@ -68,7 +68,7 @@
   </p:cSld>
   <p:clrMap bg1="lt1" tx1="dk1" bg2="lt2" tx2="dk2" accent1="accent1" accent2="accent2" accent3="accent3" accent4="accent4" accent5="accent5" accent6="accent6" hlink="hlink" folHlink="folHlink"/>
   <p:sldLayoutIdLst>
-    <p:sldLayoutId xmlns:r="http://schemas.openxmlformats.org/officeDocument/2006/relationships" id="2147483649" r:id="R74ad0ca9acd54305"/>
+    <p:sldLayoutId xmlns:r="http://schemas.openxmlformats.org/officeDocument/2006/relationships" id="2147483649" r:id="Ra7786729b4264688"/>
   </p:sldLayoutIdLst>
   <p:txStyles>
     <p:titleStyle>
@@ -619,7 +619,7 @@
           <p:cNvPr id="7" name="">
             <a:extLst xmlns:a="http://schemas.openxmlformats.org/drawingml/2006/main">
               <a:ext uri="{FF2B5EF4-FFF2-40B4-BE49-F238E27FC236}">
-                <a16:creationId xmlns:a16="http://schemas.microsoft.com/office/drawing/2014/main" id="{6064AF25-45BB-47C9-8EF5-E05D74068521}"/>
+                <a16:creationId xmlns:a16="http://schemas.microsoft.com/office/drawing/2014/main" id="{E4444AD0-3908-485E-8C65-76827F43EC53}"/>
               </a:ext>
             </a:extLst>
           </p:cNvPr>
@@ -676,7 +676,7 @@
           <p:cNvPr id="2" name="">
             <a:extLst xmlns:a="http://schemas.openxmlformats.org/drawingml/2006/main">
               <a:ext uri="{FF2B5EF4-FFF2-40B4-BE49-F238E27FC236}">
-                <a16:creationId xmlns:a16="http://schemas.microsoft.com/office/drawing/2014/main" id="{84C947D0-34F6-41A3-934C-AC377664CC35}"/>
+                <a16:creationId xmlns:a16="http://schemas.microsoft.com/office/drawing/2014/main" id="{8FE48659-1822-4FBB-AC30-6EA0B984A49E}"/>
               </a:ext>
             </a:extLst>
           </p:cNvPr>
@@ -737,7 +737,7 @@
           <p:nvPr/>
         </p:nvPicPr>
         <p:blipFill>
-          <a:blip xmlns:r="http://schemas.openxmlformats.org/officeDocument/2006/relationships" xmlns:a="http://schemas.openxmlformats.org/drawingml/2006/main" r:embed="Ra635b39037004be5"/>
+          <a:blip xmlns:r="http://schemas.openxmlformats.org/officeDocument/2006/relationships" xmlns:a="http://schemas.openxmlformats.org/drawingml/2006/main" r:embed="R7b9fbe3177c94231"/>
           <a:stretch xmlns:a="http://schemas.openxmlformats.org/drawingml/2006/main"/>
         </p:blipFill>
         <p:spPr>
@@ -755,7 +755,7 @@
           <p:cNvPr id="4" name="">
             <a:extLst xmlns:a="http://schemas.openxmlformats.org/drawingml/2006/main">
               <a:ext uri="{FF2B5EF4-FFF2-40B4-BE49-F238E27FC236}">
-                <a16:creationId xmlns:a16="http://schemas.microsoft.com/office/drawing/2014/main" id="{1529EFF1-364B-4D09-B31B-4B1DFEC03C2E}"/>
+                <a16:creationId xmlns:a16="http://schemas.microsoft.com/office/drawing/2014/main" id="{6CB606FB-A592-4FEC-9B03-B98CDF1CEAB6}"/>
               </a:ext>
             </a:extLst>
           </p:cNvPr>
@@ -802,7 +802,7 @@
                 <a:ea typeface="Arial"/>
                 <a:cs typeface="Arial"/>
               </a:rPr>
-              <a:t>RideShare mban mend udhëtimet</a:t>
+              <a:t>Si komunikon RideShare me databazën</a:t>
             </a:r>
           </a:p>
         </p:txBody>
@@ -816,13 +816,13 @@
           <p:nvPr/>
         </p:nvPicPr>
         <p:blipFill>
-          <a:blip xmlns:r="http://schemas.openxmlformats.org/officeDocument/2006/relationships" xmlns:a="http://schemas.openxmlformats.org/drawingml/2006/main" r:embed="R0ec69f57b29549c1"/>
+          <a:blip xmlns:r="http://schemas.openxmlformats.org/officeDocument/2006/relationships" xmlns:a="http://schemas.openxmlformats.org/drawingml/2006/main" r:embed="Rcb89d66de114409e"/>
           <a:stretch xmlns:a="http://schemas.openxmlformats.org/drawingml/2006/main"/>
         </p:blipFill>
         <p:spPr>
           <a:xfrm xmlns:a="http://schemas.openxmlformats.org/drawingml/2006/main">
-            <a:off x="2659297" y="1666875"/>
-            <a:ext cx="6854356" cy="3857625"/>
+            <a:off x="609600" y="1770063"/>
+            <a:ext cx="10953750" cy="3651250"/>
           </a:xfrm>
           <a:prstGeom xmlns:a="http://schemas.openxmlformats.org/drawingml/2006/main" prst="rect">
             <a:avLst/>
@@ -834,7 +834,7 @@
           <p:cNvPr id="6" name="">
             <a:extLst xmlns:a="http://schemas.openxmlformats.org/drawingml/2006/main">
               <a:ext uri="{FF2B5EF4-FFF2-40B4-BE49-F238E27FC236}">
-                <a16:creationId xmlns:a16="http://schemas.microsoft.com/office/drawing/2014/main" id="{C9ABD680-DE0C-45AB-A475-3307236780BF}"/>
+                <a16:creationId xmlns:a16="http://schemas.microsoft.com/office/drawing/2014/main" id="{17F57B7F-A1A6-49D8-82EC-535634866DD5}"/>
               </a:ext>
             </a:extLst>
           </p:cNvPr>
@@ -881,7 +881,7 @@
                 <a:ea typeface="Arial"/>
                 <a:cs typeface="Arial"/>
               </a:rPr>
-              <a:t>Javën e kaluar ndërtuam ekranet. Sot u japim një burim të përbashkët të dhënash.</a:t>
+              <a:t>Telefoni kërkon faqen. Next.js lexon udhëtimet në Neon dhe kthen pamjen.</a:t>
             </a:r>
           </a:p>
           <a:p xmlns:a="http://schemas.openxmlformats.org/drawingml/2006/main">
@@ -904,7 +904,7 @@
                 <a:ea typeface="Arial"/>
                 <a:cs typeface="Arial"/>
               </a:rPr>
-              <a:t>Neon + PostgreSQL · Ligjëratë 45 minuta për secilin grup</a:t>
+              <a:t>GitHub ruan kodin. Vercel ekzekuton aplikacionin. Neon ruan të dhënat.</a:t>
             </a:r>
           </a:p>
         </p:txBody>
@@ -912,7 +912,7 @@
     </p:spTree>
     <p:extLst>
       <p:ext uri="{BB962C8B-B14F-4D97-AF65-F5344CB8AC3E}">
-        <p14:creationId xmlns:p14="http://schemas.microsoft.com/office/powerpoint/2010/main" val="1013837018"/>
+        <p14:creationId xmlns:p14="http://schemas.microsoft.com/office/powerpoint/2010/main" val="2085737414"/>
       </p:ext>
     </p:extLst>
   </p:cSld>
@@ -943,7 +943,7 @@
           <p:cNvPr id="7" name="">
             <a:extLst xmlns:a="http://schemas.openxmlformats.org/drawingml/2006/main">
               <a:ext uri="{FF2B5EF4-FFF2-40B4-BE49-F238E27FC236}">
-                <a16:creationId xmlns:a16="http://schemas.microsoft.com/office/drawing/2014/main" id="{3FBB8C48-CF46-4590-B667-17BADA7F1165}"/>
+                <a16:creationId xmlns:a16="http://schemas.microsoft.com/office/drawing/2014/main" id="{B91EC9B4-13E5-43E7-AC40-467BCA6E78F6}"/>
               </a:ext>
             </a:extLst>
           </p:cNvPr>
@@ -1000,7 +1000,7 @@
           <p:cNvPr id="2" name="">
             <a:extLst xmlns:a="http://schemas.openxmlformats.org/drawingml/2006/main">
               <a:ext uri="{FF2B5EF4-FFF2-40B4-BE49-F238E27FC236}">
-                <a16:creationId xmlns:a16="http://schemas.microsoft.com/office/drawing/2014/main" id="{21362C45-9BCE-4C53-9337-FBAB5DEE2587}"/>
+                <a16:creationId xmlns:a16="http://schemas.microsoft.com/office/drawing/2014/main" id="{BEC26714-C599-4F7F-A609-3936EB08AF63}"/>
               </a:ext>
             </a:extLst>
           </p:cNvPr>
@@ -1057,7 +1057,7 @@
           <p:cNvPr id="3" name="">
             <a:extLst xmlns:a="http://schemas.openxmlformats.org/drawingml/2006/main">
               <a:ext uri="{FF2B5EF4-FFF2-40B4-BE49-F238E27FC236}">
-                <a16:creationId xmlns:a16="http://schemas.microsoft.com/office/drawing/2014/main" id="{1B112E3A-D2E4-47E9-8B30-CFE2B0CF6A73}"/>
+                <a16:creationId xmlns:a16="http://schemas.microsoft.com/office/drawing/2014/main" id="{F37FDA31-E72B-423D-BCDF-CAFCD3E00915}"/>
               </a:ext>
             </a:extLst>
           </p:cNvPr>
@@ -1114,7 +1114,7 @@
           <p:cNvPr id="4" name="">
             <a:extLst xmlns:a="http://schemas.openxmlformats.org/drawingml/2006/main">
               <a:ext uri="{FF2B5EF4-FFF2-40B4-BE49-F238E27FC236}">
-                <a16:creationId xmlns:a16="http://schemas.microsoft.com/office/drawing/2014/main" id="{7C9C2F61-A5A0-4D26-8063-5F2AEE4D484A}"/>
+                <a16:creationId xmlns:a16="http://schemas.microsoft.com/office/drawing/2014/main" id="{9F9DE0D1-9FFF-4CD7-ACD6-DC628D718BEA}"/>
               </a:ext>
             </a:extLst>
           </p:cNvPr>
@@ -1227,7 +1227,7 @@
           <p:cNvPr id="5" name="">
             <a:extLst xmlns:a="http://schemas.openxmlformats.org/drawingml/2006/main">
               <a:ext uri="{FF2B5EF4-FFF2-40B4-BE49-F238E27FC236}">
-                <a16:creationId xmlns:a16="http://schemas.microsoft.com/office/drawing/2014/main" id="{E4222ADF-4DC1-4AE7-BA46-1B6EFD121963}"/>
+                <a16:creationId xmlns:a16="http://schemas.microsoft.com/office/drawing/2014/main" id="{231DDE2B-DD8A-4C98-9FD7-89ED237749FD}"/>
               </a:ext>
             </a:extLst>
           </p:cNvPr>
@@ -1307,7 +1307,7 @@
           <p:cNvPr id="6" name="">
             <a:extLst xmlns:a="http://schemas.openxmlformats.org/drawingml/2006/main">
               <a:ext uri="{FF2B5EF4-FFF2-40B4-BE49-F238E27FC236}">
-                <a16:creationId xmlns:a16="http://schemas.microsoft.com/office/drawing/2014/main" id="{D582E342-0644-4559-AAD0-845F11A65A40}"/>
+                <a16:creationId xmlns:a16="http://schemas.microsoft.com/office/drawing/2014/main" id="{0AEDBED3-4C05-4850-AD38-20B55C39A6FB}"/>
               </a:ext>
             </a:extLst>
           </p:cNvPr>
@@ -1362,7 +1362,7 @@
     </p:spTree>
     <p:extLst>
       <p:ext uri="{BB962C8B-B14F-4D97-AF65-F5344CB8AC3E}">
-        <p14:creationId xmlns:p14="http://schemas.microsoft.com/office/powerpoint/2010/main" val="43629586"/>
+        <p14:creationId xmlns:p14="http://schemas.microsoft.com/office/powerpoint/2010/main" val="201459801"/>
       </p:ext>
     </p:extLst>
   </p:cSld>
@@ -1393,7 +1393,7 @@
           <p:cNvPr id="7" name="">
             <a:extLst xmlns:a="http://schemas.openxmlformats.org/drawingml/2006/main">
               <a:ext uri="{FF2B5EF4-FFF2-40B4-BE49-F238E27FC236}">
-                <a16:creationId xmlns:a16="http://schemas.microsoft.com/office/drawing/2014/main" id="{9223843D-A577-46F0-A853-FEB583FE2A67}"/>
+                <a16:creationId xmlns:a16="http://schemas.microsoft.com/office/drawing/2014/main" id="{5B3A216C-84DD-4953-BFB5-EDA4A24DEC2D}"/>
               </a:ext>
             </a:extLst>
           </p:cNvPr>
@@ -1450,7 +1450,7 @@
           <p:cNvPr id="2" name="">
             <a:extLst xmlns:a="http://schemas.openxmlformats.org/drawingml/2006/main">
               <a:ext uri="{FF2B5EF4-FFF2-40B4-BE49-F238E27FC236}">
-                <a16:creationId xmlns:a16="http://schemas.microsoft.com/office/drawing/2014/main" id="{C9020730-60B0-44DD-AA4F-96E9CDDB6DD6}"/>
+                <a16:creationId xmlns:a16="http://schemas.microsoft.com/office/drawing/2014/main" id="{259F9805-AA93-4ED4-9470-08F5F97147C0}"/>
               </a:ext>
             </a:extLst>
           </p:cNvPr>
@@ -1507,7 +1507,7 @@
           <p:cNvPr id="3" name="">
             <a:extLst xmlns:a="http://schemas.openxmlformats.org/drawingml/2006/main">
               <a:ext uri="{FF2B5EF4-FFF2-40B4-BE49-F238E27FC236}">
-                <a16:creationId xmlns:a16="http://schemas.microsoft.com/office/drawing/2014/main" id="{3547F168-C2E8-41E2-A488-74DBED066A3B}"/>
+                <a16:creationId xmlns:a16="http://schemas.microsoft.com/office/drawing/2014/main" id="{7965922B-6DD0-4FBD-BC22-9A3027388566}"/>
               </a:ext>
             </a:extLst>
           </p:cNvPr>
@@ -1564,7 +1564,7 @@
           <p:cNvPr id="4" name="">
             <a:extLst xmlns:a="http://schemas.openxmlformats.org/drawingml/2006/main">
               <a:ext uri="{FF2B5EF4-FFF2-40B4-BE49-F238E27FC236}">
-                <a16:creationId xmlns:a16="http://schemas.microsoft.com/office/drawing/2014/main" id="{7AA93283-919D-4DAF-809F-372273FEACB4}"/>
+                <a16:creationId xmlns:a16="http://schemas.microsoft.com/office/drawing/2014/main" id="{BD9FDFCF-04C2-46BB-9DD3-6F35B267F398}"/>
               </a:ext>
             </a:extLst>
           </p:cNvPr>
@@ -1677,7 +1677,7 @@
           <p:cNvPr id="5" name="">
             <a:extLst xmlns:a="http://schemas.openxmlformats.org/drawingml/2006/main">
               <a:ext uri="{FF2B5EF4-FFF2-40B4-BE49-F238E27FC236}">
-                <a16:creationId xmlns:a16="http://schemas.microsoft.com/office/drawing/2014/main" id="{52E3A1AD-ECE6-4A73-BB47-96C5D318AEC3}"/>
+                <a16:creationId xmlns:a16="http://schemas.microsoft.com/office/drawing/2014/main" id="{E327388E-F6DA-4521-BF02-251FEB42E10F}"/>
               </a:ext>
             </a:extLst>
           </p:cNvPr>
@@ -1757,7 +1757,7 @@
           <p:cNvPr id="6" name="">
             <a:extLst xmlns:a="http://schemas.openxmlformats.org/drawingml/2006/main">
               <a:ext uri="{FF2B5EF4-FFF2-40B4-BE49-F238E27FC236}">
-                <a16:creationId xmlns:a16="http://schemas.microsoft.com/office/drawing/2014/main" id="{DB4BE686-84DC-4821-B661-72300B7941E8}"/>
+                <a16:creationId xmlns:a16="http://schemas.microsoft.com/office/drawing/2014/main" id="{9C91C34A-7F2D-4F4D-B201-F3566361121C}"/>
               </a:ext>
             </a:extLst>
           </p:cNvPr>
@@ -1812,7 +1812,7 @@
     </p:spTree>
     <p:extLst>
       <p:ext uri="{BB962C8B-B14F-4D97-AF65-F5344CB8AC3E}">
-        <p14:creationId xmlns:p14="http://schemas.microsoft.com/office/powerpoint/2010/main" val="313135659"/>
+        <p14:creationId xmlns:p14="http://schemas.microsoft.com/office/powerpoint/2010/main" val="685608923"/>
       </p:ext>
     </p:extLst>
   </p:cSld>
@@ -1843,7 +1843,7 @@
           <p:cNvPr id="7" name="">
             <a:extLst xmlns:a="http://schemas.openxmlformats.org/drawingml/2006/main">
               <a:ext uri="{FF2B5EF4-FFF2-40B4-BE49-F238E27FC236}">
-                <a16:creationId xmlns:a16="http://schemas.microsoft.com/office/drawing/2014/main" id="{20CA51E5-167F-4542-A90B-D9FE7E60E002}"/>
+                <a16:creationId xmlns:a16="http://schemas.microsoft.com/office/drawing/2014/main" id="{4E0E7F05-FE36-4DF9-8723-AB3F62A8B7DA}"/>
               </a:ext>
             </a:extLst>
           </p:cNvPr>
@@ -1900,7 +1900,7 @@
           <p:cNvPr id="2" name="">
             <a:extLst xmlns:a="http://schemas.openxmlformats.org/drawingml/2006/main">
               <a:ext uri="{FF2B5EF4-FFF2-40B4-BE49-F238E27FC236}">
-                <a16:creationId xmlns:a16="http://schemas.microsoft.com/office/drawing/2014/main" id="{49F8B9D2-BD7D-4BEB-869B-3DAF46157185}"/>
+                <a16:creationId xmlns:a16="http://schemas.microsoft.com/office/drawing/2014/main" id="{70F3E372-1C47-4DB4-9AB3-DB63732297A0}"/>
               </a:ext>
             </a:extLst>
           </p:cNvPr>
@@ -1957,7 +1957,7 @@
           <p:cNvPr id="3" name="">
             <a:extLst xmlns:a="http://schemas.openxmlformats.org/drawingml/2006/main">
               <a:ext uri="{FF2B5EF4-FFF2-40B4-BE49-F238E27FC236}">
-                <a16:creationId xmlns:a16="http://schemas.microsoft.com/office/drawing/2014/main" id="{649164E0-16A7-4B4B-9964-1CB77EB931FD}"/>
+                <a16:creationId xmlns:a16="http://schemas.microsoft.com/office/drawing/2014/main" id="{3276BB5A-C40B-4FF7-A5A5-261EEAF51EBC}"/>
               </a:ext>
             </a:extLst>
           </p:cNvPr>
@@ -2014,7 +2014,7 @@
           <p:cNvPr id="4" name="">
             <a:extLst xmlns:a="http://schemas.openxmlformats.org/drawingml/2006/main">
               <a:ext uri="{FF2B5EF4-FFF2-40B4-BE49-F238E27FC236}">
-                <a16:creationId xmlns:a16="http://schemas.microsoft.com/office/drawing/2014/main" id="{4476F3BB-7C15-4A4D-9A69-BF342C69E01F}"/>
+                <a16:creationId xmlns:a16="http://schemas.microsoft.com/office/drawing/2014/main" id="{D72631E0-B90C-4DFE-9A0E-14B358E41B19}"/>
               </a:ext>
             </a:extLst>
           </p:cNvPr>
@@ -2127,7 +2127,7 @@
           <p:cNvPr id="5" name="">
             <a:extLst xmlns:a="http://schemas.openxmlformats.org/drawingml/2006/main">
               <a:ext uri="{FF2B5EF4-FFF2-40B4-BE49-F238E27FC236}">
-                <a16:creationId xmlns:a16="http://schemas.microsoft.com/office/drawing/2014/main" id="{4D447AB7-1ACF-4F1E-A969-0DBADC04709E}"/>
+                <a16:creationId xmlns:a16="http://schemas.microsoft.com/office/drawing/2014/main" id="{2B5FA663-A2A5-4E19-B22C-591B00D6097A}"/>
               </a:ext>
             </a:extLst>
           </p:cNvPr>
@@ -2253,7 +2253,7 @@
           <p:cNvPr id="6" name="">
             <a:extLst xmlns:a="http://schemas.openxmlformats.org/drawingml/2006/main">
               <a:ext uri="{FF2B5EF4-FFF2-40B4-BE49-F238E27FC236}">
-                <a16:creationId xmlns:a16="http://schemas.microsoft.com/office/drawing/2014/main" id="{A9DD9EA5-1033-4F77-BCE6-E631D5E257F2}"/>
+                <a16:creationId xmlns:a16="http://schemas.microsoft.com/office/drawing/2014/main" id="{37459226-0B9C-4387-A6EE-A290BA569891}"/>
               </a:ext>
             </a:extLst>
           </p:cNvPr>
@@ -2308,7 +2308,7 @@
     </p:spTree>
     <p:extLst>
       <p:ext uri="{BB962C8B-B14F-4D97-AF65-F5344CB8AC3E}">
-        <p14:creationId xmlns:p14="http://schemas.microsoft.com/office/powerpoint/2010/main" val="1076910239"/>
+        <p14:creationId xmlns:p14="http://schemas.microsoft.com/office/powerpoint/2010/main" val="1996564646"/>
       </p:ext>
     </p:extLst>
   </p:cSld>
@@ -2339,7 +2339,7 @@
           <p:cNvPr id="7" name="">
             <a:extLst xmlns:a="http://schemas.openxmlformats.org/drawingml/2006/main">
               <a:ext uri="{FF2B5EF4-FFF2-40B4-BE49-F238E27FC236}">
-                <a16:creationId xmlns:a16="http://schemas.microsoft.com/office/drawing/2014/main" id="{06D8C397-2405-4549-93AF-E503ABEEE4FB}"/>
+                <a16:creationId xmlns:a16="http://schemas.microsoft.com/office/drawing/2014/main" id="{4CDADC29-4C8B-4F50-B2D6-1720CC3B6CC4}"/>
               </a:ext>
             </a:extLst>
           </p:cNvPr>
@@ -2396,7 +2396,7 @@
           <p:cNvPr id="2" name="">
             <a:extLst xmlns:a="http://schemas.openxmlformats.org/drawingml/2006/main">
               <a:ext uri="{FF2B5EF4-FFF2-40B4-BE49-F238E27FC236}">
-                <a16:creationId xmlns:a16="http://schemas.microsoft.com/office/drawing/2014/main" id="{55326104-46A3-467A-9A98-75617C2D849C}"/>
+                <a16:creationId xmlns:a16="http://schemas.microsoft.com/office/drawing/2014/main" id="{3ABE2951-41B8-460F-89DB-57428D3F7C93}"/>
               </a:ext>
             </a:extLst>
           </p:cNvPr>
@@ -2453,7 +2453,7 @@
           <p:cNvPr id="3" name="">
             <a:extLst xmlns:a="http://schemas.openxmlformats.org/drawingml/2006/main">
               <a:ext uri="{FF2B5EF4-FFF2-40B4-BE49-F238E27FC236}">
-                <a16:creationId xmlns:a16="http://schemas.microsoft.com/office/drawing/2014/main" id="{A3510E55-6035-4B2C-B6CF-EAD558752869}"/>
+                <a16:creationId xmlns:a16="http://schemas.microsoft.com/office/drawing/2014/main" id="{40C13BBE-5D79-4181-AFB6-CB37B47C6A38}"/>
               </a:ext>
             </a:extLst>
           </p:cNvPr>
@@ -2510,7 +2510,7 @@
           <p:cNvPr id="4" name="">
             <a:extLst xmlns:a="http://schemas.openxmlformats.org/drawingml/2006/main">
               <a:ext uri="{FF2B5EF4-FFF2-40B4-BE49-F238E27FC236}">
-                <a16:creationId xmlns:a16="http://schemas.microsoft.com/office/drawing/2014/main" id="{715DD66B-B209-42C3-82EE-3DB400AA01F7}"/>
+                <a16:creationId xmlns:a16="http://schemas.microsoft.com/office/drawing/2014/main" id="{AEA470B9-CC22-429D-A509-056EFC0D7DF1}"/>
               </a:ext>
             </a:extLst>
           </p:cNvPr>
@@ -2623,7 +2623,7 @@
           <p:cNvPr id="5" name="">
             <a:extLst xmlns:a="http://schemas.openxmlformats.org/drawingml/2006/main">
               <a:ext uri="{FF2B5EF4-FFF2-40B4-BE49-F238E27FC236}">
-                <a16:creationId xmlns:a16="http://schemas.microsoft.com/office/drawing/2014/main" id="{C64FE656-0F18-456F-B8CE-4221C918120C}"/>
+                <a16:creationId xmlns:a16="http://schemas.microsoft.com/office/drawing/2014/main" id="{6C8DC2DE-A108-4A44-9378-A79C31CD9440}"/>
               </a:ext>
             </a:extLst>
           </p:cNvPr>
@@ -2680,7 +2680,7 @@
           <p:cNvPr id="6" name="">
             <a:extLst xmlns:a="http://schemas.openxmlformats.org/drawingml/2006/main">
               <a:ext uri="{FF2B5EF4-FFF2-40B4-BE49-F238E27FC236}">
-                <a16:creationId xmlns:a16="http://schemas.microsoft.com/office/drawing/2014/main" id="{76D94573-A9CD-4701-9118-CA2558B4B6FA}"/>
+                <a16:creationId xmlns:a16="http://schemas.microsoft.com/office/drawing/2014/main" id="{CC76C650-B795-4CCB-BB2C-4B9E88EB3D4B}"/>
               </a:ext>
             </a:extLst>
           </p:cNvPr>
@@ -2735,7 +2735,7 @@
     </p:spTree>
     <p:extLst>
       <p:ext uri="{BB962C8B-B14F-4D97-AF65-F5344CB8AC3E}">
-        <p14:creationId xmlns:p14="http://schemas.microsoft.com/office/powerpoint/2010/main" val="1597028890"/>
+        <p14:creationId xmlns:p14="http://schemas.microsoft.com/office/powerpoint/2010/main" val="1917532762"/>
       </p:ext>
     </p:extLst>
   </p:cSld>
@@ -2766,7 +2766,7 @@
           <p:cNvPr id="6" name="">
             <a:extLst xmlns:a="http://schemas.openxmlformats.org/drawingml/2006/main">
               <a:ext uri="{FF2B5EF4-FFF2-40B4-BE49-F238E27FC236}">
-                <a16:creationId xmlns:a16="http://schemas.microsoft.com/office/drawing/2014/main" id="{7E032EEC-2864-47ED-A12D-FC39880BA67B}"/>
+                <a16:creationId xmlns:a16="http://schemas.microsoft.com/office/drawing/2014/main" id="{6542CF29-6867-47D2-BE24-A358E894550C}"/>
               </a:ext>
             </a:extLst>
           </p:cNvPr>
@@ -2823,7 +2823,7 @@
           <p:cNvPr id="2" name="">
             <a:extLst xmlns:a="http://schemas.openxmlformats.org/drawingml/2006/main">
               <a:ext uri="{FF2B5EF4-FFF2-40B4-BE49-F238E27FC236}">
-                <a16:creationId xmlns:a16="http://schemas.microsoft.com/office/drawing/2014/main" id="{84AD6215-793B-4281-8156-8FCD67C3A171}"/>
+                <a16:creationId xmlns:a16="http://schemas.microsoft.com/office/drawing/2014/main" id="{77290E2B-67D4-4735-8906-EBDF528CF7E5}"/>
               </a:ext>
             </a:extLst>
           </p:cNvPr>
@@ -2880,7 +2880,7 @@
           <p:cNvPr id="3" name="">
             <a:extLst xmlns:a="http://schemas.openxmlformats.org/drawingml/2006/main">
               <a:ext uri="{FF2B5EF4-FFF2-40B4-BE49-F238E27FC236}">
-                <a16:creationId xmlns:a16="http://schemas.microsoft.com/office/drawing/2014/main" id="{DE175D9D-0F57-49CB-A50E-122B642ED566}"/>
+                <a16:creationId xmlns:a16="http://schemas.microsoft.com/office/drawing/2014/main" id="{61A5B5D2-F155-426D-BAA3-D00B975EDDD2}"/>
               </a:ext>
             </a:extLst>
           </p:cNvPr>
@@ -2937,7 +2937,7 @@
           <p:cNvPr id="4" name="">
             <a:extLst xmlns:a="http://schemas.openxmlformats.org/drawingml/2006/main">
               <a:ext uri="{FF2B5EF4-FFF2-40B4-BE49-F238E27FC236}">
-                <a16:creationId xmlns:a16="http://schemas.microsoft.com/office/drawing/2014/main" id="{27D54040-5FFE-45D7-9C0F-DBD6EBE45C8A}"/>
+                <a16:creationId xmlns:a16="http://schemas.microsoft.com/office/drawing/2014/main" id="{99C2842B-A4ED-4A99-A073-ABE34EF9DB95}"/>
               </a:ext>
             </a:extLst>
           </p:cNvPr>
@@ -3078,7 +3078,7 @@
           <p:cNvPr id="5" name="">
             <a:extLst xmlns:a="http://schemas.openxmlformats.org/drawingml/2006/main">
               <a:ext uri="{FF2B5EF4-FFF2-40B4-BE49-F238E27FC236}">
-                <a16:creationId xmlns:a16="http://schemas.microsoft.com/office/drawing/2014/main" id="{E38C9EF5-BDD9-437A-ABFD-E44BC6063B18}"/>
+                <a16:creationId xmlns:a16="http://schemas.microsoft.com/office/drawing/2014/main" id="{8B83F6DA-E203-48D3-9473-BB98C0027C5B}"/>
               </a:ext>
             </a:extLst>
           </p:cNvPr>
@@ -3133,7 +3133,7 @@
     </p:spTree>
     <p:extLst>
       <p:ext uri="{BB962C8B-B14F-4D97-AF65-F5344CB8AC3E}">
-        <p14:creationId xmlns:p14="http://schemas.microsoft.com/office/powerpoint/2010/main" val="288069148"/>
+        <p14:creationId xmlns:p14="http://schemas.microsoft.com/office/powerpoint/2010/main" val="1764387287"/>
       </p:ext>
     </p:extLst>
   </p:cSld>
@@ -3164,7 +3164,7 @@
           <p:cNvPr id="7" name="">
             <a:extLst xmlns:a="http://schemas.openxmlformats.org/drawingml/2006/main">
               <a:ext uri="{FF2B5EF4-FFF2-40B4-BE49-F238E27FC236}">
-                <a16:creationId xmlns:a16="http://schemas.microsoft.com/office/drawing/2014/main" id="{005C0E5B-793F-45FF-A2F1-C9E4952782F8}"/>
+                <a16:creationId xmlns:a16="http://schemas.microsoft.com/office/drawing/2014/main" id="{0312CF54-0A3F-4D96-92F2-222BF63FA193}"/>
               </a:ext>
             </a:extLst>
           </p:cNvPr>
@@ -3221,7 +3221,7 @@
           <p:cNvPr id="2" name="">
             <a:extLst xmlns:a="http://schemas.openxmlformats.org/drawingml/2006/main">
               <a:ext uri="{FF2B5EF4-FFF2-40B4-BE49-F238E27FC236}">
-                <a16:creationId xmlns:a16="http://schemas.microsoft.com/office/drawing/2014/main" id="{70AEF83A-E897-4E42-8850-95BC0FBBF834}"/>
+                <a16:creationId xmlns:a16="http://schemas.microsoft.com/office/drawing/2014/main" id="{4D254AB5-10AD-4421-A58D-C53702A4E733}"/>
               </a:ext>
             </a:extLst>
           </p:cNvPr>
@@ -3278,7 +3278,7 @@
           <p:cNvPr id="3" name="">
             <a:extLst xmlns:a="http://schemas.openxmlformats.org/drawingml/2006/main">
               <a:ext uri="{FF2B5EF4-FFF2-40B4-BE49-F238E27FC236}">
-                <a16:creationId xmlns:a16="http://schemas.microsoft.com/office/drawing/2014/main" id="{28FE2936-DAFA-449F-AE27-9385502812CE}"/>
+                <a16:creationId xmlns:a16="http://schemas.microsoft.com/office/drawing/2014/main" id="{6D592CD0-DF3F-4359-8797-E0DD671B8475}"/>
               </a:ext>
             </a:extLst>
           </p:cNvPr>
@@ -3335,7 +3335,7 @@
           <p:cNvPr id="4" name="">
             <a:extLst xmlns:a="http://schemas.openxmlformats.org/drawingml/2006/main">
               <a:ext uri="{FF2B5EF4-FFF2-40B4-BE49-F238E27FC236}">
-                <a16:creationId xmlns:a16="http://schemas.microsoft.com/office/drawing/2014/main" id="{E9129264-EA85-494C-B9BC-35C1144B5486}"/>
+                <a16:creationId xmlns:a16="http://schemas.microsoft.com/office/drawing/2014/main" id="{401D1DE1-5A18-4BB7-88DA-C2FB85A11CB6}"/>
               </a:ext>
             </a:extLst>
           </p:cNvPr>
@@ -3448,7 +3448,7 @@
           <p:cNvPr id="5" name="">
             <a:extLst xmlns:a="http://schemas.openxmlformats.org/drawingml/2006/main">
               <a:ext uri="{FF2B5EF4-FFF2-40B4-BE49-F238E27FC236}">
-                <a16:creationId xmlns:a16="http://schemas.microsoft.com/office/drawing/2014/main" id="{82A402E8-60E8-41D5-B923-90EF9C5C1CD4}"/>
+                <a16:creationId xmlns:a16="http://schemas.microsoft.com/office/drawing/2014/main" id="{AA4BE355-040D-47E3-9E4D-E20FB079A02B}"/>
               </a:ext>
             </a:extLst>
           </p:cNvPr>
@@ -3505,7 +3505,7 @@
           <p:cNvPr id="6" name="">
             <a:extLst xmlns:a="http://schemas.openxmlformats.org/drawingml/2006/main">
               <a:ext uri="{FF2B5EF4-FFF2-40B4-BE49-F238E27FC236}">
-                <a16:creationId xmlns:a16="http://schemas.microsoft.com/office/drawing/2014/main" id="{C2F519D4-B5B6-41A8-BF05-95997C25523E}"/>
+                <a16:creationId xmlns:a16="http://schemas.microsoft.com/office/drawing/2014/main" id="{48C947F0-12C1-480C-A46B-23ED331B1867}"/>
               </a:ext>
             </a:extLst>
           </p:cNvPr>
@@ -3560,7 +3560,7 @@
     </p:spTree>
     <p:extLst>
       <p:ext uri="{BB962C8B-B14F-4D97-AF65-F5344CB8AC3E}">
-        <p14:creationId xmlns:p14="http://schemas.microsoft.com/office/powerpoint/2010/main" val="262707331"/>
+        <p14:creationId xmlns:p14="http://schemas.microsoft.com/office/powerpoint/2010/main" val="341160478"/>
       </p:ext>
     </p:extLst>
   </p:cSld>
@@ -3591,7 +3591,7 @@
           <p:cNvPr id="5" name="">
             <a:extLst xmlns:a="http://schemas.openxmlformats.org/drawingml/2006/main">
               <a:ext uri="{FF2B5EF4-FFF2-40B4-BE49-F238E27FC236}">
-                <a16:creationId xmlns:a16="http://schemas.microsoft.com/office/drawing/2014/main" id="{FF41871A-95E6-41B8-8530-95348086C759}"/>
+                <a16:creationId xmlns:a16="http://schemas.microsoft.com/office/drawing/2014/main" id="{2855D718-3242-4A8E-887E-B2141FFC1170}"/>
               </a:ext>
             </a:extLst>
           </p:cNvPr>
@@ -3648,7 +3648,7 @@
           <p:cNvPr id="2" name="">
             <a:extLst xmlns:a="http://schemas.openxmlformats.org/drawingml/2006/main">
               <a:ext uri="{FF2B5EF4-FFF2-40B4-BE49-F238E27FC236}">
-                <a16:creationId xmlns:a16="http://schemas.microsoft.com/office/drawing/2014/main" id="{D18A79FC-0D48-4863-B962-6D89279A4FF1}"/>
+                <a16:creationId xmlns:a16="http://schemas.microsoft.com/office/drawing/2014/main" id="{B2AC5046-CA56-4C51-B461-2B2C004FAEC8}"/>
               </a:ext>
             </a:extLst>
           </p:cNvPr>
@@ -3705,7 +3705,7 @@
           <p:cNvPr id="3" name="">
             <a:extLst xmlns:a="http://schemas.openxmlformats.org/drawingml/2006/main">
               <a:ext uri="{FF2B5EF4-FFF2-40B4-BE49-F238E27FC236}">
-                <a16:creationId xmlns:a16="http://schemas.microsoft.com/office/drawing/2014/main" id="{347A2F1F-0015-4AA2-8F98-5A483EE8D501}"/>
+                <a16:creationId xmlns:a16="http://schemas.microsoft.com/office/drawing/2014/main" id="{63803796-8A6B-4646-B3E0-38D08D1AE2B7}"/>
               </a:ext>
             </a:extLst>
           </p:cNvPr>
@@ -3762,7 +3762,7 @@
           <p:cNvPr id="4" name="">
             <a:extLst xmlns:a="http://schemas.openxmlformats.org/drawingml/2006/main">
               <a:ext uri="{FF2B5EF4-FFF2-40B4-BE49-F238E27FC236}">
-                <a16:creationId xmlns:a16="http://schemas.microsoft.com/office/drawing/2014/main" id="{9E60EC9A-A9CF-4EB0-8859-2B4481F2F40B}"/>
+                <a16:creationId xmlns:a16="http://schemas.microsoft.com/office/drawing/2014/main" id="{6CA50EE9-FB5C-4F34-8BE8-12EF5B836719}"/>
               </a:ext>
             </a:extLst>
           </p:cNvPr>
@@ -3901,7 +3901,7 @@
     </p:spTree>
     <p:extLst>
       <p:ext uri="{BB962C8B-B14F-4D97-AF65-F5344CB8AC3E}">
-        <p14:creationId xmlns:p14="http://schemas.microsoft.com/office/powerpoint/2010/main" val="1832751913"/>
+        <p14:creationId xmlns:p14="http://schemas.microsoft.com/office/powerpoint/2010/main" val="2009882338"/>
       </p:ext>
     </p:extLst>
   </p:cSld>
@@ -3932,7 +3932,7 @@
           <p:cNvPr id="7" name="">
             <a:extLst xmlns:a="http://schemas.openxmlformats.org/drawingml/2006/main">
               <a:ext uri="{FF2B5EF4-FFF2-40B4-BE49-F238E27FC236}">
-                <a16:creationId xmlns:a16="http://schemas.microsoft.com/office/drawing/2014/main" id="{CB99EE05-D039-41BD-A51C-222372CBD2A3}"/>
+                <a16:creationId xmlns:a16="http://schemas.microsoft.com/office/drawing/2014/main" id="{8B1F994C-B1DB-484F-8835-490717DA8D3B}"/>
               </a:ext>
             </a:extLst>
           </p:cNvPr>
@@ -3989,7 +3989,7 @@
           <p:cNvPr id="2" name="">
             <a:extLst xmlns:a="http://schemas.openxmlformats.org/drawingml/2006/main">
               <a:ext uri="{FF2B5EF4-FFF2-40B4-BE49-F238E27FC236}">
-                <a16:creationId xmlns:a16="http://schemas.microsoft.com/office/drawing/2014/main" id="{C5D27AF6-268D-4184-9025-8E68F8DD1FBA}"/>
+                <a16:creationId xmlns:a16="http://schemas.microsoft.com/office/drawing/2014/main" id="{6A6229E0-6423-465F-8EBD-AE58E32F5B0A}"/>
               </a:ext>
             </a:extLst>
           </p:cNvPr>
@@ -4046,7 +4046,7 @@
           <p:cNvPr id="3" name="">
             <a:extLst xmlns:a="http://schemas.openxmlformats.org/drawingml/2006/main">
               <a:ext uri="{FF2B5EF4-FFF2-40B4-BE49-F238E27FC236}">
-                <a16:creationId xmlns:a16="http://schemas.microsoft.com/office/drawing/2014/main" id="{84EEC89E-1B20-4F31-9F2A-CE9579EBBB8D}"/>
+                <a16:creationId xmlns:a16="http://schemas.microsoft.com/office/drawing/2014/main" id="{AE44A3D2-E025-4F1F-9831-8DCDDD9A7C61}"/>
               </a:ext>
             </a:extLst>
           </p:cNvPr>
@@ -4103,7 +4103,7 @@
           <p:cNvPr id="4" name="">
             <a:extLst xmlns:a="http://schemas.openxmlformats.org/drawingml/2006/main">
               <a:ext uri="{FF2B5EF4-FFF2-40B4-BE49-F238E27FC236}">
-                <a16:creationId xmlns:a16="http://schemas.microsoft.com/office/drawing/2014/main" id="{CAC82D99-2AB2-415A-A800-A6E92EAE7415}"/>
+                <a16:creationId xmlns:a16="http://schemas.microsoft.com/office/drawing/2014/main" id="{75D4B34F-D625-40A5-AD33-B398FDA816C6}"/>
               </a:ext>
             </a:extLst>
           </p:cNvPr>
@@ -4188,7 +4188,7 @@
           <p:cNvPr id="5" name="">
             <a:extLst xmlns:a="http://schemas.openxmlformats.org/drawingml/2006/main">
               <a:ext uri="{FF2B5EF4-FFF2-40B4-BE49-F238E27FC236}">
-                <a16:creationId xmlns:a16="http://schemas.microsoft.com/office/drawing/2014/main" id="{016F8FAC-3B03-450A-826C-75E2718DE3BA}"/>
+                <a16:creationId xmlns:a16="http://schemas.microsoft.com/office/drawing/2014/main" id="{1D0D0B61-077C-4748-B27D-D979409A0717}"/>
               </a:ext>
             </a:extLst>
           </p:cNvPr>
@@ -4291,7 +4291,7 @@
           <p:cNvPr id="6" name="">
             <a:extLst xmlns:a="http://schemas.openxmlformats.org/drawingml/2006/main">
               <a:ext uri="{FF2B5EF4-FFF2-40B4-BE49-F238E27FC236}">
-                <a16:creationId xmlns:a16="http://schemas.microsoft.com/office/drawing/2014/main" id="{E43AF9DF-F330-4720-BC81-4A69AC5D99CF}"/>
+                <a16:creationId xmlns:a16="http://schemas.microsoft.com/office/drawing/2014/main" id="{32BF32CF-F025-4EA4-8381-B007F8A786B3}"/>
               </a:ext>
             </a:extLst>
           </p:cNvPr>
@@ -4346,7 +4346,7 @@
     </p:spTree>
     <p:extLst>
       <p:ext uri="{BB962C8B-B14F-4D97-AF65-F5344CB8AC3E}">
-        <p14:creationId xmlns:p14="http://schemas.microsoft.com/office/powerpoint/2010/main" val="1893970491"/>
+        <p14:creationId xmlns:p14="http://schemas.microsoft.com/office/powerpoint/2010/main" val="1234658242"/>
       </p:ext>
     </p:extLst>
   </p:cSld>
@@ -4377,7 +4377,7 @@
           <p:cNvPr id="6" name="">
             <a:extLst xmlns:a="http://schemas.openxmlformats.org/drawingml/2006/main">
               <a:ext uri="{FF2B5EF4-FFF2-40B4-BE49-F238E27FC236}">
-                <a16:creationId xmlns:a16="http://schemas.microsoft.com/office/drawing/2014/main" id="{B9F0533F-BAC2-4AF5-A974-241F2C6F6B8D}"/>
+                <a16:creationId xmlns:a16="http://schemas.microsoft.com/office/drawing/2014/main" id="{4E885CD0-A97E-45E0-8E79-0887A4B0A0FB}"/>
               </a:ext>
             </a:extLst>
           </p:cNvPr>
@@ -4434,7 +4434,7 @@
           <p:cNvPr id="2" name="">
             <a:extLst xmlns:a="http://schemas.openxmlformats.org/drawingml/2006/main">
               <a:ext uri="{FF2B5EF4-FFF2-40B4-BE49-F238E27FC236}">
-                <a16:creationId xmlns:a16="http://schemas.microsoft.com/office/drawing/2014/main" id="{801BBD37-9781-4E35-8432-CAB5C23767E1}"/>
+                <a16:creationId xmlns:a16="http://schemas.microsoft.com/office/drawing/2014/main" id="{CBD403FB-EC82-4683-9B90-B890C3AF63E8}"/>
               </a:ext>
             </a:extLst>
           </p:cNvPr>
@@ -4491,7 +4491,7 @@
           <p:cNvPr id="3" name="">
             <a:extLst xmlns:a="http://schemas.openxmlformats.org/drawingml/2006/main">
               <a:ext uri="{FF2B5EF4-FFF2-40B4-BE49-F238E27FC236}">
-                <a16:creationId xmlns:a16="http://schemas.microsoft.com/office/drawing/2014/main" id="{399CD36E-186A-49DC-A042-1982D63CDC7E}"/>
+                <a16:creationId xmlns:a16="http://schemas.microsoft.com/office/drawing/2014/main" id="{55086546-0C7E-4764-A691-A0829A3BC150}"/>
               </a:ext>
             </a:extLst>
           </p:cNvPr>
@@ -4548,7 +4548,7 @@
           <p:cNvPr id="4" name="">
             <a:extLst xmlns:a="http://schemas.openxmlformats.org/drawingml/2006/main">
               <a:ext uri="{FF2B5EF4-FFF2-40B4-BE49-F238E27FC236}">
-                <a16:creationId xmlns:a16="http://schemas.microsoft.com/office/drawing/2014/main" id="{495126C5-281B-4D66-B548-D4A549D7AA9A}"/>
+                <a16:creationId xmlns:a16="http://schemas.microsoft.com/office/drawing/2014/main" id="{49577D90-C537-455E-9AC9-16B37884E130}"/>
               </a:ext>
             </a:extLst>
           </p:cNvPr>
@@ -4689,7 +4689,7 @@
           <p:cNvPr id="5" name="">
             <a:extLst xmlns:a="http://schemas.openxmlformats.org/drawingml/2006/main">
               <a:ext uri="{FF2B5EF4-FFF2-40B4-BE49-F238E27FC236}">
-                <a16:creationId xmlns:a16="http://schemas.microsoft.com/office/drawing/2014/main" id="{A32898AD-C2EC-41A3-9931-CFF5A653627C}"/>
+                <a16:creationId xmlns:a16="http://schemas.microsoft.com/office/drawing/2014/main" id="{A593FA69-7F0C-4123-8F5B-52D079DD8E05}"/>
               </a:ext>
             </a:extLst>
           </p:cNvPr>
@@ -4744,7 +4744,7 @@
     </p:spTree>
     <p:extLst>
       <p:ext uri="{BB962C8B-B14F-4D97-AF65-F5344CB8AC3E}">
-        <p14:creationId xmlns:p14="http://schemas.microsoft.com/office/powerpoint/2010/main" val="1573002623"/>
+        <p14:creationId xmlns:p14="http://schemas.microsoft.com/office/powerpoint/2010/main" val="1436891095"/>
       </p:ext>
     </p:extLst>
   </p:cSld>
@@ -4775,7 +4775,7 @@
           <p:cNvPr id="5" name="">
             <a:extLst xmlns:a="http://schemas.openxmlformats.org/drawingml/2006/main">
               <a:ext uri="{FF2B5EF4-FFF2-40B4-BE49-F238E27FC236}">
-                <a16:creationId xmlns:a16="http://schemas.microsoft.com/office/drawing/2014/main" id="{F051809C-9230-468E-945E-EA844CDE4FFF}"/>
+                <a16:creationId xmlns:a16="http://schemas.microsoft.com/office/drawing/2014/main" id="{3BDD66FE-6F39-4179-8532-D70D00EFC805}"/>
               </a:ext>
             </a:extLst>
           </p:cNvPr>
@@ -4832,7 +4832,7 @@
           <p:cNvPr id="2" name="">
             <a:extLst xmlns:a="http://schemas.openxmlformats.org/drawingml/2006/main">
               <a:ext uri="{FF2B5EF4-FFF2-40B4-BE49-F238E27FC236}">
-                <a16:creationId xmlns:a16="http://schemas.microsoft.com/office/drawing/2014/main" id="{69E9B0DF-BD85-4E9C-B1F5-DEC3233D8C14}"/>
+                <a16:creationId xmlns:a16="http://schemas.microsoft.com/office/drawing/2014/main" id="{B4D9A819-212D-46A5-AF15-69158AA40C48}"/>
               </a:ext>
             </a:extLst>
           </p:cNvPr>
@@ -4889,7 +4889,7 @@
           <p:cNvPr id="3" name="">
             <a:extLst xmlns:a="http://schemas.openxmlformats.org/drawingml/2006/main">
               <a:ext uri="{FF2B5EF4-FFF2-40B4-BE49-F238E27FC236}">
-                <a16:creationId xmlns:a16="http://schemas.microsoft.com/office/drawing/2014/main" id="{B5E4A6C5-2E09-4D71-B937-F60E4EFF4196}"/>
+                <a16:creationId xmlns:a16="http://schemas.microsoft.com/office/drawing/2014/main" id="{80F852C1-A0F1-48AD-BB09-CCFA4089F71F}"/>
               </a:ext>
             </a:extLst>
           </p:cNvPr>
@@ -4946,7 +4946,7 @@
           <p:cNvPr id="4" name="">
             <a:extLst xmlns:a="http://schemas.openxmlformats.org/drawingml/2006/main">
               <a:ext uri="{FF2B5EF4-FFF2-40B4-BE49-F238E27FC236}">
-                <a16:creationId xmlns:a16="http://schemas.microsoft.com/office/drawing/2014/main" id="{971F69BD-945C-484D-A6C4-89A52BEFDFDC}"/>
+                <a16:creationId xmlns:a16="http://schemas.microsoft.com/office/drawing/2014/main" id="{51BE5D98-E072-4C3F-9B93-02B3DD4887D0}"/>
               </a:ext>
             </a:extLst>
           </p:cNvPr>
@@ -5085,7 +5085,7 @@
     </p:spTree>
     <p:extLst>
       <p:ext uri="{BB962C8B-B14F-4D97-AF65-F5344CB8AC3E}">
-        <p14:creationId xmlns:p14="http://schemas.microsoft.com/office/powerpoint/2010/main" val="2071209131"/>
+        <p14:creationId xmlns:p14="http://schemas.microsoft.com/office/powerpoint/2010/main" val="1544480383"/>
       </p:ext>
     </p:extLst>
   </p:cSld>
@@ -5116,7 +5116,7 @@
           <p:cNvPr id="6" name="">
             <a:extLst xmlns:a="http://schemas.openxmlformats.org/drawingml/2006/main">
               <a:ext uri="{FF2B5EF4-FFF2-40B4-BE49-F238E27FC236}">
-                <a16:creationId xmlns:a16="http://schemas.microsoft.com/office/drawing/2014/main" id="{E7600D80-EC2B-4612-A924-A22A39999CCE}"/>
+                <a16:creationId xmlns:a16="http://schemas.microsoft.com/office/drawing/2014/main" id="{5A79F09B-DFDD-493B-A532-2A0AAFABE6EE}"/>
               </a:ext>
             </a:extLst>
           </p:cNvPr>
@@ -5173,7 +5173,7 @@
           <p:cNvPr id="2" name="">
             <a:extLst xmlns:a="http://schemas.openxmlformats.org/drawingml/2006/main">
               <a:ext uri="{FF2B5EF4-FFF2-40B4-BE49-F238E27FC236}">
-                <a16:creationId xmlns:a16="http://schemas.microsoft.com/office/drawing/2014/main" id="{0D0C8B76-EEC5-499B-B7A4-88B81B8BF956}"/>
+                <a16:creationId xmlns:a16="http://schemas.microsoft.com/office/drawing/2014/main" id="{EC65AE90-35AB-43EB-932A-939659AE5BEE}"/>
               </a:ext>
             </a:extLst>
           </p:cNvPr>
@@ -5230,7 +5230,7 @@
           <p:cNvPr id="3" name="">
             <a:extLst xmlns:a="http://schemas.openxmlformats.org/drawingml/2006/main">
               <a:ext uri="{FF2B5EF4-FFF2-40B4-BE49-F238E27FC236}">
-                <a16:creationId xmlns:a16="http://schemas.microsoft.com/office/drawing/2014/main" id="{6304849B-404E-4BBD-B6D5-1D619B7882F3}"/>
+                <a16:creationId xmlns:a16="http://schemas.microsoft.com/office/drawing/2014/main" id="{1F3F8DAB-5ED7-4123-880B-C0C684339BD8}"/>
               </a:ext>
             </a:extLst>
           </p:cNvPr>
@@ -5287,7 +5287,7 @@
           <p:cNvPr id="4" name="">
             <a:extLst xmlns:a="http://schemas.openxmlformats.org/drawingml/2006/main">
               <a:ext uri="{FF2B5EF4-FFF2-40B4-BE49-F238E27FC236}">
-                <a16:creationId xmlns:a16="http://schemas.microsoft.com/office/drawing/2014/main" id="{38549393-176D-45DE-938A-C966AFDDB7F4}"/>
+                <a16:creationId xmlns:a16="http://schemas.microsoft.com/office/drawing/2014/main" id="{0FAACD14-520A-4272-BE4C-2B8219168873}"/>
               </a:ext>
             </a:extLst>
           </p:cNvPr>
@@ -5400,7 +5400,7 @@
           <p:cNvPr id="5" name="">
             <a:extLst xmlns:a="http://schemas.openxmlformats.org/drawingml/2006/main">
               <a:ext uri="{FF2B5EF4-FFF2-40B4-BE49-F238E27FC236}">
-                <a16:creationId xmlns:a16="http://schemas.microsoft.com/office/drawing/2014/main" id="{B77BD5C1-C3B8-474D-BAE9-58BDABD6217C}"/>
+                <a16:creationId xmlns:a16="http://schemas.microsoft.com/office/drawing/2014/main" id="{9A04E0D6-CC71-4754-9839-FEEA49D76CF1}"/>
               </a:ext>
             </a:extLst>
           </p:cNvPr>
@@ -5455,7 +5455,7 @@
     </p:spTree>
     <p:extLst>
       <p:ext uri="{BB962C8B-B14F-4D97-AF65-F5344CB8AC3E}">
-        <p14:creationId xmlns:p14="http://schemas.microsoft.com/office/powerpoint/2010/main" val="991943503"/>
+        <p14:creationId xmlns:p14="http://schemas.microsoft.com/office/powerpoint/2010/main" val="1356938526"/>
       </p:ext>
     </p:extLst>
   </p:cSld>
@@ -5486,7 +5486,7 @@
           <p:cNvPr id="6" name="">
             <a:extLst xmlns:a="http://schemas.openxmlformats.org/drawingml/2006/main">
               <a:ext uri="{FF2B5EF4-FFF2-40B4-BE49-F238E27FC236}">
-                <a16:creationId xmlns:a16="http://schemas.microsoft.com/office/drawing/2014/main" id="{24A7A570-817F-4813-923F-E470ABE82653}"/>
+                <a16:creationId xmlns:a16="http://schemas.microsoft.com/office/drawing/2014/main" id="{66F01156-58D7-4974-B21F-5D6E08E638E0}"/>
               </a:ext>
             </a:extLst>
           </p:cNvPr>
@@ -5543,7 +5543,7 @@
           <p:cNvPr id="2" name="">
             <a:extLst xmlns:a="http://schemas.openxmlformats.org/drawingml/2006/main">
               <a:ext uri="{FF2B5EF4-FFF2-40B4-BE49-F238E27FC236}">
-                <a16:creationId xmlns:a16="http://schemas.microsoft.com/office/drawing/2014/main" id="{9C77A48B-3E3E-4EF9-82CF-6074368F2DF5}"/>
+                <a16:creationId xmlns:a16="http://schemas.microsoft.com/office/drawing/2014/main" id="{FA0D1CDD-4D61-48FE-8463-080362EFCDBF}"/>
               </a:ext>
             </a:extLst>
           </p:cNvPr>
@@ -5600,7 +5600,7 @@
           <p:cNvPr id="3" name="">
             <a:extLst xmlns:a="http://schemas.openxmlformats.org/drawingml/2006/main">
               <a:ext uri="{FF2B5EF4-FFF2-40B4-BE49-F238E27FC236}">
-                <a16:creationId xmlns:a16="http://schemas.microsoft.com/office/drawing/2014/main" id="{021F3AF5-74E0-449E-AB13-215D9425FB54}"/>
+                <a16:creationId xmlns:a16="http://schemas.microsoft.com/office/drawing/2014/main" id="{B93BD3CD-C46F-4328-BC48-A74BAE2FB25B}"/>
               </a:ext>
             </a:extLst>
           </p:cNvPr>
@@ -5657,7 +5657,7 @@
           <p:cNvPr id="4" name="">
             <a:extLst xmlns:a="http://schemas.openxmlformats.org/drawingml/2006/main">
               <a:ext uri="{FF2B5EF4-FFF2-40B4-BE49-F238E27FC236}">
-                <a16:creationId xmlns:a16="http://schemas.microsoft.com/office/drawing/2014/main" id="{A4CEF351-8D75-4548-A9A7-EF95365DC56D}"/>
+                <a16:creationId xmlns:a16="http://schemas.microsoft.com/office/drawing/2014/main" id="{1B189C31-7981-4390-9DCD-88E20DA50359}"/>
               </a:ext>
             </a:extLst>
           </p:cNvPr>
@@ -5770,7 +5770,7 @@
           <p:cNvPr id="5" name="">
             <a:extLst xmlns:a="http://schemas.openxmlformats.org/drawingml/2006/main">
               <a:ext uri="{FF2B5EF4-FFF2-40B4-BE49-F238E27FC236}">
-                <a16:creationId xmlns:a16="http://schemas.microsoft.com/office/drawing/2014/main" id="{59E3496F-DE82-4500-B606-6FC9185BDB7A}"/>
+                <a16:creationId xmlns:a16="http://schemas.microsoft.com/office/drawing/2014/main" id="{8C3FBB15-DFCB-4274-B077-7F120E584E15}"/>
               </a:ext>
             </a:extLst>
           </p:cNvPr>
@@ -5848,7 +5848,7 @@
     </p:spTree>
     <p:extLst>
       <p:ext uri="{BB962C8B-B14F-4D97-AF65-F5344CB8AC3E}">
-        <p14:creationId xmlns:p14="http://schemas.microsoft.com/office/powerpoint/2010/main" val="76419847"/>
+        <p14:creationId xmlns:p14="http://schemas.microsoft.com/office/powerpoint/2010/main" val="1743364757"/>
       </p:ext>
     </p:extLst>
   </p:cSld>
@@ -5879,7 +5879,7 @@
           <p:cNvPr id="6" name="">
             <a:extLst xmlns:a="http://schemas.openxmlformats.org/drawingml/2006/main">
               <a:ext uri="{FF2B5EF4-FFF2-40B4-BE49-F238E27FC236}">
-                <a16:creationId xmlns:a16="http://schemas.microsoft.com/office/drawing/2014/main" id="{044F6874-130F-4748-B8A6-0864B39A1C9B}"/>
+                <a16:creationId xmlns:a16="http://schemas.microsoft.com/office/drawing/2014/main" id="{EB18CE52-E026-47F4-958D-083C8E37FCD4}"/>
               </a:ext>
             </a:extLst>
           </p:cNvPr>
@@ -5936,7 +5936,7 @@
           <p:cNvPr id="2" name="">
             <a:extLst xmlns:a="http://schemas.openxmlformats.org/drawingml/2006/main">
               <a:ext uri="{FF2B5EF4-FFF2-40B4-BE49-F238E27FC236}">
-                <a16:creationId xmlns:a16="http://schemas.microsoft.com/office/drawing/2014/main" id="{79E11CB0-0F8B-4B40-AA45-552321085873}"/>
+                <a16:creationId xmlns:a16="http://schemas.microsoft.com/office/drawing/2014/main" id="{A939D080-25AB-417A-81F4-91270A035F1B}"/>
               </a:ext>
             </a:extLst>
           </p:cNvPr>
@@ -5993,7 +5993,7 @@
           <p:cNvPr id="3" name="">
             <a:extLst xmlns:a="http://schemas.openxmlformats.org/drawingml/2006/main">
               <a:ext uri="{FF2B5EF4-FFF2-40B4-BE49-F238E27FC236}">
-                <a16:creationId xmlns:a16="http://schemas.microsoft.com/office/drawing/2014/main" id="{08FB5C11-D550-439C-820F-E4750446E36E}"/>
+                <a16:creationId xmlns:a16="http://schemas.microsoft.com/office/drawing/2014/main" id="{C3945234-1D1C-4FFA-AAE1-DF05003EDADC}"/>
               </a:ext>
             </a:extLst>
           </p:cNvPr>
@@ -6050,7 +6050,7 @@
           <p:cNvPr id="4" name="">
             <a:extLst xmlns:a="http://schemas.openxmlformats.org/drawingml/2006/main">
               <a:ext uri="{FF2B5EF4-FFF2-40B4-BE49-F238E27FC236}">
-                <a16:creationId xmlns:a16="http://schemas.microsoft.com/office/drawing/2014/main" id="{F11C9278-B812-4D90-81FF-969402F962EA}"/>
+                <a16:creationId xmlns:a16="http://schemas.microsoft.com/office/drawing/2014/main" id="{140C4096-128B-41D5-9FF6-06272E5437FC}"/>
               </a:ext>
             </a:extLst>
           </p:cNvPr>
@@ -6163,7 +6163,7 @@
           <p:cNvPr id="5" name="">
             <a:extLst xmlns:a="http://schemas.openxmlformats.org/drawingml/2006/main">
               <a:ext uri="{FF2B5EF4-FFF2-40B4-BE49-F238E27FC236}">
-                <a16:creationId xmlns:a16="http://schemas.microsoft.com/office/drawing/2014/main" id="{8ABC2A7B-80C7-48E7-8A3A-99327E420003}"/>
+                <a16:creationId xmlns:a16="http://schemas.microsoft.com/office/drawing/2014/main" id="{DD3A7FBA-C054-4FC5-82B9-2EFADD8406EA}"/>
               </a:ext>
             </a:extLst>
           </p:cNvPr>
@@ -6218,7 +6218,7 @@
     </p:spTree>
     <p:extLst>
       <p:ext uri="{BB962C8B-B14F-4D97-AF65-F5344CB8AC3E}">
-        <p14:creationId xmlns:p14="http://schemas.microsoft.com/office/powerpoint/2010/main" val="1243842282"/>
+        <p14:creationId xmlns:p14="http://schemas.microsoft.com/office/powerpoint/2010/main" val="2110094228"/>
       </p:ext>
     </p:extLst>
   </p:cSld>
@@ -6249,7 +6249,7 @@
           <p:cNvPr id="7" name="">
             <a:extLst xmlns:a="http://schemas.openxmlformats.org/drawingml/2006/main">
               <a:ext uri="{FF2B5EF4-FFF2-40B4-BE49-F238E27FC236}">
-                <a16:creationId xmlns:a16="http://schemas.microsoft.com/office/drawing/2014/main" id="{C382FEA6-32CE-4F82-AC30-EF6C341D29EC}"/>
+                <a16:creationId xmlns:a16="http://schemas.microsoft.com/office/drawing/2014/main" id="{BD8683C2-8902-47BA-ACE1-A7F4DF9FB793}"/>
               </a:ext>
             </a:extLst>
           </p:cNvPr>
@@ -6306,7 +6306,7 @@
           <p:cNvPr id="2" name="">
             <a:extLst xmlns:a="http://schemas.openxmlformats.org/drawingml/2006/main">
               <a:ext uri="{FF2B5EF4-FFF2-40B4-BE49-F238E27FC236}">
-                <a16:creationId xmlns:a16="http://schemas.microsoft.com/office/drawing/2014/main" id="{81328DB9-07DF-414B-9439-1A51994AB994}"/>
+                <a16:creationId xmlns:a16="http://schemas.microsoft.com/office/drawing/2014/main" id="{570140A7-D266-4DEF-9AD7-449C4DF17345}"/>
               </a:ext>
             </a:extLst>
           </p:cNvPr>
@@ -6363,7 +6363,7 @@
           <p:cNvPr id="3" name="">
             <a:extLst xmlns:a="http://schemas.openxmlformats.org/drawingml/2006/main">
               <a:ext uri="{FF2B5EF4-FFF2-40B4-BE49-F238E27FC236}">
-                <a16:creationId xmlns:a16="http://schemas.microsoft.com/office/drawing/2014/main" id="{3EA7DCD4-FECC-4CEB-8255-1615D50B4B22}"/>
+                <a16:creationId xmlns:a16="http://schemas.microsoft.com/office/drawing/2014/main" id="{9B247B6E-779C-42E6-81CC-A7936102E516}"/>
               </a:ext>
             </a:extLst>
           </p:cNvPr>
@@ -6836,7 +6836,7 @@
           <p:cNvPr id="5" name="">
             <a:extLst xmlns:a="http://schemas.openxmlformats.org/drawingml/2006/main">
               <a:ext uri="{FF2B5EF4-FFF2-40B4-BE49-F238E27FC236}">
-                <a16:creationId xmlns:a16="http://schemas.microsoft.com/office/drawing/2014/main" id="{4E0EA83A-B5BB-4513-9635-7B87DD718840}"/>
+                <a16:creationId xmlns:a16="http://schemas.microsoft.com/office/drawing/2014/main" id="{21FE0A07-C5D4-41BF-BCE4-8CF2C760B212}"/>
               </a:ext>
             </a:extLst>
           </p:cNvPr>
@@ -6921,7 +6921,7 @@
           <p:cNvPr id="6" name="">
             <a:extLst xmlns:a="http://schemas.openxmlformats.org/drawingml/2006/main">
               <a:ext uri="{FF2B5EF4-FFF2-40B4-BE49-F238E27FC236}">
-                <a16:creationId xmlns:a16="http://schemas.microsoft.com/office/drawing/2014/main" id="{F2049937-290E-44AE-9209-C791B1F5C372}"/>
+                <a16:creationId xmlns:a16="http://schemas.microsoft.com/office/drawing/2014/main" id="{4FE8459D-823B-4ED6-8B14-4E274FFA8478}"/>
               </a:ext>
             </a:extLst>
           </p:cNvPr>
@@ -6976,7 +6976,7 @@
     </p:spTree>
     <p:extLst>
       <p:ext uri="{BB962C8B-B14F-4D97-AF65-F5344CB8AC3E}">
-        <p14:creationId xmlns:p14="http://schemas.microsoft.com/office/powerpoint/2010/main" val="1242275336"/>
+        <p14:creationId xmlns:p14="http://schemas.microsoft.com/office/powerpoint/2010/main" val="567590007"/>
       </p:ext>
     </p:extLst>
   </p:cSld>
@@ -7007,7 +7007,7 @@
           <p:cNvPr id="7" name="">
             <a:extLst xmlns:a="http://schemas.openxmlformats.org/drawingml/2006/main">
               <a:ext uri="{FF2B5EF4-FFF2-40B4-BE49-F238E27FC236}">
-                <a16:creationId xmlns:a16="http://schemas.microsoft.com/office/drawing/2014/main" id="{E2B4374B-5EEF-45A1-9363-694734D0EBB3}"/>
+                <a16:creationId xmlns:a16="http://schemas.microsoft.com/office/drawing/2014/main" id="{7A56CA47-4BF8-4159-A699-05C1124717D2}"/>
               </a:ext>
             </a:extLst>
           </p:cNvPr>
@@ -7064,7 +7064,7 @@
           <p:cNvPr id="2" name="">
             <a:extLst xmlns:a="http://schemas.openxmlformats.org/drawingml/2006/main">
               <a:ext uri="{FF2B5EF4-FFF2-40B4-BE49-F238E27FC236}">
-                <a16:creationId xmlns:a16="http://schemas.microsoft.com/office/drawing/2014/main" id="{2F9AC65A-CAF8-4DF3-9854-0052A0620D18}"/>
+                <a16:creationId xmlns:a16="http://schemas.microsoft.com/office/drawing/2014/main" id="{AFF113A7-4918-49C3-B14D-CF3799599A47}"/>
               </a:ext>
             </a:extLst>
           </p:cNvPr>
@@ -7121,7 +7121,7 @@
           <p:cNvPr id="3" name="">
             <a:extLst xmlns:a="http://schemas.openxmlformats.org/drawingml/2006/main">
               <a:ext uri="{FF2B5EF4-FFF2-40B4-BE49-F238E27FC236}">
-                <a16:creationId xmlns:a16="http://schemas.microsoft.com/office/drawing/2014/main" id="{8B79825F-4CB1-4E04-B63D-E9F9E37E2602}"/>
+                <a16:creationId xmlns:a16="http://schemas.microsoft.com/office/drawing/2014/main" id="{A28F80F0-BBD9-4FE6-A36B-EC9AB438C09B}"/>
               </a:ext>
             </a:extLst>
           </p:cNvPr>
@@ -7178,7 +7178,7 @@
           <p:cNvPr id="4" name="">
             <a:extLst xmlns:a="http://schemas.openxmlformats.org/drawingml/2006/main">
               <a:ext uri="{FF2B5EF4-FFF2-40B4-BE49-F238E27FC236}">
-                <a16:creationId xmlns:a16="http://schemas.microsoft.com/office/drawing/2014/main" id="{C08212D9-9188-4C36-96E1-C7992564242C}"/>
+                <a16:creationId xmlns:a16="http://schemas.microsoft.com/office/drawing/2014/main" id="{3F6B693C-CBD9-4B86-8426-0970F20BE0EE}"/>
               </a:ext>
             </a:extLst>
           </p:cNvPr>
@@ -7319,7 +7319,7 @@
           <p:cNvPr id="5" name="">
             <a:extLst xmlns:a="http://schemas.openxmlformats.org/drawingml/2006/main">
               <a:ext uri="{FF2B5EF4-FFF2-40B4-BE49-F238E27FC236}">
-                <a16:creationId xmlns:a16="http://schemas.microsoft.com/office/drawing/2014/main" id="{EDA61498-4EB6-4476-AEF7-300C0309C215}"/>
+                <a16:creationId xmlns:a16="http://schemas.microsoft.com/office/drawing/2014/main" id="{A1446670-385B-46FC-B2FD-D5B75FED6128}"/>
               </a:ext>
             </a:extLst>
           </p:cNvPr>
@@ -7422,7 +7422,7 @@
           <p:cNvPr id="6" name="">
             <a:extLst xmlns:a="http://schemas.openxmlformats.org/drawingml/2006/main">
               <a:ext uri="{FF2B5EF4-FFF2-40B4-BE49-F238E27FC236}">
-                <a16:creationId xmlns:a16="http://schemas.microsoft.com/office/drawing/2014/main" id="{621BED62-59E4-4375-9AF2-D21CD965847F}"/>
+                <a16:creationId xmlns:a16="http://schemas.microsoft.com/office/drawing/2014/main" id="{D74E583E-9E43-47C4-8958-530DF5A2CB43}"/>
               </a:ext>
             </a:extLst>
           </p:cNvPr>
@@ -7477,7 +7477,7 @@
     </p:spTree>
     <p:extLst>
       <p:ext uri="{BB962C8B-B14F-4D97-AF65-F5344CB8AC3E}">
-        <p14:creationId xmlns:p14="http://schemas.microsoft.com/office/powerpoint/2010/main" val="1818488791"/>
+        <p14:creationId xmlns:p14="http://schemas.microsoft.com/office/powerpoint/2010/main" val="1229558058"/>
       </p:ext>
     </p:extLst>
   </p:cSld>
@@ -7508,7 +7508,7 @@
           <p:cNvPr id="6" name="">
             <a:extLst xmlns:a="http://schemas.openxmlformats.org/drawingml/2006/main">
               <a:ext uri="{FF2B5EF4-FFF2-40B4-BE49-F238E27FC236}">
-                <a16:creationId xmlns:a16="http://schemas.microsoft.com/office/drawing/2014/main" id="{3AD65419-AE2D-47ED-9E30-753BB1718424}"/>
+                <a16:creationId xmlns:a16="http://schemas.microsoft.com/office/drawing/2014/main" id="{CBD13E73-9223-4268-AD0E-95C02E1810A0}"/>
               </a:ext>
             </a:extLst>
           </p:cNvPr>
@@ -7565,7 +7565,7 @@
           <p:cNvPr id="2" name="">
             <a:extLst xmlns:a="http://schemas.openxmlformats.org/drawingml/2006/main">
               <a:ext uri="{FF2B5EF4-FFF2-40B4-BE49-F238E27FC236}">
-                <a16:creationId xmlns:a16="http://schemas.microsoft.com/office/drawing/2014/main" id="{26768E4B-B51F-4B09-A5F2-9BC960B15745}"/>
+                <a16:creationId xmlns:a16="http://schemas.microsoft.com/office/drawing/2014/main" id="{B99D2ED9-18A5-4D9E-9C03-AE53A5F64B08}"/>
               </a:ext>
             </a:extLst>
           </p:cNvPr>
@@ -7622,7 +7622,7 @@
           <p:cNvPr id="3" name="">
             <a:extLst xmlns:a="http://schemas.openxmlformats.org/drawingml/2006/main">
               <a:ext uri="{FF2B5EF4-FFF2-40B4-BE49-F238E27FC236}">
-                <a16:creationId xmlns:a16="http://schemas.microsoft.com/office/drawing/2014/main" id="{DD23FF3D-E33F-4F56-9DA0-E112797AB8B7}"/>
+                <a16:creationId xmlns:a16="http://schemas.microsoft.com/office/drawing/2014/main" id="{B80E32FC-CB54-43EE-901C-ADD7C44B1BD9}"/>
               </a:ext>
             </a:extLst>
           </p:cNvPr>
@@ -7679,7 +7679,7 @@
           <p:cNvPr id="4" name="">
             <a:extLst xmlns:a="http://schemas.openxmlformats.org/drawingml/2006/main">
               <a:ext uri="{FF2B5EF4-FFF2-40B4-BE49-F238E27FC236}">
-                <a16:creationId xmlns:a16="http://schemas.microsoft.com/office/drawing/2014/main" id="{64D62F80-28AB-42F2-8AAC-92825A41366F}"/>
+                <a16:creationId xmlns:a16="http://schemas.microsoft.com/office/drawing/2014/main" id="{DDB79063-9754-4CF6-8F7D-58E7BF13A463}"/>
               </a:ext>
             </a:extLst>
           </p:cNvPr>
@@ -7792,7 +7792,7 @@
           <p:cNvPr id="5" name="">
             <a:extLst xmlns:a="http://schemas.openxmlformats.org/drawingml/2006/main">
               <a:ext uri="{FF2B5EF4-FFF2-40B4-BE49-F238E27FC236}">
-                <a16:creationId xmlns:a16="http://schemas.microsoft.com/office/drawing/2014/main" id="{284BAB30-1A34-4875-AAB6-7C6831906B0E}"/>
+                <a16:creationId xmlns:a16="http://schemas.microsoft.com/office/drawing/2014/main" id="{6CB3C2C4-D83F-4E9C-86F1-40430A48D470}"/>
               </a:ext>
             </a:extLst>
           </p:cNvPr>
@@ -7893,7 +7893,7 @@
     </p:spTree>
     <p:extLst>
       <p:ext uri="{BB962C8B-B14F-4D97-AF65-F5344CB8AC3E}">
-        <p14:creationId xmlns:p14="http://schemas.microsoft.com/office/powerpoint/2010/main" val="872823588"/>
+        <p14:creationId xmlns:p14="http://schemas.microsoft.com/office/powerpoint/2010/main" val="334347254"/>
       </p:ext>
     </p:extLst>
   </p:cSld>
@@ -7924,7 +7924,7 @@
           <p:cNvPr id="7" name="">
             <a:extLst xmlns:a="http://schemas.openxmlformats.org/drawingml/2006/main">
               <a:ext uri="{FF2B5EF4-FFF2-40B4-BE49-F238E27FC236}">
-                <a16:creationId xmlns:a16="http://schemas.microsoft.com/office/drawing/2014/main" id="{B0AA2F7A-9824-40AC-A440-AB900DA5BD57}"/>
+                <a16:creationId xmlns:a16="http://schemas.microsoft.com/office/drawing/2014/main" id="{E7B8D03E-5FA7-4859-BB2C-E4DE01B83D7A}"/>
               </a:ext>
             </a:extLst>
           </p:cNvPr>
@@ -7981,7 +7981,7 @@
           <p:cNvPr id="2" name="">
             <a:extLst xmlns:a="http://schemas.openxmlformats.org/drawingml/2006/main">
               <a:ext uri="{FF2B5EF4-FFF2-40B4-BE49-F238E27FC236}">
-                <a16:creationId xmlns:a16="http://schemas.microsoft.com/office/drawing/2014/main" id="{8862D0A0-4463-4CA2-9563-6FF88D67315B}"/>
+                <a16:creationId xmlns:a16="http://schemas.microsoft.com/office/drawing/2014/main" id="{C91AE3DA-02A1-41CF-8C1A-236F28F43D48}"/>
               </a:ext>
             </a:extLst>
           </p:cNvPr>
@@ -8038,7 +8038,7 @@
           <p:cNvPr id="3" name="">
             <a:extLst xmlns:a="http://schemas.openxmlformats.org/drawingml/2006/main">
               <a:ext uri="{FF2B5EF4-FFF2-40B4-BE49-F238E27FC236}">
-                <a16:creationId xmlns:a16="http://schemas.microsoft.com/office/drawing/2014/main" id="{8541FE2F-EE22-42AD-B6B5-5B4BA7335B98}"/>
+                <a16:creationId xmlns:a16="http://schemas.microsoft.com/office/drawing/2014/main" id="{22B15E07-C8D2-42AA-AE3F-A040AD7F0E37}"/>
               </a:ext>
             </a:extLst>
           </p:cNvPr>
@@ -8095,7 +8095,7 @@
           <p:cNvPr id="4" name="">
             <a:extLst xmlns:a="http://schemas.openxmlformats.org/drawingml/2006/main">
               <a:ext uri="{FF2B5EF4-FFF2-40B4-BE49-F238E27FC236}">
-                <a16:creationId xmlns:a16="http://schemas.microsoft.com/office/drawing/2014/main" id="{6D737F55-8A28-41BC-9C57-DE5DD8D0214B}"/>
+                <a16:creationId xmlns:a16="http://schemas.microsoft.com/office/drawing/2014/main" id="{A52A84F4-5C18-4E4A-A818-52F4F00D354A}"/>
               </a:ext>
             </a:extLst>
           </p:cNvPr>
@@ -8180,7 +8180,7 @@
           <p:cNvPr id="5" name="">
             <a:extLst xmlns:a="http://schemas.openxmlformats.org/drawingml/2006/main">
               <a:ext uri="{FF2B5EF4-FFF2-40B4-BE49-F238E27FC236}">
-                <a16:creationId xmlns:a16="http://schemas.microsoft.com/office/drawing/2014/main" id="{2797EC1D-EFE8-4DDF-A250-0E927B1E1937}"/>
+                <a16:creationId xmlns:a16="http://schemas.microsoft.com/office/drawing/2014/main" id="{EFC5C609-B701-46A9-AC82-ECCFED5C0B33}"/>
               </a:ext>
             </a:extLst>
           </p:cNvPr>
@@ -8283,7 +8283,7 @@
           <p:cNvPr id="6" name="">
             <a:extLst xmlns:a="http://schemas.openxmlformats.org/drawingml/2006/main">
               <a:ext uri="{FF2B5EF4-FFF2-40B4-BE49-F238E27FC236}">
-                <a16:creationId xmlns:a16="http://schemas.microsoft.com/office/drawing/2014/main" id="{49C5674A-412F-47AE-9B20-45DF65A388FC}"/>
+                <a16:creationId xmlns:a16="http://schemas.microsoft.com/office/drawing/2014/main" id="{398744DC-4521-4AB8-B79E-1E647749D198}"/>
               </a:ext>
             </a:extLst>
           </p:cNvPr>
@@ -8338,7 +8338,7 @@
     </p:spTree>
     <p:extLst>
       <p:ext uri="{BB962C8B-B14F-4D97-AF65-F5344CB8AC3E}">
-        <p14:creationId xmlns:p14="http://schemas.microsoft.com/office/powerpoint/2010/main" val="237674924"/>
+        <p14:creationId xmlns:p14="http://schemas.microsoft.com/office/powerpoint/2010/main" val="1781508192"/>
       </p:ext>
     </p:extLst>
   </p:cSld>
@@ -8369,7 +8369,7 @@
           <p:cNvPr id="7" name="">
             <a:extLst xmlns:a="http://schemas.openxmlformats.org/drawingml/2006/main">
               <a:ext uri="{FF2B5EF4-FFF2-40B4-BE49-F238E27FC236}">
-                <a16:creationId xmlns:a16="http://schemas.microsoft.com/office/drawing/2014/main" id="{F2002B98-DBEE-47B1-B91E-DC5C5ACA4548}"/>
+                <a16:creationId xmlns:a16="http://schemas.microsoft.com/office/drawing/2014/main" id="{4562F9B2-F638-4E76-A483-33E66FD6245E}"/>
               </a:ext>
             </a:extLst>
           </p:cNvPr>
@@ -8426,7 +8426,7 @@
           <p:cNvPr id="2" name="">
             <a:extLst xmlns:a="http://schemas.openxmlformats.org/drawingml/2006/main">
               <a:ext uri="{FF2B5EF4-FFF2-40B4-BE49-F238E27FC236}">
-                <a16:creationId xmlns:a16="http://schemas.microsoft.com/office/drawing/2014/main" id="{8CC93428-7895-4618-9C9F-1E470B3DB88B}"/>
+                <a16:creationId xmlns:a16="http://schemas.microsoft.com/office/drawing/2014/main" id="{FEF2B515-5173-4B85-86AD-E8B4BADF0F91}"/>
               </a:ext>
             </a:extLst>
           </p:cNvPr>
@@ -8483,7 +8483,7 @@
           <p:cNvPr id="3" name="">
             <a:extLst xmlns:a="http://schemas.openxmlformats.org/drawingml/2006/main">
               <a:ext uri="{FF2B5EF4-FFF2-40B4-BE49-F238E27FC236}">
-                <a16:creationId xmlns:a16="http://schemas.microsoft.com/office/drawing/2014/main" id="{A2177AE7-3CF3-430D-BA11-4BECB2352388}"/>
+                <a16:creationId xmlns:a16="http://schemas.microsoft.com/office/drawing/2014/main" id="{AA868AC3-9493-4B5A-8AF2-91D404C2C0E9}"/>
               </a:ext>
             </a:extLst>
           </p:cNvPr>
@@ -8544,7 +8544,7 @@
           <p:nvPr/>
         </p:nvPicPr>
         <p:blipFill>
-          <a:blip xmlns:r="http://schemas.openxmlformats.org/officeDocument/2006/relationships" xmlns:a="http://schemas.openxmlformats.org/drawingml/2006/main" r:embed="R99d400a2c64241a8"/>
+          <a:blip xmlns:r="http://schemas.openxmlformats.org/officeDocument/2006/relationships" xmlns:a="http://schemas.openxmlformats.org/drawingml/2006/main" r:embed="R02daadb73a384a44"/>
           <a:stretch xmlns:a="http://schemas.openxmlformats.org/drawingml/2006/main"/>
         </p:blipFill>
         <p:spPr>
@@ -8562,7 +8562,7 @@
           <p:cNvPr id="5" name="">
             <a:extLst xmlns:a="http://schemas.openxmlformats.org/drawingml/2006/main">
               <a:ext uri="{FF2B5EF4-FFF2-40B4-BE49-F238E27FC236}">
-                <a16:creationId xmlns:a16="http://schemas.microsoft.com/office/drawing/2014/main" id="{556E404A-7271-4FF6-91FA-7C02CAA1D86D}"/>
+                <a16:creationId xmlns:a16="http://schemas.microsoft.com/office/drawing/2014/main" id="{AAB277D1-7128-40FD-8839-9145F9ACDFFE}"/>
               </a:ext>
             </a:extLst>
           </p:cNvPr>
@@ -8619,7 +8619,7 @@
           <p:cNvPr id="6" name="">
             <a:extLst xmlns:a="http://schemas.openxmlformats.org/drawingml/2006/main">
               <a:ext uri="{FF2B5EF4-FFF2-40B4-BE49-F238E27FC236}">
-                <a16:creationId xmlns:a16="http://schemas.microsoft.com/office/drawing/2014/main" id="{933D0E42-4DE5-4598-9013-BDFA85FE8B24}"/>
+                <a16:creationId xmlns:a16="http://schemas.microsoft.com/office/drawing/2014/main" id="{A3F2BD95-23F8-45E7-98C1-FD3ABA86E899}"/>
               </a:ext>
             </a:extLst>
           </p:cNvPr>
@@ -8674,7 +8674,7 @@
     </p:spTree>
     <p:extLst>
       <p:ext uri="{BB962C8B-B14F-4D97-AF65-F5344CB8AC3E}">
-        <p14:creationId xmlns:p14="http://schemas.microsoft.com/office/powerpoint/2010/main" val="97481855"/>
+        <p14:creationId xmlns:p14="http://schemas.microsoft.com/office/powerpoint/2010/main" val="1255033957"/>
       </p:ext>
     </p:extLst>
   </p:cSld>

</xml_diff>

<commit_message>
Replace week 4 covers with cloud infrastructure diagrams (#43)
</commit_message>
<xml_diff>
--- a/lendet/2026-2027/mobile/lectures/ligjerata-04-neon-postgresql-rideshare-2026.pptx
+++ b/lendet/2026-2027/mobile/lectures/ligjerata-04-neon-postgresql-rideshare-2026.pptx
@@ -2,28 +2,28 @@
 <file path=ppt/presentation.xml><?xml version="1.0" encoding="utf-8"?>
 <p:presentation xmlns:p="http://schemas.openxmlformats.org/presentationml/2006/main">
   <p:sldMasterIdLst>
-    <p:sldMasterId xmlns:r="http://schemas.openxmlformats.org/officeDocument/2006/relationships" id="2147483648" r:id="R32f700e982f04b62"/>
+    <p:sldMasterId xmlns:r="http://schemas.openxmlformats.org/officeDocument/2006/relationships" id="2147483648" r:id="R32c6a9eb752d418c"/>
   </p:sldMasterIdLst>
   <p:sldIdLst>
-    <p:sldId xmlns:r="http://schemas.openxmlformats.org/officeDocument/2006/relationships" id="256" r:id="R0b58241ca65c4a25"/>
-    <p:sldId xmlns:r="http://schemas.openxmlformats.org/officeDocument/2006/relationships" id="257" r:id="R1b08c80eb2854183"/>
-    <p:sldId xmlns:r="http://schemas.openxmlformats.org/officeDocument/2006/relationships" id="258" r:id="R04221dabb39d48ab"/>
-    <p:sldId xmlns:r="http://schemas.openxmlformats.org/officeDocument/2006/relationships" id="259" r:id="R9579cb5cf91147ab"/>
-    <p:sldId xmlns:r="http://schemas.openxmlformats.org/officeDocument/2006/relationships" id="260" r:id="R68057e8fac5c4adf"/>
-    <p:sldId xmlns:r="http://schemas.openxmlformats.org/officeDocument/2006/relationships" id="261" r:id="Re270c51eb55c4cd3"/>
-    <p:sldId xmlns:r="http://schemas.openxmlformats.org/officeDocument/2006/relationships" id="262" r:id="Ra926b2f054134575"/>
-    <p:sldId xmlns:r="http://schemas.openxmlformats.org/officeDocument/2006/relationships" id="263" r:id="R43da0ced30d34969"/>
-    <p:sldId xmlns:r="http://schemas.openxmlformats.org/officeDocument/2006/relationships" id="264" r:id="R051e3f8fba1f44ff"/>
-    <p:sldId xmlns:r="http://schemas.openxmlformats.org/officeDocument/2006/relationships" id="265" r:id="R9639caeb60ec4bdb"/>
-    <p:sldId xmlns:r="http://schemas.openxmlformats.org/officeDocument/2006/relationships" id="266" r:id="Rdaf5fcf9055c40e3"/>
-    <p:sldId xmlns:r="http://schemas.openxmlformats.org/officeDocument/2006/relationships" id="267" r:id="Rb7f18537419343c1"/>
-    <p:sldId xmlns:r="http://schemas.openxmlformats.org/officeDocument/2006/relationships" id="268" r:id="R54faa88fb0da400f"/>
-    <p:sldId xmlns:r="http://schemas.openxmlformats.org/officeDocument/2006/relationships" id="269" r:id="R0d90b6d7a7b940b0"/>
-    <p:sldId xmlns:r="http://schemas.openxmlformats.org/officeDocument/2006/relationships" id="270" r:id="R124c16c5404a4ef3"/>
-    <p:sldId xmlns:r="http://schemas.openxmlformats.org/officeDocument/2006/relationships" id="271" r:id="R4b6017b86c7a430f"/>
-    <p:sldId xmlns:r="http://schemas.openxmlformats.org/officeDocument/2006/relationships" id="272" r:id="R870c7b9d29244f78"/>
-    <p:sldId xmlns:r="http://schemas.openxmlformats.org/officeDocument/2006/relationships" id="273" r:id="R878a77bad1e34ea8"/>
-    <p:sldId xmlns:r="http://schemas.openxmlformats.org/officeDocument/2006/relationships" id="274" r:id="R549bd33a29c84bc2"/>
+    <p:sldId xmlns:r="http://schemas.openxmlformats.org/officeDocument/2006/relationships" id="256" r:id="Ra876a60a489f4bc9"/>
+    <p:sldId xmlns:r="http://schemas.openxmlformats.org/officeDocument/2006/relationships" id="257" r:id="R225528af12c04fbc"/>
+    <p:sldId xmlns:r="http://schemas.openxmlformats.org/officeDocument/2006/relationships" id="258" r:id="Rb9528da0e9694116"/>
+    <p:sldId xmlns:r="http://schemas.openxmlformats.org/officeDocument/2006/relationships" id="259" r:id="Re8aca3b46b15401f"/>
+    <p:sldId xmlns:r="http://schemas.openxmlformats.org/officeDocument/2006/relationships" id="260" r:id="R2bd05c2b2ee94015"/>
+    <p:sldId xmlns:r="http://schemas.openxmlformats.org/officeDocument/2006/relationships" id="261" r:id="Rf11bb080a3254ff9"/>
+    <p:sldId xmlns:r="http://schemas.openxmlformats.org/officeDocument/2006/relationships" id="262" r:id="Rf4ebb075ec0b41a3"/>
+    <p:sldId xmlns:r="http://schemas.openxmlformats.org/officeDocument/2006/relationships" id="263" r:id="Rc0be5e9fa4d24ca2"/>
+    <p:sldId xmlns:r="http://schemas.openxmlformats.org/officeDocument/2006/relationships" id="264" r:id="Raa28d02aa4bf4d1b"/>
+    <p:sldId xmlns:r="http://schemas.openxmlformats.org/officeDocument/2006/relationships" id="265" r:id="Rf6dd8d9e2c2c4017"/>
+    <p:sldId xmlns:r="http://schemas.openxmlformats.org/officeDocument/2006/relationships" id="266" r:id="R5a01840c332146a0"/>
+    <p:sldId xmlns:r="http://schemas.openxmlformats.org/officeDocument/2006/relationships" id="267" r:id="R77137f03398e4e14"/>
+    <p:sldId xmlns:r="http://schemas.openxmlformats.org/officeDocument/2006/relationships" id="268" r:id="Rdea3d882bc2445f3"/>
+    <p:sldId xmlns:r="http://schemas.openxmlformats.org/officeDocument/2006/relationships" id="269" r:id="R3d965ea79fbe4b45"/>
+    <p:sldId xmlns:r="http://schemas.openxmlformats.org/officeDocument/2006/relationships" id="270" r:id="R67d24730111e4ccc"/>
+    <p:sldId xmlns:r="http://schemas.openxmlformats.org/officeDocument/2006/relationships" id="271" r:id="R4c82b1a80aef41eb"/>
+    <p:sldId xmlns:r="http://schemas.openxmlformats.org/officeDocument/2006/relationships" id="272" r:id="R0bd03a94435e4390"/>
+    <p:sldId xmlns:r="http://schemas.openxmlformats.org/officeDocument/2006/relationships" id="273" r:id="Ra87217fc09a54fdb"/>
+    <p:sldId xmlns:r="http://schemas.openxmlformats.org/officeDocument/2006/relationships" id="274" r:id="R8708fb9bb89f445c"/>
   </p:sldIdLst>
   <p:sldSz cx="12192000" cy="6858000"/>
   <p:notesSz cx="6858000" cy="9144000"/>
@@ -68,7 +68,7 @@
   </p:cSld>
   <p:clrMap bg1="lt1" tx1="dk1" bg2="lt2" tx2="dk2" accent1="accent1" accent2="accent2" accent3="accent3" accent4="accent4" accent5="accent5" accent6="accent6" hlink="hlink" folHlink="folHlink"/>
   <p:sldLayoutIdLst>
-    <p:sldLayoutId xmlns:r="http://schemas.openxmlformats.org/officeDocument/2006/relationships" id="2147483649" r:id="R74ad0ca9acd54305"/>
+    <p:sldLayoutId xmlns:r="http://schemas.openxmlformats.org/officeDocument/2006/relationships" id="2147483649" r:id="Ra7786729b4264688"/>
   </p:sldLayoutIdLst>
   <p:txStyles>
     <p:titleStyle>
@@ -619,7 +619,7 @@
           <p:cNvPr id="7" name="">
             <a:extLst xmlns:a="http://schemas.openxmlformats.org/drawingml/2006/main">
               <a:ext uri="{FF2B5EF4-FFF2-40B4-BE49-F238E27FC236}">
-                <a16:creationId xmlns:a16="http://schemas.microsoft.com/office/drawing/2014/main" id="{6064AF25-45BB-47C9-8EF5-E05D74068521}"/>
+                <a16:creationId xmlns:a16="http://schemas.microsoft.com/office/drawing/2014/main" id="{E4444AD0-3908-485E-8C65-76827F43EC53}"/>
               </a:ext>
             </a:extLst>
           </p:cNvPr>
@@ -676,7 +676,7 @@
           <p:cNvPr id="2" name="">
             <a:extLst xmlns:a="http://schemas.openxmlformats.org/drawingml/2006/main">
               <a:ext uri="{FF2B5EF4-FFF2-40B4-BE49-F238E27FC236}">
-                <a16:creationId xmlns:a16="http://schemas.microsoft.com/office/drawing/2014/main" id="{84C947D0-34F6-41A3-934C-AC377664CC35}"/>
+                <a16:creationId xmlns:a16="http://schemas.microsoft.com/office/drawing/2014/main" id="{8FE48659-1822-4FBB-AC30-6EA0B984A49E}"/>
               </a:ext>
             </a:extLst>
           </p:cNvPr>
@@ -737,7 +737,7 @@
           <p:nvPr/>
         </p:nvPicPr>
         <p:blipFill>
-          <a:blip xmlns:r="http://schemas.openxmlformats.org/officeDocument/2006/relationships" xmlns:a="http://schemas.openxmlformats.org/drawingml/2006/main" r:embed="Ra635b39037004be5"/>
+          <a:blip xmlns:r="http://schemas.openxmlformats.org/officeDocument/2006/relationships" xmlns:a="http://schemas.openxmlformats.org/drawingml/2006/main" r:embed="R7b9fbe3177c94231"/>
           <a:stretch xmlns:a="http://schemas.openxmlformats.org/drawingml/2006/main"/>
         </p:blipFill>
         <p:spPr>
@@ -755,7 +755,7 @@
           <p:cNvPr id="4" name="">
             <a:extLst xmlns:a="http://schemas.openxmlformats.org/drawingml/2006/main">
               <a:ext uri="{FF2B5EF4-FFF2-40B4-BE49-F238E27FC236}">
-                <a16:creationId xmlns:a16="http://schemas.microsoft.com/office/drawing/2014/main" id="{1529EFF1-364B-4D09-B31B-4B1DFEC03C2E}"/>
+                <a16:creationId xmlns:a16="http://schemas.microsoft.com/office/drawing/2014/main" id="{6CB606FB-A592-4FEC-9B03-B98CDF1CEAB6}"/>
               </a:ext>
             </a:extLst>
           </p:cNvPr>
@@ -802,7 +802,7 @@
                 <a:ea typeface="Arial"/>
                 <a:cs typeface="Arial"/>
               </a:rPr>
-              <a:t>RideShare mban mend udhëtimet</a:t>
+              <a:t>Si komunikon RideShare me databazën</a:t>
             </a:r>
           </a:p>
         </p:txBody>
@@ -816,13 +816,13 @@
           <p:nvPr/>
         </p:nvPicPr>
         <p:blipFill>
-          <a:blip xmlns:r="http://schemas.openxmlformats.org/officeDocument/2006/relationships" xmlns:a="http://schemas.openxmlformats.org/drawingml/2006/main" r:embed="R0ec69f57b29549c1"/>
+          <a:blip xmlns:r="http://schemas.openxmlformats.org/officeDocument/2006/relationships" xmlns:a="http://schemas.openxmlformats.org/drawingml/2006/main" r:embed="Rcb89d66de114409e"/>
           <a:stretch xmlns:a="http://schemas.openxmlformats.org/drawingml/2006/main"/>
         </p:blipFill>
         <p:spPr>
           <a:xfrm xmlns:a="http://schemas.openxmlformats.org/drawingml/2006/main">
-            <a:off x="2659297" y="1666875"/>
-            <a:ext cx="6854356" cy="3857625"/>
+            <a:off x="609600" y="1770063"/>
+            <a:ext cx="10953750" cy="3651250"/>
           </a:xfrm>
           <a:prstGeom xmlns:a="http://schemas.openxmlformats.org/drawingml/2006/main" prst="rect">
             <a:avLst/>
@@ -834,7 +834,7 @@
           <p:cNvPr id="6" name="">
             <a:extLst xmlns:a="http://schemas.openxmlformats.org/drawingml/2006/main">
               <a:ext uri="{FF2B5EF4-FFF2-40B4-BE49-F238E27FC236}">
-                <a16:creationId xmlns:a16="http://schemas.microsoft.com/office/drawing/2014/main" id="{C9ABD680-DE0C-45AB-A475-3307236780BF}"/>
+                <a16:creationId xmlns:a16="http://schemas.microsoft.com/office/drawing/2014/main" id="{17F57B7F-A1A6-49D8-82EC-535634866DD5}"/>
               </a:ext>
             </a:extLst>
           </p:cNvPr>
@@ -881,7 +881,7 @@
                 <a:ea typeface="Arial"/>
                 <a:cs typeface="Arial"/>
               </a:rPr>
-              <a:t>Javën e kaluar ndërtuam ekranet. Sot u japim një burim të përbashkët të dhënash.</a:t>
+              <a:t>Telefoni kërkon faqen. Next.js lexon udhëtimet në Neon dhe kthen pamjen.</a:t>
             </a:r>
           </a:p>
           <a:p xmlns:a="http://schemas.openxmlformats.org/drawingml/2006/main">
@@ -904,7 +904,7 @@
                 <a:ea typeface="Arial"/>
                 <a:cs typeface="Arial"/>
               </a:rPr>
-              <a:t>Neon + PostgreSQL · Ligjëratë 45 minuta për secilin grup</a:t>
+              <a:t>GitHub ruan kodin. Vercel ekzekuton aplikacionin. Neon ruan të dhënat.</a:t>
             </a:r>
           </a:p>
         </p:txBody>
@@ -912,7 +912,7 @@
     </p:spTree>
     <p:extLst>
       <p:ext uri="{BB962C8B-B14F-4D97-AF65-F5344CB8AC3E}">
-        <p14:creationId xmlns:p14="http://schemas.microsoft.com/office/powerpoint/2010/main" val="1013837018"/>
+        <p14:creationId xmlns:p14="http://schemas.microsoft.com/office/powerpoint/2010/main" val="2085737414"/>
       </p:ext>
     </p:extLst>
   </p:cSld>
@@ -943,7 +943,7 @@
           <p:cNvPr id="7" name="">
             <a:extLst xmlns:a="http://schemas.openxmlformats.org/drawingml/2006/main">
               <a:ext uri="{FF2B5EF4-FFF2-40B4-BE49-F238E27FC236}">
-                <a16:creationId xmlns:a16="http://schemas.microsoft.com/office/drawing/2014/main" id="{3FBB8C48-CF46-4590-B667-17BADA7F1165}"/>
+                <a16:creationId xmlns:a16="http://schemas.microsoft.com/office/drawing/2014/main" id="{B91EC9B4-13E5-43E7-AC40-467BCA6E78F6}"/>
               </a:ext>
             </a:extLst>
           </p:cNvPr>
@@ -1000,7 +1000,7 @@
           <p:cNvPr id="2" name="">
             <a:extLst xmlns:a="http://schemas.openxmlformats.org/drawingml/2006/main">
               <a:ext uri="{FF2B5EF4-FFF2-40B4-BE49-F238E27FC236}">
-                <a16:creationId xmlns:a16="http://schemas.microsoft.com/office/drawing/2014/main" id="{21362C45-9BCE-4C53-9337-FBAB5DEE2587}"/>
+                <a16:creationId xmlns:a16="http://schemas.microsoft.com/office/drawing/2014/main" id="{BEC26714-C599-4F7F-A609-3936EB08AF63}"/>
               </a:ext>
             </a:extLst>
           </p:cNvPr>
@@ -1057,7 +1057,7 @@
           <p:cNvPr id="3" name="">
             <a:extLst xmlns:a="http://schemas.openxmlformats.org/drawingml/2006/main">
               <a:ext uri="{FF2B5EF4-FFF2-40B4-BE49-F238E27FC236}">
-                <a16:creationId xmlns:a16="http://schemas.microsoft.com/office/drawing/2014/main" id="{1B112E3A-D2E4-47E9-8B30-CFE2B0CF6A73}"/>
+                <a16:creationId xmlns:a16="http://schemas.microsoft.com/office/drawing/2014/main" id="{F37FDA31-E72B-423D-BCDF-CAFCD3E00915}"/>
               </a:ext>
             </a:extLst>
           </p:cNvPr>
@@ -1114,7 +1114,7 @@
           <p:cNvPr id="4" name="">
             <a:extLst xmlns:a="http://schemas.openxmlformats.org/drawingml/2006/main">
               <a:ext uri="{FF2B5EF4-FFF2-40B4-BE49-F238E27FC236}">
-                <a16:creationId xmlns:a16="http://schemas.microsoft.com/office/drawing/2014/main" id="{7C9C2F61-A5A0-4D26-8063-5F2AEE4D484A}"/>
+                <a16:creationId xmlns:a16="http://schemas.microsoft.com/office/drawing/2014/main" id="{9F9DE0D1-9FFF-4CD7-ACD6-DC628D718BEA}"/>
               </a:ext>
             </a:extLst>
           </p:cNvPr>
@@ -1227,7 +1227,7 @@
           <p:cNvPr id="5" name="">
             <a:extLst xmlns:a="http://schemas.openxmlformats.org/drawingml/2006/main">
               <a:ext uri="{FF2B5EF4-FFF2-40B4-BE49-F238E27FC236}">
-                <a16:creationId xmlns:a16="http://schemas.microsoft.com/office/drawing/2014/main" id="{E4222ADF-4DC1-4AE7-BA46-1B6EFD121963}"/>
+                <a16:creationId xmlns:a16="http://schemas.microsoft.com/office/drawing/2014/main" id="{231DDE2B-DD8A-4C98-9FD7-89ED237749FD}"/>
               </a:ext>
             </a:extLst>
           </p:cNvPr>
@@ -1307,7 +1307,7 @@
           <p:cNvPr id="6" name="">
             <a:extLst xmlns:a="http://schemas.openxmlformats.org/drawingml/2006/main">
               <a:ext uri="{FF2B5EF4-FFF2-40B4-BE49-F238E27FC236}">
-                <a16:creationId xmlns:a16="http://schemas.microsoft.com/office/drawing/2014/main" id="{D582E342-0644-4559-AAD0-845F11A65A40}"/>
+                <a16:creationId xmlns:a16="http://schemas.microsoft.com/office/drawing/2014/main" id="{0AEDBED3-4C05-4850-AD38-20B55C39A6FB}"/>
               </a:ext>
             </a:extLst>
           </p:cNvPr>
@@ -1362,7 +1362,7 @@
     </p:spTree>
     <p:extLst>
       <p:ext uri="{BB962C8B-B14F-4D97-AF65-F5344CB8AC3E}">
-        <p14:creationId xmlns:p14="http://schemas.microsoft.com/office/powerpoint/2010/main" val="43629586"/>
+        <p14:creationId xmlns:p14="http://schemas.microsoft.com/office/powerpoint/2010/main" val="201459801"/>
       </p:ext>
     </p:extLst>
   </p:cSld>
@@ -1393,7 +1393,7 @@
           <p:cNvPr id="7" name="">
             <a:extLst xmlns:a="http://schemas.openxmlformats.org/drawingml/2006/main">
               <a:ext uri="{FF2B5EF4-FFF2-40B4-BE49-F238E27FC236}">
-                <a16:creationId xmlns:a16="http://schemas.microsoft.com/office/drawing/2014/main" id="{9223843D-A577-46F0-A853-FEB583FE2A67}"/>
+                <a16:creationId xmlns:a16="http://schemas.microsoft.com/office/drawing/2014/main" id="{5B3A216C-84DD-4953-BFB5-EDA4A24DEC2D}"/>
               </a:ext>
             </a:extLst>
           </p:cNvPr>
@@ -1450,7 +1450,7 @@
           <p:cNvPr id="2" name="">
             <a:extLst xmlns:a="http://schemas.openxmlformats.org/drawingml/2006/main">
               <a:ext uri="{FF2B5EF4-FFF2-40B4-BE49-F238E27FC236}">
-                <a16:creationId xmlns:a16="http://schemas.microsoft.com/office/drawing/2014/main" id="{C9020730-60B0-44DD-AA4F-96E9CDDB6DD6}"/>
+                <a16:creationId xmlns:a16="http://schemas.microsoft.com/office/drawing/2014/main" id="{259F9805-AA93-4ED4-9470-08F5F97147C0}"/>
               </a:ext>
             </a:extLst>
           </p:cNvPr>
@@ -1507,7 +1507,7 @@
           <p:cNvPr id="3" name="">
             <a:extLst xmlns:a="http://schemas.openxmlformats.org/drawingml/2006/main">
               <a:ext uri="{FF2B5EF4-FFF2-40B4-BE49-F238E27FC236}">
-                <a16:creationId xmlns:a16="http://schemas.microsoft.com/office/drawing/2014/main" id="{3547F168-C2E8-41E2-A488-74DBED066A3B}"/>
+                <a16:creationId xmlns:a16="http://schemas.microsoft.com/office/drawing/2014/main" id="{7965922B-6DD0-4FBD-BC22-9A3027388566}"/>
               </a:ext>
             </a:extLst>
           </p:cNvPr>
@@ -1564,7 +1564,7 @@
           <p:cNvPr id="4" name="">
             <a:extLst xmlns:a="http://schemas.openxmlformats.org/drawingml/2006/main">
               <a:ext uri="{FF2B5EF4-FFF2-40B4-BE49-F238E27FC236}">
-                <a16:creationId xmlns:a16="http://schemas.microsoft.com/office/drawing/2014/main" id="{7AA93283-919D-4DAF-809F-372273FEACB4}"/>
+                <a16:creationId xmlns:a16="http://schemas.microsoft.com/office/drawing/2014/main" id="{BD9FDFCF-04C2-46BB-9DD3-6F35B267F398}"/>
               </a:ext>
             </a:extLst>
           </p:cNvPr>
@@ -1677,7 +1677,7 @@
           <p:cNvPr id="5" name="">
             <a:extLst xmlns:a="http://schemas.openxmlformats.org/drawingml/2006/main">
               <a:ext uri="{FF2B5EF4-FFF2-40B4-BE49-F238E27FC236}">
-                <a16:creationId xmlns:a16="http://schemas.microsoft.com/office/drawing/2014/main" id="{52E3A1AD-ECE6-4A73-BB47-96C5D318AEC3}"/>
+                <a16:creationId xmlns:a16="http://schemas.microsoft.com/office/drawing/2014/main" id="{E327388E-F6DA-4521-BF02-251FEB42E10F}"/>
               </a:ext>
             </a:extLst>
           </p:cNvPr>
@@ -1757,7 +1757,7 @@
           <p:cNvPr id="6" name="">
             <a:extLst xmlns:a="http://schemas.openxmlformats.org/drawingml/2006/main">
               <a:ext uri="{FF2B5EF4-FFF2-40B4-BE49-F238E27FC236}">
-                <a16:creationId xmlns:a16="http://schemas.microsoft.com/office/drawing/2014/main" id="{DB4BE686-84DC-4821-B661-72300B7941E8}"/>
+                <a16:creationId xmlns:a16="http://schemas.microsoft.com/office/drawing/2014/main" id="{9C91C34A-7F2D-4F4D-B201-F3566361121C}"/>
               </a:ext>
             </a:extLst>
           </p:cNvPr>
@@ -1812,7 +1812,7 @@
     </p:spTree>
     <p:extLst>
       <p:ext uri="{BB962C8B-B14F-4D97-AF65-F5344CB8AC3E}">
-        <p14:creationId xmlns:p14="http://schemas.microsoft.com/office/powerpoint/2010/main" val="313135659"/>
+        <p14:creationId xmlns:p14="http://schemas.microsoft.com/office/powerpoint/2010/main" val="685608923"/>
       </p:ext>
     </p:extLst>
   </p:cSld>
@@ -1843,7 +1843,7 @@
           <p:cNvPr id="7" name="">
             <a:extLst xmlns:a="http://schemas.openxmlformats.org/drawingml/2006/main">
               <a:ext uri="{FF2B5EF4-FFF2-40B4-BE49-F238E27FC236}">
-                <a16:creationId xmlns:a16="http://schemas.microsoft.com/office/drawing/2014/main" id="{20CA51E5-167F-4542-A90B-D9FE7E60E002}"/>
+                <a16:creationId xmlns:a16="http://schemas.microsoft.com/office/drawing/2014/main" id="{4E0E7F05-FE36-4DF9-8723-AB3F62A8B7DA}"/>
               </a:ext>
             </a:extLst>
           </p:cNvPr>
@@ -1900,7 +1900,7 @@
           <p:cNvPr id="2" name="">
             <a:extLst xmlns:a="http://schemas.openxmlformats.org/drawingml/2006/main">
               <a:ext uri="{FF2B5EF4-FFF2-40B4-BE49-F238E27FC236}">
-                <a16:creationId xmlns:a16="http://schemas.microsoft.com/office/drawing/2014/main" id="{49F8B9D2-BD7D-4BEB-869B-3DAF46157185}"/>
+                <a16:creationId xmlns:a16="http://schemas.microsoft.com/office/drawing/2014/main" id="{70F3E372-1C47-4DB4-9AB3-DB63732297A0}"/>
               </a:ext>
             </a:extLst>
           </p:cNvPr>
@@ -1957,7 +1957,7 @@
           <p:cNvPr id="3" name="">
             <a:extLst xmlns:a="http://schemas.openxmlformats.org/drawingml/2006/main">
               <a:ext uri="{FF2B5EF4-FFF2-40B4-BE49-F238E27FC236}">
-                <a16:creationId xmlns:a16="http://schemas.microsoft.com/office/drawing/2014/main" id="{649164E0-16A7-4B4B-9964-1CB77EB931FD}"/>
+                <a16:creationId xmlns:a16="http://schemas.microsoft.com/office/drawing/2014/main" id="{3276BB5A-C40B-4FF7-A5A5-261EEAF51EBC}"/>
               </a:ext>
             </a:extLst>
           </p:cNvPr>
@@ -2014,7 +2014,7 @@
           <p:cNvPr id="4" name="">
             <a:extLst xmlns:a="http://schemas.openxmlformats.org/drawingml/2006/main">
               <a:ext uri="{FF2B5EF4-FFF2-40B4-BE49-F238E27FC236}">
-                <a16:creationId xmlns:a16="http://schemas.microsoft.com/office/drawing/2014/main" id="{4476F3BB-7C15-4A4D-9A69-BF342C69E01F}"/>
+                <a16:creationId xmlns:a16="http://schemas.microsoft.com/office/drawing/2014/main" id="{D72631E0-B90C-4DFE-9A0E-14B358E41B19}"/>
               </a:ext>
             </a:extLst>
           </p:cNvPr>
@@ -2127,7 +2127,7 @@
           <p:cNvPr id="5" name="">
             <a:extLst xmlns:a="http://schemas.openxmlformats.org/drawingml/2006/main">
               <a:ext uri="{FF2B5EF4-FFF2-40B4-BE49-F238E27FC236}">
-                <a16:creationId xmlns:a16="http://schemas.microsoft.com/office/drawing/2014/main" id="{4D447AB7-1ACF-4F1E-A969-0DBADC04709E}"/>
+                <a16:creationId xmlns:a16="http://schemas.microsoft.com/office/drawing/2014/main" id="{2B5FA663-A2A5-4E19-B22C-591B00D6097A}"/>
               </a:ext>
             </a:extLst>
           </p:cNvPr>
@@ -2253,7 +2253,7 @@
           <p:cNvPr id="6" name="">
             <a:extLst xmlns:a="http://schemas.openxmlformats.org/drawingml/2006/main">
               <a:ext uri="{FF2B5EF4-FFF2-40B4-BE49-F238E27FC236}">
-                <a16:creationId xmlns:a16="http://schemas.microsoft.com/office/drawing/2014/main" id="{A9DD9EA5-1033-4F77-BCE6-E631D5E257F2}"/>
+                <a16:creationId xmlns:a16="http://schemas.microsoft.com/office/drawing/2014/main" id="{37459226-0B9C-4387-A6EE-A290BA569891}"/>
               </a:ext>
             </a:extLst>
           </p:cNvPr>
@@ -2308,7 +2308,7 @@
     </p:spTree>
     <p:extLst>
       <p:ext uri="{BB962C8B-B14F-4D97-AF65-F5344CB8AC3E}">
-        <p14:creationId xmlns:p14="http://schemas.microsoft.com/office/powerpoint/2010/main" val="1076910239"/>
+        <p14:creationId xmlns:p14="http://schemas.microsoft.com/office/powerpoint/2010/main" val="1996564646"/>
       </p:ext>
     </p:extLst>
   </p:cSld>
@@ -2339,7 +2339,7 @@
           <p:cNvPr id="7" name="">
             <a:extLst xmlns:a="http://schemas.openxmlformats.org/drawingml/2006/main">
               <a:ext uri="{FF2B5EF4-FFF2-40B4-BE49-F238E27FC236}">
-                <a16:creationId xmlns:a16="http://schemas.microsoft.com/office/drawing/2014/main" id="{06D8C397-2405-4549-93AF-E503ABEEE4FB}"/>
+                <a16:creationId xmlns:a16="http://schemas.microsoft.com/office/drawing/2014/main" id="{4CDADC29-4C8B-4F50-B2D6-1720CC3B6CC4}"/>
               </a:ext>
             </a:extLst>
           </p:cNvPr>
@@ -2396,7 +2396,7 @@
           <p:cNvPr id="2" name="">
             <a:extLst xmlns:a="http://schemas.openxmlformats.org/drawingml/2006/main">
               <a:ext uri="{FF2B5EF4-FFF2-40B4-BE49-F238E27FC236}">
-                <a16:creationId xmlns:a16="http://schemas.microsoft.com/office/drawing/2014/main" id="{55326104-46A3-467A-9A98-75617C2D849C}"/>
+                <a16:creationId xmlns:a16="http://schemas.microsoft.com/office/drawing/2014/main" id="{3ABE2951-41B8-460F-89DB-57428D3F7C93}"/>
               </a:ext>
             </a:extLst>
           </p:cNvPr>
@@ -2453,7 +2453,7 @@
           <p:cNvPr id="3" name="">
             <a:extLst xmlns:a="http://schemas.openxmlformats.org/drawingml/2006/main">
               <a:ext uri="{FF2B5EF4-FFF2-40B4-BE49-F238E27FC236}">
-                <a16:creationId xmlns:a16="http://schemas.microsoft.com/office/drawing/2014/main" id="{A3510E55-6035-4B2C-B6CF-EAD558752869}"/>
+                <a16:creationId xmlns:a16="http://schemas.microsoft.com/office/drawing/2014/main" id="{40C13BBE-5D79-4181-AFB6-CB37B47C6A38}"/>
               </a:ext>
             </a:extLst>
           </p:cNvPr>
@@ -2510,7 +2510,7 @@
           <p:cNvPr id="4" name="">
             <a:extLst xmlns:a="http://schemas.openxmlformats.org/drawingml/2006/main">
               <a:ext uri="{FF2B5EF4-FFF2-40B4-BE49-F238E27FC236}">
-                <a16:creationId xmlns:a16="http://schemas.microsoft.com/office/drawing/2014/main" id="{715DD66B-B209-42C3-82EE-3DB400AA01F7}"/>
+                <a16:creationId xmlns:a16="http://schemas.microsoft.com/office/drawing/2014/main" id="{AEA470B9-CC22-429D-A509-056EFC0D7DF1}"/>
               </a:ext>
             </a:extLst>
           </p:cNvPr>
@@ -2623,7 +2623,7 @@
           <p:cNvPr id="5" name="">
             <a:extLst xmlns:a="http://schemas.openxmlformats.org/drawingml/2006/main">
               <a:ext uri="{FF2B5EF4-FFF2-40B4-BE49-F238E27FC236}">
-                <a16:creationId xmlns:a16="http://schemas.microsoft.com/office/drawing/2014/main" id="{C64FE656-0F18-456F-B8CE-4221C918120C}"/>
+                <a16:creationId xmlns:a16="http://schemas.microsoft.com/office/drawing/2014/main" id="{6C8DC2DE-A108-4A44-9378-A79C31CD9440}"/>
               </a:ext>
             </a:extLst>
           </p:cNvPr>
@@ -2680,7 +2680,7 @@
           <p:cNvPr id="6" name="">
             <a:extLst xmlns:a="http://schemas.openxmlformats.org/drawingml/2006/main">
               <a:ext uri="{FF2B5EF4-FFF2-40B4-BE49-F238E27FC236}">
-                <a16:creationId xmlns:a16="http://schemas.microsoft.com/office/drawing/2014/main" id="{76D94573-A9CD-4701-9118-CA2558B4B6FA}"/>
+                <a16:creationId xmlns:a16="http://schemas.microsoft.com/office/drawing/2014/main" id="{CC76C650-B795-4CCB-BB2C-4B9E88EB3D4B}"/>
               </a:ext>
             </a:extLst>
           </p:cNvPr>
@@ -2735,7 +2735,7 @@
     </p:spTree>
     <p:extLst>
       <p:ext uri="{BB962C8B-B14F-4D97-AF65-F5344CB8AC3E}">
-        <p14:creationId xmlns:p14="http://schemas.microsoft.com/office/powerpoint/2010/main" val="1597028890"/>
+        <p14:creationId xmlns:p14="http://schemas.microsoft.com/office/powerpoint/2010/main" val="1917532762"/>
       </p:ext>
     </p:extLst>
   </p:cSld>
@@ -2766,7 +2766,7 @@
           <p:cNvPr id="6" name="">
             <a:extLst xmlns:a="http://schemas.openxmlformats.org/drawingml/2006/main">
               <a:ext uri="{FF2B5EF4-FFF2-40B4-BE49-F238E27FC236}">
-                <a16:creationId xmlns:a16="http://schemas.microsoft.com/office/drawing/2014/main" id="{7E032EEC-2864-47ED-A12D-FC39880BA67B}"/>
+                <a16:creationId xmlns:a16="http://schemas.microsoft.com/office/drawing/2014/main" id="{6542CF29-6867-47D2-BE24-A358E894550C}"/>
               </a:ext>
             </a:extLst>
           </p:cNvPr>
@@ -2823,7 +2823,7 @@
           <p:cNvPr id="2" name="">
             <a:extLst xmlns:a="http://schemas.openxmlformats.org/drawingml/2006/main">
               <a:ext uri="{FF2B5EF4-FFF2-40B4-BE49-F238E27FC236}">
-                <a16:creationId xmlns:a16="http://schemas.microsoft.com/office/drawing/2014/main" id="{84AD6215-793B-4281-8156-8FCD67C3A171}"/>
+                <a16:creationId xmlns:a16="http://schemas.microsoft.com/office/drawing/2014/main" id="{77290E2B-67D4-4735-8906-EBDF528CF7E5}"/>
               </a:ext>
             </a:extLst>
           </p:cNvPr>
@@ -2880,7 +2880,7 @@
           <p:cNvPr id="3" name="">
             <a:extLst xmlns:a="http://schemas.openxmlformats.org/drawingml/2006/main">
               <a:ext uri="{FF2B5EF4-FFF2-40B4-BE49-F238E27FC236}">
-                <a16:creationId xmlns:a16="http://schemas.microsoft.com/office/drawing/2014/main" id="{DE175D9D-0F57-49CB-A50E-122B642ED566}"/>
+                <a16:creationId xmlns:a16="http://schemas.microsoft.com/office/drawing/2014/main" id="{61A5B5D2-F155-426D-BAA3-D00B975EDDD2}"/>
               </a:ext>
             </a:extLst>
           </p:cNvPr>
@@ -2937,7 +2937,7 @@
           <p:cNvPr id="4" name="">
             <a:extLst xmlns:a="http://schemas.openxmlformats.org/drawingml/2006/main">
               <a:ext uri="{FF2B5EF4-FFF2-40B4-BE49-F238E27FC236}">
-                <a16:creationId xmlns:a16="http://schemas.microsoft.com/office/drawing/2014/main" id="{27D54040-5FFE-45D7-9C0F-DBD6EBE45C8A}"/>
+                <a16:creationId xmlns:a16="http://schemas.microsoft.com/office/drawing/2014/main" id="{99C2842B-A4ED-4A99-A073-ABE34EF9DB95}"/>
               </a:ext>
             </a:extLst>
           </p:cNvPr>
@@ -3078,7 +3078,7 @@
           <p:cNvPr id="5" name="">
             <a:extLst xmlns:a="http://schemas.openxmlformats.org/drawingml/2006/main">
               <a:ext uri="{FF2B5EF4-FFF2-40B4-BE49-F238E27FC236}">
-                <a16:creationId xmlns:a16="http://schemas.microsoft.com/office/drawing/2014/main" id="{E38C9EF5-BDD9-437A-ABFD-E44BC6063B18}"/>
+                <a16:creationId xmlns:a16="http://schemas.microsoft.com/office/drawing/2014/main" id="{8B83F6DA-E203-48D3-9473-BB98C0027C5B}"/>
               </a:ext>
             </a:extLst>
           </p:cNvPr>
@@ -3133,7 +3133,7 @@
     </p:spTree>
     <p:extLst>
       <p:ext uri="{BB962C8B-B14F-4D97-AF65-F5344CB8AC3E}">
-        <p14:creationId xmlns:p14="http://schemas.microsoft.com/office/powerpoint/2010/main" val="288069148"/>
+        <p14:creationId xmlns:p14="http://schemas.microsoft.com/office/powerpoint/2010/main" val="1764387287"/>
       </p:ext>
     </p:extLst>
   </p:cSld>
@@ -3164,7 +3164,7 @@
           <p:cNvPr id="7" name="">
             <a:extLst xmlns:a="http://schemas.openxmlformats.org/drawingml/2006/main">
               <a:ext uri="{FF2B5EF4-FFF2-40B4-BE49-F238E27FC236}">
-                <a16:creationId xmlns:a16="http://schemas.microsoft.com/office/drawing/2014/main" id="{005C0E5B-793F-45FF-A2F1-C9E4952782F8}"/>
+                <a16:creationId xmlns:a16="http://schemas.microsoft.com/office/drawing/2014/main" id="{0312CF54-0A3F-4D96-92F2-222BF63FA193}"/>
               </a:ext>
             </a:extLst>
           </p:cNvPr>
@@ -3221,7 +3221,7 @@
           <p:cNvPr id="2" name="">
             <a:extLst xmlns:a="http://schemas.openxmlformats.org/drawingml/2006/main">
               <a:ext uri="{FF2B5EF4-FFF2-40B4-BE49-F238E27FC236}">
-                <a16:creationId xmlns:a16="http://schemas.microsoft.com/office/drawing/2014/main" id="{70AEF83A-E897-4E42-8850-95BC0FBBF834}"/>
+                <a16:creationId xmlns:a16="http://schemas.microsoft.com/office/drawing/2014/main" id="{4D254AB5-10AD-4421-A58D-C53702A4E733}"/>
               </a:ext>
             </a:extLst>
           </p:cNvPr>
@@ -3278,7 +3278,7 @@
           <p:cNvPr id="3" name="">
             <a:extLst xmlns:a="http://schemas.openxmlformats.org/drawingml/2006/main">
               <a:ext uri="{FF2B5EF4-FFF2-40B4-BE49-F238E27FC236}">
-                <a16:creationId xmlns:a16="http://schemas.microsoft.com/office/drawing/2014/main" id="{28FE2936-DAFA-449F-AE27-9385502812CE}"/>
+                <a16:creationId xmlns:a16="http://schemas.microsoft.com/office/drawing/2014/main" id="{6D592CD0-DF3F-4359-8797-E0DD671B8475}"/>
               </a:ext>
             </a:extLst>
           </p:cNvPr>
@@ -3335,7 +3335,7 @@
           <p:cNvPr id="4" name="">
             <a:extLst xmlns:a="http://schemas.openxmlformats.org/drawingml/2006/main">
               <a:ext uri="{FF2B5EF4-FFF2-40B4-BE49-F238E27FC236}">
-                <a16:creationId xmlns:a16="http://schemas.microsoft.com/office/drawing/2014/main" id="{E9129264-EA85-494C-B9BC-35C1144B5486}"/>
+                <a16:creationId xmlns:a16="http://schemas.microsoft.com/office/drawing/2014/main" id="{401D1DE1-5A18-4BB7-88DA-C2FB85A11CB6}"/>
               </a:ext>
             </a:extLst>
           </p:cNvPr>
@@ -3448,7 +3448,7 @@
           <p:cNvPr id="5" name="">
             <a:extLst xmlns:a="http://schemas.openxmlformats.org/drawingml/2006/main">
               <a:ext uri="{FF2B5EF4-FFF2-40B4-BE49-F238E27FC236}">
-                <a16:creationId xmlns:a16="http://schemas.microsoft.com/office/drawing/2014/main" id="{82A402E8-60E8-41D5-B923-90EF9C5C1CD4}"/>
+                <a16:creationId xmlns:a16="http://schemas.microsoft.com/office/drawing/2014/main" id="{AA4BE355-040D-47E3-9E4D-E20FB079A02B}"/>
               </a:ext>
             </a:extLst>
           </p:cNvPr>
@@ -3505,7 +3505,7 @@
           <p:cNvPr id="6" name="">
             <a:extLst xmlns:a="http://schemas.openxmlformats.org/drawingml/2006/main">
               <a:ext uri="{FF2B5EF4-FFF2-40B4-BE49-F238E27FC236}">
-                <a16:creationId xmlns:a16="http://schemas.microsoft.com/office/drawing/2014/main" id="{C2F519D4-B5B6-41A8-BF05-95997C25523E}"/>
+                <a16:creationId xmlns:a16="http://schemas.microsoft.com/office/drawing/2014/main" id="{48C947F0-12C1-480C-A46B-23ED331B1867}"/>
               </a:ext>
             </a:extLst>
           </p:cNvPr>
@@ -3560,7 +3560,7 @@
     </p:spTree>
     <p:extLst>
       <p:ext uri="{BB962C8B-B14F-4D97-AF65-F5344CB8AC3E}">
-        <p14:creationId xmlns:p14="http://schemas.microsoft.com/office/powerpoint/2010/main" val="262707331"/>
+        <p14:creationId xmlns:p14="http://schemas.microsoft.com/office/powerpoint/2010/main" val="341160478"/>
       </p:ext>
     </p:extLst>
   </p:cSld>
@@ -3591,7 +3591,7 @@
           <p:cNvPr id="5" name="">
             <a:extLst xmlns:a="http://schemas.openxmlformats.org/drawingml/2006/main">
               <a:ext uri="{FF2B5EF4-FFF2-40B4-BE49-F238E27FC236}">
-                <a16:creationId xmlns:a16="http://schemas.microsoft.com/office/drawing/2014/main" id="{FF41871A-95E6-41B8-8530-95348086C759}"/>
+                <a16:creationId xmlns:a16="http://schemas.microsoft.com/office/drawing/2014/main" id="{2855D718-3242-4A8E-887E-B2141FFC1170}"/>
               </a:ext>
             </a:extLst>
           </p:cNvPr>
@@ -3648,7 +3648,7 @@
           <p:cNvPr id="2" name="">
             <a:extLst xmlns:a="http://schemas.openxmlformats.org/drawingml/2006/main">
               <a:ext uri="{FF2B5EF4-FFF2-40B4-BE49-F238E27FC236}">
-                <a16:creationId xmlns:a16="http://schemas.microsoft.com/office/drawing/2014/main" id="{D18A79FC-0D48-4863-B962-6D89279A4FF1}"/>
+                <a16:creationId xmlns:a16="http://schemas.microsoft.com/office/drawing/2014/main" id="{B2AC5046-CA56-4C51-B461-2B2C004FAEC8}"/>
               </a:ext>
             </a:extLst>
           </p:cNvPr>
@@ -3705,7 +3705,7 @@
           <p:cNvPr id="3" name="">
             <a:extLst xmlns:a="http://schemas.openxmlformats.org/drawingml/2006/main">
               <a:ext uri="{FF2B5EF4-FFF2-40B4-BE49-F238E27FC236}">
-                <a16:creationId xmlns:a16="http://schemas.microsoft.com/office/drawing/2014/main" id="{347A2F1F-0015-4AA2-8F98-5A483EE8D501}"/>
+                <a16:creationId xmlns:a16="http://schemas.microsoft.com/office/drawing/2014/main" id="{63803796-8A6B-4646-B3E0-38D08D1AE2B7}"/>
               </a:ext>
             </a:extLst>
           </p:cNvPr>
@@ -3762,7 +3762,7 @@
           <p:cNvPr id="4" name="">
             <a:extLst xmlns:a="http://schemas.openxmlformats.org/drawingml/2006/main">
               <a:ext uri="{FF2B5EF4-FFF2-40B4-BE49-F238E27FC236}">
-                <a16:creationId xmlns:a16="http://schemas.microsoft.com/office/drawing/2014/main" id="{9E60EC9A-A9CF-4EB0-8859-2B4481F2F40B}"/>
+                <a16:creationId xmlns:a16="http://schemas.microsoft.com/office/drawing/2014/main" id="{6CA50EE9-FB5C-4F34-8BE8-12EF5B836719}"/>
               </a:ext>
             </a:extLst>
           </p:cNvPr>
@@ -3901,7 +3901,7 @@
     </p:spTree>
     <p:extLst>
       <p:ext uri="{BB962C8B-B14F-4D97-AF65-F5344CB8AC3E}">
-        <p14:creationId xmlns:p14="http://schemas.microsoft.com/office/powerpoint/2010/main" val="1832751913"/>
+        <p14:creationId xmlns:p14="http://schemas.microsoft.com/office/powerpoint/2010/main" val="2009882338"/>
       </p:ext>
     </p:extLst>
   </p:cSld>
@@ -3932,7 +3932,7 @@
           <p:cNvPr id="7" name="">
             <a:extLst xmlns:a="http://schemas.openxmlformats.org/drawingml/2006/main">
               <a:ext uri="{FF2B5EF4-FFF2-40B4-BE49-F238E27FC236}">
-                <a16:creationId xmlns:a16="http://schemas.microsoft.com/office/drawing/2014/main" id="{CB99EE05-D039-41BD-A51C-222372CBD2A3}"/>
+                <a16:creationId xmlns:a16="http://schemas.microsoft.com/office/drawing/2014/main" id="{8B1F994C-B1DB-484F-8835-490717DA8D3B}"/>
               </a:ext>
             </a:extLst>
           </p:cNvPr>
@@ -3989,7 +3989,7 @@
           <p:cNvPr id="2" name="">
             <a:extLst xmlns:a="http://schemas.openxmlformats.org/drawingml/2006/main">
               <a:ext uri="{FF2B5EF4-FFF2-40B4-BE49-F238E27FC236}">
-                <a16:creationId xmlns:a16="http://schemas.microsoft.com/office/drawing/2014/main" id="{C5D27AF6-268D-4184-9025-8E68F8DD1FBA}"/>
+                <a16:creationId xmlns:a16="http://schemas.microsoft.com/office/drawing/2014/main" id="{6A6229E0-6423-465F-8EBD-AE58E32F5B0A}"/>
               </a:ext>
             </a:extLst>
           </p:cNvPr>
@@ -4046,7 +4046,7 @@
           <p:cNvPr id="3" name="">
             <a:extLst xmlns:a="http://schemas.openxmlformats.org/drawingml/2006/main">
               <a:ext uri="{FF2B5EF4-FFF2-40B4-BE49-F238E27FC236}">
-                <a16:creationId xmlns:a16="http://schemas.microsoft.com/office/drawing/2014/main" id="{84EEC89E-1B20-4F31-9F2A-CE9579EBBB8D}"/>
+                <a16:creationId xmlns:a16="http://schemas.microsoft.com/office/drawing/2014/main" id="{AE44A3D2-E025-4F1F-9831-8DCDDD9A7C61}"/>
               </a:ext>
             </a:extLst>
           </p:cNvPr>
@@ -4103,7 +4103,7 @@
           <p:cNvPr id="4" name="">
             <a:extLst xmlns:a="http://schemas.openxmlformats.org/drawingml/2006/main">
               <a:ext uri="{FF2B5EF4-FFF2-40B4-BE49-F238E27FC236}">
-                <a16:creationId xmlns:a16="http://schemas.microsoft.com/office/drawing/2014/main" id="{CAC82D99-2AB2-415A-A800-A6E92EAE7415}"/>
+                <a16:creationId xmlns:a16="http://schemas.microsoft.com/office/drawing/2014/main" id="{75D4B34F-D625-40A5-AD33-B398FDA816C6}"/>
               </a:ext>
             </a:extLst>
           </p:cNvPr>
@@ -4188,7 +4188,7 @@
           <p:cNvPr id="5" name="">
             <a:extLst xmlns:a="http://schemas.openxmlformats.org/drawingml/2006/main">
               <a:ext uri="{FF2B5EF4-FFF2-40B4-BE49-F238E27FC236}">
-                <a16:creationId xmlns:a16="http://schemas.microsoft.com/office/drawing/2014/main" id="{016F8FAC-3B03-450A-826C-75E2718DE3BA}"/>
+                <a16:creationId xmlns:a16="http://schemas.microsoft.com/office/drawing/2014/main" id="{1D0D0B61-077C-4748-B27D-D979409A0717}"/>
               </a:ext>
             </a:extLst>
           </p:cNvPr>
@@ -4291,7 +4291,7 @@
           <p:cNvPr id="6" name="">
             <a:extLst xmlns:a="http://schemas.openxmlformats.org/drawingml/2006/main">
               <a:ext uri="{FF2B5EF4-FFF2-40B4-BE49-F238E27FC236}">
-                <a16:creationId xmlns:a16="http://schemas.microsoft.com/office/drawing/2014/main" id="{E43AF9DF-F330-4720-BC81-4A69AC5D99CF}"/>
+                <a16:creationId xmlns:a16="http://schemas.microsoft.com/office/drawing/2014/main" id="{32BF32CF-F025-4EA4-8381-B007F8A786B3}"/>
               </a:ext>
             </a:extLst>
           </p:cNvPr>
@@ -4346,7 +4346,7 @@
     </p:spTree>
     <p:extLst>
       <p:ext uri="{BB962C8B-B14F-4D97-AF65-F5344CB8AC3E}">
-        <p14:creationId xmlns:p14="http://schemas.microsoft.com/office/powerpoint/2010/main" val="1893970491"/>
+        <p14:creationId xmlns:p14="http://schemas.microsoft.com/office/powerpoint/2010/main" val="1234658242"/>
       </p:ext>
     </p:extLst>
   </p:cSld>
@@ -4377,7 +4377,7 @@
           <p:cNvPr id="6" name="">
             <a:extLst xmlns:a="http://schemas.openxmlformats.org/drawingml/2006/main">
               <a:ext uri="{FF2B5EF4-FFF2-40B4-BE49-F238E27FC236}">
-                <a16:creationId xmlns:a16="http://schemas.microsoft.com/office/drawing/2014/main" id="{B9F0533F-BAC2-4AF5-A974-241F2C6F6B8D}"/>
+                <a16:creationId xmlns:a16="http://schemas.microsoft.com/office/drawing/2014/main" id="{4E885CD0-A97E-45E0-8E79-0887A4B0A0FB}"/>
               </a:ext>
             </a:extLst>
           </p:cNvPr>
@@ -4434,7 +4434,7 @@
           <p:cNvPr id="2" name="">
             <a:extLst xmlns:a="http://schemas.openxmlformats.org/drawingml/2006/main">
               <a:ext uri="{FF2B5EF4-FFF2-40B4-BE49-F238E27FC236}">
-                <a16:creationId xmlns:a16="http://schemas.microsoft.com/office/drawing/2014/main" id="{801BBD37-9781-4E35-8432-CAB5C23767E1}"/>
+                <a16:creationId xmlns:a16="http://schemas.microsoft.com/office/drawing/2014/main" id="{CBD403FB-EC82-4683-9B90-B890C3AF63E8}"/>
               </a:ext>
             </a:extLst>
           </p:cNvPr>
@@ -4491,7 +4491,7 @@
           <p:cNvPr id="3" name="">
             <a:extLst xmlns:a="http://schemas.openxmlformats.org/drawingml/2006/main">
               <a:ext uri="{FF2B5EF4-FFF2-40B4-BE49-F238E27FC236}">
-                <a16:creationId xmlns:a16="http://schemas.microsoft.com/office/drawing/2014/main" id="{399CD36E-186A-49DC-A042-1982D63CDC7E}"/>
+                <a16:creationId xmlns:a16="http://schemas.microsoft.com/office/drawing/2014/main" id="{55086546-0C7E-4764-A691-A0829A3BC150}"/>
               </a:ext>
             </a:extLst>
           </p:cNvPr>
@@ -4548,7 +4548,7 @@
           <p:cNvPr id="4" name="">
             <a:extLst xmlns:a="http://schemas.openxmlformats.org/drawingml/2006/main">
               <a:ext uri="{FF2B5EF4-FFF2-40B4-BE49-F238E27FC236}">
-                <a16:creationId xmlns:a16="http://schemas.microsoft.com/office/drawing/2014/main" id="{495126C5-281B-4D66-B548-D4A549D7AA9A}"/>
+                <a16:creationId xmlns:a16="http://schemas.microsoft.com/office/drawing/2014/main" id="{49577D90-C537-455E-9AC9-16B37884E130}"/>
               </a:ext>
             </a:extLst>
           </p:cNvPr>
@@ -4689,7 +4689,7 @@
           <p:cNvPr id="5" name="">
             <a:extLst xmlns:a="http://schemas.openxmlformats.org/drawingml/2006/main">
               <a:ext uri="{FF2B5EF4-FFF2-40B4-BE49-F238E27FC236}">
-                <a16:creationId xmlns:a16="http://schemas.microsoft.com/office/drawing/2014/main" id="{A32898AD-C2EC-41A3-9931-CFF5A653627C}"/>
+                <a16:creationId xmlns:a16="http://schemas.microsoft.com/office/drawing/2014/main" id="{A593FA69-7F0C-4123-8F5B-52D079DD8E05}"/>
               </a:ext>
             </a:extLst>
           </p:cNvPr>
@@ -4744,7 +4744,7 @@
     </p:spTree>
     <p:extLst>
       <p:ext uri="{BB962C8B-B14F-4D97-AF65-F5344CB8AC3E}">
-        <p14:creationId xmlns:p14="http://schemas.microsoft.com/office/powerpoint/2010/main" val="1573002623"/>
+        <p14:creationId xmlns:p14="http://schemas.microsoft.com/office/powerpoint/2010/main" val="1436891095"/>
       </p:ext>
     </p:extLst>
   </p:cSld>
@@ -4775,7 +4775,7 @@
           <p:cNvPr id="5" name="">
             <a:extLst xmlns:a="http://schemas.openxmlformats.org/drawingml/2006/main">
               <a:ext uri="{FF2B5EF4-FFF2-40B4-BE49-F238E27FC236}">
-                <a16:creationId xmlns:a16="http://schemas.microsoft.com/office/drawing/2014/main" id="{F051809C-9230-468E-945E-EA844CDE4FFF}"/>
+                <a16:creationId xmlns:a16="http://schemas.microsoft.com/office/drawing/2014/main" id="{3BDD66FE-6F39-4179-8532-D70D00EFC805}"/>
               </a:ext>
             </a:extLst>
           </p:cNvPr>
@@ -4832,7 +4832,7 @@
           <p:cNvPr id="2" name="">
             <a:extLst xmlns:a="http://schemas.openxmlformats.org/drawingml/2006/main">
               <a:ext uri="{FF2B5EF4-FFF2-40B4-BE49-F238E27FC236}">
-                <a16:creationId xmlns:a16="http://schemas.microsoft.com/office/drawing/2014/main" id="{69E9B0DF-BD85-4E9C-B1F5-DEC3233D8C14}"/>
+                <a16:creationId xmlns:a16="http://schemas.microsoft.com/office/drawing/2014/main" id="{B4D9A819-212D-46A5-AF15-69158AA40C48}"/>
               </a:ext>
             </a:extLst>
           </p:cNvPr>
@@ -4889,7 +4889,7 @@
           <p:cNvPr id="3" name="">
             <a:extLst xmlns:a="http://schemas.openxmlformats.org/drawingml/2006/main">
               <a:ext uri="{FF2B5EF4-FFF2-40B4-BE49-F238E27FC236}">
-                <a16:creationId xmlns:a16="http://schemas.microsoft.com/office/drawing/2014/main" id="{B5E4A6C5-2E09-4D71-B937-F60E4EFF4196}"/>
+                <a16:creationId xmlns:a16="http://schemas.microsoft.com/office/drawing/2014/main" id="{80F852C1-A0F1-48AD-BB09-CCFA4089F71F}"/>
               </a:ext>
             </a:extLst>
           </p:cNvPr>
@@ -4946,7 +4946,7 @@
           <p:cNvPr id="4" name="">
             <a:extLst xmlns:a="http://schemas.openxmlformats.org/drawingml/2006/main">
               <a:ext uri="{FF2B5EF4-FFF2-40B4-BE49-F238E27FC236}">
-                <a16:creationId xmlns:a16="http://schemas.microsoft.com/office/drawing/2014/main" id="{971F69BD-945C-484D-A6C4-89A52BEFDFDC}"/>
+                <a16:creationId xmlns:a16="http://schemas.microsoft.com/office/drawing/2014/main" id="{51BE5D98-E072-4C3F-9B93-02B3DD4887D0}"/>
               </a:ext>
             </a:extLst>
           </p:cNvPr>
@@ -5085,7 +5085,7 @@
     </p:spTree>
     <p:extLst>
       <p:ext uri="{BB962C8B-B14F-4D97-AF65-F5344CB8AC3E}">
-        <p14:creationId xmlns:p14="http://schemas.microsoft.com/office/powerpoint/2010/main" val="2071209131"/>
+        <p14:creationId xmlns:p14="http://schemas.microsoft.com/office/powerpoint/2010/main" val="1544480383"/>
       </p:ext>
     </p:extLst>
   </p:cSld>
@@ -5116,7 +5116,7 @@
           <p:cNvPr id="6" name="">
             <a:extLst xmlns:a="http://schemas.openxmlformats.org/drawingml/2006/main">
               <a:ext uri="{FF2B5EF4-FFF2-40B4-BE49-F238E27FC236}">
-                <a16:creationId xmlns:a16="http://schemas.microsoft.com/office/drawing/2014/main" id="{E7600D80-EC2B-4612-A924-A22A39999CCE}"/>
+                <a16:creationId xmlns:a16="http://schemas.microsoft.com/office/drawing/2014/main" id="{5A79F09B-DFDD-493B-A532-2A0AAFABE6EE}"/>
               </a:ext>
             </a:extLst>
           </p:cNvPr>
@@ -5173,7 +5173,7 @@
           <p:cNvPr id="2" name="">
             <a:extLst xmlns:a="http://schemas.openxmlformats.org/drawingml/2006/main">
               <a:ext uri="{FF2B5EF4-FFF2-40B4-BE49-F238E27FC236}">
-                <a16:creationId xmlns:a16="http://schemas.microsoft.com/office/drawing/2014/main" id="{0D0C8B76-EEC5-499B-B7A4-88B81B8BF956}"/>
+                <a16:creationId xmlns:a16="http://schemas.microsoft.com/office/drawing/2014/main" id="{EC65AE90-35AB-43EB-932A-939659AE5BEE}"/>
               </a:ext>
             </a:extLst>
           </p:cNvPr>
@@ -5230,7 +5230,7 @@
           <p:cNvPr id="3" name="">
             <a:extLst xmlns:a="http://schemas.openxmlformats.org/drawingml/2006/main">
               <a:ext uri="{FF2B5EF4-FFF2-40B4-BE49-F238E27FC236}">
-                <a16:creationId xmlns:a16="http://schemas.microsoft.com/office/drawing/2014/main" id="{6304849B-404E-4BBD-B6D5-1D619B7882F3}"/>
+                <a16:creationId xmlns:a16="http://schemas.microsoft.com/office/drawing/2014/main" id="{1F3F8DAB-5ED7-4123-880B-C0C684339BD8}"/>
               </a:ext>
             </a:extLst>
           </p:cNvPr>
@@ -5287,7 +5287,7 @@
           <p:cNvPr id="4" name="">
             <a:extLst xmlns:a="http://schemas.openxmlformats.org/drawingml/2006/main">
               <a:ext uri="{FF2B5EF4-FFF2-40B4-BE49-F238E27FC236}">
-                <a16:creationId xmlns:a16="http://schemas.microsoft.com/office/drawing/2014/main" id="{38549393-176D-45DE-938A-C966AFDDB7F4}"/>
+                <a16:creationId xmlns:a16="http://schemas.microsoft.com/office/drawing/2014/main" id="{0FAACD14-520A-4272-BE4C-2B8219168873}"/>
               </a:ext>
             </a:extLst>
           </p:cNvPr>
@@ -5400,7 +5400,7 @@
           <p:cNvPr id="5" name="">
             <a:extLst xmlns:a="http://schemas.openxmlformats.org/drawingml/2006/main">
               <a:ext uri="{FF2B5EF4-FFF2-40B4-BE49-F238E27FC236}">
-                <a16:creationId xmlns:a16="http://schemas.microsoft.com/office/drawing/2014/main" id="{B77BD5C1-C3B8-474D-BAE9-58BDABD6217C}"/>
+                <a16:creationId xmlns:a16="http://schemas.microsoft.com/office/drawing/2014/main" id="{9A04E0D6-CC71-4754-9839-FEEA49D76CF1}"/>
               </a:ext>
             </a:extLst>
           </p:cNvPr>
@@ -5455,7 +5455,7 @@
     </p:spTree>
     <p:extLst>
       <p:ext uri="{BB962C8B-B14F-4D97-AF65-F5344CB8AC3E}">
-        <p14:creationId xmlns:p14="http://schemas.microsoft.com/office/powerpoint/2010/main" val="991943503"/>
+        <p14:creationId xmlns:p14="http://schemas.microsoft.com/office/powerpoint/2010/main" val="1356938526"/>
       </p:ext>
     </p:extLst>
   </p:cSld>
@@ -5486,7 +5486,7 @@
           <p:cNvPr id="6" name="">
             <a:extLst xmlns:a="http://schemas.openxmlformats.org/drawingml/2006/main">
               <a:ext uri="{FF2B5EF4-FFF2-40B4-BE49-F238E27FC236}">
-                <a16:creationId xmlns:a16="http://schemas.microsoft.com/office/drawing/2014/main" id="{24A7A570-817F-4813-923F-E470ABE82653}"/>
+                <a16:creationId xmlns:a16="http://schemas.microsoft.com/office/drawing/2014/main" id="{66F01156-58D7-4974-B21F-5D6E08E638E0}"/>
               </a:ext>
             </a:extLst>
           </p:cNvPr>
@@ -5543,7 +5543,7 @@
           <p:cNvPr id="2" name="">
             <a:extLst xmlns:a="http://schemas.openxmlformats.org/drawingml/2006/main">
               <a:ext uri="{FF2B5EF4-FFF2-40B4-BE49-F238E27FC236}">
-                <a16:creationId xmlns:a16="http://schemas.microsoft.com/office/drawing/2014/main" id="{9C77A48B-3E3E-4EF9-82CF-6074368F2DF5}"/>
+                <a16:creationId xmlns:a16="http://schemas.microsoft.com/office/drawing/2014/main" id="{FA0D1CDD-4D61-48FE-8463-080362EFCDBF}"/>
               </a:ext>
             </a:extLst>
           </p:cNvPr>
@@ -5600,7 +5600,7 @@
           <p:cNvPr id="3" name="">
             <a:extLst xmlns:a="http://schemas.openxmlformats.org/drawingml/2006/main">
               <a:ext uri="{FF2B5EF4-FFF2-40B4-BE49-F238E27FC236}">
-                <a16:creationId xmlns:a16="http://schemas.microsoft.com/office/drawing/2014/main" id="{021F3AF5-74E0-449E-AB13-215D9425FB54}"/>
+                <a16:creationId xmlns:a16="http://schemas.microsoft.com/office/drawing/2014/main" id="{B93BD3CD-C46F-4328-BC48-A74BAE2FB25B}"/>
               </a:ext>
             </a:extLst>
           </p:cNvPr>
@@ -5657,7 +5657,7 @@
           <p:cNvPr id="4" name="">
             <a:extLst xmlns:a="http://schemas.openxmlformats.org/drawingml/2006/main">
               <a:ext uri="{FF2B5EF4-FFF2-40B4-BE49-F238E27FC236}">
-                <a16:creationId xmlns:a16="http://schemas.microsoft.com/office/drawing/2014/main" id="{A4CEF351-8D75-4548-A9A7-EF95365DC56D}"/>
+                <a16:creationId xmlns:a16="http://schemas.microsoft.com/office/drawing/2014/main" id="{1B189C31-7981-4390-9DCD-88E20DA50359}"/>
               </a:ext>
             </a:extLst>
           </p:cNvPr>
@@ -5770,7 +5770,7 @@
           <p:cNvPr id="5" name="">
             <a:extLst xmlns:a="http://schemas.openxmlformats.org/drawingml/2006/main">
               <a:ext uri="{FF2B5EF4-FFF2-40B4-BE49-F238E27FC236}">
-                <a16:creationId xmlns:a16="http://schemas.microsoft.com/office/drawing/2014/main" id="{59E3496F-DE82-4500-B606-6FC9185BDB7A}"/>
+                <a16:creationId xmlns:a16="http://schemas.microsoft.com/office/drawing/2014/main" id="{8C3FBB15-DFCB-4274-B077-7F120E584E15}"/>
               </a:ext>
             </a:extLst>
           </p:cNvPr>
@@ -5848,7 +5848,7 @@
     </p:spTree>
     <p:extLst>
       <p:ext uri="{BB962C8B-B14F-4D97-AF65-F5344CB8AC3E}">
-        <p14:creationId xmlns:p14="http://schemas.microsoft.com/office/powerpoint/2010/main" val="76419847"/>
+        <p14:creationId xmlns:p14="http://schemas.microsoft.com/office/powerpoint/2010/main" val="1743364757"/>
       </p:ext>
     </p:extLst>
   </p:cSld>
@@ -5879,7 +5879,7 @@
           <p:cNvPr id="6" name="">
             <a:extLst xmlns:a="http://schemas.openxmlformats.org/drawingml/2006/main">
               <a:ext uri="{FF2B5EF4-FFF2-40B4-BE49-F238E27FC236}">
-                <a16:creationId xmlns:a16="http://schemas.microsoft.com/office/drawing/2014/main" id="{044F6874-130F-4748-B8A6-0864B39A1C9B}"/>
+                <a16:creationId xmlns:a16="http://schemas.microsoft.com/office/drawing/2014/main" id="{EB18CE52-E026-47F4-958D-083C8E37FCD4}"/>
               </a:ext>
             </a:extLst>
           </p:cNvPr>
@@ -5936,7 +5936,7 @@
           <p:cNvPr id="2" name="">
             <a:extLst xmlns:a="http://schemas.openxmlformats.org/drawingml/2006/main">
               <a:ext uri="{FF2B5EF4-FFF2-40B4-BE49-F238E27FC236}">
-                <a16:creationId xmlns:a16="http://schemas.microsoft.com/office/drawing/2014/main" id="{79E11CB0-0F8B-4B40-AA45-552321085873}"/>
+                <a16:creationId xmlns:a16="http://schemas.microsoft.com/office/drawing/2014/main" id="{A939D080-25AB-417A-81F4-91270A035F1B}"/>
               </a:ext>
             </a:extLst>
           </p:cNvPr>
@@ -5993,7 +5993,7 @@
           <p:cNvPr id="3" name="">
             <a:extLst xmlns:a="http://schemas.openxmlformats.org/drawingml/2006/main">
               <a:ext uri="{FF2B5EF4-FFF2-40B4-BE49-F238E27FC236}">
-                <a16:creationId xmlns:a16="http://schemas.microsoft.com/office/drawing/2014/main" id="{08FB5C11-D550-439C-820F-E4750446E36E}"/>
+                <a16:creationId xmlns:a16="http://schemas.microsoft.com/office/drawing/2014/main" id="{C3945234-1D1C-4FFA-AAE1-DF05003EDADC}"/>
               </a:ext>
             </a:extLst>
           </p:cNvPr>
@@ -6050,7 +6050,7 @@
           <p:cNvPr id="4" name="">
             <a:extLst xmlns:a="http://schemas.openxmlformats.org/drawingml/2006/main">
               <a:ext uri="{FF2B5EF4-FFF2-40B4-BE49-F238E27FC236}">
-                <a16:creationId xmlns:a16="http://schemas.microsoft.com/office/drawing/2014/main" id="{F11C9278-B812-4D90-81FF-969402F962EA}"/>
+                <a16:creationId xmlns:a16="http://schemas.microsoft.com/office/drawing/2014/main" id="{140C4096-128B-41D5-9FF6-06272E5437FC}"/>
               </a:ext>
             </a:extLst>
           </p:cNvPr>
@@ -6163,7 +6163,7 @@
           <p:cNvPr id="5" name="">
             <a:extLst xmlns:a="http://schemas.openxmlformats.org/drawingml/2006/main">
               <a:ext uri="{FF2B5EF4-FFF2-40B4-BE49-F238E27FC236}">
-                <a16:creationId xmlns:a16="http://schemas.microsoft.com/office/drawing/2014/main" id="{8ABC2A7B-80C7-48E7-8A3A-99327E420003}"/>
+                <a16:creationId xmlns:a16="http://schemas.microsoft.com/office/drawing/2014/main" id="{DD3A7FBA-C054-4FC5-82B9-2EFADD8406EA}"/>
               </a:ext>
             </a:extLst>
           </p:cNvPr>
@@ -6218,7 +6218,7 @@
     </p:spTree>
     <p:extLst>
       <p:ext uri="{BB962C8B-B14F-4D97-AF65-F5344CB8AC3E}">
-        <p14:creationId xmlns:p14="http://schemas.microsoft.com/office/powerpoint/2010/main" val="1243842282"/>
+        <p14:creationId xmlns:p14="http://schemas.microsoft.com/office/powerpoint/2010/main" val="2110094228"/>
       </p:ext>
     </p:extLst>
   </p:cSld>
@@ -6249,7 +6249,7 @@
           <p:cNvPr id="7" name="">
             <a:extLst xmlns:a="http://schemas.openxmlformats.org/drawingml/2006/main">
               <a:ext uri="{FF2B5EF4-FFF2-40B4-BE49-F238E27FC236}">
-                <a16:creationId xmlns:a16="http://schemas.microsoft.com/office/drawing/2014/main" id="{C382FEA6-32CE-4F82-AC30-EF6C341D29EC}"/>
+                <a16:creationId xmlns:a16="http://schemas.microsoft.com/office/drawing/2014/main" id="{BD8683C2-8902-47BA-ACE1-A7F4DF9FB793}"/>
               </a:ext>
             </a:extLst>
           </p:cNvPr>
@@ -6306,7 +6306,7 @@
           <p:cNvPr id="2" name="">
             <a:extLst xmlns:a="http://schemas.openxmlformats.org/drawingml/2006/main">
               <a:ext uri="{FF2B5EF4-FFF2-40B4-BE49-F238E27FC236}">
-                <a16:creationId xmlns:a16="http://schemas.microsoft.com/office/drawing/2014/main" id="{81328DB9-07DF-414B-9439-1A51994AB994}"/>
+                <a16:creationId xmlns:a16="http://schemas.microsoft.com/office/drawing/2014/main" id="{570140A7-D266-4DEF-9AD7-449C4DF17345}"/>
               </a:ext>
             </a:extLst>
           </p:cNvPr>
@@ -6363,7 +6363,7 @@
           <p:cNvPr id="3" name="">
             <a:extLst xmlns:a="http://schemas.openxmlformats.org/drawingml/2006/main">
               <a:ext uri="{FF2B5EF4-FFF2-40B4-BE49-F238E27FC236}">
-                <a16:creationId xmlns:a16="http://schemas.microsoft.com/office/drawing/2014/main" id="{3EA7DCD4-FECC-4CEB-8255-1615D50B4B22}"/>
+                <a16:creationId xmlns:a16="http://schemas.microsoft.com/office/drawing/2014/main" id="{9B247B6E-779C-42E6-81CC-A7936102E516}"/>
               </a:ext>
             </a:extLst>
           </p:cNvPr>
@@ -6836,7 +6836,7 @@
           <p:cNvPr id="5" name="">
             <a:extLst xmlns:a="http://schemas.openxmlformats.org/drawingml/2006/main">
               <a:ext uri="{FF2B5EF4-FFF2-40B4-BE49-F238E27FC236}">
-                <a16:creationId xmlns:a16="http://schemas.microsoft.com/office/drawing/2014/main" id="{4E0EA83A-B5BB-4513-9635-7B87DD718840}"/>
+                <a16:creationId xmlns:a16="http://schemas.microsoft.com/office/drawing/2014/main" id="{21FE0A07-C5D4-41BF-BCE4-8CF2C760B212}"/>
               </a:ext>
             </a:extLst>
           </p:cNvPr>
@@ -6921,7 +6921,7 @@
           <p:cNvPr id="6" name="">
             <a:extLst xmlns:a="http://schemas.openxmlformats.org/drawingml/2006/main">
               <a:ext uri="{FF2B5EF4-FFF2-40B4-BE49-F238E27FC236}">
-                <a16:creationId xmlns:a16="http://schemas.microsoft.com/office/drawing/2014/main" id="{F2049937-290E-44AE-9209-C791B1F5C372}"/>
+                <a16:creationId xmlns:a16="http://schemas.microsoft.com/office/drawing/2014/main" id="{4FE8459D-823B-4ED6-8B14-4E274FFA8478}"/>
               </a:ext>
             </a:extLst>
           </p:cNvPr>
@@ -6976,7 +6976,7 @@
     </p:spTree>
     <p:extLst>
       <p:ext uri="{BB962C8B-B14F-4D97-AF65-F5344CB8AC3E}">
-        <p14:creationId xmlns:p14="http://schemas.microsoft.com/office/powerpoint/2010/main" val="1242275336"/>
+        <p14:creationId xmlns:p14="http://schemas.microsoft.com/office/powerpoint/2010/main" val="567590007"/>
       </p:ext>
     </p:extLst>
   </p:cSld>
@@ -7007,7 +7007,7 @@
           <p:cNvPr id="7" name="">
             <a:extLst xmlns:a="http://schemas.openxmlformats.org/drawingml/2006/main">
               <a:ext uri="{FF2B5EF4-FFF2-40B4-BE49-F238E27FC236}">
-                <a16:creationId xmlns:a16="http://schemas.microsoft.com/office/drawing/2014/main" id="{E2B4374B-5EEF-45A1-9363-694734D0EBB3}"/>
+                <a16:creationId xmlns:a16="http://schemas.microsoft.com/office/drawing/2014/main" id="{7A56CA47-4BF8-4159-A699-05C1124717D2}"/>
               </a:ext>
             </a:extLst>
           </p:cNvPr>
@@ -7064,7 +7064,7 @@
           <p:cNvPr id="2" name="">
             <a:extLst xmlns:a="http://schemas.openxmlformats.org/drawingml/2006/main">
               <a:ext uri="{FF2B5EF4-FFF2-40B4-BE49-F238E27FC236}">
-                <a16:creationId xmlns:a16="http://schemas.microsoft.com/office/drawing/2014/main" id="{2F9AC65A-CAF8-4DF3-9854-0052A0620D18}"/>
+                <a16:creationId xmlns:a16="http://schemas.microsoft.com/office/drawing/2014/main" id="{AFF113A7-4918-49C3-B14D-CF3799599A47}"/>
               </a:ext>
             </a:extLst>
           </p:cNvPr>
@@ -7121,7 +7121,7 @@
           <p:cNvPr id="3" name="">
             <a:extLst xmlns:a="http://schemas.openxmlformats.org/drawingml/2006/main">
               <a:ext uri="{FF2B5EF4-FFF2-40B4-BE49-F238E27FC236}">
-                <a16:creationId xmlns:a16="http://schemas.microsoft.com/office/drawing/2014/main" id="{8B79825F-4CB1-4E04-B63D-E9F9E37E2602}"/>
+                <a16:creationId xmlns:a16="http://schemas.microsoft.com/office/drawing/2014/main" id="{A28F80F0-BBD9-4FE6-A36B-EC9AB438C09B}"/>
               </a:ext>
             </a:extLst>
           </p:cNvPr>
@@ -7178,7 +7178,7 @@
           <p:cNvPr id="4" name="">
             <a:extLst xmlns:a="http://schemas.openxmlformats.org/drawingml/2006/main">
               <a:ext uri="{FF2B5EF4-FFF2-40B4-BE49-F238E27FC236}">
-                <a16:creationId xmlns:a16="http://schemas.microsoft.com/office/drawing/2014/main" id="{C08212D9-9188-4C36-96E1-C7992564242C}"/>
+                <a16:creationId xmlns:a16="http://schemas.microsoft.com/office/drawing/2014/main" id="{3F6B693C-CBD9-4B86-8426-0970F20BE0EE}"/>
               </a:ext>
             </a:extLst>
           </p:cNvPr>
@@ -7319,7 +7319,7 @@
           <p:cNvPr id="5" name="">
             <a:extLst xmlns:a="http://schemas.openxmlformats.org/drawingml/2006/main">
               <a:ext uri="{FF2B5EF4-FFF2-40B4-BE49-F238E27FC236}">
-                <a16:creationId xmlns:a16="http://schemas.microsoft.com/office/drawing/2014/main" id="{EDA61498-4EB6-4476-AEF7-300C0309C215}"/>
+                <a16:creationId xmlns:a16="http://schemas.microsoft.com/office/drawing/2014/main" id="{A1446670-385B-46FC-B2FD-D5B75FED6128}"/>
               </a:ext>
             </a:extLst>
           </p:cNvPr>
@@ -7422,7 +7422,7 @@
           <p:cNvPr id="6" name="">
             <a:extLst xmlns:a="http://schemas.openxmlformats.org/drawingml/2006/main">
               <a:ext uri="{FF2B5EF4-FFF2-40B4-BE49-F238E27FC236}">
-                <a16:creationId xmlns:a16="http://schemas.microsoft.com/office/drawing/2014/main" id="{621BED62-59E4-4375-9AF2-D21CD965847F}"/>
+                <a16:creationId xmlns:a16="http://schemas.microsoft.com/office/drawing/2014/main" id="{D74E583E-9E43-47C4-8958-530DF5A2CB43}"/>
               </a:ext>
             </a:extLst>
           </p:cNvPr>
@@ -7477,7 +7477,7 @@
     </p:spTree>
     <p:extLst>
       <p:ext uri="{BB962C8B-B14F-4D97-AF65-F5344CB8AC3E}">
-        <p14:creationId xmlns:p14="http://schemas.microsoft.com/office/powerpoint/2010/main" val="1818488791"/>
+        <p14:creationId xmlns:p14="http://schemas.microsoft.com/office/powerpoint/2010/main" val="1229558058"/>
       </p:ext>
     </p:extLst>
   </p:cSld>
@@ -7508,7 +7508,7 @@
           <p:cNvPr id="6" name="">
             <a:extLst xmlns:a="http://schemas.openxmlformats.org/drawingml/2006/main">
               <a:ext uri="{FF2B5EF4-FFF2-40B4-BE49-F238E27FC236}">
-                <a16:creationId xmlns:a16="http://schemas.microsoft.com/office/drawing/2014/main" id="{3AD65419-AE2D-47ED-9E30-753BB1718424}"/>
+                <a16:creationId xmlns:a16="http://schemas.microsoft.com/office/drawing/2014/main" id="{CBD13E73-9223-4268-AD0E-95C02E1810A0}"/>
               </a:ext>
             </a:extLst>
           </p:cNvPr>
@@ -7565,7 +7565,7 @@
           <p:cNvPr id="2" name="">
             <a:extLst xmlns:a="http://schemas.openxmlformats.org/drawingml/2006/main">
               <a:ext uri="{FF2B5EF4-FFF2-40B4-BE49-F238E27FC236}">
-                <a16:creationId xmlns:a16="http://schemas.microsoft.com/office/drawing/2014/main" id="{26768E4B-B51F-4B09-A5F2-9BC960B15745}"/>
+                <a16:creationId xmlns:a16="http://schemas.microsoft.com/office/drawing/2014/main" id="{B99D2ED9-18A5-4D9E-9C03-AE53A5F64B08}"/>
               </a:ext>
             </a:extLst>
           </p:cNvPr>
@@ -7622,7 +7622,7 @@
           <p:cNvPr id="3" name="">
             <a:extLst xmlns:a="http://schemas.openxmlformats.org/drawingml/2006/main">
               <a:ext uri="{FF2B5EF4-FFF2-40B4-BE49-F238E27FC236}">
-                <a16:creationId xmlns:a16="http://schemas.microsoft.com/office/drawing/2014/main" id="{DD23FF3D-E33F-4F56-9DA0-E112797AB8B7}"/>
+                <a16:creationId xmlns:a16="http://schemas.microsoft.com/office/drawing/2014/main" id="{B80E32FC-CB54-43EE-901C-ADD7C44B1BD9}"/>
               </a:ext>
             </a:extLst>
           </p:cNvPr>
@@ -7679,7 +7679,7 @@
           <p:cNvPr id="4" name="">
             <a:extLst xmlns:a="http://schemas.openxmlformats.org/drawingml/2006/main">
               <a:ext uri="{FF2B5EF4-FFF2-40B4-BE49-F238E27FC236}">
-                <a16:creationId xmlns:a16="http://schemas.microsoft.com/office/drawing/2014/main" id="{64D62F80-28AB-42F2-8AAC-92825A41366F}"/>
+                <a16:creationId xmlns:a16="http://schemas.microsoft.com/office/drawing/2014/main" id="{DDB79063-9754-4CF6-8F7D-58E7BF13A463}"/>
               </a:ext>
             </a:extLst>
           </p:cNvPr>
@@ -7792,7 +7792,7 @@
           <p:cNvPr id="5" name="">
             <a:extLst xmlns:a="http://schemas.openxmlformats.org/drawingml/2006/main">
               <a:ext uri="{FF2B5EF4-FFF2-40B4-BE49-F238E27FC236}">
-                <a16:creationId xmlns:a16="http://schemas.microsoft.com/office/drawing/2014/main" id="{284BAB30-1A34-4875-AAB6-7C6831906B0E}"/>
+                <a16:creationId xmlns:a16="http://schemas.microsoft.com/office/drawing/2014/main" id="{6CB3C2C4-D83F-4E9C-86F1-40430A48D470}"/>
               </a:ext>
             </a:extLst>
           </p:cNvPr>
@@ -7893,7 +7893,7 @@
     </p:spTree>
     <p:extLst>
       <p:ext uri="{BB962C8B-B14F-4D97-AF65-F5344CB8AC3E}">
-        <p14:creationId xmlns:p14="http://schemas.microsoft.com/office/powerpoint/2010/main" val="872823588"/>
+        <p14:creationId xmlns:p14="http://schemas.microsoft.com/office/powerpoint/2010/main" val="334347254"/>
       </p:ext>
     </p:extLst>
   </p:cSld>
@@ -7924,7 +7924,7 @@
           <p:cNvPr id="7" name="">
             <a:extLst xmlns:a="http://schemas.openxmlformats.org/drawingml/2006/main">
               <a:ext uri="{FF2B5EF4-FFF2-40B4-BE49-F238E27FC236}">
-                <a16:creationId xmlns:a16="http://schemas.microsoft.com/office/drawing/2014/main" id="{B0AA2F7A-9824-40AC-A440-AB900DA5BD57}"/>
+                <a16:creationId xmlns:a16="http://schemas.microsoft.com/office/drawing/2014/main" id="{E7B8D03E-5FA7-4859-BB2C-E4DE01B83D7A}"/>
               </a:ext>
             </a:extLst>
           </p:cNvPr>
@@ -7981,7 +7981,7 @@
           <p:cNvPr id="2" name="">
             <a:extLst xmlns:a="http://schemas.openxmlformats.org/drawingml/2006/main">
               <a:ext uri="{FF2B5EF4-FFF2-40B4-BE49-F238E27FC236}">
-                <a16:creationId xmlns:a16="http://schemas.microsoft.com/office/drawing/2014/main" id="{8862D0A0-4463-4CA2-9563-6FF88D67315B}"/>
+                <a16:creationId xmlns:a16="http://schemas.microsoft.com/office/drawing/2014/main" id="{C91AE3DA-02A1-41CF-8C1A-236F28F43D48}"/>
               </a:ext>
             </a:extLst>
           </p:cNvPr>
@@ -8038,7 +8038,7 @@
           <p:cNvPr id="3" name="">
             <a:extLst xmlns:a="http://schemas.openxmlformats.org/drawingml/2006/main">
               <a:ext uri="{FF2B5EF4-FFF2-40B4-BE49-F238E27FC236}">
-                <a16:creationId xmlns:a16="http://schemas.microsoft.com/office/drawing/2014/main" id="{8541FE2F-EE22-42AD-B6B5-5B4BA7335B98}"/>
+                <a16:creationId xmlns:a16="http://schemas.microsoft.com/office/drawing/2014/main" id="{22B15E07-C8D2-42AA-AE3F-A040AD7F0E37}"/>
               </a:ext>
             </a:extLst>
           </p:cNvPr>
@@ -8095,7 +8095,7 @@
           <p:cNvPr id="4" name="">
             <a:extLst xmlns:a="http://schemas.openxmlformats.org/drawingml/2006/main">
               <a:ext uri="{FF2B5EF4-FFF2-40B4-BE49-F238E27FC236}">
-                <a16:creationId xmlns:a16="http://schemas.microsoft.com/office/drawing/2014/main" id="{6D737F55-8A28-41BC-9C57-DE5DD8D0214B}"/>
+                <a16:creationId xmlns:a16="http://schemas.microsoft.com/office/drawing/2014/main" id="{A52A84F4-5C18-4E4A-A818-52F4F00D354A}"/>
               </a:ext>
             </a:extLst>
           </p:cNvPr>
@@ -8180,7 +8180,7 @@
           <p:cNvPr id="5" name="">
             <a:extLst xmlns:a="http://schemas.openxmlformats.org/drawingml/2006/main">
               <a:ext uri="{FF2B5EF4-FFF2-40B4-BE49-F238E27FC236}">
-                <a16:creationId xmlns:a16="http://schemas.microsoft.com/office/drawing/2014/main" id="{2797EC1D-EFE8-4DDF-A250-0E927B1E1937}"/>
+                <a16:creationId xmlns:a16="http://schemas.microsoft.com/office/drawing/2014/main" id="{EFC5C609-B701-46A9-AC82-ECCFED5C0B33}"/>
               </a:ext>
             </a:extLst>
           </p:cNvPr>
@@ -8283,7 +8283,7 @@
           <p:cNvPr id="6" name="">
             <a:extLst xmlns:a="http://schemas.openxmlformats.org/drawingml/2006/main">
               <a:ext uri="{FF2B5EF4-FFF2-40B4-BE49-F238E27FC236}">
-                <a16:creationId xmlns:a16="http://schemas.microsoft.com/office/drawing/2014/main" id="{49C5674A-412F-47AE-9B20-45DF65A388FC}"/>
+                <a16:creationId xmlns:a16="http://schemas.microsoft.com/office/drawing/2014/main" id="{398744DC-4521-4AB8-B79E-1E647749D198}"/>
               </a:ext>
             </a:extLst>
           </p:cNvPr>
@@ -8338,7 +8338,7 @@
     </p:spTree>
     <p:extLst>
       <p:ext uri="{BB962C8B-B14F-4D97-AF65-F5344CB8AC3E}">
-        <p14:creationId xmlns:p14="http://schemas.microsoft.com/office/powerpoint/2010/main" val="237674924"/>
+        <p14:creationId xmlns:p14="http://schemas.microsoft.com/office/powerpoint/2010/main" val="1781508192"/>
       </p:ext>
     </p:extLst>
   </p:cSld>
@@ -8369,7 +8369,7 @@
           <p:cNvPr id="7" name="">
             <a:extLst xmlns:a="http://schemas.openxmlformats.org/drawingml/2006/main">
               <a:ext uri="{FF2B5EF4-FFF2-40B4-BE49-F238E27FC236}">
-                <a16:creationId xmlns:a16="http://schemas.microsoft.com/office/drawing/2014/main" id="{F2002B98-DBEE-47B1-B91E-DC5C5ACA4548}"/>
+                <a16:creationId xmlns:a16="http://schemas.microsoft.com/office/drawing/2014/main" id="{4562F9B2-F638-4E76-A483-33E66FD6245E}"/>
               </a:ext>
             </a:extLst>
           </p:cNvPr>
@@ -8426,7 +8426,7 @@
           <p:cNvPr id="2" name="">
             <a:extLst xmlns:a="http://schemas.openxmlformats.org/drawingml/2006/main">
               <a:ext uri="{FF2B5EF4-FFF2-40B4-BE49-F238E27FC236}">
-                <a16:creationId xmlns:a16="http://schemas.microsoft.com/office/drawing/2014/main" id="{8CC93428-7895-4618-9C9F-1E470B3DB88B}"/>
+                <a16:creationId xmlns:a16="http://schemas.microsoft.com/office/drawing/2014/main" id="{FEF2B515-5173-4B85-86AD-E8B4BADF0F91}"/>
               </a:ext>
             </a:extLst>
           </p:cNvPr>
@@ -8483,7 +8483,7 @@
           <p:cNvPr id="3" name="">
             <a:extLst xmlns:a="http://schemas.openxmlformats.org/drawingml/2006/main">
               <a:ext uri="{FF2B5EF4-FFF2-40B4-BE49-F238E27FC236}">
-                <a16:creationId xmlns:a16="http://schemas.microsoft.com/office/drawing/2014/main" id="{A2177AE7-3CF3-430D-BA11-4BECB2352388}"/>
+                <a16:creationId xmlns:a16="http://schemas.microsoft.com/office/drawing/2014/main" id="{AA868AC3-9493-4B5A-8AF2-91D404C2C0E9}"/>
               </a:ext>
             </a:extLst>
           </p:cNvPr>
@@ -8544,7 +8544,7 @@
           <p:nvPr/>
         </p:nvPicPr>
         <p:blipFill>
-          <a:blip xmlns:r="http://schemas.openxmlformats.org/officeDocument/2006/relationships" xmlns:a="http://schemas.openxmlformats.org/drawingml/2006/main" r:embed="R99d400a2c64241a8"/>
+          <a:blip xmlns:r="http://schemas.openxmlformats.org/officeDocument/2006/relationships" xmlns:a="http://schemas.openxmlformats.org/drawingml/2006/main" r:embed="R02daadb73a384a44"/>
           <a:stretch xmlns:a="http://schemas.openxmlformats.org/drawingml/2006/main"/>
         </p:blipFill>
         <p:spPr>
@@ -8562,7 +8562,7 @@
           <p:cNvPr id="5" name="">
             <a:extLst xmlns:a="http://schemas.openxmlformats.org/drawingml/2006/main">
               <a:ext uri="{FF2B5EF4-FFF2-40B4-BE49-F238E27FC236}">
-                <a16:creationId xmlns:a16="http://schemas.microsoft.com/office/drawing/2014/main" id="{556E404A-7271-4FF6-91FA-7C02CAA1D86D}"/>
+                <a16:creationId xmlns:a16="http://schemas.microsoft.com/office/drawing/2014/main" id="{AAB277D1-7128-40FD-8839-9145F9ACDFFE}"/>
               </a:ext>
             </a:extLst>
           </p:cNvPr>
@@ -8619,7 +8619,7 @@
           <p:cNvPr id="6" name="">
             <a:extLst xmlns:a="http://schemas.openxmlformats.org/drawingml/2006/main">
               <a:ext uri="{FF2B5EF4-FFF2-40B4-BE49-F238E27FC236}">
-                <a16:creationId xmlns:a16="http://schemas.microsoft.com/office/drawing/2014/main" id="{933D0E42-4DE5-4598-9013-BDFA85FE8B24}"/>
+                <a16:creationId xmlns:a16="http://schemas.microsoft.com/office/drawing/2014/main" id="{A3F2BD95-23F8-45E7-98C1-FD3ABA86E899}"/>
               </a:ext>
             </a:extLst>
           </p:cNvPr>
@@ -8674,7 +8674,7 @@
     </p:spTree>
     <p:extLst>
       <p:ext uri="{BB962C8B-B14F-4D97-AF65-F5344CB8AC3E}">
-        <p14:creationId xmlns:p14="http://schemas.microsoft.com/office/powerpoint/2010/main" val="97481855"/>
+        <p14:creationId xmlns:p14="http://schemas.microsoft.com/office/powerpoint/2010/main" val="1255033957"/>
       </p:ext>
     </p:extLst>
   </p:cSld>

</xml_diff>

<commit_message>
Open week 4 with prediction, recall and pair activities
</commit_message>
<xml_diff>
--- a/lendet/2026-2027/mobile/lectures/ligjerata-04-neon-postgresql-rideshare-2026.pptx
+++ b/lendet/2026-2027/mobile/lectures/ligjerata-04-neon-postgresql-rideshare-2026.pptx
@@ -2,28 +2,28 @@
 <file path=ppt/presentation.xml><?xml version="1.0" encoding="utf-8"?>
 <p:presentation xmlns:p="http://schemas.openxmlformats.org/presentationml/2006/main">
   <p:sldMasterIdLst>
-    <p:sldMasterId xmlns:r="http://schemas.openxmlformats.org/officeDocument/2006/relationships" id="2147483648" r:id="R32c6a9eb752d418c"/>
+    <p:sldMasterId xmlns:r="http://schemas.openxmlformats.org/officeDocument/2006/relationships" id="2147483648" r:id="Rfbc03226f6eb4e4e"/>
   </p:sldMasterIdLst>
   <p:sldIdLst>
-    <p:sldId xmlns:r="http://schemas.openxmlformats.org/officeDocument/2006/relationships" id="256" r:id="Ra876a60a489f4bc9"/>
-    <p:sldId xmlns:r="http://schemas.openxmlformats.org/officeDocument/2006/relationships" id="257" r:id="R225528af12c04fbc"/>
-    <p:sldId xmlns:r="http://schemas.openxmlformats.org/officeDocument/2006/relationships" id="258" r:id="Rb9528da0e9694116"/>
-    <p:sldId xmlns:r="http://schemas.openxmlformats.org/officeDocument/2006/relationships" id="259" r:id="Re8aca3b46b15401f"/>
-    <p:sldId xmlns:r="http://schemas.openxmlformats.org/officeDocument/2006/relationships" id="260" r:id="R2bd05c2b2ee94015"/>
-    <p:sldId xmlns:r="http://schemas.openxmlformats.org/officeDocument/2006/relationships" id="261" r:id="Rf11bb080a3254ff9"/>
-    <p:sldId xmlns:r="http://schemas.openxmlformats.org/officeDocument/2006/relationships" id="262" r:id="Rf4ebb075ec0b41a3"/>
-    <p:sldId xmlns:r="http://schemas.openxmlformats.org/officeDocument/2006/relationships" id="263" r:id="Rc0be5e9fa4d24ca2"/>
-    <p:sldId xmlns:r="http://schemas.openxmlformats.org/officeDocument/2006/relationships" id="264" r:id="Raa28d02aa4bf4d1b"/>
-    <p:sldId xmlns:r="http://schemas.openxmlformats.org/officeDocument/2006/relationships" id="265" r:id="Rf6dd8d9e2c2c4017"/>
-    <p:sldId xmlns:r="http://schemas.openxmlformats.org/officeDocument/2006/relationships" id="266" r:id="R5a01840c332146a0"/>
-    <p:sldId xmlns:r="http://schemas.openxmlformats.org/officeDocument/2006/relationships" id="267" r:id="R77137f03398e4e14"/>
-    <p:sldId xmlns:r="http://schemas.openxmlformats.org/officeDocument/2006/relationships" id="268" r:id="Rdea3d882bc2445f3"/>
-    <p:sldId xmlns:r="http://schemas.openxmlformats.org/officeDocument/2006/relationships" id="269" r:id="R3d965ea79fbe4b45"/>
-    <p:sldId xmlns:r="http://schemas.openxmlformats.org/officeDocument/2006/relationships" id="270" r:id="R67d24730111e4ccc"/>
-    <p:sldId xmlns:r="http://schemas.openxmlformats.org/officeDocument/2006/relationships" id="271" r:id="R4c82b1a80aef41eb"/>
-    <p:sldId xmlns:r="http://schemas.openxmlformats.org/officeDocument/2006/relationships" id="272" r:id="R0bd03a94435e4390"/>
-    <p:sldId xmlns:r="http://schemas.openxmlformats.org/officeDocument/2006/relationships" id="273" r:id="Ra87217fc09a54fdb"/>
-    <p:sldId xmlns:r="http://schemas.openxmlformats.org/officeDocument/2006/relationships" id="274" r:id="R8708fb9bb89f445c"/>
+    <p:sldId xmlns:r="http://schemas.openxmlformats.org/officeDocument/2006/relationships" id="256" r:id="R3b6dfc7129344470"/>
+    <p:sldId xmlns:r="http://schemas.openxmlformats.org/officeDocument/2006/relationships" id="257" r:id="R70386f0001524a25"/>
+    <p:sldId xmlns:r="http://schemas.openxmlformats.org/officeDocument/2006/relationships" id="258" r:id="Rf378e82c3b73438e"/>
+    <p:sldId xmlns:r="http://schemas.openxmlformats.org/officeDocument/2006/relationships" id="259" r:id="Rb2b16735c67144d6"/>
+    <p:sldId xmlns:r="http://schemas.openxmlformats.org/officeDocument/2006/relationships" id="260" r:id="R5d0c67ab1bd14563"/>
+    <p:sldId xmlns:r="http://schemas.openxmlformats.org/officeDocument/2006/relationships" id="261" r:id="R468ffb7a7c1341ae"/>
+    <p:sldId xmlns:r="http://schemas.openxmlformats.org/officeDocument/2006/relationships" id="262" r:id="R3cdbab9ff8654143"/>
+    <p:sldId xmlns:r="http://schemas.openxmlformats.org/officeDocument/2006/relationships" id="263" r:id="Rffe5a0e75bef4dfb"/>
+    <p:sldId xmlns:r="http://schemas.openxmlformats.org/officeDocument/2006/relationships" id="264" r:id="R2fe99c39a0004de8"/>
+    <p:sldId xmlns:r="http://schemas.openxmlformats.org/officeDocument/2006/relationships" id="265" r:id="R7a4b041bce5e43a4"/>
+    <p:sldId xmlns:r="http://schemas.openxmlformats.org/officeDocument/2006/relationships" id="266" r:id="R853c7a729f9046e5"/>
+    <p:sldId xmlns:r="http://schemas.openxmlformats.org/officeDocument/2006/relationships" id="267" r:id="R33ab35c420c14286"/>
+    <p:sldId xmlns:r="http://schemas.openxmlformats.org/officeDocument/2006/relationships" id="268" r:id="Re2b64fe008e549f2"/>
+    <p:sldId xmlns:r="http://schemas.openxmlformats.org/officeDocument/2006/relationships" id="269" r:id="R3c4d5f459a6c4e28"/>
+    <p:sldId xmlns:r="http://schemas.openxmlformats.org/officeDocument/2006/relationships" id="270" r:id="R1a5f24de1e6049ef"/>
+    <p:sldId xmlns:r="http://schemas.openxmlformats.org/officeDocument/2006/relationships" id="271" r:id="R83672bba7da3427a"/>
+    <p:sldId xmlns:r="http://schemas.openxmlformats.org/officeDocument/2006/relationships" id="272" r:id="R80aadb8499344884"/>
+    <p:sldId xmlns:r="http://schemas.openxmlformats.org/officeDocument/2006/relationships" id="273" r:id="R120a5256b4fa4932"/>
+    <p:sldId xmlns:r="http://schemas.openxmlformats.org/officeDocument/2006/relationships" id="274" r:id="R916db68a60a9448e"/>
   </p:sldIdLst>
   <p:sldSz cx="12192000" cy="6858000"/>
   <p:notesSz cx="6858000" cy="9144000"/>
@@ -68,7 +68,7 @@
   </p:cSld>
   <p:clrMap bg1="lt1" tx1="dk1" bg2="lt2" tx2="dk2" accent1="accent1" accent2="accent2" accent3="accent3" accent4="accent4" accent5="accent5" accent6="accent6" hlink="hlink" folHlink="folHlink"/>
   <p:sldLayoutIdLst>
-    <p:sldLayoutId xmlns:r="http://schemas.openxmlformats.org/officeDocument/2006/relationships" id="2147483649" r:id="Ra7786729b4264688"/>
+    <p:sldLayoutId xmlns:r="http://schemas.openxmlformats.org/officeDocument/2006/relationships" id="2147483649" r:id="Rfa954cd63d044e00"/>
   </p:sldLayoutIdLst>
   <p:txStyles>
     <p:titleStyle>
@@ -616,10 +616,10 @@
       </p:grpSpPr>
       <p:sp>
         <p:nvSpPr>
-          <p:cNvPr id="7" name="">
-            <a:extLst xmlns:a="http://schemas.openxmlformats.org/drawingml/2006/main">
-              <a:ext uri="{FF2B5EF4-FFF2-40B4-BE49-F238E27FC236}">
-                <a16:creationId xmlns:a16="http://schemas.microsoft.com/office/drawing/2014/main" id="{E4444AD0-3908-485E-8C65-76827F43EC53}"/>
+          <p:cNvPr id="9" name="">
+            <a:extLst xmlns:a="http://schemas.openxmlformats.org/drawingml/2006/main">
+              <a:ext uri="{FF2B5EF4-FFF2-40B4-BE49-F238E27FC236}">
+                <a16:creationId xmlns:a16="http://schemas.microsoft.com/office/drawing/2014/main" id="{0EE494C5-12F5-46D4-8B4F-085A908AC1DE}"/>
               </a:ext>
             </a:extLst>
           </p:cNvPr>
@@ -666,7 +666,7 @@
                 <a:ea typeface="Arial"/>
                 <a:cs typeface="Arial"/>
               </a:rPr>
-              <a:t>JAVA 4 · 08.10.2026</a:t>
+              <a:t>JAVA 4 · 08.10.2026 · SFIDA E HAPJES · 0–2 MIN</a:t>
             </a:r>
           </a:p>
         </p:txBody>
@@ -676,7 +676,7 @@
           <p:cNvPr id="2" name="">
             <a:extLst xmlns:a="http://schemas.openxmlformats.org/drawingml/2006/main">
               <a:ext uri="{FF2B5EF4-FFF2-40B4-BE49-F238E27FC236}">
-                <a16:creationId xmlns:a16="http://schemas.microsoft.com/office/drawing/2014/main" id="{8FE48659-1822-4FBB-AC30-6EA0B984A49E}"/>
+                <a16:creationId xmlns:a16="http://schemas.microsoft.com/office/drawing/2014/main" id="{5CD53E60-A67C-4263-B6DF-B52C70E98A9E}"/>
               </a:ext>
             </a:extLst>
           </p:cNvPr>
@@ -724,85 +724,6 @@
                 <a:cs typeface="Arial"/>
               </a:rPr>
               <a:t>01 / 19</a:t>
-            </a:r>
-          </a:p>
-        </p:txBody>
-      </p:sp>
-      <p:pic>
-        <p:nvPicPr>
-          <p:cNvPr id="9" name=""/>
-          <p:cNvPicPr>
-            <a:picLocks xmlns:a="http://schemas.openxmlformats.org/drawingml/2006/main" noChangeAspect="1"/>
-          </p:cNvPicPr>
-          <p:nvPr/>
-        </p:nvPicPr>
-        <p:blipFill>
-          <a:blip xmlns:r="http://schemas.openxmlformats.org/officeDocument/2006/relationships" xmlns:a="http://schemas.openxmlformats.org/drawingml/2006/main" r:embed="R7b9fbe3177c94231"/>
-          <a:stretch xmlns:a="http://schemas.openxmlformats.org/drawingml/2006/main"/>
-        </p:blipFill>
-        <p:spPr>
-          <a:xfrm xmlns:a="http://schemas.openxmlformats.org/drawingml/2006/main">
-            <a:off x="10287000" y="925435"/>
-            <a:ext cx="1238250" cy="244630"/>
-          </a:xfrm>
-          <a:prstGeom xmlns:a="http://schemas.openxmlformats.org/drawingml/2006/main" prst="rect">
-            <a:avLst/>
-          </a:prstGeom>
-        </p:spPr>
-      </p:pic>
-      <p:sp>
-        <p:nvSpPr>
-          <p:cNvPr id="4" name="">
-            <a:extLst xmlns:a="http://schemas.openxmlformats.org/drawingml/2006/main">
-              <a:ext uri="{FF2B5EF4-FFF2-40B4-BE49-F238E27FC236}">
-                <a16:creationId xmlns:a16="http://schemas.microsoft.com/office/drawing/2014/main" id="{6CB606FB-A592-4FEC-9B03-B98CDF1CEAB6}"/>
-              </a:ext>
-            </a:extLst>
-          </p:cNvPr>
-          <p:cNvSpPr>
-            <a:spLocks xmlns:a="http://schemas.openxmlformats.org/drawingml/2006/main" noGrp="1"/>
-          </p:cNvSpPr>
-          <p:nvPr/>
-        </p:nvSpPr>
-        <p:spPr>
-          <a:xfrm xmlns:a="http://schemas.openxmlformats.org/drawingml/2006/main">
-            <a:off x="609600" y="857250"/>
-            <a:ext cx="9429750" cy="714375"/>
-          </a:xfrm>
-          <a:prstGeom xmlns:a="http://schemas.openxmlformats.org/drawingml/2006/main" prst="rect">
-            <a:avLst/>
-          </a:prstGeom>
-          <a:noFill xmlns:a="http://schemas.openxmlformats.org/drawingml/2006/main"/>
-          <a:ln xmlns:a="http://schemas.openxmlformats.org/drawingml/2006/main" w="0">
-            <a:noFill/>
-          </a:ln>
-        </p:spPr>
-        <p:txBody>
-          <a:bodyPr xmlns:a="http://schemas.openxmlformats.org/drawingml/2006/main">
-            <a:noAutofit/>
-          </a:bodyPr>
-          <a:lstStyle xmlns:a="http://schemas.openxmlformats.org/drawingml/2006/main"/>
-          <a:p xmlns:a="http://schemas.openxmlformats.org/drawingml/2006/main">
-            <a:pPr>
-              <a:defRPr sz="3300" b="1">
-                <a:solidFill>
-                  <a:srgbClr val="FFFFFF"/>
-                </a:solidFill>
-                <a:latin typeface="Arial"/>
-                <a:ea typeface="Arial"/>
-                <a:cs typeface="Arial"/>
-              </a:defRPr>
-            </a:pPr>
-            <a:r>
-              <a:rPr sz="3300" b="1">
-                <a:solidFill>
-                  <a:srgbClr val="FFFFFF"/>
-                </a:solidFill>
-                <a:latin typeface="Arial"/>
-                <a:ea typeface="Arial"/>
-                <a:cs typeface="Arial"/>
-              </a:rPr>
-              <a:t>Si komunikon RideShare me databazën</a:t>
             </a:r>
           </a:p>
         </p:txBody>
@@ -816,13 +737,13 @@
           <p:nvPr/>
         </p:nvPicPr>
         <p:blipFill>
-          <a:blip xmlns:r="http://schemas.openxmlformats.org/officeDocument/2006/relationships" xmlns:a="http://schemas.openxmlformats.org/drawingml/2006/main" r:embed="Rcb89d66de114409e"/>
+          <a:blip xmlns:r="http://schemas.openxmlformats.org/officeDocument/2006/relationships" xmlns:a="http://schemas.openxmlformats.org/drawingml/2006/main" r:embed="R1b3363b6b5ee438d"/>
           <a:stretch xmlns:a="http://schemas.openxmlformats.org/drawingml/2006/main"/>
         </p:blipFill>
         <p:spPr>
           <a:xfrm xmlns:a="http://schemas.openxmlformats.org/drawingml/2006/main">
-            <a:off x="609600" y="1770063"/>
-            <a:ext cx="10953750" cy="3651250"/>
+            <a:off x="10287000" y="925435"/>
+            <a:ext cx="1238250" cy="244630"/>
           </a:xfrm>
           <a:prstGeom xmlns:a="http://schemas.openxmlformats.org/drawingml/2006/main" prst="rect">
             <a:avLst/>
@@ -831,80 +752,369 @@
       </p:pic>
       <p:sp>
         <p:nvSpPr>
+          <p:cNvPr id="4" name="">
+            <a:extLst xmlns:a="http://schemas.openxmlformats.org/drawingml/2006/main">
+              <a:ext uri="{FF2B5EF4-FFF2-40B4-BE49-F238E27FC236}">
+                <a16:creationId xmlns:a16="http://schemas.microsoft.com/office/drawing/2014/main" id="{6325C784-1B51-44A3-9171-E7C8D0045ABB}"/>
+              </a:ext>
+            </a:extLst>
+          </p:cNvPr>
+          <p:cNvSpPr>
+            <a:spLocks xmlns:a="http://schemas.openxmlformats.org/drawingml/2006/main" noGrp="1"/>
+          </p:cNvSpPr>
+          <p:nvPr/>
+        </p:nvSpPr>
+        <p:spPr>
+          <a:xfrm xmlns:a="http://schemas.openxmlformats.org/drawingml/2006/main">
+            <a:off x="609600" y="933450"/>
+            <a:ext cx="9429750" cy="952500"/>
+          </a:xfrm>
+          <a:prstGeom xmlns:a="http://schemas.openxmlformats.org/drawingml/2006/main" prst="rect">
+            <a:avLst/>
+          </a:prstGeom>
+          <a:noFill xmlns:a="http://schemas.openxmlformats.org/drawingml/2006/main"/>
+          <a:ln xmlns:a="http://schemas.openxmlformats.org/drawingml/2006/main" w="0">
+            <a:noFill/>
+          </a:ln>
+        </p:spPr>
+        <p:txBody>
+          <a:bodyPr xmlns:a="http://schemas.openxmlformats.org/drawingml/2006/main">
+            <a:noAutofit/>
+          </a:bodyPr>
+          <a:lstStyle xmlns:a="http://schemas.openxmlformats.org/drawingml/2006/main"/>
+          <a:p xmlns:a="http://schemas.openxmlformats.org/drawingml/2006/main">
+            <a:pPr>
+              <a:defRPr sz="3300" b="1">
+                <a:solidFill>
+                  <a:srgbClr val="FFFFFF"/>
+                </a:solidFill>
+                <a:latin typeface="Arial"/>
+                <a:ea typeface="Arial"/>
+                <a:cs typeface="Arial"/>
+              </a:defRPr>
+            </a:pPr>
+            <a:r>
+              <a:rPr sz="3300" b="1">
+                <a:solidFill>
+                  <a:srgbClr val="FFFFFF"/>
+                </a:solidFill>
+                <a:latin typeface="Arial"/>
+                <a:ea typeface="Arial"/>
+                <a:cs typeface="Arial"/>
+              </a:rPr>
+              <a:t>Nisja për në AAB ndryshoi. Po aplikacioni?</a:t>
+            </a:r>
+          </a:p>
+        </p:txBody>
+      </p:sp>
+      <p:sp>
+        <p:nvSpPr>
+          <p:cNvPr id="5" name="">
+            <a:extLst xmlns:a="http://schemas.openxmlformats.org/drawingml/2006/main">
+              <a:ext uri="{FF2B5EF4-FFF2-40B4-BE49-F238E27FC236}">
+                <a16:creationId xmlns:a16="http://schemas.microsoft.com/office/drawing/2014/main" id="{E39B07FB-7C08-49DA-993A-71DF6A0BD5B1}"/>
+              </a:ext>
+            </a:extLst>
+          </p:cNvPr>
+          <p:cNvSpPr>
+            <a:spLocks xmlns:a="http://schemas.openxmlformats.org/drawingml/2006/main" noGrp="1"/>
+          </p:cNvSpPr>
+          <p:nvPr/>
+        </p:nvSpPr>
+        <p:spPr>
+          <a:xfrm xmlns:a="http://schemas.openxmlformats.org/drawingml/2006/main">
+            <a:off x="609600" y="1952625"/>
+            <a:ext cx="10953750" cy="1666875"/>
+          </a:xfrm>
+          <a:prstGeom xmlns:a="http://schemas.openxmlformats.org/drawingml/2006/main" prst="rect">
+            <a:avLst/>
+          </a:prstGeom>
+          <a:noFill xmlns:a="http://schemas.openxmlformats.org/drawingml/2006/main"/>
+          <a:ln xmlns:a="http://schemas.openxmlformats.org/drawingml/2006/main" w="0">
+            <a:noFill/>
+          </a:ln>
+        </p:spPr>
+        <p:txBody>
+          <a:bodyPr xmlns:a="http://schemas.openxmlformats.org/drawingml/2006/main">
+            <a:noAutofit/>
+          </a:bodyPr>
+          <a:lstStyle xmlns:a="http://schemas.openxmlformats.org/drawingml/2006/main"/>
+          <a:p xmlns:a="http://schemas.openxmlformats.org/drawingml/2006/main">
+            <a:pPr>
+              <a:defRPr sz="2025" b="0">
+                <a:solidFill>
+                  <a:srgbClr val="EAF1FF"/>
+                </a:solidFill>
+                <a:latin typeface="Arial"/>
+                <a:ea typeface="Arial"/>
+                <a:cs typeface="Arial"/>
+              </a:defRPr>
+            </a:pPr>
+            <a:r>
+              <a:rPr sz="2025" b="0">
+                <a:solidFill>
+                  <a:srgbClr val="EAF1FF"/>
+                </a:solidFill>
+                <a:latin typeface="Arial"/>
+                <a:ea typeface="Arial"/>
+                <a:cs typeface="Arial"/>
+              </a:rPr>
+              <a:t>Udhëtimi Prishtinë–AAB ishte në 08:15. Nisja kalon në 08:25.</a:t>
+            </a:r>
+          </a:p>
+          <a:p xmlns:a="http://schemas.openxmlformats.org/drawingml/2006/main">
+            <a:r>
+              <a:t/>
+            </a:r>
+          </a:p>
+          <a:p xmlns:a="http://schemas.openxmlformats.org/drawingml/2006/main">
+            <a:pPr>
+              <a:defRPr sz="2025" b="0">
+                <a:solidFill>
+                  <a:srgbClr val="EAF1FF"/>
+                </a:solidFill>
+                <a:latin typeface="Arial"/>
+                <a:ea typeface="Arial"/>
+                <a:cs typeface="Arial"/>
+              </a:defRPr>
+            </a:pPr>
+            <a:r>
+              <a:rPr sz="2025" b="0">
+                <a:solidFill>
+                  <a:srgbClr val="EAF1FF"/>
+                </a:solidFill>
+                <a:latin typeface="Arial"/>
+                <a:ea typeface="Arial"/>
+                <a:cs typeface="Arial"/>
+              </a:rPr>
+              <a:t>Sot bëjmë që lista dhe detajet të tregojnë të njëjtën orë të re.</a:t>
+            </a:r>
+          </a:p>
+        </p:txBody>
+      </p:sp>
+      <p:sp>
+        <p:nvSpPr>
           <p:cNvPr id="6" name="">
             <a:extLst xmlns:a="http://schemas.openxmlformats.org/drawingml/2006/main">
               <a:ext uri="{FF2B5EF4-FFF2-40B4-BE49-F238E27FC236}">
-                <a16:creationId xmlns:a16="http://schemas.microsoft.com/office/drawing/2014/main" id="{17F57B7F-A1A6-49D8-82EC-535634866DD5}"/>
-              </a:ext>
-            </a:extLst>
-          </p:cNvPr>
-          <p:cNvSpPr>
-            <a:spLocks xmlns:a="http://schemas.openxmlformats.org/drawingml/2006/main" noGrp="1"/>
-          </p:cNvSpPr>
-          <p:nvPr/>
-        </p:nvSpPr>
-        <p:spPr>
-          <a:xfrm xmlns:a="http://schemas.openxmlformats.org/drawingml/2006/main">
-            <a:off x="609600" y="5667375"/>
-            <a:ext cx="10953750" cy="619125"/>
-          </a:xfrm>
-          <a:prstGeom xmlns:a="http://schemas.openxmlformats.org/drawingml/2006/main" prst="rect">
-            <a:avLst/>
-          </a:prstGeom>
-          <a:noFill xmlns:a="http://schemas.openxmlformats.org/drawingml/2006/main"/>
-          <a:ln xmlns:a="http://schemas.openxmlformats.org/drawingml/2006/main" w="0">
-            <a:noFill/>
-          </a:ln>
-        </p:spPr>
-        <p:txBody>
-          <a:bodyPr xmlns:a="http://schemas.openxmlformats.org/drawingml/2006/main">
-            <a:noAutofit/>
-          </a:bodyPr>
-          <a:lstStyle xmlns:a="http://schemas.openxmlformats.org/drawingml/2006/main"/>
-          <a:p xmlns:a="http://schemas.openxmlformats.org/drawingml/2006/main">
-            <a:pPr>
-              <a:defRPr sz="1725" b="0">
-                <a:solidFill>
-                  <a:srgbClr val="EAF1FF"/>
-                </a:solidFill>
-                <a:latin typeface="Arial"/>
-                <a:ea typeface="Arial"/>
-                <a:cs typeface="Arial"/>
-              </a:defRPr>
-            </a:pPr>
-            <a:r>
-              <a:rPr sz="1725" b="0">
-                <a:solidFill>
-                  <a:srgbClr val="EAF1FF"/>
-                </a:solidFill>
-                <a:latin typeface="Arial"/>
-                <a:ea typeface="Arial"/>
-                <a:cs typeface="Arial"/>
-              </a:rPr>
-              <a:t>Telefoni kërkon faqen. Next.js lexon udhëtimet në Neon dhe kthen pamjen.</a:t>
-            </a:r>
-          </a:p>
-          <a:p xmlns:a="http://schemas.openxmlformats.org/drawingml/2006/main">
-            <a:pPr>
-              <a:defRPr sz="1725" b="0">
-                <a:solidFill>
-                  <a:srgbClr val="EAF1FF"/>
-                </a:solidFill>
-                <a:latin typeface="Arial"/>
-                <a:ea typeface="Arial"/>
-                <a:cs typeface="Arial"/>
-              </a:defRPr>
-            </a:pPr>
-            <a:r>
-              <a:rPr sz="1725" b="0">
-                <a:solidFill>
-                  <a:srgbClr val="EAF1FF"/>
-                </a:solidFill>
-                <a:latin typeface="Arial"/>
-                <a:ea typeface="Arial"/>
-                <a:cs typeface="Arial"/>
-              </a:rPr>
-              <a:t>GitHub ruan kodin. Vercel ekzekuton aplikacionin. Neon ruan të dhënat.</a:t>
+                <a16:creationId xmlns:a16="http://schemas.microsoft.com/office/drawing/2014/main" id="{C2B0A692-AE2D-40A3-BC33-C889EAFD777F}"/>
+              </a:ext>
+            </a:extLst>
+          </p:cNvPr>
+          <p:cNvSpPr>
+            <a:spLocks xmlns:a="http://schemas.openxmlformats.org/drawingml/2006/main" noGrp="1"/>
+          </p:cNvSpPr>
+          <p:nvPr/>
+        </p:nvSpPr>
+        <p:spPr>
+          <a:xfrm xmlns:a="http://schemas.openxmlformats.org/drawingml/2006/main">
+            <a:off x="609600" y="3714750"/>
+            <a:ext cx="10953750" cy="666750"/>
+          </a:xfrm>
+          <a:prstGeom xmlns:a="http://schemas.openxmlformats.org/drawingml/2006/main" prst="rect">
+            <a:avLst/>
+          </a:prstGeom>
+          <a:noFill xmlns:a="http://schemas.openxmlformats.org/drawingml/2006/main"/>
+          <a:ln xmlns:a="http://schemas.openxmlformats.org/drawingml/2006/main" w="0">
+            <a:noFill/>
+          </a:ln>
+        </p:spPr>
+        <p:txBody>
+          <a:bodyPr xmlns:a="http://schemas.openxmlformats.org/drawingml/2006/main">
+            <a:noAutofit/>
+          </a:bodyPr>
+          <a:lstStyle xmlns:a="http://schemas.openxmlformats.org/drawingml/2006/main"/>
+          <a:p xmlns:a="http://schemas.openxmlformats.org/drawingml/2006/main">
+            <a:pPr>
+              <a:defRPr sz="2100" b="1">
+                <a:solidFill>
+                  <a:srgbClr val="89DDFF"/>
+                </a:solidFill>
+                <a:latin typeface="Arial"/>
+                <a:ea typeface="Arial"/>
+                <a:cs typeface="Arial"/>
+              </a:defRPr>
+            </a:pPr>
+            <a:r>
+              <a:rPr sz="2100" b="1">
+                <a:solidFill>
+                  <a:srgbClr val="89DDFF"/>
+                </a:solidFill>
+                <a:latin typeface="Arial"/>
+                <a:ea typeface="Arial"/>
+                <a:cs typeface="Arial"/>
+              </a:rPr>
+              <a:t>Ku do ta ndryshonit orën që të dy ekranet të pajtohen?</a:t>
+            </a:r>
+          </a:p>
+        </p:txBody>
+      </p:sp>
+      <p:sp>
+        <p:nvSpPr>
+          <p:cNvPr id="7" name="">
+            <a:extLst xmlns:a="http://schemas.openxmlformats.org/drawingml/2006/main">
+              <a:ext uri="{FF2B5EF4-FFF2-40B4-BE49-F238E27FC236}">
+                <a16:creationId xmlns:a16="http://schemas.microsoft.com/office/drawing/2014/main" id="{B9192F9B-870E-40E3-B706-E0BC59F7A956}"/>
+              </a:ext>
+            </a:extLst>
+          </p:cNvPr>
+          <p:cNvSpPr>
+            <a:spLocks xmlns:a="http://schemas.openxmlformats.org/drawingml/2006/main" noGrp="1"/>
+          </p:cNvSpPr>
+          <p:nvPr/>
+        </p:nvSpPr>
+        <p:spPr>
+          <a:xfrm xmlns:a="http://schemas.openxmlformats.org/drawingml/2006/main">
+            <a:off x="609600" y="4429125"/>
+            <a:ext cx="10953750" cy="1381125"/>
+          </a:xfrm>
+          <a:prstGeom xmlns:a="http://schemas.openxmlformats.org/drawingml/2006/main" prst="rect">
+            <a:avLst/>
+          </a:prstGeom>
+          <a:noFill xmlns:a="http://schemas.openxmlformats.org/drawingml/2006/main"/>
+          <a:ln xmlns:a="http://schemas.openxmlformats.org/drawingml/2006/main" w="0">
+            <a:noFill/>
+          </a:ln>
+        </p:spPr>
+        <p:txBody>
+          <a:bodyPr xmlns:a="http://schemas.openxmlformats.org/drawingml/2006/main">
+            <a:noAutofit/>
+          </a:bodyPr>
+          <a:lstStyle xmlns:a="http://schemas.openxmlformats.org/drawingml/2006/main"/>
+          <a:p xmlns:a="http://schemas.openxmlformats.org/drawingml/2006/main">
+            <a:pPr>
+              <a:defRPr sz="1875" b="0">
+                <a:solidFill>
+                  <a:srgbClr val="EAF1FF"/>
+                </a:solidFill>
+                <a:latin typeface="Arial"/>
+                <a:ea typeface="Arial"/>
+                <a:cs typeface="Arial"/>
+              </a:defRPr>
+            </a:pPr>
+            <a:r>
+              <a:rPr sz="1875" b="0">
+                <a:solidFill>
+                  <a:srgbClr val="EAF1FF"/>
+                </a:solidFill>
+                <a:latin typeface="Arial"/>
+                <a:ea typeface="Arial"/>
+                <a:cs typeface="Arial"/>
+              </a:rPr>
+              <a:t>A · Veçmas në kartë dhe në faqen e detajeve.</a:t>
+            </a:r>
+          </a:p>
+          <a:p xmlns:a="http://schemas.openxmlformats.org/drawingml/2006/main">
+            <a:r>
+              <a:t/>
+            </a:r>
+          </a:p>
+          <a:p xmlns:a="http://schemas.openxmlformats.org/drawingml/2006/main">
+            <a:pPr>
+              <a:defRPr sz="1875" b="0">
+                <a:solidFill>
+                  <a:srgbClr val="EAF1FF"/>
+                </a:solidFill>
+                <a:latin typeface="Arial"/>
+                <a:ea typeface="Arial"/>
+                <a:cs typeface="Arial"/>
+              </a:defRPr>
+            </a:pPr>
+            <a:r>
+              <a:rPr sz="1875" b="0">
+                <a:solidFill>
+                  <a:srgbClr val="EAF1FF"/>
+                </a:solidFill>
+                <a:latin typeface="Arial"/>
+                <a:ea typeface="Arial"/>
+                <a:cs typeface="Arial"/>
+              </a:rPr>
+              <a:t>B · Në një burim të përbashkët që e lexojnë të dy ekranet.</a:t>
+            </a:r>
+          </a:p>
+          <a:p xmlns:a="http://schemas.openxmlformats.org/drawingml/2006/main">
+            <a:r>
+              <a:t/>
+            </a:r>
+          </a:p>
+          <a:p xmlns:a="http://schemas.openxmlformats.org/drawingml/2006/main">
+            <a:pPr>
+              <a:defRPr sz="1875" b="0">
+                <a:solidFill>
+                  <a:srgbClr val="EAF1FF"/>
+                </a:solidFill>
+                <a:latin typeface="Arial"/>
+                <a:ea typeface="Arial"/>
+                <a:cs typeface="Arial"/>
+              </a:defRPr>
+            </a:pPr>
+            <a:r>
+              <a:rPr sz="1875" b="0">
+                <a:solidFill>
+                  <a:srgbClr val="EAF1FF"/>
+                </a:solidFill>
+                <a:latin typeface="Arial"/>
+                <a:ea typeface="Arial"/>
+                <a:cs typeface="Arial"/>
+              </a:rPr>
+              <a:t>C · Askund. Ora në aplikacion ndryshon vetvetiu.</a:t>
+            </a:r>
+          </a:p>
+        </p:txBody>
+      </p:sp>
+      <p:sp>
+        <p:nvSpPr>
+          <p:cNvPr id="8" name="">
+            <a:extLst xmlns:a="http://schemas.openxmlformats.org/drawingml/2006/main">
+              <a:ext uri="{FF2B5EF4-FFF2-40B4-BE49-F238E27FC236}">
+                <a16:creationId xmlns:a16="http://schemas.microsoft.com/office/drawing/2014/main" id="{F21E479E-A096-46BD-99EB-12C7E2CF1F79}"/>
+              </a:ext>
+            </a:extLst>
+          </p:cNvPr>
+          <p:cNvSpPr>
+            <a:spLocks xmlns:a="http://schemas.openxmlformats.org/drawingml/2006/main" noGrp="1"/>
+          </p:cNvSpPr>
+          <p:nvPr/>
+        </p:nvSpPr>
+        <p:spPr>
+          <a:xfrm xmlns:a="http://schemas.openxmlformats.org/drawingml/2006/main">
+            <a:off x="609600" y="5953125"/>
+            <a:ext cx="10953750" cy="381000"/>
+          </a:xfrm>
+          <a:prstGeom xmlns:a="http://schemas.openxmlformats.org/drawingml/2006/main" prst="rect">
+            <a:avLst/>
+          </a:prstGeom>
+          <a:noFill xmlns:a="http://schemas.openxmlformats.org/drawingml/2006/main"/>
+          <a:ln xmlns:a="http://schemas.openxmlformats.org/drawingml/2006/main" w="0">
+            <a:noFill/>
+          </a:ln>
+        </p:spPr>
+        <p:txBody>
+          <a:bodyPr xmlns:a="http://schemas.openxmlformats.org/drawingml/2006/main">
+            <a:noAutofit/>
+          </a:bodyPr>
+          <a:lstStyle xmlns:a="http://schemas.openxmlformats.org/drawingml/2006/main"/>
+          <a:p xmlns:a="http://schemas.openxmlformats.org/drawingml/2006/main">
+            <a:pPr>
+              <a:defRPr sz="1650" b="0">
+                <a:solidFill>
+                  <a:srgbClr val="8EE9D1"/>
+                </a:solidFill>
+                <a:latin typeface="Arial"/>
+                <a:ea typeface="Arial"/>
+                <a:cs typeface="Arial"/>
+              </a:defRPr>
+            </a:pPr>
+            <a:r>
+              <a:rPr sz="1650" b="0">
+                <a:solidFill>
+                  <a:srgbClr val="8EE9D1"/>
+                </a:solidFill>
+                <a:latin typeface="Arial"/>
+                <a:ea typeface="Arial"/>
+                <a:cs typeface="Arial"/>
+              </a:rPr>
+              <a:t>Votoni, krahasoni arsyetimet dhe hapni përgjigjen në versionin interaktiv.</a:t>
             </a:r>
           </a:p>
         </p:txBody>
@@ -912,7 +1122,7 @@
     </p:spTree>
     <p:extLst>
       <p:ext uri="{BB962C8B-B14F-4D97-AF65-F5344CB8AC3E}">
-        <p14:creationId xmlns:p14="http://schemas.microsoft.com/office/powerpoint/2010/main" val="2085737414"/>
+        <p14:creationId xmlns:p14="http://schemas.microsoft.com/office/powerpoint/2010/main" val="1615965025"/>
       </p:ext>
     </p:extLst>
   </p:cSld>
@@ -943,7 +1153,7 @@
           <p:cNvPr id="7" name="">
             <a:extLst xmlns:a="http://schemas.openxmlformats.org/drawingml/2006/main">
               <a:ext uri="{FF2B5EF4-FFF2-40B4-BE49-F238E27FC236}">
-                <a16:creationId xmlns:a16="http://schemas.microsoft.com/office/drawing/2014/main" id="{B91EC9B4-13E5-43E7-AC40-467BCA6E78F6}"/>
+                <a16:creationId xmlns:a16="http://schemas.microsoft.com/office/drawing/2014/main" id="{0294B229-D120-4D69-BDF8-03C76873B90E}"/>
               </a:ext>
             </a:extLst>
           </p:cNvPr>
@@ -1000,7 +1210,7 @@
           <p:cNvPr id="2" name="">
             <a:extLst xmlns:a="http://schemas.openxmlformats.org/drawingml/2006/main">
               <a:ext uri="{FF2B5EF4-FFF2-40B4-BE49-F238E27FC236}">
-                <a16:creationId xmlns:a16="http://schemas.microsoft.com/office/drawing/2014/main" id="{BEC26714-C599-4F7F-A609-3936EB08AF63}"/>
+                <a16:creationId xmlns:a16="http://schemas.microsoft.com/office/drawing/2014/main" id="{EDC7FE9E-E4A5-43DE-8B37-28B6E007C49E}"/>
               </a:ext>
             </a:extLst>
           </p:cNvPr>
@@ -1057,7 +1267,7 @@
           <p:cNvPr id="3" name="">
             <a:extLst xmlns:a="http://schemas.openxmlformats.org/drawingml/2006/main">
               <a:ext uri="{FF2B5EF4-FFF2-40B4-BE49-F238E27FC236}">
-                <a16:creationId xmlns:a16="http://schemas.microsoft.com/office/drawing/2014/main" id="{F37FDA31-E72B-423D-BCDF-CAFCD3E00915}"/>
+                <a16:creationId xmlns:a16="http://schemas.microsoft.com/office/drawing/2014/main" id="{6D33BBF2-E6C4-4E92-A119-BB1B9F233C0E}"/>
               </a:ext>
             </a:extLst>
           </p:cNvPr>
@@ -1114,7 +1324,7 @@
           <p:cNvPr id="4" name="">
             <a:extLst xmlns:a="http://schemas.openxmlformats.org/drawingml/2006/main">
               <a:ext uri="{FF2B5EF4-FFF2-40B4-BE49-F238E27FC236}">
-                <a16:creationId xmlns:a16="http://schemas.microsoft.com/office/drawing/2014/main" id="{9F9DE0D1-9FFF-4CD7-ACD6-DC628D718BEA}"/>
+                <a16:creationId xmlns:a16="http://schemas.microsoft.com/office/drawing/2014/main" id="{581B179F-849A-4151-9FDF-B5B6A2F9BD43}"/>
               </a:ext>
             </a:extLst>
           </p:cNvPr>
@@ -1227,7 +1437,7 @@
           <p:cNvPr id="5" name="">
             <a:extLst xmlns:a="http://schemas.openxmlformats.org/drawingml/2006/main">
               <a:ext uri="{FF2B5EF4-FFF2-40B4-BE49-F238E27FC236}">
-                <a16:creationId xmlns:a16="http://schemas.microsoft.com/office/drawing/2014/main" id="{231DDE2B-DD8A-4C98-9FD7-89ED237749FD}"/>
+                <a16:creationId xmlns:a16="http://schemas.microsoft.com/office/drawing/2014/main" id="{A2EE1CE7-B07D-4287-B522-0F9140A3F6E7}"/>
               </a:ext>
             </a:extLst>
           </p:cNvPr>
@@ -1307,7 +1517,7 @@
           <p:cNvPr id="6" name="">
             <a:extLst xmlns:a="http://schemas.openxmlformats.org/drawingml/2006/main">
               <a:ext uri="{FF2B5EF4-FFF2-40B4-BE49-F238E27FC236}">
-                <a16:creationId xmlns:a16="http://schemas.microsoft.com/office/drawing/2014/main" id="{0AEDBED3-4C05-4850-AD38-20B55C39A6FB}"/>
+                <a16:creationId xmlns:a16="http://schemas.microsoft.com/office/drawing/2014/main" id="{C0C581BE-4602-42EE-821E-5BADB2DA50A6}"/>
               </a:ext>
             </a:extLst>
           </p:cNvPr>
@@ -1362,7 +1572,7 @@
     </p:spTree>
     <p:extLst>
       <p:ext uri="{BB962C8B-B14F-4D97-AF65-F5344CB8AC3E}">
-        <p14:creationId xmlns:p14="http://schemas.microsoft.com/office/powerpoint/2010/main" val="201459801"/>
+        <p14:creationId xmlns:p14="http://schemas.microsoft.com/office/powerpoint/2010/main" val="1126929307"/>
       </p:ext>
     </p:extLst>
   </p:cSld>
@@ -1393,7 +1603,7 @@
           <p:cNvPr id="7" name="">
             <a:extLst xmlns:a="http://schemas.openxmlformats.org/drawingml/2006/main">
               <a:ext uri="{FF2B5EF4-FFF2-40B4-BE49-F238E27FC236}">
-                <a16:creationId xmlns:a16="http://schemas.microsoft.com/office/drawing/2014/main" id="{5B3A216C-84DD-4953-BFB5-EDA4A24DEC2D}"/>
+                <a16:creationId xmlns:a16="http://schemas.microsoft.com/office/drawing/2014/main" id="{A93D680C-DEBC-46DE-92CF-F926782EB982}"/>
               </a:ext>
             </a:extLst>
           </p:cNvPr>
@@ -1450,7 +1660,7 @@
           <p:cNvPr id="2" name="">
             <a:extLst xmlns:a="http://schemas.openxmlformats.org/drawingml/2006/main">
               <a:ext uri="{FF2B5EF4-FFF2-40B4-BE49-F238E27FC236}">
-                <a16:creationId xmlns:a16="http://schemas.microsoft.com/office/drawing/2014/main" id="{259F9805-AA93-4ED4-9470-08F5F97147C0}"/>
+                <a16:creationId xmlns:a16="http://schemas.microsoft.com/office/drawing/2014/main" id="{6F8D31D4-4E0E-4210-BCA3-17E70852079D}"/>
               </a:ext>
             </a:extLst>
           </p:cNvPr>
@@ -1507,7 +1717,7 @@
           <p:cNvPr id="3" name="">
             <a:extLst xmlns:a="http://schemas.openxmlformats.org/drawingml/2006/main">
               <a:ext uri="{FF2B5EF4-FFF2-40B4-BE49-F238E27FC236}">
-                <a16:creationId xmlns:a16="http://schemas.microsoft.com/office/drawing/2014/main" id="{7965922B-6DD0-4FBD-BC22-9A3027388566}"/>
+                <a16:creationId xmlns:a16="http://schemas.microsoft.com/office/drawing/2014/main" id="{7B633F57-4A11-43D8-9C20-C8C085EA17C8}"/>
               </a:ext>
             </a:extLst>
           </p:cNvPr>
@@ -1564,7 +1774,7 @@
           <p:cNvPr id="4" name="">
             <a:extLst xmlns:a="http://schemas.openxmlformats.org/drawingml/2006/main">
               <a:ext uri="{FF2B5EF4-FFF2-40B4-BE49-F238E27FC236}">
-                <a16:creationId xmlns:a16="http://schemas.microsoft.com/office/drawing/2014/main" id="{BD9FDFCF-04C2-46BB-9DD3-6F35B267F398}"/>
+                <a16:creationId xmlns:a16="http://schemas.microsoft.com/office/drawing/2014/main" id="{F0192672-3FBD-417B-BBBD-F5A073ECBCB9}"/>
               </a:ext>
             </a:extLst>
           </p:cNvPr>
@@ -1677,7 +1887,7 @@
           <p:cNvPr id="5" name="">
             <a:extLst xmlns:a="http://schemas.openxmlformats.org/drawingml/2006/main">
               <a:ext uri="{FF2B5EF4-FFF2-40B4-BE49-F238E27FC236}">
-                <a16:creationId xmlns:a16="http://schemas.microsoft.com/office/drawing/2014/main" id="{E327388E-F6DA-4521-BF02-251FEB42E10F}"/>
+                <a16:creationId xmlns:a16="http://schemas.microsoft.com/office/drawing/2014/main" id="{35F66F1A-1EB7-4F85-A256-E79020B1E293}"/>
               </a:ext>
             </a:extLst>
           </p:cNvPr>
@@ -1757,7 +1967,7 @@
           <p:cNvPr id="6" name="">
             <a:extLst xmlns:a="http://schemas.openxmlformats.org/drawingml/2006/main">
               <a:ext uri="{FF2B5EF4-FFF2-40B4-BE49-F238E27FC236}">
-                <a16:creationId xmlns:a16="http://schemas.microsoft.com/office/drawing/2014/main" id="{9C91C34A-7F2D-4F4D-B201-F3566361121C}"/>
+                <a16:creationId xmlns:a16="http://schemas.microsoft.com/office/drawing/2014/main" id="{FF8025AB-8524-431B-BD1E-8F6968706844}"/>
               </a:ext>
             </a:extLst>
           </p:cNvPr>
@@ -1812,7 +2022,7 @@
     </p:spTree>
     <p:extLst>
       <p:ext uri="{BB962C8B-B14F-4D97-AF65-F5344CB8AC3E}">
-        <p14:creationId xmlns:p14="http://schemas.microsoft.com/office/powerpoint/2010/main" val="685608923"/>
+        <p14:creationId xmlns:p14="http://schemas.microsoft.com/office/powerpoint/2010/main" val="408363311"/>
       </p:ext>
     </p:extLst>
   </p:cSld>
@@ -1843,7 +2053,7 @@
           <p:cNvPr id="7" name="">
             <a:extLst xmlns:a="http://schemas.openxmlformats.org/drawingml/2006/main">
               <a:ext uri="{FF2B5EF4-FFF2-40B4-BE49-F238E27FC236}">
-                <a16:creationId xmlns:a16="http://schemas.microsoft.com/office/drawing/2014/main" id="{4E0E7F05-FE36-4DF9-8723-AB3F62A8B7DA}"/>
+                <a16:creationId xmlns:a16="http://schemas.microsoft.com/office/drawing/2014/main" id="{DED545FB-93AC-47D7-8022-70EAF3C90B8A}"/>
               </a:ext>
             </a:extLst>
           </p:cNvPr>
@@ -1900,7 +2110,7 @@
           <p:cNvPr id="2" name="">
             <a:extLst xmlns:a="http://schemas.openxmlformats.org/drawingml/2006/main">
               <a:ext uri="{FF2B5EF4-FFF2-40B4-BE49-F238E27FC236}">
-                <a16:creationId xmlns:a16="http://schemas.microsoft.com/office/drawing/2014/main" id="{70F3E372-1C47-4DB4-9AB3-DB63732297A0}"/>
+                <a16:creationId xmlns:a16="http://schemas.microsoft.com/office/drawing/2014/main" id="{FBB1250A-3F8F-41B4-AC15-E745F674442A}"/>
               </a:ext>
             </a:extLst>
           </p:cNvPr>
@@ -1957,7 +2167,7 @@
           <p:cNvPr id="3" name="">
             <a:extLst xmlns:a="http://schemas.openxmlformats.org/drawingml/2006/main">
               <a:ext uri="{FF2B5EF4-FFF2-40B4-BE49-F238E27FC236}">
-                <a16:creationId xmlns:a16="http://schemas.microsoft.com/office/drawing/2014/main" id="{3276BB5A-C40B-4FF7-A5A5-261EEAF51EBC}"/>
+                <a16:creationId xmlns:a16="http://schemas.microsoft.com/office/drawing/2014/main" id="{BA2D7E1C-94F7-41F8-BEB9-7164853D1902}"/>
               </a:ext>
             </a:extLst>
           </p:cNvPr>
@@ -2014,7 +2224,7 @@
           <p:cNvPr id="4" name="">
             <a:extLst xmlns:a="http://schemas.openxmlformats.org/drawingml/2006/main">
               <a:ext uri="{FF2B5EF4-FFF2-40B4-BE49-F238E27FC236}">
-                <a16:creationId xmlns:a16="http://schemas.microsoft.com/office/drawing/2014/main" id="{D72631E0-B90C-4DFE-9A0E-14B358E41B19}"/>
+                <a16:creationId xmlns:a16="http://schemas.microsoft.com/office/drawing/2014/main" id="{0A8D7E30-20C3-44BD-BE51-C92D3B1A61AE}"/>
               </a:ext>
             </a:extLst>
           </p:cNvPr>
@@ -2127,7 +2337,7 @@
           <p:cNvPr id="5" name="">
             <a:extLst xmlns:a="http://schemas.openxmlformats.org/drawingml/2006/main">
               <a:ext uri="{FF2B5EF4-FFF2-40B4-BE49-F238E27FC236}">
-                <a16:creationId xmlns:a16="http://schemas.microsoft.com/office/drawing/2014/main" id="{2B5FA663-A2A5-4E19-B22C-591B00D6097A}"/>
+                <a16:creationId xmlns:a16="http://schemas.microsoft.com/office/drawing/2014/main" id="{E36AD798-4CAC-4D43-9D74-609BBC17F708}"/>
               </a:ext>
             </a:extLst>
           </p:cNvPr>
@@ -2253,7 +2463,7 @@
           <p:cNvPr id="6" name="">
             <a:extLst xmlns:a="http://schemas.openxmlformats.org/drawingml/2006/main">
               <a:ext uri="{FF2B5EF4-FFF2-40B4-BE49-F238E27FC236}">
-                <a16:creationId xmlns:a16="http://schemas.microsoft.com/office/drawing/2014/main" id="{37459226-0B9C-4387-A6EE-A290BA569891}"/>
+                <a16:creationId xmlns:a16="http://schemas.microsoft.com/office/drawing/2014/main" id="{03B39943-B17F-497B-995D-2D04CDDB0A41}"/>
               </a:ext>
             </a:extLst>
           </p:cNvPr>
@@ -2308,7 +2518,7 @@
     </p:spTree>
     <p:extLst>
       <p:ext uri="{BB962C8B-B14F-4D97-AF65-F5344CB8AC3E}">
-        <p14:creationId xmlns:p14="http://schemas.microsoft.com/office/powerpoint/2010/main" val="1996564646"/>
+        <p14:creationId xmlns:p14="http://schemas.microsoft.com/office/powerpoint/2010/main" val="1981138521"/>
       </p:ext>
     </p:extLst>
   </p:cSld>
@@ -2339,7 +2549,7 @@
           <p:cNvPr id="7" name="">
             <a:extLst xmlns:a="http://schemas.openxmlformats.org/drawingml/2006/main">
               <a:ext uri="{FF2B5EF4-FFF2-40B4-BE49-F238E27FC236}">
-                <a16:creationId xmlns:a16="http://schemas.microsoft.com/office/drawing/2014/main" id="{4CDADC29-4C8B-4F50-B2D6-1720CC3B6CC4}"/>
+                <a16:creationId xmlns:a16="http://schemas.microsoft.com/office/drawing/2014/main" id="{DE57B2B7-7F05-41AA-971C-646B02140FE7}"/>
               </a:ext>
             </a:extLst>
           </p:cNvPr>
@@ -2396,7 +2606,7 @@
           <p:cNvPr id="2" name="">
             <a:extLst xmlns:a="http://schemas.openxmlformats.org/drawingml/2006/main">
               <a:ext uri="{FF2B5EF4-FFF2-40B4-BE49-F238E27FC236}">
-                <a16:creationId xmlns:a16="http://schemas.microsoft.com/office/drawing/2014/main" id="{3ABE2951-41B8-460F-89DB-57428D3F7C93}"/>
+                <a16:creationId xmlns:a16="http://schemas.microsoft.com/office/drawing/2014/main" id="{BDEBC636-00E2-49A5-9262-88EA237E0F9A}"/>
               </a:ext>
             </a:extLst>
           </p:cNvPr>
@@ -2453,7 +2663,7 @@
           <p:cNvPr id="3" name="">
             <a:extLst xmlns:a="http://schemas.openxmlformats.org/drawingml/2006/main">
               <a:ext uri="{FF2B5EF4-FFF2-40B4-BE49-F238E27FC236}">
-                <a16:creationId xmlns:a16="http://schemas.microsoft.com/office/drawing/2014/main" id="{40C13BBE-5D79-4181-AFB6-CB37B47C6A38}"/>
+                <a16:creationId xmlns:a16="http://schemas.microsoft.com/office/drawing/2014/main" id="{54DF2DE1-86BF-41D8-90D2-6497E74CB8F6}"/>
               </a:ext>
             </a:extLst>
           </p:cNvPr>
@@ -2510,7 +2720,7 @@
           <p:cNvPr id="4" name="">
             <a:extLst xmlns:a="http://schemas.openxmlformats.org/drawingml/2006/main">
               <a:ext uri="{FF2B5EF4-FFF2-40B4-BE49-F238E27FC236}">
-                <a16:creationId xmlns:a16="http://schemas.microsoft.com/office/drawing/2014/main" id="{AEA470B9-CC22-429D-A509-056EFC0D7DF1}"/>
+                <a16:creationId xmlns:a16="http://schemas.microsoft.com/office/drawing/2014/main" id="{C38A89E8-BDA1-4AA2-9667-EAEA75D18B0E}"/>
               </a:ext>
             </a:extLst>
           </p:cNvPr>
@@ -2623,7 +2833,7 @@
           <p:cNvPr id="5" name="">
             <a:extLst xmlns:a="http://schemas.openxmlformats.org/drawingml/2006/main">
               <a:ext uri="{FF2B5EF4-FFF2-40B4-BE49-F238E27FC236}">
-                <a16:creationId xmlns:a16="http://schemas.microsoft.com/office/drawing/2014/main" id="{6C8DC2DE-A108-4A44-9378-A79C31CD9440}"/>
+                <a16:creationId xmlns:a16="http://schemas.microsoft.com/office/drawing/2014/main" id="{0213ADD6-B046-400F-BCD3-23C7608CD37B}"/>
               </a:ext>
             </a:extLst>
           </p:cNvPr>
@@ -2680,7 +2890,7 @@
           <p:cNvPr id="6" name="">
             <a:extLst xmlns:a="http://schemas.openxmlformats.org/drawingml/2006/main">
               <a:ext uri="{FF2B5EF4-FFF2-40B4-BE49-F238E27FC236}">
-                <a16:creationId xmlns:a16="http://schemas.microsoft.com/office/drawing/2014/main" id="{CC76C650-B795-4CCB-BB2C-4B9E88EB3D4B}"/>
+                <a16:creationId xmlns:a16="http://schemas.microsoft.com/office/drawing/2014/main" id="{7C4910C2-63BF-4129-891E-F2BBEE11B6BF}"/>
               </a:ext>
             </a:extLst>
           </p:cNvPr>
@@ -2735,7 +2945,7 @@
     </p:spTree>
     <p:extLst>
       <p:ext uri="{BB962C8B-B14F-4D97-AF65-F5344CB8AC3E}">
-        <p14:creationId xmlns:p14="http://schemas.microsoft.com/office/powerpoint/2010/main" val="1917532762"/>
+        <p14:creationId xmlns:p14="http://schemas.microsoft.com/office/powerpoint/2010/main" val="480808677"/>
       </p:ext>
     </p:extLst>
   </p:cSld>
@@ -2766,7 +2976,7 @@
           <p:cNvPr id="6" name="">
             <a:extLst xmlns:a="http://schemas.openxmlformats.org/drawingml/2006/main">
               <a:ext uri="{FF2B5EF4-FFF2-40B4-BE49-F238E27FC236}">
-                <a16:creationId xmlns:a16="http://schemas.microsoft.com/office/drawing/2014/main" id="{6542CF29-6867-47D2-BE24-A358E894550C}"/>
+                <a16:creationId xmlns:a16="http://schemas.microsoft.com/office/drawing/2014/main" id="{3F16F8F7-2AC2-4005-B70F-7A4850705111}"/>
               </a:ext>
             </a:extLst>
           </p:cNvPr>
@@ -2823,7 +3033,7 @@
           <p:cNvPr id="2" name="">
             <a:extLst xmlns:a="http://schemas.openxmlformats.org/drawingml/2006/main">
               <a:ext uri="{FF2B5EF4-FFF2-40B4-BE49-F238E27FC236}">
-                <a16:creationId xmlns:a16="http://schemas.microsoft.com/office/drawing/2014/main" id="{77290E2B-67D4-4735-8906-EBDF528CF7E5}"/>
+                <a16:creationId xmlns:a16="http://schemas.microsoft.com/office/drawing/2014/main" id="{D7ADD8E5-407C-4B5D-BDA7-697B9D354A59}"/>
               </a:ext>
             </a:extLst>
           </p:cNvPr>
@@ -2880,7 +3090,7 @@
           <p:cNvPr id="3" name="">
             <a:extLst xmlns:a="http://schemas.openxmlformats.org/drawingml/2006/main">
               <a:ext uri="{FF2B5EF4-FFF2-40B4-BE49-F238E27FC236}">
-                <a16:creationId xmlns:a16="http://schemas.microsoft.com/office/drawing/2014/main" id="{61A5B5D2-F155-426D-BAA3-D00B975EDDD2}"/>
+                <a16:creationId xmlns:a16="http://schemas.microsoft.com/office/drawing/2014/main" id="{A7DA59C1-946C-43CF-A166-E60A2912E386}"/>
               </a:ext>
             </a:extLst>
           </p:cNvPr>
@@ -2937,7 +3147,7 @@
           <p:cNvPr id="4" name="">
             <a:extLst xmlns:a="http://schemas.openxmlformats.org/drawingml/2006/main">
               <a:ext uri="{FF2B5EF4-FFF2-40B4-BE49-F238E27FC236}">
-                <a16:creationId xmlns:a16="http://schemas.microsoft.com/office/drawing/2014/main" id="{99C2842B-A4ED-4A99-A073-ABE34EF9DB95}"/>
+                <a16:creationId xmlns:a16="http://schemas.microsoft.com/office/drawing/2014/main" id="{FB8D8B4D-EC69-4BD7-AA97-B36EB982B13F}"/>
               </a:ext>
             </a:extLst>
           </p:cNvPr>
@@ -3078,7 +3288,7 @@
           <p:cNvPr id="5" name="">
             <a:extLst xmlns:a="http://schemas.openxmlformats.org/drawingml/2006/main">
               <a:ext uri="{FF2B5EF4-FFF2-40B4-BE49-F238E27FC236}">
-                <a16:creationId xmlns:a16="http://schemas.microsoft.com/office/drawing/2014/main" id="{8B83F6DA-E203-48D3-9473-BB98C0027C5B}"/>
+                <a16:creationId xmlns:a16="http://schemas.microsoft.com/office/drawing/2014/main" id="{B6C6176B-D4B2-4012-9CB8-D4548FE99F07}"/>
               </a:ext>
             </a:extLst>
           </p:cNvPr>
@@ -3133,7 +3343,7 @@
     </p:spTree>
     <p:extLst>
       <p:ext uri="{BB962C8B-B14F-4D97-AF65-F5344CB8AC3E}">
-        <p14:creationId xmlns:p14="http://schemas.microsoft.com/office/powerpoint/2010/main" val="1764387287"/>
+        <p14:creationId xmlns:p14="http://schemas.microsoft.com/office/powerpoint/2010/main" val="1531662947"/>
       </p:ext>
     </p:extLst>
   </p:cSld>
@@ -3164,7 +3374,7 @@
           <p:cNvPr id="7" name="">
             <a:extLst xmlns:a="http://schemas.openxmlformats.org/drawingml/2006/main">
               <a:ext uri="{FF2B5EF4-FFF2-40B4-BE49-F238E27FC236}">
-                <a16:creationId xmlns:a16="http://schemas.microsoft.com/office/drawing/2014/main" id="{0312CF54-0A3F-4D96-92F2-222BF63FA193}"/>
+                <a16:creationId xmlns:a16="http://schemas.microsoft.com/office/drawing/2014/main" id="{BAF4C656-B81E-471A-98B7-9370758D5C65}"/>
               </a:ext>
             </a:extLst>
           </p:cNvPr>
@@ -3221,7 +3431,7 @@
           <p:cNvPr id="2" name="">
             <a:extLst xmlns:a="http://schemas.openxmlformats.org/drawingml/2006/main">
               <a:ext uri="{FF2B5EF4-FFF2-40B4-BE49-F238E27FC236}">
-                <a16:creationId xmlns:a16="http://schemas.microsoft.com/office/drawing/2014/main" id="{4D254AB5-10AD-4421-A58D-C53702A4E733}"/>
+                <a16:creationId xmlns:a16="http://schemas.microsoft.com/office/drawing/2014/main" id="{371890C6-362C-4F32-BB3A-B8C41C3C44A6}"/>
               </a:ext>
             </a:extLst>
           </p:cNvPr>
@@ -3278,7 +3488,7 @@
           <p:cNvPr id="3" name="">
             <a:extLst xmlns:a="http://schemas.openxmlformats.org/drawingml/2006/main">
               <a:ext uri="{FF2B5EF4-FFF2-40B4-BE49-F238E27FC236}">
-                <a16:creationId xmlns:a16="http://schemas.microsoft.com/office/drawing/2014/main" id="{6D592CD0-DF3F-4359-8797-E0DD671B8475}"/>
+                <a16:creationId xmlns:a16="http://schemas.microsoft.com/office/drawing/2014/main" id="{9B4A7F88-D37B-493A-9A3B-A44F6E9B3DC1}"/>
               </a:ext>
             </a:extLst>
           </p:cNvPr>
@@ -3335,7 +3545,7 @@
           <p:cNvPr id="4" name="">
             <a:extLst xmlns:a="http://schemas.openxmlformats.org/drawingml/2006/main">
               <a:ext uri="{FF2B5EF4-FFF2-40B4-BE49-F238E27FC236}">
-                <a16:creationId xmlns:a16="http://schemas.microsoft.com/office/drawing/2014/main" id="{401D1DE1-5A18-4BB7-88DA-C2FB85A11CB6}"/>
+                <a16:creationId xmlns:a16="http://schemas.microsoft.com/office/drawing/2014/main" id="{7113DFAB-949F-4D4B-9A31-BB8C36807FE6}"/>
               </a:ext>
             </a:extLst>
           </p:cNvPr>
@@ -3448,7 +3658,7 @@
           <p:cNvPr id="5" name="">
             <a:extLst xmlns:a="http://schemas.openxmlformats.org/drawingml/2006/main">
               <a:ext uri="{FF2B5EF4-FFF2-40B4-BE49-F238E27FC236}">
-                <a16:creationId xmlns:a16="http://schemas.microsoft.com/office/drawing/2014/main" id="{AA4BE355-040D-47E3-9E4D-E20FB079A02B}"/>
+                <a16:creationId xmlns:a16="http://schemas.microsoft.com/office/drawing/2014/main" id="{5E312EC7-F012-4308-90C5-5F320A068397}"/>
               </a:ext>
             </a:extLst>
           </p:cNvPr>
@@ -3505,7 +3715,7 @@
           <p:cNvPr id="6" name="">
             <a:extLst xmlns:a="http://schemas.openxmlformats.org/drawingml/2006/main">
               <a:ext uri="{FF2B5EF4-FFF2-40B4-BE49-F238E27FC236}">
-                <a16:creationId xmlns:a16="http://schemas.microsoft.com/office/drawing/2014/main" id="{48C947F0-12C1-480C-A46B-23ED331B1867}"/>
+                <a16:creationId xmlns:a16="http://schemas.microsoft.com/office/drawing/2014/main" id="{A88E4318-0463-4763-9F0A-D80509B2C846}"/>
               </a:ext>
             </a:extLst>
           </p:cNvPr>
@@ -3560,7 +3770,7 @@
     </p:spTree>
     <p:extLst>
       <p:ext uri="{BB962C8B-B14F-4D97-AF65-F5344CB8AC3E}">
-        <p14:creationId xmlns:p14="http://schemas.microsoft.com/office/powerpoint/2010/main" val="341160478"/>
+        <p14:creationId xmlns:p14="http://schemas.microsoft.com/office/powerpoint/2010/main" val="1731574848"/>
       </p:ext>
     </p:extLst>
   </p:cSld>
@@ -3591,7 +3801,7 @@
           <p:cNvPr id="5" name="">
             <a:extLst xmlns:a="http://schemas.openxmlformats.org/drawingml/2006/main">
               <a:ext uri="{FF2B5EF4-FFF2-40B4-BE49-F238E27FC236}">
-                <a16:creationId xmlns:a16="http://schemas.microsoft.com/office/drawing/2014/main" id="{2855D718-3242-4A8E-887E-B2141FFC1170}"/>
+                <a16:creationId xmlns:a16="http://schemas.microsoft.com/office/drawing/2014/main" id="{646130E6-9104-4951-96FD-E0276DC4D2AC}"/>
               </a:ext>
             </a:extLst>
           </p:cNvPr>
@@ -3648,7 +3858,7 @@
           <p:cNvPr id="2" name="">
             <a:extLst xmlns:a="http://schemas.openxmlformats.org/drawingml/2006/main">
               <a:ext uri="{FF2B5EF4-FFF2-40B4-BE49-F238E27FC236}">
-                <a16:creationId xmlns:a16="http://schemas.microsoft.com/office/drawing/2014/main" id="{B2AC5046-CA56-4C51-B461-2B2C004FAEC8}"/>
+                <a16:creationId xmlns:a16="http://schemas.microsoft.com/office/drawing/2014/main" id="{6FD10870-B365-4FBC-A578-FB6F5985245B}"/>
               </a:ext>
             </a:extLst>
           </p:cNvPr>
@@ -3705,7 +3915,7 @@
           <p:cNvPr id="3" name="">
             <a:extLst xmlns:a="http://schemas.openxmlformats.org/drawingml/2006/main">
               <a:ext uri="{FF2B5EF4-FFF2-40B4-BE49-F238E27FC236}">
-                <a16:creationId xmlns:a16="http://schemas.microsoft.com/office/drawing/2014/main" id="{63803796-8A6B-4646-B3E0-38D08D1AE2B7}"/>
+                <a16:creationId xmlns:a16="http://schemas.microsoft.com/office/drawing/2014/main" id="{DA87B70F-D606-4865-A72F-78F33DD59743}"/>
               </a:ext>
             </a:extLst>
           </p:cNvPr>
@@ -3762,7 +3972,7 @@
           <p:cNvPr id="4" name="">
             <a:extLst xmlns:a="http://schemas.openxmlformats.org/drawingml/2006/main">
               <a:ext uri="{FF2B5EF4-FFF2-40B4-BE49-F238E27FC236}">
-                <a16:creationId xmlns:a16="http://schemas.microsoft.com/office/drawing/2014/main" id="{6CA50EE9-FB5C-4F34-8BE8-12EF5B836719}"/>
+                <a16:creationId xmlns:a16="http://schemas.microsoft.com/office/drawing/2014/main" id="{0FCAD625-55C4-411A-986A-1078208FF36F}"/>
               </a:ext>
             </a:extLst>
           </p:cNvPr>
@@ -3901,7 +4111,7 @@
     </p:spTree>
     <p:extLst>
       <p:ext uri="{BB962C8B-B14F-4D97-AF65-F5344CB8AC3E}">
-        <p14:creationId xmlns:p14="http://schemas.microsoft.com/office/powerpoint/2010/main" val="2009882338"/>
+        <p14:creationId xmlns:p14="http://schemas.microsoft.com/office/powerpoint/2010/main" val="1921941160"/>
       </p:ext>
     </p:extLst>
   </p:cSld>
@@ -3929,10 +4139,10 @@
       </p:grpSpPr>
       <p:sp>
         <p:nvSpPr>
-          <p:cNvPr id="7" name="">
-            <a:extLst xmlns:a="http://schemas.openxmlformats.org/drawingml/2006/main">
-              <a:ext uri="{FF2B5EF4-FFF2-40B4-BE49-F238E27FC236}">
-                <a16:creationId xmlns:a16="http://schemas.microsoft.com/office/drawing/2014/main" id="{8B1F994C-B1DB-484F-8835-490717DA8D3B}"/>
+          <p:cNvPr id="8" name="">
+            <a:extLst xmlns:a="http://schemas.openxmlformats.org/drawingml/2006/main">
+              <a:ext uri="{FF2B5EF4-FFF2-40B4-BE49-F238E27FC236}">
+                <a16:creationId xmlns:a16="http://schemas.microsoft.com/office/drawing/2014/main" id="{8FB82B62-8528-45FF-B0EA-5E33ACC3EC02}"/>
               </a:ext>
             </a:extLst>
           </p:cNvPr>
@@ -3989,7 +4199,7 @@
           <p:cNvPr id="2" name="">
             <a:extLst xmlns:a="http://schemas.openxmlformats.org/drawingml/2006/main">
               <a:ext uri="{FF2B5EF4-FFF2-40B4-BE49-F238E27FC236}">
-                <a16:creationId xmlns:a16="http://schemas.microsoft.com/office/drawing/2014/main" id="{6A6229E0-6423-465F-8EBD-AE58E32F5B0A}"/>
+                <a16:creationId xmlns:a16="http://schemas.microsoft.com/office/drawing/2014/main" id="{5C4A7BC2-89B0-40D2-9135-0F959BC98416}"/>
               </a:ext>
             </a:extLst>
           </p:cNvPr>
@@ -4046,7 +4256,7 @@
           <p:cNvPr id="3" name="">
             <a:extLst xmlns:a="http://schemas.openxmlformats.org/drawingml/2006/main">
               <a:ext uri="{FF2B5EF4-FFF2-40B4-BE49-F238E27FC236}">
-                <a16:creationId xmlns:a16="http://schemas.microsoft.com/office/drawing/2014/main" id="{AE44A3D2-E025-4F1F-9831-8DCDDD9A7C61}"/>
+                <a16:creationId xmlns:a16="http://schemas.microsoft.com/office/drawing/2014/main" id="{49BB0E80-54D6-41A5-892F-A643BACDB562}"/>
               </a:ext>
             </a:extLst>
           </p:cNvPr>
@@ -4103,46 +4313,46 @@
           <p:cNvPr id="4" name="">
             <a:extLst xmlns:a="http://schemas.openxmlformats.org/drawingml/2006/main">
               <a:ext uri="{FF2B5EF4-FFF2-40B4-BE49-F238E27FC236}">
-                <a16:creationId xmlns:a16="http://schemas.microsoft.com/office/drawing/2014/main" id="{75D4B34F-D625-40A5-AD33-B398FDA816C6}"/>
-              </a:ext>
-            </a:extLst>
-          </p:cNvPr>
-          <p:cNvSpPr>
-            <a:spLocks xmlns:a="http://schemas.openxmlformats.org/drawingml/2006/main" noGrp="1"/>
-          </p:cNvSpPr>
-          <p:nvPr/>
-        </p:nvSpPr>
-        <p:spPr>
-          <a:xfrm xmlns:a="http://schemas.openxmlformats.org/drawingml/2006/main">
-            <a:off x="609600" y="2047875"/>
-            <a:ext cx="10953750" cy="3048000"/>
-          </a:xfrm>
-          <a:prstGeom xmlns:a="http://schemas.openxmlformats.org/drawingml/2006/main" prst="rect">
-            <a:avLst/>
-          </a:prstGeom>
-          <a:noFill xmlns:a="http://schemas.openxmlformats.org/drawingml/2006/main"/>
-          <a:ln xmlns:a="http://schemas.openxmlformats.org/drawingml/2006/main" w="0">
-            <a:noFill/>
-          </a:ln>
-        </p:spPr>
-        <p:txBody>
-          <a:bodyPr xmlns:a="http://schemas.openxmlformats.org/drawingml/2006/main">
-            <a:noAutofit/>
-          </a:bodyPr>
-          <a:lstStyle xmlns:a="http://schemas.openxmlformats.org/drawingml/2006/main"/>
-          <a:p xmlns:a="http://schemas.openxmlformats.org/drawingml/2006/main">
-            <a:pPr>
-              <a:defRPr sz="2175" b="0">
-                <a:solidFill>
-                  <a:srgbClr val="EAF1FF"/>
-                </a:solidFill>
-                <a:latin typeface="Arial"/>
-                <a:ea typeface="Arial"/>
-                <a:cs typeface="Arial"/>
-              </a:defRPr>
-            </a:pPr>
-            <a:r>
-              <a:rPr sz="2175" b="0">
+                <a16:creationId xmlns:a16="http://schemas.microsoft.com/office/drawing/2014/main" id="{1A6A04FB-A72D-4FE0-8A00-7D8614511CD4}"/>
+              </a:ext>
+            </a:extLst>
+          </p:cNvPr>
+          <p:cNvSpPr>
+            <a:spLocks xmlns:a="http://schemas.openxmlformats.org/drawingml/2006/main" noGrp="1"/>
+          </p:cNvSpPr>
+          <p:nvPr/>
+        </p:nvSpPr>
+        <p:spPr>
+          <a:xfrm xmlns:a="http://schemas.openxmlformats.org/drawingml/2006/main">
+            <a:off x="609600" y="1952625"/>
+            <a:ext cx="10953750" cy="1666875"/>
+          </a:xfrm>
+          <a:prstGeom xmlns:a="http://schemas.openxmlformats.org/drawingml/2006/main" prst="rect">
+            <a:avLst/>
+          </a:prstGeom>
+          <a:noFill xmlns:a="http://schemas.openxmlformats.org/drawingml/2006/main"/>
+          <a:ln xmlns:a="http://schemas.openxmlformats.org/drawingml/2006/main" w="0">
+            <a:noFill/>
+          </a:ln>
+        </p:spPr>
+        <p:txBody>
+          <a:bodyPr xmlns:a="http://schemas.openxmlformats.org/drawingml/2006/main">
+            <a:noAutofit/>
+          </a:bodyPr>
+          <a:lstStyle xmlns:a="http://schemas.openxmlformats.org/drawingml/2006/main"/>
+          <a:p xmlns:a="http://schemas.openxmlformats.org/drawingml/2006/main">
+            <a:pPr>
+              <a:defRPr sz="2025" b="0">
+                <a:solidFill>
+                  <a:srgbClr val="EAF1FF"/>
+                </a:solidFill>
+                <a:latin typeface="Arial"/>
+                <a:ea typeface="Arial"/>
+                <a:cs typeface="Arial"/>
+              </a:defRPr>
+            </a:pPr>
+            <a:r>
+              <a:rPr sz="2025" b="0">
                 <a:solidFill>
                   <a:srgbClr val="EAF1FF"/>
                 </a:solidFill>
@@ -4160,17 +4370,17 @@
           </a:p>
           <a:p xmlns:a="http://schemas.openxmlformats.org/drawingml/2006/main">
             <a:pPr>
-              <a:defRPr sz="2175" b="0">
-                <a:solidFill>
-                  <a:srgbClr val="EAF1FF"/>
-                </a:solidFill>
-                <a:latin typeface="Arial"/>
-                <a:ea typeface="Arial"/>
-                <a:cs typeface="Arial"/>
-              </a:defRPr>
-            </a:pPr>
-            <a:r>
-              <a:rPr sz="2175" b="0">
+              <a:defRPr sz="2025" b="0">
+                <a:solidFill>
+                  <a:srgbClr val="EAF1FF"/>
+                </a:solidFill>
+                <a:latin typeface="Arial"/>
+                <a:ea typeface="Arial"/>
+                <a:cs typeface="Arial"/>
+              </a:defRPr>
+            </a:pPr>
+            <a:r>
+              <a:rPr sz="2025" b="0">
                 <a:solidFill>
                   <a:srgbClr val="EAF1FF"/>
                 </a:solidFill>
@@ -4188,19 +4398,76 @@
           <p:cNvPr id="5" name="">
             <a:extLst xmlns:a="http://schemas.openxmlformats.org/drawingml/2006/main">
               <a:ext uri="{FF2B5EF4-FFF2-40B4-BE49-F238E27FC236}">
-                <a16:creationId xmlns:a16="http://schemas.microsoft.com/office/drawing/2014/main" id="{1D0D0B61-077C-4748-B27D-D979409A0717}"/>
-              </a:ext>
-            </a:extLst>
-          </p:cNvPr>
-          <p:cNvSpPr>
-            <a:spLocks xmlns:a="http://schemas.openxmlformats.org/drawingml/2006/main" noGrp="1"/>
-          </p:cNvSpPr>
-          <p:nvPr/>
-        </p:nvSpPr>
-        <p:spPr>
-          <a:xfrm xmlns:a="http://schemas.openxmlformats.org/drawingml/2006/main">
-            <a:off x="609600" y="4048125"/>
-            <a:ext cx="10953750" cy="1095375"/>
+                <a16:creationId xmlns:a16="http://schemas.microsoft.com/office/drawing/2014/main" id="{E5659D83-7712-44AE-BD03-7A98DC68A7F6}"/>
+              </a:ext>
+            </a:extLst>
+          </p:cNvPr>
+          <p:cNvSpPr>
+            <a:spLocks xmlns:a="http://schemas.openxmlformats.org/drawingml/2006/main" noGrp="1"/>
+          </p:cNvSpPr>
+          <p:nvPr/>
+        </p:nvSpPr>
+        <p:spPr>
+          <a:xfrm xmlns:a="http://schemas.openxmlformats.org/drawingml/2006/main">
+            <a:off x="609600" y="3714750"/>
+            <a:ext cx="10953750" cy="666750"/>
+          </a:xfrm>
+          <a:prstGeom xmlns:a="http://schemas.openxmlformats.org/drawingml/2006/main" prst="rect">
+            <a:avLst/>
+          </a:prstGeom>
+          <a:noFill xmlns:a="http://schemas.openxmlformats.org/drawingml/2006/main"/>
+          <a:ln xmlns:a="http://schemas.openxmlformats.org/drawingml/2006/main" w="0">
+            <a:noFill/>
+          </a:ln>
+        </p:spPr>
+        <p:txBody>
+          <a:bodyPr xmlns:a="http://schemas.openxmlformats.org/drawingml/2006/main">
+            <a:noAutofit/>
+          </a:bodyPr>
+          <a:lstStyle xmlns:a="http://schemas.openxmlformats.org/drawingml/2006/main"/>
+          <a:p xmlns:a="http://schemas.openxmlformats.org/drawingml/2006/main">
+            <a:pPr>
+              <a:defRPr sz="2100" b="1">
+                <a:solidFill>
+                  <a:srgbClr val="89DDFF"/>
+                </a:solidFill>
+                <a:latin typeface="Arial"/>
+                <a:ea typeface="Arial"/>
+                <a:cs typeface="Arial"/>
+              </a:defRPr>
+            </a:pPr>
+            <a:r>
+              <a:rPr sz="2100" b="1">
+                <a:solidFill>
+                  <a:srgbClr val="89DDFF"/>
+                </a:solidFill>
+                <a:latin typeface="Arial"/>
+                <a:ea typeface="Arial"/>
+                <a:cs typeface="Arial"/>
+              </a:rPr>
+              <a:t>Zgjidh përgjigjen</a:t>
+            </a:r>
+          </a:p>
+        </p:txBody>
+      </p:sp>
+      <p:sp>
+        <p:nvSpPr>
+          <p:cNvPr id="6" name="">
+            <a:extLst xmlns:a="http://schemas.openxmlformats.org/drawingml/2006/main">
+              <a:ext uri="{FF2B5EF4-FFF2-40B4-BE49-F238E27FC236}">
+                <a16:creationId xmlns:a16="http://schemas.microsoft.com/office/drawing/2014/main" id="{53B1E2D1-7D58-4F35-B76F-796C96774A23}"/>
+              </a:ext>
+            </a:extLst>
+          </p:cNvPr>
+          <p:cNvSpPr>
+            <a:spLocks xmlns:a="http://schemas.openxmlformats.org/drawingml/2006/main" noGrp="1"/>
+          </p:cNvSpPr>
+          <p:nvPr/>
+        </p:nvSpPr>
+        <p:spPr>
+          <a:xfrm xmlns:a="http://schemas.openxmlformats.org/drawingml/2006/main">
+            <a:off x="609600" y="4429125"/>
+            <a:ext cx="10953750" cy="1381125"/>
           </a:xfrm>
           <a:prstGeom xmlns:a="http://schemas.openxmlformats.org/drawingml/2006/main" prst="rect">
             <a:avLst/>
@@ -4239,6 +4506,11 @@
             </a:r>
           </a:p>
           <a:p xmlns:a="http://schemas.openxmlformats.org/drawingml/2006/main">
+            <a:r>
+              <a:t/>
+            </a:r>
+          </a:p>
+          <a:p xmlns:a="http://schemas.openxmlformats.org/drawingml/2006/main">
             <a:pPr>
               <a:defRPr sz="1875" b="0">
                 <a:solidFill>
@@ -4262,6 +4534,11 @@
             </a:r>
           </a:p>
           <a:p xmlns:a="http://schemas.openxmlformats.org/drawingml/2006/main">
+            <a:r>
+              <a:t/>
+            </a:r>
+          </a:p>
+          <a:p xmlns:a="http://schemas.openxmlformats.org/drawingml/2006/main">
             <a:pPr>
               <a:defRPr sz="1875" b="0">
                 <a:solidFill>
@@ -4288,39 +4565,39 @@
       </p:sp>
       <p:sp>
         <p:nvSpPr>
-          <p:cNvPr id="6" name="">
-            <a:extLst xmlns:a="http://schemas.openxmlformats.org/drawingml/2006/main">
-              <a:ext uri="{FF2B5EF4-FFF2-40B4-BE49-F238E27FC236}">
-                <a16:creationId xmlns:a16="http://schemas.microsoft.com/office/drawing/2014/main" id="{32BF32CF-F025-4EA4-8381-B007F8A786B3}"/>
-              </a:ext>
-            </a:extLst>
-          </p:cNvPr>
-          <p:cNvSpPr>
-            <a:spLocks xmlns:a="http://schemas.openxmlformats.org/drawingml/2006/main" noGrp="1"/>
-          </p:cNvSpPr>
-          <p:nvPr/>
-        </p:nvSpPr>
-        <p:spPr>
-          <a:xfrm xmlns:a="http://schemas.openxmlformats.org/drawingml/2006/main">
-            <a:off x="609600" y="5476875"/>
-            <a:ext cx="10953750" cy="904875"/>
-          </a:xfrm>
-          <a:prstGeom xmlns:a="http://schemas.openxmlformats.org/drawingml/2006/main" prst="rect">
-            <a:avLst/>
-          </a:prstGeom>
-          <a:noFill xmlns:a="http://schemas.openxmlformats.org/drawingml/2006/main"/>
-          <a:ln xmlns:a="http://schemas.openxmlformats.org/drawingml/2006/main" w="0">
-            <a:noFill/>
-          </a:ln>
-        </p:spPr>
-        <p:txBody>
-          <a:bodyPr xmlns:a="http://schemas.openxmlformats.org/drawingml/2006/main">
-            <a:noAutofit/>
-          </a:bodyPr>
-          <a:lstStyle xmlns:a="http://schemas.openxmlformats.org/drawingml/2006/main"/>
-          <a:p xmlns:a="http://schemas.openxmlformats.org/drawingml/2006/main">
-            <a:pPr>
-              <a:defRPr sz="1800" b="0">
+          <p:cNvPr id="7" name="">
+            <a:extLst xmlns:a="http://schemas.openxmlformats.org/drawingml/2006/main">
+              <a:ext uri="{FF2B5EF4-FFF2-40B4-BE49-F238E27FC236}">
+                <a16:creationId xmlns:a16="http://schemas.microsoft.com/office/drawing/2014/main" id="{CCBA4719-7E75-43D6-9439-14D05C271D40}"/>
+              </a:ext>
+            </a:extLst>
+          </p:cNvPr>
+          <p:cNvSpPr>
+            <a:spLocks xmlns:a="http://schemas.openxmlformats.org/drawingml/2006/main" noGrp="1"/>
+          </p:cNvSpPr>
+          <p:nvPr/>
+        </p:nvSpPr>
+        <p:spPr>
+          <a:xfrm xmlns:a="http://schemas.openxmlformats.org/drawingml/2006/main">
+            <a:off x="609600" y="5905500"/>
+            <a:ext cx="10953750" cy="714375"/>
+          </a:xfrm>
+          <a:prstGeom xmlns:a="http://schemas.openxmlformats.org/drawingml/2006/main" prst="rect">
+            <a:avLst/>
+          </a:prstGeom>
+          <a:noFill xmlns:a="http://schemas.openxmlformats.org/drawingml/2006/main"/>
+          <a:ln xmlns:a="http://schemas.openxmlformats.org/drawingml/2006/main" w="0">
+            <a:noFill/>
+          </a:ln>
+        </p:spPr>
+        <p:txBody>
+          <a:bodyPr xmlns:a="http://schemas.openxmlformats.org/drawingml/2006/main">
+            <a:noAutofit/>
+          </a:bodyPr>
+          <a:lstStyle xmlns:a="http://schemas.openxmlformats.org/drawingml/2006/main"/>
+          <a:p xmlns:a="http://schemas.openxmlformats.org/drawingml/2006/main">
+            <a:pPr>
+              <a:defRPr sz="1650" b="0">
                 <a:solidFill>
                   <a:srgbClr val="8EE9D1"/>
                 </a:solidFill>
@@ -4330,7 +4607,7 @@
               </a:defRPr>
             </a:pPr>
             <a:r>
-              <a:rPr sz="1800" b="0">
+              <a:rPr sz="1650" b="0">
                 <a:solidFill>
                   <a:srgbClr val="8EE9D1"/>
                 </a:solidFill>
@@ -4346,7 +4623,7 @@
     </p:spTree>
     <p:extLst>
       <p:ext uri="{BB962C8B-B14F-4D97-AF65-F5344CB8AC3E}">
-        <p14:creationId xmlns:p14="http://schemas.microsoft.com/office/powerpoint/2010/main" val="1234658242"/>
+        <p14:creationId xmlns:p14="http://schemas.microsoft.com/office/powerpoint/2010/main" val="1336204240"/>
       </p:ext>
     </p:extLst>
   </p:cSld>
@@ -4377,7 +4654,7 @@
           <p:cNvPr id="6" name="">
             <a:extLst xmlns:a="http://schemas.openxmlformats.org/drawingml/2006/main">
               <a:ext uri="{FF2B5EF4-FFF2-40B4-BE49-F238E27FC236}">
-                <a16:creationId xmlns:a16="http://schemas.microsoft.com/office/drawing/2014/main" id="{4E885CD0-A97E-45E0-8E79-0887A4B0A0FB}"/>
+                <a16:creationId xmlns:a16="http://schemas.microsoft.com/office/drawing/2014/main" id="{37FB457C-6595-4162-B01D-68D7CE3FD0D2}"/>
               </a:ext>
             </a:extLst>
           </p:cNvPr>
@@ -4434,7 +4711,7 @@
           <p:cNvPr id="2" name="">
             <a:extLst xmlns:a="http://schemas.openxmlformats.org/drawingml/2006/main">
               <a:ext uri="{FF2B5EF4-FFF2-40B4-BE49-F238E27FC236}">
-                <a16:creationId xmlns:a16="http://schemas.microsoft.com/office/drawing/2014/main" id="{CBD403FB-EC82-4683-9B90-B890C3AF63E8}"/>
+                <a16:creationId xmlns:a16="http://schemas.microsoft.com/office/drawing/2014/main" id="{6AEDCE2F-CE9B-4EF1-B2CC-570FF3A72F8F}"/>
               </a:ext>
             </a:extLst>
           </p:cNvPr>
@@ -4491,7 +4768,7 @@
           <p:cNvPr id="3" name="">
             <a:extLst xmlns:a="http://schemas.openxmlformats.org/drawingml/2006/main">
               <a:ext uri="{FF2B5EF4-FFF2-40B4-BE49-F238E27FC236}">
-                <a16:creationId xmlns:a16="http://schemas.microsoft.com/office/drawing/2014/main" id="{55086546-0C7E-4764-A691-A0829A3BC150}"/>
+                <a16:creationId xmlns:a16="http://schemas.microsoft.com/office/drawing/2014/main" id="{3DD6D139-5924-447F-9984-EE40EB2F8644}"/>
               </a:ext>
             </a:extLst>
           </p:cNvPr>
@@ -4548,7 +4825,7 @@
           <p:cNvPr id="4" name="">
             <a:extLst xmlns:a="http://schemas.openxmlformats.org/drawingml/2006/main">
               <a:ext uri="{FF2B5EF4-FFF2-40B4-BE49-F238E27FC236}">
-                <a16:creationId xmlns:a16="http://schemas.microsoft.com/office/drawing/2014/main" id="{49577D90-C537-455E-9AC9-16B37884E130}"/>
+                <a16:creationId xmlns:a16="http://schemas.microsoft.com/office/drawing/2014/main" id="{9CEFFFF9-837D-4914-B5B5-FEB6E4B6A217}"/>
               </a:ext>
             </a:extLst>
           </p:cNvPr>
@@ -4689,7 +4966,7 @@
           <p:cNvPr id="5" name="">
             <a:extLst xmlns:a="http://schemas.openxmlformats.org/drawingml/2006/main">
               <a:ext uri="{FF2B5EF4-FFF2-40B4-BE49-F238E27FC236}">
-                <a16:creationId xmlns:a16="http://schemas.microsoft.com/office/drawing/2014/main" id="{A593FA69-7F0C-4123-8F5B-52D079DD8E05}"/>
+                <a16:creationId xmlns:a16="http://schemas.microsoft.com/office/drawing/2014/main" id="{94B92799-9667-4D3A-B4E0-1DBC3521E15A}"/>
               </a:ext>
             </a:extLst>
           </p:cNvPr>
@@ -4744,7 +5021,7 @@
     </p:spTree>
     <p:extLst>
       <p:ext uri="{BB962C8B-B14F-4D97-AF65-F5344CB8AC3E}">
-        <p14:creationId xmlns:p14="http://schemas.microsoft.com/office/powerpoint/2010/main" val="1436891095"/>
+        <p14:creationId xmlns:p14="http://schemas.microsoft.com/office/powerpoint/2010/main" val="1165277424"/>
       </p:ext>
     </p:extLst>
   </p:cSld>
@@ -4775,7 +5052,7 @@
           <p:cNvPr id="5" name="">
             <a:extLst xmlns:a="http://schemas.openxmlformats.org/drawingml/2006/main">
               <a:ext uri="{FF2B5EF4-FFF2-40B4-BE49-F238E27FC236}">
-                <a16:creationId xmlns:a16="http://schemas.microsoft.com/office/drawing/2014/main" id="{3BDD66FE-6F39-4179-8532-D70D00EFC805}"/>
+                <a16:creationId xmlns:a16="http://schemas.microsoft.com/office/drawing/2014/main" id="{75BF7304-5E49-45EA-8597-87DFA6E008A0}"/>
               </a:ext>
             </a:extLst>
           </p:cNvPr>
@@ -4832,7 +5109,7 @@
           <p:cNvPr id="2" name="">
             <a:extLst xmlns:a="http://schemas.openxmlformats.org/drawingml/2006/main">
               <a:ext uri="{FF2B5EF4-FFF2-40B4-BE49-F238E27FC236}">
-                <a16:creationId xmlns:a16="http://schemas.microsoft.com/office/drawing/2014/main" id="{B4D9A819-212D-46A5-AF15-69158AA40C48}"/>
+                <a16:creationId xmlns:a16="http://schemas.microsoft.com/office/drawing/2014/main" id="{C4FEE152-F971-4BA9-9257-CA6D6FB6CD7F}"/>
               </a:ext>
             </a:extLst>
           </p:cNvPr>
@@ -4889,7 +5166,7 @@
           <p:cNvPr id="3" name="">
             <a:extLst xmlns:a="http://schemas.openxmlformats.org/drawingml/2006/main">
               <a:ext uri="{FF2B5EF4-FFF2-40B4-BE49-F238E27FC236}">
-                <a16:creationId xmlns:a16="http://schemas.microsoft.com/office/drawing/2014/main" id="{80F852C1-A0F1-48AD-BB09-CCFA4089F71F}"/>
+                <a16:creationId xmlns:a16="http://schemas.microsoft.com/office/drawing/2014/main" id="{9BE8BB21-9725-4B7C-91E8-06C285DF3D1C}"/>
               </a:ext>
             </a:extLst>
           </p:cNvPr>
@@ -4946,7 +5223,7 @@
           <p:cNvPr id="4" name="">
             <a:extLst xmlns:a="http://schemas.openxmlformats.org/drawingml/2006/main">
               <a:ext uri="{FF2B5EF4-FFF2-40B4-BE49-F238E27FC236}">
-                <a16:creationId xmlns:a16="http://schemas.microsoft.com/office/drawing/2014/main" id="{51BE5D98-E072-4C3F-9B93-02B3DD4887D0}"/>
+                <a16:creationId xmlns:a16="http://schemas.microsoft.com/office/drawing/2014/main" id="{AFAD5CB0-8C38-4CF3-9F6E-ECB765C446B0}"/>
               </a:ext>
             </a:extLst>
           </p:cNvPr>
@@ -5085,7 +5362,7 @@
     </p:spTree>
     <p:extLst>
       <p:ext uri="{BB962C8B-B14F-4D97-AF65-F5344CB8AC3E}">
-        <p14:creationId xmlns:p14="http://schemas.microsoft.com/office/powerpoint/2010/main" val="1544480383"/>
+        <p14:creationId xmlns:p14="http://schemas.microsoft.com/office/powerpoint/2010/main" val="135406597"/>
       </p:ext>
     </p:extLst>
   </p:cSld>
@@ -5113,10 +5390,10 @@
       </p:grpSpPr>
       <p:sp>
         <p:nvSpPr>
-          <p:cNvPr id="6" name="">
-            <a:extLst xmlns:a="http://schemas.openxmlformats.org/drawingml/2006/main">
-              <a:ext uri="{FF2B5EF4-FFF2-40B4-BE49-F238E27FC236}">
-                <a16:creationId xmlns:a16="http://schemas.microsoft.com/office/drawing/2014/main" id="{5A79F09B-DFDD-493B-A532-2A0AAFABE6EE}"/>
+          <p:cNvPr id="8" name="">
+            <a:extLst xmlns:a="http://schemas.openxmlformats.org/drawingml/2006/main">
+              <a:ext uri="{FF2B5EF4-FFF2-40B4-BE49-F238E27FC236}">
+                <a16:creationId xmlns:a16="http://schemas.microsoft.com/office/drawing/2014/main" id="{2D0C2B6C-F74C-46E9-9E31-6C12DC0E17E3}"/>
               </a:ext>
             </a:extLst>
           </p:cNvPr>
@@ -5163,7 +5440,7 @@
                 <a:ea typeface="Arial"/>
                 <a:cs typeface="Arial"/>
               </a:rPr>
-              <a:t>PROBLEMI · 0–5 MIN</a:t>
+              <a:t>RIKUJTIM NË ÇIFT · 2–4 MIN</a:t>
             </a:r>
           </a:p>
         </p:txBody>
@@ -5173,7 +5450,7 @@
           <p:cNvPr id="2" name="">
             <a:extLst xmlns:a="http://schemas.openxmlformats.org/drawingml/2006/main">
               <a:ext uri="{FF2B5EF4-FFF2-40B4-BE49-F238E27FC236}">
-                <a16:creationId xmlns:a16="http://schemas.microsoft.com/office/drawing/2014/main" id="{EC65AE90-35AB-43EB-932A-939659AE5BEE}"/>
+                <a16:creationId xmlns:a16="http://schemas.microsoft.com/office/drawing/2014/main" id="{4C01D2FA-BAFF-46BE-91E7-87F98F843731}"/>
               </a:ext>
             </a:extLst>
           </p:cNvPr>
@@ -5230,7 +5507,7 @@
           <p:cNvPr id="3" name="">
             <a:extLst xmlns:a="http://schemas.openxmlformats.org/drawingml/2006/main">
               <a:ext uri="{FF2B5EF4-FFF2-40B4-BE49-F238E27FC236}">
-                <a16:creationId xmlns:a16="http://schemas.microsoft.com/office/drawing/2014/main" id="{1F3F8DAB-5ED7-4123-880B-C0C684339BD8}"/>
+                <a16:creationId xmlns:a16="http://schemas.microsoft.com/office/drawing/2014/main" id="{E1EF9082-F241-4343-A1D4-4082DC3684F1}"/>
               </a:ext>
             </a:extLst>
           </p:cNvPr>
@@ -5277,7 +5554,7 @@
                 <a:ea typeface="Arial"/>
                 <a:cs typeface="Arial"/>
               </a:rPr>
-              <a:t>Shoferi ndryshon orën</a:t>
+              <a:t>Çfarë kemi tashmë nga Java 3?</a:t>
             </a:r>
           </a:p>
         </p:txBody>
@@ -5287,54 +5564,54 @@
           <p:cNvPr id="4" name="">
             <a:extLst xmlns:a="http://schemas.openxmlformats.org/drawingml/2006/main">
               <a:ext uri="{FF2B5EF4-FFF2-40B4-BE49-F238E27FC236}">
-                <a16:creationId xmlns:a16="http://schemas.microsoft.com/office/drawing/2014/main" id="{0FAACD14-520A-4272-BE4C-2B8219168873}"/>
-              </a:ext>
-            </a:extLst>
-          </p:cNvPr>
-          <p:cNvSpPr>
-            <a:spLocks xmlns:a="http://schemas.openxmlformats.org/drawingml/2006/main" noGrp="1"/>
-          </p:cNvSpPr>
-          <p:nvPr/>
-        </p:nvSpPr>
-        <p:spPr>
-          <a:xfrm xmlns:a="http://schemas.openxmlformats.org/drawingml/2006/main">
-            <a:off x="609600" y="2047875"/>
-            <a:ext cx="10953750" cy="3048000"/>
-          </a:xfrm>
-          <a:prstGeom xmlns:a="http://schemas.openxmlformats.org/drawingml/2006/main" prst="rect">
-            <a:avLst/>
-          </a:prstGeom>
-          <a:noFill xmlns:a="http://schemas.openxmlformats.org/drawingml/2006/main"/>
-          <a:ln xmlns:a="http://schemas.openxmlformats.org/drawingml/2006/main" w="0">
-            <a:noFill/>
-          </a:ln>
-        </p:spPr>
-        <p:txBody>
-          <a:bodyPr xmlns:a="http://schemas.openxmlformats.org/drawingml/2006/main">
-            <a:noAutofit/>
-          </a:bodyPr>
-          <a:lstStyle xmlns:a="http://schemas.openxmlformats.org/drawingml/2006/main"/>
-          <a:p xmlns:a="http://schemas.openxmlformats.org/drawingml/2006/main">
-            <a:pPr>
-              <a:defRPr sz="2175" b="0">
-                <a:solidFill>
-                  <a:srgbClr val="EAF1FF"/>
-                </a:solidFill>
-                <a:latin typeface="Arial"/>
-                <a:ea typeface="Arial"/>
-                <a:cs typeface="Arial"/>
-              </a:defRPr>
-            </a:pPr>
-            <a:r>
-              <a:rPr sz="2175" b="0">
-                <a:solidFill>
-                  <a:srgbClr val="EAF1FF"/>
-                </a:solidFill>
-                <a:latin typeface="Arial"/>
-                <a:ea typeface="Arial"/>
-                <a:cs typeface="Arial"/>
-              </a:rPr>
-              <a:t>Arta zgjodhi udhëtimin e orës 08:15. Shoferi e ndryshon nisjen në 08:25.</a:t>
+                <a16:creationId xmlns:a16="http://schemas.microsoft.com/office/drawing/2014/main" id="{585EBA06-D073-4BBE-B2F6-DA3546A109C7}"/>
+              </a:ext>
+            </a:extLst>
+          </p:cNvPr>
+          <p:cNvSpPr>
+            <a:spLocks xmlns:a="http://schemas.openxmlformats.org/drawingml/2006/main" noGrp="1"/>
+          </p:cNvSpPr>
+          <p:nvPr/>
+        </p:nvSpPr>
+        <p:spPr>
+          <a:xfrm xmlns:a="http://schemas.openxmlformats.org/drawingml/2006/main">
+            <a:off x="609600" y="1952625"/>
+            <a:ext cx="10953750" cy="1666875"/>
+          </a:xfrm>
+          <a:prstGeom xmlns:a="http://schemas.openxmlformats.org/drawingml/2006/main" prst="rect">
+            <a:avLst/>
+          </a:prstGeom>
+          <a:noFill xmlns:a="http://schemas.openxmlformats.org/drawingml/2006/main"/>
+          <a:ln xmlns:a="http://schemas.openxmlformats.org/drawingml/2006/main" w="0">
+            <a:noFill/>
+          </a:ln>
+        </p:spPr>
+        <p:txBody>
+          <a:bodyPr xmlns:a="http://schemas.openxmlformats.org/drawingml/2006/main">
+            <a:noAutofit/>
+          </a:bodyPr>
+          <a:lstStyle xmlns:a="http://schemas.openxmlformats.org/drawingml/2006/main"/>
+          <a:p xmlns:a="http://schemas.openxmlformats.org/drawingml/2006/main">
+            <a:pPr>
+              <a:defRPr sz="2025" b="0">
+                <a:solidFill>
+                  <a:srgbClr val="EAF1FF"/>
+                </a:solidFill>
+                <a:latin typeface="Arial"/>
+                <a:ea typeface="Arial"/>
+                <a:cs typeface="Arial"/>
+              </a:defRPr>
+            </a:pPr>
+            <a:r>
+              <a:rPr sz="2025" b="0">
+                <a:solidFill>
+                  <a:srgbClr val="EAF1FF"/>
+                </a:solidFill>
+                <a:latin typeface="Arial"/>
+                <a:ea typeface="Arial"/>
+                <a:cs typeface="Arial"/>
+              </a:rPr>
+              <a:t>KartaUdhetimi shfaq udhëtimin. Lista hap detajet dhe simulimin e kërkesës.</a:t>
             </a:r>
           </a:p>
           <a:p xmlns:a="http://schemas.openxmlformats.org/drawingml/2006/main">
@@ -5344,25 +5621,139 @@
           </a:p>
           <a:p xmlns:a="http://schemas.openxmlformats.org/drawingml/2006/main">
             <a:pPr>
-              <a:defRPr sz="2175" b="0">
-                <a:solidFill>
-                  <a:srgbClr val="EAF1FF"/>
-                </a:solidFill>
-                <a:latin typeface="Arial"/>
-                <a:ea typeface="Arial"/>
-                <a:cs typeface="Arial"/>
-              </a:defRPr>
-            </a:pPr>
-            <a:r>
-              <a:rPr sz="2175" b="0">
-                <a:solidFill>
-                  <a:srgbClr val="EAF1FF"/>
-                </a:solidFill>
-                <a:latin typeface="Arial"/>
-                <a:ea typeface="Arial"/>
-                <a:cs typeface="Arial"/>
-              </a:rPr>
-              <a:t>Parashiko: ku duhet të shihet ora e re — në kartë, në detaje apo në të dyja?</a:t>
+              <a:defRPr sz="2025" b="0">
+                <a:solidFill>
+                  <a:srgbClr val="EAF1FF"/>
+                </a:solidFill>
+                <a:latin typeface="Arial"/>
+                <a:ea typeface="Arial"/>
+                <a:cs typeface="Arial"/>
+              </a:defRPr>
+            </a:pPr>
+            <a:r>
+              <a:rPr sz="2025" b="0">
+                <a:solidFill>
+                  <a:srgbClr val="EAF1FF"/>
+                </a:solidFill>
+                <a:latin typeface="Arial"/>
+                <a:ea typeface="Arial"/>
+                <a:cs typeface="Arial"/>
+              </a:rPr>
+              <a:t>Njëri shpjegon rrugën mes ekraneve, tjetri kujton burimin e të dhënave. Pastaj ndërroni rolet.</a:t>
+            </a:r>
+          </a:p>
+        </p:txBody>
+      </p:sp>
+      <p:sp>
+        <p:nvSpPr>
+          <p:cNvPr id="5" name="">
+            <a:extLst xmlns:a="http://schemas.openxmlformats.org/drawingml/2006/main">
+              <a:ext uri="{FF2B5EF4-FFF2-40B4-BE49-F238E27FC236}">
+                <a16:creationId xmlns:a16="http://schemas.microsoft.com/office/drawing/2014/main" id="{1A23E905-C2C3-4018-B821-80D3A86F3A7E}"/>
+              </a:ext>
+            </a:extLst>
+          </p:cNvPr>
+          <p:cNvSpPr>
+            <a:spLocks xmlns:a="http://schemas.openxmlformats.org/drawingml/2006/main" noGrp="1"/>
+          </p:cNvSpPr>
+          <p:nvPr/>
+        </p:nvSpPr>
+        <p:spPr>
+          <a:xfrm xmlns:a="http://schemas.openxmlformats.org/drawingml/2006/main">
+            <a:off x="609600" y="3714750"/>
+            <a:ext cx="10953750" cy="666750"/>
+          </a:xfrm>
+          <a:prstGeom xmlns:a="http://schemas.openxmlformats.org/drawingml/2006/main" prst="rect">
+            <a:avLst/>
+          </a:prstGeom>
+          <a:noFill xmlns:a="http://schemas.openxmlformats.org/drawingml/2006/main"/>
+          <a:ln xmlns:a="http://schemas.openxmlformats.org/drawingml/2006/main" w="0">
+            <a:noFill/>
+          </a:ln>
+        </p:spPr>
+        <p:txBody>
+          <a:bodyPr xmlns:a="http://schemas.openxmlformats.org/drawingml/2006/main">
+            <a:noAutofit/>
+          </a:bodyPr>
+          <a:lstStyle xmlns:a="http://schemas.openxmlformats.org/drawingml/2006/main"/>
+          <a:p xmlns:a="http://schemas.openxmlformats.org/drawingml/2006/main">
+            <a:pPr>
+              <a:defRPr sz="2100" b="1">
+                <a:solidFill>
+                  <a:srgbClr val="89DDFF"/>
+                </a:solidFill>
+                <a:latin typeface="Arial"/>
+                <a:ea typeface="Arial"/>
+                <a:cs typeface="Arial"/>
+              </a:defRPr>
+            </a:pPr>
+            <a:r>
+              <a:rPr sz="2100" b="1">
+                <a:solidFill>
+                  <a:srgbClr val="89DDFF"/>
+                </a:solidFill>
+                <a:latin typeface="Arial"/>
+                <a:ea typeface="Arial"/>
+                <a:cs typeface="Arial"/>
+              </a:rPr>
+              <a:t>Ku ruheshin udhëtimet në shembullin e Javës 3?</a:t>
+            </a:r>
+          </a:p>
+        </p:txBody>
+      </p:sp>
+      <p:sp>
+        <p:nvSpPr>
+          <p:cNvPr id="6" name="">
+            <a:extLst xmlns:a="http://schemas.openxmlformats.org/drawingml/2006/main">
+              <a:ext uri="{FF2B5EF4-FFF2-40B4-BE49-F238E27FC236}">
+                <a16:creationId xmlns:a16="http://schemas.microsoft.com/office/drawing/2014/main" id="{41383627-44AE-43A4-BCEC-6AB038DC8504}"/>
+              </a:ext>
+            </a:extLst>
+          </p:cNvPr>
+          <p:cNvSpPr>
+            <a:spLocks xmlns:a="http://schemas.openxmlformats.org/drawingml/2006/main" noGrp="1"/>
+          </p:cNvSpPr>
+          <p:nvPr/>
+        </p:nvSpPr>
+        <p:spPr>
+          <a:xfrm xmlns:a="http://schemas.openxmlformats.org/drawingml/2006/main">
+            <a:off x="609600" y="4429125"/>
+            <a:ext cx="10953750" cy="1381125"/>
+          </a:xfrm>
+          <a:prstGeom xmlns:a="http://schemas.openxmlformats.org/drawingml/2006/main" prst="rect">
+            <a:avLst/>
+          </a:prstGeom>
+          <a:noFill xmlns:a="http://schemas.openxmlformats.org/drawingml/2006/main"/>
+          <a:ln xmlns:a="http://schemas.openxmlformats.org/drawingml/2006/main" w="0">
+            <a:noFill/>
+          </a:ln>
+        </p:spPr>
+        <p:txBody>
+          <a:bodyPr xmlns:a="http://schemas.openxmlformats.org/drawingml/2006/main">
+            <a:noAutofit/>
+          </a:bodyPr>
+          <a:lstStyle xmlns:a="http://schemas.openxmlformats.org/drawingml/2006/main"/>
+          <a:p xmlns:a="http://schemas.openxmlformats.org/drawingml/2006/main">
+            <a:pPr>
+              <a:defRPr sz="1875" b="0">
+                <a:solidFill>
+                  <a:srgbClr val="EAF1FF"/>
+                </a:solidFill>
+                <a:latin typeface="Arial"/>
+                <a:ea typeface="Arial"/>
+                <a:cs typeface="Arial"/>
+              </a:defRPr>
+            </a:pPr>
+            <a:r>
+              <a:rPr sz="1875" b="0">
+                <a:solidFill>
+                  <a:srgbClr val="EAF1FF"/>
+                </a:solidFill>
+                <a:latin typeface="Arial"/>
+                <a:ea typeface="Arial"/>
+                <a:cs typeface="Arial"/>
+              </a:rPr>
+              <a:t>A · Në një varg të të dhënave brenda kodit.</a:t>
             </a:r>
           </a:p>
           <a:p xmlns:a="http://schemas.openxmlformats.org/drawingml/2006/main">
@@ -5372,64 +5763,92 @@
           </a:p>
           <a:p xmlns:a="http://schemas.openxmlformats.org/drawingml/2006/main">
             <a:pPr>
-              <a:defRPr sz="2175" b="0">
-                <a:solidFill>
-                  <a:srgbClr val="EAF1FF"/>
-                </a:solidFill>
-                <a:latin typeface="Arial"/>
-                <a:ea typeface="Arial"/>
-                <a:cs typeface="Arial"/>
-              </a:defRPr>
-            </a:pPr>
-            <a:r>
-              <a:rPr sz="2175" b="0">
-                <a:solidFill>
-                  <a:srgbClr val="EAF1FF"/>
-                </a:solidFill>
-                <a:latin typeface="Arial"/>
-                <a:ea typeface="Arial"/>
-                <a:cs typeface="Arial"/>
-              </a:rPr>
-              <a:t>Diskuto me personin pranë teje për 20 sekonda; pastaj zbulojmë përgjigjen.</a:t>
-            </a:r>
-          </a:p>
-        </p:txBody>
-      </p:sp>
-      <p:sp>
-        <p:nvSpPr>
-          <p:cNvPr id="5" name="">
-            <a:extLst xmlns:a="http://schemas.openxmlformats.org/drawingml/2006/main">
-              <a:ext uri="{FF2B5EF4-FFF2-40B4-BE49-F238E27FC236}">
-                <a16:creationId xmlns:a16="http://schemas.microsoft.com/office/drawing/2014/main" id="{9A04E0D6-CC71-4754-9839-FEEA49D76CF1}"/>
-              </a:ext>
-            </a:extLst>
-          </p:cNvPr>
-          <p:cNvSpPr>
-            <a:spLocks xmlns:a="http://schemas.openxmlformats.org/drawingml/2006/main" noGrp="1"/>
-          </p:cNvSpPr>
-          <p:nvPr/>
-        </p:nvSpPr>
-        <p:spPr>
-          <a:xfrm xmlns:a="http://schemas.openxmlformats.org/drawingml/2006/main">
-            <a:off x="609600" y="5334000"/>
-            <a:ext cx="10953750" cy="1095375"/>
-          </a:xfrm>
-          <a:prstGeom xmlns:a="http://schemas.openxmlformats.org/drawingml/2006/main" prst="rect">
-            <a:avLst/>
-          </a:prstGeom>
-          <a:noFill xmlns:a="http://schemas.openxmlformats.org/drawingml/2006/main"/>
-          <a:ln xmlns:a="http://schemas.openxmlformats.org/drawingml/2006/main" w="0">
-            <a:noFill/>
-          </a:ln>
-        </p:spPr>
-        <p:txBody>
-          <a:bodyPr xmlns:a="http://schemas.openxmlformats.org/drawingml/2006/main">
-            <a:noAutofit/>
-          </a:bodyPr>
-          <a:lstStyle xmlns:a="http://schemas.openxmlformats.org/drawingml/2006/main"/>
-          <a:p xmlns:a="http://schemas.openxmlformats.org/drawingml/2006/main">
-            <a:pPr>
-              <a:defRPr sz="1800" b="0">
+              <a:defRPr sz="1875" b="0">
+                <a:solidFill>
+                  <a:srgbClr val="EAF1FF"/>
+                </a:solidFill>
+                <a:latin typeface="Arial"/>
+                <a:ea typeface="Arial"/>
+                <a:cs typeface="Arial"/>
+              </a:defRPr>
+            </a:pPr>
+            <a:r>
+              <a:rPr sz="1875" b="0">
+                <a:solidFill>
+                  <a:srgbClr val="EAF1FF"/>
+                </a:solidFill>
+                <a:latin typeface="Arial"/>
+                <a:ea typeface="Arial"/>
+                <a:cs typeface="Arial"/>
+              </a:rPr>
+              <a:t>B · Në databazën Neon.</a:t>
+            </a:r>
+          </a:p>
+          <a:p xmlns:a="http://schemas.openxmlformats.org/drawingml/2006/main">
+            <a:r>
+              <a:t/>
+            </a:r>
+          </a:p>
+          <a:p xmlns:a="http://schemas.openxmlformats.org/drawingml/2006/main">
+            <a:pPr>
+              <a:defRPr sz="1875" b="0">
+                <a:solidFill>
+                  <a:srgbClr val="EAF1FF"/>
+                </a:solidFill>
+                <a:latin typeface="Arial"/>
+                <a:ea typeface="Arial"/>
+                <a:cs typeface="Arial"/>
+              </a:defRPr>
+            </a:pPr>
+            <a:r>
+              <a:rPr sz="1875" b="0">
+                <a:solidFill>
+                  <a:srgbClr val="EAF1FF"/>
+                </a:solidFill>
+                <a:latin typeface="Arial"/>
+                <a:ea typeface="Arial"/>
+                <a:cs typeface="Arial"/>
+              </a:rPr>
+              <a:t>C · Te GitHub Issues.</a:t>
+            </a:r>
+          </a:p>
+        </p:txBody>
+      </p:sp>
+      <p:sp>
+        <p:nvSpPr>
+          <p:cNvPr id="7" name="">
+            <a:extLst xmlns:a="http://schemas.openxmlformats.org/drawingml/2006/main">
+              <a:ext uri="{FF2B5EF4-FFF2-40B4-BE49-F238E27FC236}">
+                <a16:creationId xmlns:a16="http://schemas.microsoft.com/office/drawing/2014/main" id="{CDF1EB9D-1D14-47AD-A5C3-35B0C30AEA1B}"/>
+              </a:ext>
+            </a:extLst>
+          </p:cNvPr>
+          <p:cNvSpPr>
+            <a:spLocks xmlns:a="http://schemas.openxmlformats.org/drawingml/2006/main" noGrp="1"/>
+          </p:cNvSpPr>
+          <p:nvPr/>
+        </p:nvSpPr>
+        <p:spPr>
+          <a:xfrm xmlns:a="http://schemas.openxmlformats.org/drawingml/2006/main">
+            <a:off x="609600" y="5953125"/>
+            <a:ext cx="10953750" cy="381000"/>
+          </a:xfrm>
+          <a:prstGeom xmlns:a="http://schemas.openxmlformats.org/drawingml/2006/main" prst="rect">
+            <a:avLst/>
+          </a:prstGeom>
+          <a:noFill xmlns:a="http://schemas.openxmlformats.org/drawingml/2006/main"/>
+          <a:ln xmlns:a="http://schemas.openxmlformats.org/drawingml/2006/main" w="0">
+            <a:noFill/>
+          </a:ln>
+        </p:spPr>
+        <p:txBody>
+          <a:bodyPr xmlns:a="http://schemas.openxmlformats.org/drawingml/2006/main">
+            <a:noAutofit/>
+          </a:bodyPr>
+          <a:lstStyle xmlns:a="http://schemas.openxmlformats.org/drawingml/2006/main"/>
+          <a:p xmlns:a="http://schemas.openxmlformats.org/drawingml/2006/main">
+            <a:pPr>
+              <a:defRPr sz="1650" b="0">
                 <a:solidFill>
                   <a:srgbClr val="8EE9D1"/>
                 </a:solidFill>
@@ -5439,7 +5858,7 @@
               </a:defRPr>
             </a:pPr>
             <a:r>
-              <a:rPr sz="1800" b="0">
+              <a:rPr sz="1650" b="0">
                 <a:solidFill>
                   <a:srgbClr val="8EE9D1"/>
                 </a:solidFill>
@@ -5447,7 +5866,7 @@
                 <a:ea typeface="Arial"/>
                 <a:cs typeface="Arial"/>
               </a:rPr>
-              <a:t>Përgjigjja: Në të dyja. Ora është e dhënë: e ndryshojmë një herë në databazë dhe të dy ekranet e lexojnë përsëri.</a:t>
+              <a:t>Votoni, krahasoni arsyetimet dhe hapni përgjigjen në versionin interaktiv.</a:t>
             </a:r>
           </a:p>
         </p:txBody>
@@ -5455,7 +5874,7 @@
     </p:spTree>
     <p:extLst>
       <p:ext uri="{BB962C8B-B14F-4D97-AF65-F5344CB8AC3E}">
-        <p14:creationId xmlns:p14="http://schemas.microsoft.com/office/powerpoint/2010/main" val="1356938526"/>
+        <p14:creationId xmlns:p14="http://schemas.microsoft.com/office/powerpoint/2010/main" val="1449631613"/>
       </p:ext>
     </p:extLst>
   </p:cSld>
@@ -5483,10 +5902,10 @@
       </p:grpSpPr>
       <p:sp>
         <p:nvSpPr>
-          <p:cNvPr id="6" name="">
-            <a:extLst xmlns:a="http://schemas.openxmlformats.org/drawingml/2006/main">
-              <a:ext uri="{FF2B5EF4-FFF2-40B4-BE49-F238E27FC236}">
-                <a16:creationId xmlns:a16="http://schemas.microsoft.com/office/drawing/2014/main" id="{66F01156-58D7-4974-B21F-5D6E08E638E0}"/>
+          <p:cNvPr id="7" name="">
+            <a:extLst xmlns:a="http://schemas.openxmlformats.org/drawingml/2006/main">
+              <a:ext uri="{FF2B5EF4-FFF2-40B4-BE49-F238E27FC236}">
+                <a16:creationId xmlns:a16="http://schemas.microsoft.com/office/drawing/2014/main" id="{23B75887-EEB9-4961-B602-CCAF47B994D7}"/>
               </a:ext>
             </a:extLst>
           </p:cNvPr>
@@ -5533,7 +5952,7 @@
                 <a:ea typeface="Arial"/>
                 <a:cs typeface="Arial"/>
               </a:rPr>
-              <a:t>VAZHDIMI</a:t>
+              <a:t>SYNIMI I JAVËS 4 · HARTA E APLIKACIONIT</a:t>
             </a:r>
           </a:p>
         </p:txBody>
@@ -5543,7 +5962,7 @@
           <p:cNvPr id="2" name="">
             <a:extLst xmlns:a="http://schemas.openxmlformats.org/drawingml/2006/main">
               <a:ext uri="{FF2B5EF4-FFF2-40B4-BE49-F238E27FC236}">
-                <a16:creationId xmlns:a16="http://schemas.microsoft.com/office/drawing/2014/main" id="{FA0D1CDD-4D61-48FE-8463-080362EFCDBF}"/>
+                <a16:creationId xmlns:a16="http://schemas.microsoft.com/office/drawing/2014/main" id="{BB3DE64C-D787-49FF-9202-F9BF145D1046}"/>
               </a:ext>
             </a:extLst>
           </p:cNvPr>
@@ -5595,24 +6014,46 @@
           </a:p>
         </p:txBody>
       </p:sp>
-      <p:sp>
-        <p:nvSpPr>
-          <p:cNvPr id="3" name="">
-            <a:extLst xmlns:a="http://schemas.openxmlformats.org/drawingml/2006/main">
-              <a:ext uri="{FF2B5EF4-FFF2-40B4-BE49-F238E27FC236}">
-                <a16:creationId xmlns:a16="http://schemas.microsoft.com/office/drawing/2014/main" id="{B93BD3CD-C46F-4328-BC48-A74BAE2FB25B}"/>
-              </a:ext>
-            </a:extLst>
-          </p:cNvPr>
-          <p:cNvSpPr>
-            <a:spLocks xmlns:a="http://schemas.openxmlformats.org/drawingml/2006/main" noGrp="1"/>
-          </p:cNvSpPr>
-          <p:nvPr/>
-        </p:nvSpPr>
-        <p:spPr>
-          <a:xfrm xmlns:a="http://schemas.openxmlformats.org/drawingml/2006/main">
-            <a:off x="609600" y="933450"/>
-            <a:ext cx="10953750" cy="952500"/>
+      <p:pic>
+        <p:nvPicPr>
+          <p:cNvPr id="9" name=""/>
+          <p:cNvPicPr>
+            <a:picLocks xmlns:a="http://schemas.openxmlformats.org/drawingml/2006/main" noChangeAspect="1"/>
+          </p:cNvPicPr>
+          <p:nvPr/>
+        </p:nvPicPr>
+        <p:blipFill>
+          <a:blip xmlns:r="http://schemas.openxmlformats.org/officeDocument/2006/relationships" xmlns:a="http://schemas.openxmlformats.org/drawingml/2006/main" r:embed="Rd383b8d15d204db9"/>
+          <a:stretch xmlns:a="http://schemas.openxmlformats.org/drawingml/2006/main"/>
+        </p:blipFill>
+        <p:spPr>
+          <a:xfrm xmlns:a="http://schemas.openxmlformats.org/drawingml/2006/main">
+            <a:off x="10287000" y="925435"/>
+            <a:ext cx="1238250" cy="244630"/>
+          </a:xfrm>
+          <a:prstGeom xmlns:a="http://schemas.openxmlformats.org/drawingml/2006/main" prst="rect">
+            <a:avLst/>
+          </a:prstGeom>
+        </p:spPr>
+      </p:pic>
+      <p:sp>
+        <p:nvSpPr>
+          <p:cNvPr id="4" name="">
+            <a:extLst xmlns:a="http://schemas.openxmlformats.org/drawingml/2006/main">
+              <a:ext uri="{FF2B5EF4-FFF2-40B4-BE49-F238E27FC236}">
+                <a16:creationId xmlns:a16="http://schemas.microsoft.com/office/drawing/2014/main" id="{DA58086E-DEF6-4C08-8185-4EBA6D44F98B}"/>
+              </a:ext>
+            </a:extLst>
+          </p:cNvPr>
+          <p:cNvSpPr>
+            <a:spLocks xmlns:a="http://schemas.openxmlformats.org/drawingml/2006/main" noGrp="1"/>
+          </p:cNvSpPr>
+          <p:nvPr/>
+        </p:nvSpPr>
+        <p:spPr>
+          <a:xfrm xmlns:a="http://schemas.openxmlformats.org/drawingml/2006/main">
+            <a:off x="609600" y="857250"/>
+            <a:ext cx="9429750" cy="714375"/>
           </a:xfrm>
           <a:prstGeom xmlns:a="http://schemas.openxmlformats.org/drawingml/2006/main" prst="rect">
             <a:avLst/>
@@ -5647,200 +6088,109 @@
                 <a:ea typeface="Arial"/>
                 <a:cs typeface="Arial"/>
               </a:rPr>
-              <a:t>Çfarë mbajmë nga Java 3</a:t>
-            </a:r>
-          </a:p>
-        </p:txBody>
-      </p:sp>
-      <p:sp>
-        <p:nvSpPr>
-          <p:cNvPr id="4" name="">
-            <a:extLst xmlns:a="http://schemas.openxmlformats.org/drawingml/2006/main">
-              <a:ext uri="{FF2B5EF4-FFF2-40B4-BE49-F238E27FC236}">
-                <a16:creationId xmlns:a16="http://schemas.microsoft.com/office/drawing/2014/main" id="{1B189C31-7981-4390-9DCD-88E20DA50359}"/>
-              </a:ext>
-            </a:extLst>
-          </p:cNvPr>
-          <p:cNvSpPr>
-            <a:spLocks xmlns:a="http://schemas.openxmlformats.org/drawingml/2006/main" noGrp="1"/>
-          </p:cNvSpPr>
-          <p:nvPr/>
-        </p:nvSpPr>
-        <p:spPr>
-          <a:xfrm xmlns:a="http://schemas.openxmlformats.org/drawingml/2006/main">
-            <a:off x="609600" y="2047875"/>
-            <a:ext cx="10953750" cy="2333625"/>
-          </a:xfrm>
-          <a:prstGeom xmlns:a="http://schemas.openxmlformats.org/drawingml/2006/main" prst="rect">
-            <a:avLst/>
-          </a:prstGeom>
-          <a:noFill xmlns:a="http://schemas.openxmlformats.org/drawingml/2006/main"/>
-          <a:ln xmlns:a="http://schemas.openxmlformats.org/drawingml/2006/main" w="0">
-            <a:noFill/>
-          </a:ln>
-        </p:spPr>
-        <p:txBody>
-          <a:bodyPr xmlns:a="http://schemas.openxmlformats.org/drawingml/2006/main">
-            <a:noAutofit/>
-          </a:bodyPr>
-          <a:lstStyle xmlns:a="http://schemas.openxmlformats.org/drawingml/2006/main"/>
-          <a:p xmlns:a="http://schemas.openxmlformats.org/drawingml/2006/main">
-            <a:pPr>
-              <a:defRPr sz="1950" b="0">
-                <a:solidFill>
-                  <a:srgbClr val="EAF1FF"/>
-                </a:solidFill>
-                <a:latin typeface="Arial"/>
-                <a:ea typeface="Arial"/>
-                <a:cs typeface="Arial"/>
-              </a:defRPr>
-            </a:pPr>
-            <a:r>
-              <a:rPr sz="1950" b="0">
-                <a:solidFill>
-                  <a:srgbClr val="EAF1FF"/>
-                </a:solidFill>
-                <a:latin typeface="Arial"/>
-                <a:ea typeface="Arial"/>
-                <a:cs typeface="Arial"/>
-              </a:rPr>
-              <a:t>Tri kartat, komponenti KartaUdhetimi dhe adresat mbeten.</a:t>
-            </a:r>
-          </a:p>
-          <a:p xmlns:a="http://schemas.openxmlformats.org/drawingml/2006/main">
-            <a:r>
-              <a:t/>
-            </a:r>
-          </a:p>
-          <a:p xmlns:a="http://schemas.openxmlformats.org/drawingml/2006/main">
-            <a:pPr>
-              <a:defRPr sz="1950" b="0">
-                <a:solidFill>
-                  <a:srgbClr val="EAF1FF"/>
-                </a:solidFill>
-                <a:latin typeface="Arial"/>
-                <a:ea typeface="Arial"/>
-                <a:cs typeface="Arial"/>
-              </a:defRPr>
-            </a:pPr>
-            <a:r>
-              <a:rPr sz="1950" b="0">
-                <a:solidFill>
-                  <a:srgbClr val="EAF1FF"/>
-                </a:solidFill>
-                <a:latin typeface="Arial"/>
-                <a:ea typeface="Arial"/>
-                <a:cs typeface="Arial"/>
-              </a:rPr>
-              <a:t>Lista → /udhetimi/2 → /udhetimi/2/kerkesa</a:t>
-            </a:r>
-          </a:p>
-          <a:p xmlns:a="http://schemas.openxmlformats.org/drawingml/2006/main">
-            <a:r>
-              <a:t/>
-            </a:r>
-          </a:p>
-          <a:p xmlns:a="http://schemas.openxmlformats.org/drawingml/2006/main">
-            <a:pPr>
-              <a:defRPr sz="1950" b="0">
-                <a:solidFill>
-                  <a:srgbClr val="EAF1FF"/>
-                </a:solidFill>
-                <a:latin typeface="Arial"/>
-                <a:ea typeface="Arial"/>
-                <a:cs typeface="Arial"/>
-              </a:defRPr>
-            </a:pPr>
-            <a:r>
-              <a:rPr sz="1950" b="0">
-                <a:solidFill>
-                  <a:srgbClr val="EAF1FF"/>
-                </a:solidFill>
-                <a:latin typeface="Arial"/>
-                <a:ea typeface="Arial"/>
-                <a:cs typeface="Arial"/>
-              </a:rPr>
-              <a:t>Ndryshon burimi: vargu në kod zëvendësohet me një pyetje te Neon.</a:t>
-            </a:r>
-          </a:p>
-        </p:txBody>
-      </p:sp>
-      <p:sp>
-        <p:nvSpPr>
-          <p:cNvPr id="5" name="">
-            <a:extLst xmlns:a="http://schemas.openxmlformats.org/drawingml/2006/main">
-              <a:ext uri="{FF2B5EF4-FFF2-40B4-BE49-F238E27FC236}">
-                <a16:creationId xmlns:a16="http://schemas.microsoft.com/office/drawing/2014/main" id="{8C3FBB15-DFCB-4274-B077-7F120E584E15}"/>
-              </a:ext>
-            </a:extLst>
-          </p:cNvPr>
-          <p:cNvSpPr>
-            <a:spLocks xmlns:a="http://schemas.openxmlformats.org/drawingml/2006/main" noGrp="1"/>
-          </p:cNvSpPr>
-          <p:nvPr/>
-        </p:nvSpPr>
-        <p:spPr>
-          <a:xfrm xmlns:a="http://schemas.openxmlformats.org/drawingml/2006/main">
-            <a:off x="609600" y="4514850"/>
-            <a:ext cx="10953750" cy="1333500"/>
-          </a:xfrm>
-          <a:prstGeom xmlns:a="http://schemas.openxmlformats.org/drawingml/2006/main" prst="rect">
-            <a:avLst/>
-          </a:prstGeom>
-          <a:noFill xmlns:a="http://schemas.openxmlformats.org/drawingml/2006/main"/>
-          <a:ln xmlns:a="http://schemas.openxmlformats.org/drawingml/2006/main" w="0">
-            <a:noFill/>
-          </a:ln>
-        </p:spPr>
-        <p:txBody>
-          <a:bodyPr xmlns:a="http://schemas.openxmlformats.org/drawingml/2006/main">
-            <a:noAutofit/>
-          </a:bodyPr>
-          <a:lstStyle xmlns:a="http://schemas.openxmlformats.org/drawingml/2006/main"/>
-          <a:p xmlns:a="http://schemas.openxmlformats.org/drawingml/2006/main">
-            <a:pPr>
-              <a:defRPr sz="1875" b="0">
-                <a:solidFill>
-                  <a:srgbClr val="8EE9D1"/>
-                </a:solidFill>
-                <a:latin typeface="Arial"/>
-                <a:ea typeface="Arial"/>
-                <a:cs typeface="Arial"/>
-              </a:defRPr>
-            </a:pPr>
-            <a:r>
-              <a:rPr sz="1875" b="0">
-                <a:solidFill>
-                  <a:srgbClr val="8EE9D1"/>
-                </a:solidFill>
-                <a:latin typeface="Arial"/>
-                <a:ea typeface="Arial"/>
-                <a:cs typeface="Arial"/>
-              </a:rPr>
-              <a:t>Java 3: udhetimet.find(...)</a:t>
-            </a:r>
-          </a:p>
-          <a:p xmlns:a="http://schemas.openxmlformats.org/drawingml/2006/main">
-            <a:pPr>
-              <a:defRPr sz="1875" b="0">
-                <a:solidFill>
-                  <a:srgbClr val="8EE9D1"/>
-                </a:solidFill>
-                <a:latin typeface="Arial"/>
-                <a:ea typeface="Arial"/>
-                <a:cs typeface="Arial"/>
-              </a:defRPr>
-            </a:pPr>
-            <a:r>
-              <a:rPr sz="1875" b="0">
-                <a:solidFill>
-                  <a:srgbClr val="8EE9D1"/>
-                </a:solidFill>
-                <a:latin typeface="Arial"/>
-                <a:ea typeface="Arial"/>
-                <a:cs typeface="Arial"/>
-              </a:rPr>
-              <a:t>Java 4: await gjejUdhetimin(id)</a:t>
+              <a:t>Sot ekranet lexojnë nga një burim</a:t>
+            </a:r>
+          </a:p>
+        </p:txBody>
+      </p:sp>
+      <p:pic>
+        <p:nvPicPr>
+          <p:cNvPr id="11" name=""/>
+          <p:cNvPicPr>
+            <a:picLocks xmlns:a="http://schemas.openxmlformats.org/drawingml/2006/main" noChangeAspect="1"/>
+          </p:cNvPicPr>
+          <p:nvPr/>
+        </p:nvPicPr>
+        <p:blipFill>
+          <a:blip xmlns:r="http://schemas.openxmlformats.org/officeDocument/2006/relationships" xmlns:a="http://schemas.openxmlformats.org/drawingml/2006/main" r:embed="Reb45c9c614ca406c"/>
+          <a:stretch xmlns:a="http://schemas.openxmlformats.org/drawingml/2006/main"/>
+        </p:blipFill>
+        <p:spPr>
+          <a:xfrm xmlns:a="http://schemas.openxmlformats.org/drawingml/2006/main">
+            <a:off x="609600" y="1770063"/>
+            <a:ext cx="10953750" cy="3651250"/>
+          </a:xfrm>
+          <a:prstGeom xmlns:a="http://schemas.openxmlformats.org/drawingml/2006/main" prst="rect">
+            <a:avLst/>
+          </a:prstGeom>
+        </p:spPr>
+      </p:pic>
+      <p:sp>
+        <p:nvSpPr>
+          <p:cNvPr id="6" name="">
+            <a:extLst xmlns:a="http://schemas.openxmlformats.org/drawingml/2006/main">
+              <a:ext uri="{FF2B5EF4-FFF2-40B4-BE49-F238E27FC236}">
+                <a16:creationId xmlns:a16="http://schemas.microsoft.com/office/drawing/2014/main" id="{D7B20F84-9940-4B3F-87B8-620EAF94325D}"/>
+              </a:ext>
+            </a:extLst>
+          </p:cNvPr>
+          <p:cNvSpPr>
+            <a:spLocks xmlns:a="http://schemas.openxmlformats.org/drawingml/2006/main" noGrp="1"/>
+          </p:cNvSpPr>
+          <p:nvPr/>
+        </p:nvSpPr>
+        <p:spPr>
+          <a:xfrm xmlns:a="http://schemas.openxmlformats.org/drawingml/2006/main">
+            <a:off x="609600" y="5667375"/>
+            <a:ext cx="10953750" cy="619125"/>
+          </a:xfrm>
+          <a:prstGeom xmlns:a="http://schemas.openxmlformats.org/drawingml/2006/main" prst="rect">
+            <a:avLst/>
+          </a:prstGeom>
+          <a:noFill xmlns:a="http://schemas.openxmlformats.org/drawingml/2006/main"/>
+          <a:ln xmlns:a="http://schemas.openxmlformats.org/drawingml/2006/main" w="0">
+            <a:noFill/>
+          </a:ln>
+        </p:spPr>
+        <p:txBody>
+          <a:bodyPr xmlns:a="http://schemas.openxmlformats.org/drawingml/2006/main">
+            <a:noAutofit/>
+          </a:bodyPr>
+          <a:lstStyle xmlns:a="http://schemas.openxmlformats.org/drawingml/2006/main"/>
+          <a:p xmlns:a="http://schemas.openxmlformats.org/drawingml/2006/main">
+            <a:pPr>
+              <a:defRPr sz="1725" b="0">
+                <a:solidFill>
+                  <a:srgbClr val="EAF1FF"/>
+                </a:solidFill>
+                <a:latin typeface="Arial"/>
+                <a:ea typeface="Arial"/>
+                <a:cs typeface="Arial"/>
+              </a:defRPr>
+            </a:pPr>
+            <a:r>
+              <a:rPr sz="1725" b="0">
+                <a:solidFill>
+                  <a:srgbClr val="EAF1FF"/>
+                </a:solidFill>
+                <a:latin typeface="Arial"/>
+                <a:ea typeface="Arial"/>
+                <a:cs typeface="Arial"/>
+              </a:rPr>
+              <a:t>Neon ruan udhëtimet. Next.js i lexon dhe ndërton listën e detajet.</a:t>
+            </a:r>
+          </a:p>
+          <a:p xmlns:a="http://schemas.openxmlformats.org/drawingml/2006/main">
+            <a:pPr>
+              <a:defRPr sz="1725" b="0">
+                <a:solidFill>
+                  <a:srgbClr val="EAF1FF"/>
+                </a:solidFill>
+                <a:latin typeface="Arial"/>
+                <a:ea typeface="Arial"/>
+                <a:cs typeface="Arial"/>
+              </a:defRPr>
+            </a:pPr>
+            <a:r>
+              <a:rPr sz="1725" b="0">
+                <a:solidFill>
+                  <a:srgbClr val="EAF1FF"/>
+                </a:solidFill>
+                <a:latin typeface="Arial"/>
+                <a:ea typeface="Arial"/>
+                <a:cs typeface="Arial"/>
+              </a:rPr>
+              <a:t>Në fund shpjegon ku ndryshon ora, kush e lexon dhe pse duhet rifreskimi.</a:t>
             </a:r>
           </a:p>
         </p:txBody>
@@ -5848,7 +6198,7 @@
     </p:spTree>
     <p:extLst>
       <p:ext uri="{BB962C8B-B14F-4D97-AF65-F5344CB8AC3E}">
-        <p14:creationId xmlns:p14="http://schemas.microsoft.com/office/powerpoint/2010/main" val="1743364757"/>
+        <p14:creationId xmlns:p14="http://schemas.microsoft.com/office/powerpoint/2010/main" val="1796133305"/>
       </p:ext>
     </p:extLst>
   </p:cSld>
@@ -5879,7 +6229,7 @@
           <p:cNvPr id="6" name="">
             <a:extLst xmlns:a="http://schemas.openxmlformats.org/drawingml/2006/main">
               <a:ext uri="{FF2B5EF4-FFF2-40B4-BE49-F238E27FC236}">
-                <a16:creationId xmlns:a16="http://schemas.microsoft.com/office/drawing/2014/main" id="{EB18CE52-E026-47F4-958D-083C8E37FCD4}"/>
+                <a16:creationId xmlns:a16="http://schemas.microsoft.com/office/drawing/2014/main" id="{4CE6A477-1283-4C79-A107-F72408E7D1F0}"/>
               </a:ext>
             </a:extLst>
           </p:cNvPr>
@@ -5936,7 +6286,7 @@
           <p:cNvPr id="2" name="">
             <a:extLst xmlns:a="http://schemas.openxmlformats.org/drawingml/2006/main">
               <a:ext uri="{FF2B5EF4-FFF2-40B4-BE49-F238E27FC236}">
-                <a16:creationId xmlns:a16="http://schemas.microsoft.com/office/drawing/2014/main" id="{A939D080-25AB-417A-81F4-91270A035F1B}"/>
+                <a16:creationId xmlns:a16="http://schemas.microsoft.com/office/drawing/2014/main" id="{9E873886-0BF9-4299-82FD-E3D81DAA1CB0}"/>
               </a:ext>
             </a:extLst>
           </p:cNvPr>
@@ -5993,7 +6343,7 @@
           <p:cNvPr id="3" name="">
             <a:extLst xmlns:a="http://schemas.openxmlformats.org/drawingml/2006/main">
               <a:ext uri="{FF2B5EF4-FFF2-40B4-BE49-F238E27FC236}">
-                <a16:creationId xmlns:a16="http://schemas.microsoft.com/office/drawing/2014/main" id="{C3945234-1D1C-4FFA-AAE1-DF05003EDADC}"/>
+                <a16:creationId xmlns:a16="http://schemas.microsoft.com/office/drawing/2014/main" id="{64462B1B-4D04-459A-9AF0-7B60050A96C2}"/>
               </a:ext>
             </a:extLst>
           </p:cNvPr>
@@ -6050,7 +6400,7 @@
           <p:cNvPr id="4" name="">
             <a:extLst xmlns:a="http://schemas.openxmlformats.org/drawingml/2006/main">
               <a:ext uri="{FF2B5EF4-FFF2-40B4-BE49-F238E27FC236}">
-                <a16:creationId xmlns:a16="http://schemas.microsoft.com/office/drawing/2014/main" id="{140C4096-128B-41D5-9FF6-06272E5437FC}"/>
+                <a16:creationId xmlns:a16="http://schemas.microsoft.com/office/drawing/2014/main" id="{6311E85F-C161-4B78-BD6D-0785F436A6E7}"/>
               </a:ext>
             </a:extLst>
           </p:cNvPr>
@@ -6163,7 +6513,7 @@
           <p:cNvPr id="5" name="">
             <a:extLst xmlns:a="http://schemas.openxmlformats.org/drawingml/2006/main">
               <a:ext uri="{FF2B5EF4-FFF2-40B4-BE49-F238E27FC236}">
-                <a16:creationId xmlns:a16="http://schemas.microsoft.com/office/drawing/2014/main" id="{DD3A7FBA-C054-4FC5-82B9-2EFADD8406EA}"/>
+                <a16:creationId xmlns:a16="http://schemas.microsoft.com/office/drawing/2014/main" id="{0EEAE42E-0F1E-42D7-91E8-887FD670C4A4}"/>
               </a:ext>
             </a:extLst>
           </p:cNvPr>
@@ -6218,7 +6568,7 @@
     </p:spTree>
     <p:extLst>
       <p:ext uri="{BB962C8B-B14F-4D97-AF65-F5344CB8AC3E}">
-        <p14:creationId xmlns:p14="http://schemas.microsoft.com/office/powerpoint/2010/main" val="2110094228"/>
+        <p14:creationId xmlns:p14="http://schemas.microsoft.com/office/powerpoint/2010/main" val="742125346"/>
       </p:ext>
     </p:extLst>
   </p:cSld>
@@ -6249,7 +6599,7 @@
           <p:cNvPr id="7" name="">
             <a:extLst xmlns:a="http://schemas.openxmlformats.org/drawingml/2006/main">
               <a:ext uri="{FF2B5EF4-FFF2-40B4-BE49-F238E27FC236}">
-                <a16:creationId xmlns:a16="http://schemas.microsoft.com/office/drawing/2014/main" id="{BD8683C2-8902-47BA-ACE1-A7F4DF9FB793}"/>
+                <a16:creationId xmlns:a16="http://schemas.microsoft.com/office/drawing/2014/main" id="{1BD99406-F1E4-4393-AFF5-4AA25DE724B2}"/>
               </a:ext>
             </a:extLst>
           </p:cNvPr>
@@ -6306,7 +6656,7 @@
           <p:cNvPr id="2" name="">
             <a:extLst xmlns:a="http://schemas.openxmlformats.org/drawingml/2006/main">
               <a:ext uri="{FF2B5EF4-FFF2-40B4-BE49-F238E27FC236}">
-                <a16:creationId xmlns:a16="http://schemas.microsoft.com/office/drawing/2014/main" id="{570140A7-D266-4DEF-9AD7-449C4DF17345}"/>
+                <a16:creationId xmlns:a16="http://schemas.microsoft.com/office/drawing/2014/main" id="{DE12073C-DC22-49ED-A389-E886A88CAF3D}"/>
               </a:ext>
             </a:extLst>
           </p:cNvPr>
@@ -6363,7 +6713,7 @@
           <p:cNvPr id="3" name="">
             <a:extLst xmlns:a="http://schemas.openxmlformats.org/drawingml/2006/main">
               <a:ext uri="{FF2B5EF4-FFF2-40B4-BE49-F238E27FC236}">
-                <a16:creationId xmlns:a16="http://schemas.microsoft.com/office/drawing/2014/main" id="{9B247B6E-779C-42E6-81CC-A7936102E516}"/>
+                <a16:creationId xmlns:a16="http://schemas.microsoft.com/office/drawing/2014/main" id="{F488C42D-B397-403A-9687-EFEE37DF659F}"/>
               </a:ext>
             </a:extLst>
           </p:cNvPr>
@@ -6836,7 +7186,7 @@
           <p:cNvPr id="5" name="">
             <a:extLst xmlns:a="http://schemas.openxmlformats.org/drawingml/2006/main">
               <a:ext uri="{FF2B5EF4-FFF2-40B4-BE49-F238E27FC236}">
-                <a16:creationId xmlns:a16="http://schemas.microsoft.com/office/drawing/2014/main" id="{21FE0A07-C5D4-41BF-BCE4-8CF2C760B212}"/>
+                <a16:creationId xmlns:a16="http://schemas.microsoft.com/office/drawing/2014/main" id="{66405DDD-D4A8-455E-BBF0-084EC78F05CE}"/>
               </a:ext>
             </a:extLst>
           </p:cNvPr>
@@ -6921,7 +7271,7 @@
           <p:cNvPr id="6" name="">
             <a:extLst xmlns:a="http://schemas.openxmlformats.org/drawingml/2006/main">
               <a:ext uri="{FF2B5EF4-FFF2-40B4-BE49-F238E27FC236}">
-                <a16:creationId xmlns:a16="http://schemas.microsoft.com/office/drawing/2014/main" id="{4FE8459D-823B-4ED6-8B14-4E274FFA8478}"/>
+                <a16:creationId xmlns:a16="http://schemas.microsoft.com/office/drawing/2014/main" id="{1823C564-0B57-4A97-85CF-63676DB7EACE}"/>
               </a:ext>
             </a:extLst>
           </p:cNvPr>
@@ -6976,7 +7326,7 @@
     </p:spTree>
     <p:extLst>
       <p:ext uri="{BB962C8B-B14F-4D97-AF65-F5344CB8AC3E}">
-        <p14:creationId xmlns:p14="http://schemas.microsoft.com/office/powerpoint/2010/main" val="567590007"/>
+        <p14:creationId xmlns:p14="http://schemas.microsoft.com/office/powerpoint/2010/main" val="1798374231"/>
       </p:ext>
     </p:extLst>
   </p:cSld>
@@ -7007,7 +7357,7 @@
           <p:cNvPr id="7" name="">
             <a:extLst xmlns:a="http://schemas.openxmlformats.org/drawingml/2006/main">
               <a:ext uri="{FF2B5EF4-FFF2-40B4-BE49-F238E27FC236}">
-                <a16:creationId xmlns:a16="http://schemas.microsoft.com/office/drawing/2014/main" id="{7A56CA47-4BF8-4159-A699-05C1124717D2}"/>
+                <a16:creationId xmlns:a16="http://schemas.microsoft.com/office/drawing/2014/main" id="{20E3C843-7704-4946-A967-04459E06E301}"/>
               </a:ext>
             </a:extLst>
           </p:cNvPr>
@@ -7064,7 +7414,7 @@
           <p:cNvPr id="2" name="">
             <a:extLst xmlns:a="http://schemas.openxmlformats.org/drawingml/2006/main">
               <a:ext uri="{FF2B5EF4-FFF2-40B4-BE49-F238E27FC236}">
-                <a16:creationId xmlns:a16="http://schemas.microsoft.com/office/drawing/2014/main" id="{AFF113A7-4918-49C3-B14D-CF3799599A47}"/>
+                <a16:creationId xmlns:a16="http://schemas.microsoft.com/office/drawing/2014/main" id="{DAB0F5E3-9D5A-4247-A0B1-EFA491627A07}"/>
               </a:ext>
             </a:extLst>
           </p:cNvPr>
@@ -7121,7 +7471,7 @@
           <p:cNvPr id="3" name="">
             <a:extLst xmlns:a="http://schemas.openxmlformats.org/drawingml/2006/main">
               <a:ext uri="{FF2B5EF4-FFF2-40B4-BE49-F238E27FC236}">
-                <a16:creationId xmlns:a16="http://schemas.microsoft.com/office/drawing/2014/main" id="{A28F80F0-BBD9-4FE6-A36B-EC9AB438C09B}"/>
+                <a16:creationId xmlns:a16="http://schemas.microsoft.com/office/drawing/2014/main" id="{BE44538D-224D-4F91-B434-B655ADE22C36}"/>
               </a:ext>
             </a:extLst>
           </p:cNvPr>
@@ -7178,7 +7528,7 @@
           <p:cNvPr id="4" name="">
             <a:extLst xmlns:a="http://schemas.openxmlformats.org/drawingml/2006/main">
               <a:ext uri="{FF2B5EF4-FFF2-40B4-BE49-F238E27FC236}">
-                <a16:creationId xmlns:a16="http://schemas.microsoft.com/office/drawing/2014/main" id="{3F6B693C-CBD9-4B86-8426-0970F20BE0EE}"/>
+                <a16:creationId xmlns:a16="http://schemas.microsoft.com/office/drawing/2014/main" id="{18AABB9E-CBF9-4E22-B8F8-7A9BC6F5CCFB}"/>
               </a:ext>
             </a:extLst>
           </p:cNvPr>
@@ -7319,7 +7669,7 @@
           <p:cNvPr id="5" name="">
             <a:extLst xmlns:a="http://schemas.openxmlformats.org/drawingml/2006/main">
               <a:ext uri="{FF2B5EF4-FFF2-40B4-BE49-F238E27FC236}">
-                <a16:creationId xmlns:a16="http://schemas.microsoft.com/office/drawing/2014/main" id="{A1446670-385B-46FC-B2FD-D5B75FED6128}"/>
+                <a16:creationId xmlns:a16="http://schemas.microsoft.com/office/drawing/2014/main" id="{4F50200C-CBC7-47E4-8788-7458E7A9034B}"/>
               </a:ext>
             </a:extLst>
           </p:cNvPr>
@@ -7422,7 +7772,7 @@
           <p:cNvPr id="6" name="">
             <a:extLst xmlns:a="http://schemas.openxmlformats.org/drawingml/2006/main">
               <a:ext uri="{FF2B5EF4-FFF2-40B4-BE49-F238E27FC236}">
-                <a16:creationId xmlns:a16="http://schemas.microsoft.com/office/drawing/2014/main" id="{D74E583E-9E43-47C4-8958-530DF5A2CB43}"/>
+                <a16:creationId xmlns:a16="http://schemas.microsoft.com/office/drawing/2014/main" id="{5D0612AE-D0E8-4EFD-89A1-EC49DFFF4EB3}"/>
               </a:ext>
             </a:extLst>
           </p:cNvPr>
@@ -7477,7 +7827,7 @@
     </p:spTree>
     <p:extLst>
       <p:ext uri="{BB962C8B-B14F-4D97-AF65-F5344CB8AC3E}">
-        <p14:creationId xmlns:p14="http://schemas.microsoft.com/office/powerpoint/2010/main" val="1229558058"/>
+        <p14:creationId xmlns:p14="http://schemas.microsoft.com/office/powerpoint/2010/main" val="739383253"/>
       </p:ext>
     </p:extLst>
   </p:cSld>
@@ -7508,7 +7858,7 @@
           <p:cNvPr id="6" name="">
             <a:extLst xmlns:a="http://schemas.openxmlformats.org/drawingml/2006/main">
               <a:ext uri="{FF2B5EF4-FFF2-40B4-BE49-F238E27FC236}">
-                <a16:creationId xmlns:a16="http://schemas.microsoft.com/office/drawing/2014/main" id="{CBD13E73-9223-4268-AD0E-95C02E1810A0}"/>
+                <a16:creationId xmlns:a16="http://schemas.microsoft.com/office/drawing/2014/main" id="{36419DED-9C56-4851-9EDE-7A8EB43C1DA4}"/>
               </a:ext>
             </a:extLst>
           </p:cNvPr>
@@ -7565,7 +7915,7 @@
           <p:cNvPr id="2" name="">
             <a:extLst xmlns:a="http://schemas.openxmlformats.org/drawingml/2006/main">
               <a:ext uri="{FF2B5EF4-FFF2-40B4-BE49-F238E27FC236}">
-                <a16:creationId xmlns:a16="http://schemas.microsoft.com/office/drawing/2014/main" id="{B99D2ED9-18A5-4D9E-9C03-AE53A5F64B08}"/>
+                <a16:creationId xmlns:a16="http://schemas.microsoft.com/office/drawing/2014/main" id="{D7DD5365-932A-4086-BD8C-899B72E34E6E}"/>
               </a:ext>
             </a:extLst>
           </p:cNvPr>
@@ -7622,7 +7972,7 @@
           <p:cNvPr id="3" name="">
             <a:extLst xmlns:a="http://schemas.openxmlformats.org/drawingml/2006/main">
               <a:ext uri="{FF2B5EF4-FFF2-40B4-BE49-F238E27FC236}">
-                <a16:creationId xmlns:a16="http://schemas.microsoft.com/office/drawing/2014/main" id="{B80E32FC-CB54-43EE-901C-ADD7C44B1BD9}"/>
+                <a16:creationId xmlns:a16="http://schemas.microsoft.com/office/drawing/2014/main" id="{38E56D23-0A34-4A3B-A85B-F09575E5D066}"/>
               </a:ext>
             </a:extLst>
           </p:cNvPr>
@@ -7679,7 +8029,7 @@
           <p:cNvPr id="4" name="">
             <a:extLst xmlns:a="http://schemas.openxmlformats.org/drawingml/2006/main">
               <a:ext uri="{FF2B5EF4-FFF2-40B4-BE49-F238E27FC236}">
-                <a16:creationId xmlns:a16="http://schemas.microsoft.com/office/drawing/2014/main" id="{DDB79063-9754-4CF6-8F7D-58E7BF13A463}"/>
+                <a16:creationId xmlns:a16="http://schemas.microsoft.com/office/drawing/2014/main" id="{AE7978BB-7C26-4387-B589-27C27A130A34}"/>
               </a:ext>
             </a:extLst>
           </p:cNvPr>
@@ -7792,7 +8142,7 @@
           <p:cNvPr id="5" name="">
             <a:extLst xmlns:a="http://schemas.openxmlformats.org/drawingml/2006/main">
               <a:ext uri="{FF2B5EF4-FFF2-40B4-BE49-F238E27FC236}">
-                <a16:creationId xmlns:a16="http://schemas.microsoft.com/office/drawing/2014/main" id="{6CB3C2C4-D83F-4E9C-86F1-40430A48D470}"/>
+                <a16:creationId xmlns:a16="http://schemas.microsoft.com/office/drawing/2014/main" id="{F87EBD07-616D-475B-9608-CCD99BD38512}"/>
               </a:ext>
             </a:extLst>
           </p:cNvPr>
@@ -7893,7 +8243,7 @@
     </p:spTree>
     <p:extLst>
       <p:ext uri="{BB962C8B-B14F-4D97-AF65-F5344CB8AC3E}">
-        <p14:creationId xmlns:p14="http://schemas.microsoft.com/office/powerpoint/2010/main" val="334347254"/>
+        <p14:creationId xmlns:p14="http://schemas.microsoft.com/office/powerpoint/2010/main" val="368498341"/>
       </p:ext>
     </p:extLst>
   </p:cSld>
@@ -7924,7 +8274,7 @@
           <p:cNvPr id="7" name="">
             <a:extLst xmlns:a="http://schemas.openxmlformats.org/drawingml/2006/main">
               <a:ext uri="{FF2B5EF4-FFF2-40B4-BE49-F238E27FC236}">
-                <a16:creationId xmlns:a16="http://schemas.microsoft.com/office/drawing/2014/main" id="{E7B8D03E-5FA7-4859-BB2C-E4DE01B83D7A}"/>
+                <a16:creationId xmlns:a16="http://schemas.microsoft.com/office/drawing/2014/main" id="{0A120F4D-40AE-4F5C-9E06-4EC59E8B74E4}"/>
               </a:ext>
             </a:extLst>
           </p:cNvPr>
@@ -7981,7 +8331,7 @@
           <p:cNvPr id="2" name="">
             <a:extLst xmlns:a="http://schemas.openxmlformats.org/drawingml/2006/main">
               <a:ext uri="{FF2B5EF4-FFF2-40B4-BE49-F238E27FC236}">
-                <a16:creationId xmlns:a16="http://schemas.microsoft.com/office/drawing/2014/main" id="{C91AE3DA-02A1-41CF-8C1A-236F28F43D48}"/>
+                <a16:creationId xmlns:a16="http://schemas.microsoft.com/office/drawing/2014/main" id="{131B96FE-F32E-43AE-9E20-C5D413C6E80D}"/>
               </a:ext>
             </a:extLst>
           </p:cNvPr>
@@ -8038,7 +8388,7 @@
           <p:cNvPr id="3" name="">
             <a:extLst xmlns:a="http://schemas.openxmlformats.org/drawingml/2006/main">
               <a:ext uri="{FF2B5EF4-FFF2-40B4-BE49-F238E27FC236}">
-                <a16:creationId xmlns:a16="http://schemas.microsoft.com/office/drawing/2014/main" id="{22B15E07-C8D2-42AA-AE3F-A040AD7F0E37}"/>
+                <a16:creationId xmlns:a16="http://schemas.microsoft.com/office/drawing/2014/main" id="{1DC6F4C8-F087-4FEA-BF1C-88881C88ED07}"/>
               </a:ext>
             </a:extLst>
           </p:cNvPr>
@@ -8095,7 +8445,7 @@
           <p:cNvPr id="4" name="">
             <a:extLst xmlns:a="http://schemas.openxmlformats.org/drawingml/2006/main">
               <a:ext uri="{FF2B5EF4-FFF2-40B4-BE49-F238E27FC236}">
-                <a16:creationId xmlns:a16="http://schemas.microsoft.com/office/drawing/2014/main" id="{A52A84F4-5C18-4E4A-A818-52F4F00D354A}"/>
+                <a16:creationId xmlns:a16="http://schemas.microsoft.com/office/drawing/2014/main" id="{46336534-0080-4942-8AD6-1D84AD622E44}"/>
               </a:ext>
             </a:extLst>
           </p:cNvPr>
@@ -8180,7 +8530,7 @@
           <p:cNvPr id="5" name="">
             <a:extLst xmlns:a="http://schemas.openxmlformats.org/drawingml/2006/main">
               <a:ext uri="{FF2B5EF4-FFF2-40B4-BE49-F238E27FC236}">
-                <a16:creationId xmlns:a16="http://schemas.microsoft.com/office/drawing/2014/main" id="{EFC5C609-B701-46A9-AC82-ECCFED5C0B33}"/>
+                <a16:creationId xmlns:a16="http://schemas.microsoft.com/office/drawing/2014/main" id="{C532EC24-981D-48A6-89C8-B2583ED40C20}"/>
               </a:ext>
             </a:extLst>
           </p:cNvPr>
@@ -8283,7 +8633,7 @@
           <p:cNvPr id="6" name="">
             <a:extLst xmlns:a="http://schemas.openxmlformats.org/drawingml/2006/main">
               <a:ext uri="{FF2B5EF4-FFF2-40B4-BE49-F238E27FC236}">
-                <a16:creationId xmlns:a16="http://schemas.microsoft.com/office/drawing/2014/main" id="{398744DC-4521-4AB8-B79E-1E647749D198}"/>
+                <a16:creationId xmlns:a16="http://schemas.microsoft.com/office/drawing/2014/main" id="{D6A3CD4F-EEFE-4FEC-8F53-D1571D1487D2}"/>
               </a:ext>
             </a:extLst>
           </p:cNvPr>
@@ -8338,7 +8688,7 @@
     </p:spTree>
     <p:extLst>
       <p:ext uri="{BB962C8B-B14F-4D97-AF65-F5344CB8AC3E}">
-        <p14:creationId xmlns:p14="http://schemas.microsoft.com/office/powerpoint/2010/main" val="1781508192"/>
+        <p14:creationId xmlns:p14="http://schemas.microsoft.com/office/powerpoint/2010/main" val="1103593455"/>
       </p:ext>
     </p:extLst>
   </p:cSld>
@@ -8369,7 +8719,7 @@
           <p:cNvPr id="7" name="">
             <a:extLst xmlns:a="http://schemas.openxmlformats.org/drawingml/2006/main">
               <a:ext uri="{FF2B5EF4-FFF2-40B4-BE49-F238E27FC236}">
-                <a16:creationId xmlns:a16="http://schemas.microsoft.com/office/drawing/2014/main" id="{4562F9B2-F638-4E76-A483-33E66FD6245E}"/>
+                <a16:creationId xmlns:a16="http://schemas.microsoft.com/office/drawing/2014/main" id="{15FF2CC6-A333-4475-AB5A-C74306626ED1}"/>
               </a:ext>
             </a:extLst>
           </p:cNvPr>
@@ -8426,7 +8776,7 @@
           <p:cNvPr id="2" name="">
             <a:extLst xmlns:a="http://schemas.openxmlformats.org/drawingml/2006/main">
               <a:ext uri="{FF2B5EF4-FFF2-40B4-BE49-F238E27FC236}">
-                <a16:creationId xmlns:a16="http://schemas.microsoft.com/office/drawing/2014/main" id="{FEF2B515-5173-4B85-86AD-E8B4BADF0F91}"/>
+                <a16:creationId xmlns:a16="http://schemas.microsoft.com/office/drawing/2014/main" id="{75605991-0394-4319-9749-131A2FB2919B}"/>
               </a:ext>
             </a:extLst>
           </p:cNvPr>
@@ -8483,7 +8833,7 @@
           <p:cNvPr id="3" name="">
             <a:extLst xmlns:a="http://schemas.openxmlformats.org/drawingml/2006/main">
               <a:ext uri="{FF2B5EF4-FFF2-40B4-BE49-F238E27FC236}">
-                <a16:creationId xmlns:a16="http://schemas.microsoft.com/office/drawing/2014/main" id="{AA868AC3-9493-4B5A-8AF2-91D404C2C0E9}"/>
+                <a16:creationId xmlns:a16="http://schemas.microsoft.com/office/drawing/2014/main" id="{FF763B87-3461-407F-BB13-00B55330861B}"/>
               </a:ext>
             </a:extLst>
           </p:cNvPr>
@@ -8544,7 +8894,7 @@
           <p:nvPr/>
         </p:nvPicPr>
         <p:blipFill>
-          <a:blip xmlns:r="http://schemas.openxmlformats.org/officeDocument/2006/relationships" xmlns:a="http://schemas.openxmlformats.org/drawingml/2006/main" r:embed="R02daadb73a384a44"/>
+          <a:blip xmlns:r="http://schemas.openxmlformats.org/officeDocument/2006/relationships" xmlns:a="http://schemas.openxmlformats.org/drawingml/2006/main" r:embed="Rd127ba89976c4fab"/>
           <a:stretch xmlns:a="http://schemas.openxmlformats.org/drawingml/2006/main"/>
         </p:blipFill>
         <p:spPr>
@@ -8562,7 +8912,7 @@
           <p:cNvPr id="5" name="">
             <a:extLst xmlns:a="http://schemas.openxmlformats.org/drawingml/2006/main">
               <a:ext uri="{FF2B5EF4-FFF2-40B4-BE49-F238E27FC236}">
-                <a16:creationId xmlns:a16="http://schemas.microsoft.com/office/drawing/2014/main" id="{AAB277D1-7128-40FD-8839-9145F9ACDFFE}"/>
+                <a16:creationId xmlns:a16="http://schemas.microsoft.com/office/drawing/2014/main" id="{01D9EA02-E24F-414B-B9FE-67DE9307EE20}"/>
               </a:ext>
             </a:extLst>
           </p:cNvPr>
@@ -8619,7 +8969,7 @@
           <p:cNvPr id="6" name="">
             <a:extLst xmlns:a="http://schemas.openxmlformats.org/drawingml/2006/main">
               <a:ext uri="{FF2B5EF4-FFF2-40B4-BE49-F238E27FC236}">
-                <a16:creationId xmlns:a16="http://schemas.microsoft.com/office/drawing/2014/main" id="{A3F2BD95-23F8-45E7-98C1-FD3ABA86E899}"/>
+                <a16:creationId xmlns:a16="http://schemas.microsoft.com/office/drawing/2014/main" id="{FE55AEC7-7265-4AA6-AFD2-ABC66D58EEDC}"/>
               </a:ext>
             </a:extLst>
           </p:cNvPr>
@@ -8674,7 +9024,7 @@
     </p:spTree>
     <p:extLst>
       <p:ext uri="{BB962C8B-B14F-4D97-AF65-F5344CB8AC3E}">
-        <p14:creationId xmlns:p14="http://schemas.microsoft.com/office/powerpoint/2010/main" val="1255033957"/>
+        <p14:creationId xmlns:p14="http://schemas.microsoft.com/office/powerpoint/2010/main" val="1290065969"/>
       </p:ext>
     </p:extLst>
   </p:cSld>

</xml_diff>

<commit_message>
Open week 4 with prediction, recall and pair activities (#44)
</commit_message>
<xml_diff>
--- a/lendet/2026-2027/mobile/lectures/ligjerata-04-neon-postgresql-rideshare-2026.pptx
+++ b/lendet/2026-2027/mobile/lectures/ligjerata-04-neon-postgresql-rideshare-2026.pptx
@@ -2,28 +2,28 @@
 <file path=ppt/presentation.xml><?xml version="1.0" encoding="utf-8"?>
 <p:presentation xmlns:p="http://schemas.openxmlformats.org/presentationml/2006/main">
   <p:sldMasterIdLst>
-    <p:sldMasterId xmlns:r="http://schemas.openxmlformats.org/officeDocument/2006/relationships" id="2147483648" r:id="R32c6a9eb752d418c"/>
+    <p:sldMasterId xmlns:r="http://schemas.openxmlformats.org/officeDocument/2006/relationships" id="2147483648" r:id="Rfbc03226f6eb4e4e"/>
   </p:sldMasterIdLst>
   <p:sldIdLst>
-    <p:sldId xmlns:r="http://schemas.openxmlformats.org/officeDocument/2006/relationships" id="256" r:id="Ra876a60a489f4bc9"/>
-    <p:sldId xmlns:r="http://schemas.openxmlformats.org/officeDocument/2006/relationships" id="257" r:id="R225528af12c04fbc"/>
-    <p:sldId xmlns:r="http://schemas.openxmlformats.org/officeDocument/2006/relationships" id="258" r:id="Rb9528da0e9694116"/>
-    <p:sldId xmlns:r="http://schemas.openxmlformats.org/officeDocument/2006/relationships" id="259" r:id="Re8aca3b46b15401f"/>
-    <p:sldId xmlns:r="http://schemas.openxmlformats.org/officeDocument/2006/relationships" id="260" r:id="R2bd05c2b2ee94015"/>
-    <p:sldId xmlns:r="http://schemas.openxmlformats.org/officeDocument/2006/relationships" id="261" r:id="Rf11bb080a3254ff9"/>
-    <p:sldId xmlns:r="http://schemas.openxmlformats.org/officeDocument/2006/relationships" id="262" r:id="Rf4ebb075ec0b41a3"/>
-    <p:sldId xmlns:r="http://schemas.openxmlformats.org/officeDocument/2006/relationships" id="263" r:id="Rc0be5e9fa4d24ca2"/>
-    <p:sldId xmlns:r="http://schemas.openxmlformats.org/officeDocument/2006/relationships" id="264" r:id="Raa28d02aa4bf4d1b"/>
-    <p:sldId xmlns:r="http://schemas.openxmlformats.org/officeDocument/2006/relationships" id="265" r:id="Rf6dd8d9e2c2c4017"/>
-    <p:sldId xmlns:r="http://schemas.openxmlformats.org/officeDocument/2006/relationships" id="266" r:id="R5a01840c332146a0"/>
-    <p:sldId xmlns:r="http://schemas.openxmlformats.org/officeDocument/2006/relationships" id="267" r:id="R77137f03398e4e14"/>
-    <p:sldId xmlns:r="http://schemas.openxmlformats.org/officeDocument/2006/relationships" id="268" r:id="Rdea3d882bc2445f3"/>
-    <p:sldId xmlns:r="http://schemas.openxmlformats.org/officeDocument/2006/relationships" id="269" r:id="R3d965ea79fbe4b45"/>
-    <p:sldId xmlns:r="http://schemas.openxmlformats.org/officeDocument/2006/relationships" id="270" r:id="R67d24730111e4ccc"/>
-    <p:sldId xmlns:r="http://schemas.openxmlformats.org/officeDocument/2006/relationships" id="271" r:id="R4c82b1a80aef41eb"/>
-    <p:sldId xmlns:r="http://schemas.openxmlformats.org/officeDocument/2006/relationships" id="272" r:id="R0bd03a94435e4390"/>
-    <p:sldId xmlns:r="http://schemas.openxmlformats.org/officeDocument/2006/relationships" id="273" r:id="Ra87217fc09a54fdb"/>
-    <p:sldId xmlns:r="http://schemas.openxmlformats.org/officeDocument/2006/relationships" id="274" r:id="R8708fb9bb89f445c"/>
+    <p:sldId xmlns:r="http://schemas.openxmlformats.org/officeDocument/2006/relationships" id="256" r:id="R3b6dfc7129344470"/>
+    <p:sldId xmlns:r="http://schemas.openxmlformats.org/officeDocument/2006/relationships" id="257" r:id="R70386f0001524a25"/>
+    <p:sldId xmlns:r="http://schemas.openxmlformats.org/officeDocument/2006/relationships" id="258" r:id="Rf378e82c3b73438e"/>
+    <p:sldId xmlns:r="http://schemas.openxmlformats.org/officeDocument/2006/relationships" id="259" r:id="Rb2b16735c67144d6"/>
+    <p:sldId xmlns:r="http://schemas.openxmlformats.org/officeDocument/2006/relationships" id="260" r:id="R5d0c67ab1bd14563"/>
+    <p:sldId xmlns:r="http://schemas.openxmlformats.org/officeDocument/2006/relationships" id="261" r:id="R468ffb7a7c1341ae"/>
+    <p:sldId xmlns:r="http://schemas.openxmlformats.org/officeDocument/2006/relationships" id="262" r:id="R3cdbab9ff8654143"/>
+    <p:sldId xmlns:r="http://schemas.openxmlformats.org/officeDocument/2006/relationships" id="263" r:id="Rffe5a0e75bef4dfb"/>
+    <p:sldId xmlns:r="http://schemas.openxmlformats.org/officeDocument/2006/relationships" id="264" r:id="R2fe99c39a0004de8"/>
+    <p:sldId xmlns:r="http://schemas.openxmlformats.org/officeDocument/2006/relationships" id="265" r:id="R7a4b041bce5e43a4"/>
+    <p:sldId xmlns:r="http://schemas.openxmlformats.org/officeDocument/2006/relationships" id="266" r:id="R853c7a729f9046e5"/>
+    <p:sldId xmlns:r="http://schemas.openxmlformats.org/officeDocument/2006/relationships" id="267" r:id="R33ab35c420c14286"/>
+    <p:sldId xmlns:r="http://schemas.openxmlformats.org/officeDocument/2006/relationships" id="268" r:id="Re2b64fe008e549f2"/>
+    <p:sldId xmlns:r="http://schemas.openxmlformats.org/officeDocument/2006/relationships" id="269" r:id="R3c4d5f459a6c4e28"/>
+    <p:sldId xmlns:r="http://schemas.openxmlformats.org/officeDocument/2006/relationships" id="270" r:id="R1a5f24de1e6049ef"/>
+    <p:sldId xmlns:r="http://schemas.openxmlformats.org/officeDocument/2006/relationships" id="271" r:id="R83672bba7da3427a"/>
+    <p:sldId xmlns:r="http://schemas.openxmlformats.org/officeDocument/2006/relationships" id="272" r:id="R80aadb8499344884"/>
+    <p:sldId xmlns:r="http://schemas.openxmlformats.org/officeDocument/2006/relationships" id="273" r:id="R120a5256b4fa4932"/>
+    <p:sldId xmlns:r="http://schemas.openxmlformats.org/officeDocument/2006/relationships" id="274" r:id="R916db68a60a9448e"/>
   </p:sldIdLst>
   <p:sldSz cx="12192000" cy="6858000"/>
   <p:notesSz cx="6858000" cy="9144000"/>
@@ -68,7 +68,7 @@
   </p:cSld>
   <p:clrMap bg1="lt1" tx1="dk1" bg2="lt2" tx2="dk2" accent1="accent1" accent2="accent2" accent3="accent3" accent4="accent4" accent5="accent5" accent6="accent6" hlink="hlink" folHlink="folHlink"/>
   <p:sldLayoutIdLst>
-    <p:sldLayoutId xmlns:r="http://schemas.openxmlformats.org/officeDocument/2006/relationships" id="2147483649" r:id="Ra7786729b4264688"/>
+    <p:sldLayoutId xmlns:r="http://schemas.openxmlformats.org/officeDocument/2006/relationships" id="2147483649" r:id="Rfa954cd63d044e00"/>
   </p:sldLayoutIdLst>
   <p:txStyles>
     <p:titleStyle>
@@ -616,10 +616,10 @@
       </p:grpSpPr>
       <p:sp>
         <p:nvSpPr>
-          <p:cNvPr id="7" name="">
-            <a:extLst xmlns:a="http://schemas.openxmlformats.org/drawingml/2006/main">
-              <a:ext uri="{FF2B5EF4-FFF2-40B4-BE49-F238E27FC236}">
-                <a16:creationId xmlns:a16="http://schemas.microsoft.com/office/drawing/2014/main" id="{E4444AD0-3908-485E-8C65-76827F43EC53}"/>
+          <p:cNvPr id="9" name="">
+            <a:extLst xmlns:a="http://schemas.openxmlformats.org/drawingml/2006/main">
+              <a:ext uri="{FF2B5EF4-FFF2-40B4-BE49-F238E27FC236}">
+                <a16:creationId xmlns:a16="http://schemas.microsoft.com/office/drawing/2014/main" id="{0EE494C5-12F5-46D4-8B4F-085A908AC1DE}"/>
               </a:ext>
             </a:extLst>
           </p:cNvPr>
@@ -666,7 +666,7 @@
                 <a:ea typeface="Arial"/>
                 <a:cs typeface="Arial"/>
               </a:rPr>
-              <a:t>JAVA 4 · 08.10.2026</a:t>
+              <a:t>JAVA 4 · 08.10.2026 · SFIDA E HAPJES · 0–2 MIN</a:t>
             </a:r>
           </a:p>
         </p:txBody>
@@ -676,7 +676,7 @@
           <p:cNvPr id="2" name="">
             <a:extLst xmlns:a="http://schemas.openxmlformats.org/drawingml/2006/main">
               <a:ext uri="{FF2B5EF4-FFF2-40B4-BE49-F238E27FC236}">
-                <a16:creationId xmlns:a16="http://schemas.microsoft.com/office/drawing/2014/main" id="{8FE48659-1822-4FBB-AC30-6EA0B984A49E}"/>
+                <a16:creationId xmlns:a16="http://schemas.microsoft.com/office/drawing/2014/main" id="{5CD53E60-A67C-4263-B6DF-B52C70E98A9E}"/>
               </a:ext>
             </a:extLst>
           </p:cNvPr>
@@ -724,85 +724,6 @@
                 <a:cs typeface="Arial"/>
               </a:rPr>
               <a:t>01 / 19</a:t>
-            </a:r>
-          </a:p>
-        </p:txBody>
-      </p:sp>
-      <p:pic>
-        <p:nvPicPr>
-          <p:cNvPr id="9" name=""/>
-          <p:cNvPicPr>
-            <a:picLocks xmlns:a="http://schemas.openxmlformats.org/drawingml/2006/main" noChangeAspect="1"/>
-          </p:cNvPicPr>
-          <p:nvPr/>
-        </p:nvPicPr>
-        <p:blipFill>
-          <a:blip xmlns:r="http://schemas.openxmlformats.org/officeDocument/2006/relationships" xmlns:a="http://schemas.openxmlformats.org/drawingml/2006/main" r:embed="R7b9fbe3177c94231"/>
-          <a:stretch xmlns:a="http://schemas.openxmlformats.org/drawingml/2006/main"/>
-        </p:blipFill>
-        <p:spPr>
-          <a:xfrm xmlns:a="http://schemas.openxmlformats.org/drawingml/2006/main">
-            <a:off x="10287000" y="925435"/>
-            <a:ext cx="1238250" cy="244630"/>
-          </a:xfrm>
-          <a:prstGeom xmlns:a="http://schemas.openxmlformats.org/drawingml/2006/main" prst="rect">
-            <a:avLst/>
-          </a:prstGeom>
-        </p:spPr>
-      </p:pic>
-      <p:sp>
-        <p:nvSpPr>
-          <p:cNvPr id="4" name="">
-            <a:extLst xmlns:a="http://schemas.openxmlformats.org/drawingml/2006/main">
-              <a:ext uri="{FF2B5EF4-FFF2-40B4-BE49-F238E27FC236}">
-                <a16:creationId xmlns:a16="http://schemas.microsoft.com/office/drawing/2014/main" id="{6CB606FB-A592-4FEC-9B03-B98CDF1CEAB6}"/>
-              </a:ext>
-            </a:extLst>
-          </p:cNvPr>
-          <p:cNvSpPr>
-            <a:spLocks xmlns:a="http://schemas.openxmlformats.org/drawingml/2006/main" noGrp="1"/>
-          </p:cNvSpPr>
-          <p:nvPr/>
-        </p:nvSpPr>
-        <p:spPr>
-          <a:xfrm xmlns:a="http://schemas.openxmlformats.org/drawingml/2006/main">
-            <a:off x="609600" y="857250"/>
-            <a:ext cx="9429750" cy="714375"/>
-          </a:xfrm>
-          <a:prstGeom xmlns:a="http://schemas.openxmlformats.org/drawingml/2006/main" prst="rect">
-            <a:avLst/>
-          </a:prstGeom>
-          <a:noFill xmlns:a="http://schemas.openxmlformats.org/drawingml/2006/main"/>
-          <a:ln xmlns:a="http://schemas.openxmlformats.org/drawingml/2006/main" w="0">
-            <a:noFill/>
-          </a:ln>
-        </p:spPr>
-        <p:txBody>
-          <a:bodyPr xmlns:a="http://schemas.openxmlformats.org/drawingml/2006/main">
-            <a:noAutofit/>
-          </a:bodyPr>
-          <a:lstStyle xmlns:a="http://schemas.openxmlformats.org/drawingml/2006/main"/>
-          <a:p xmlns:a="http://schemas.openxmlformats.org/drawingml/2006/main">
-            <a:pPr>
-              <a:defRPr sz="3300" b="1">
-                <a:solidFill>
-                  <a:srgbClr val="FFFFFF"/>
-                </a:solidFill>
-                <a:latin typeface="Arial"/>
-                <a:ea typeface="Arial"/>
-                <a:cs typeface="Arial"/>
-              </a:defRPr>
-            </a:pPr>
-            <a:r>
-              <a:rPr sz="3300" b="1">
-                <a:solidFill>
-                  <a:srgbClr val="FFFFFF"/>
-                </a:solidFill>
-                <a:latin typeface="Arial"/>
-                <a:ea typeface="Arial"/>
-                <a:cs typeface="Arial"/>
-              </a:rPr>
-              <a:t>Si komunikon RideShare me databazën</a:t>
             </a:r>
           </a:p>
         </p:txBody>
@@ -816,13 +737,13 @@
           <p:nvPr/>
         </p:nvPicPr>
         <p:blipFill>
-          <a:blip xmlns:r="http://schemas.openxmlformats.org/officeDocument/2006/relationships" xmlns:a="http://schemas.openxmlformats.org/drawingml/2006/main" r:embed="Rcb89d66de114409e"/>
+          <a:blip xmlns:r="http://schemas.openxmlformats.org/officeDocument/2006/relationships" xmlns:a="http://schemas.openxmlformats.org/drawingml/2006/main" r:embed="R1b3363b6b5ee438d"/>
           <a:stretch xmlns:a="http://schemas.openxmlformats.org/drawingml/2006/main"/>
         </p:blipFill>
         <p:spPr>
           <a:xfrm xmlns:a="http://schemas.openxmlformats.org/drawingml/2006/main">
-            <a:off x="609600" y="1770063"/>
-            <a:ext cx="10953750" cy="3651250"/>
+            <a:off x="10287000" y="925435"/>
+            <a:ext cx="1238250" cy="244630"/>
           </a:xfrm>
           <a:prstGeom xmlns:a="http://schemas.openxmlformats.org/drawingml/2006/main" prst="rect">
             <a:avLst/>
@@ -831,80 +752,369 @@
       </p:pic>
       <p:sp>
         <p:nvSpPr>
+          <p:cNvPr id="4" name="">
+            <a:extLst xmlns:a="http://schemas.openxmlformats.org/drawingml/2006/main">
+              <a:ext uri="{FF2B5EF4-FFF2-40B4-BE49-F238E27FC236}">
+                <a16:creationId xmlns:a16="http://schemas.microsoft.com/office/drawing/2014/main" id="{6325C784-1B51-44A3-9171-E7C8D0045ABB}"/>
+              </a:ext>
+            </a:extLst>
+          </p:cNvPr>
+          <p:cNvSpPr>
+            <a:spLocks xmlns:a="http://schemas.openxmlformats.org/drawingml/2006/main" noGrp="1"/>
+          </p:cNvSpPr>
+          <p:nvPr/>
+        </p:nvSpPr>
+        <p:spPr>
+          <a:xfrm xmlns:a="http://schemas.openxmlformats.org/drawingml/2006/main">
+            <a:off x="609600" y="933450"/>
+            <a:ext cx="9429750" cy="952500"/>
+          </a:xfrm>
+          <a:prstGeom xmlns:a="http://schemas.openxmlformats.org/drawingml/2006/main" prst="rect">
+            <a:avLst/>
+          </a:prstGeom>
+          <a:noFill xmlns:a="http://schemas.openxmlformats.org/drawingml/2006/main"/>
+          <a:ln xmlns:a="http://schemas.openxmlformats.org/drawingml/2006/main" w="0">
+            <a:noFill/>
+          </a:ln>
+        </p:spPr>
+        <p:txBody>
+          <a:bodyPr xmlns:a="http://schemas.openxmlformats.org/drawingml/2006/main">
+            <a:noAutofit/>
+          </a:bodyPr>
+          <a:lstStyle xmlns:a="http://schemas.openxmlformats.org/drawingml/2006/main"/>
+          <a:p xmlns:a="http://schemas.openxmlformats.org/drawingml/2006/main">
+            <a:pPr>
+              <a:defRPr sz="3300" b="1">
+                <a:solidFill>
+                  <a:srgbClr val="FFFFFF"/>
+                </a:solidFill>
+                <a:latin typeface="Arial"/>
+                <a:ea typeface="Arial"/>
+                <a:cs typeface="Arial"/>
+              </a:defRPr>
+            </a:pPr>
+            <a:r>
+              <a:rPr sz="3300" b="1">
+                <a:solidFill>
+                  <a:srgbClr val="FFFFFF"/>
+                </a:solidFill>
+                <a:latin typeface="Arial"/>
+                <a:ea typeface="Arial"/>
+                <a:cs typeface="Arial"/>
+              </a:rPr>
+              <a:t>Nisja për në AAB ndryshoi. Po aplikacioni?</a:t>
+            </a:r>
+          </a:p>
+        </p:txBody>
+      </p:sp>
+      <p:sp>
+        <p:nvSpPr>
+          <p:cNvPr id="5" name="">
+            <a:extLst xmlns:a="http://schemas.openxmlformats.org/drawingml/2006/main">
+              <a:ext uri="{FF2B5EF4-FFF2-40B4-BE49-F238E27FC236}">
+                <a16:creationId xmlns:a16="http://schemas.microsoft.com/office/drawing/2014/main" id="{E39B07FB-7C08-49DA-993A-71DF6A0BD5B1}"/>
+              </a:ext>
+            </a:extLst>
+          </p:cNvPr>
+          <p:cNvSpPr>
+            <a:spLocks xmlns:a="http://schemas.openxmlformats.org/drawingml/2006/main" noGrp="1"/>
+          </p:cNvSpPr>
+          <p:nvPr/>
+        </p:nvSpPr>
+        <p:spPr>
+          <a:xfrm xmlns:a="http://schemas.openxmlformats.org/drawingml/2006/main">
+            <a:off x="609600" y="1952625"/>
+            <a:ext cx="10953750" cy="1666875"/>
+          </a:xfrm>
+          <a:prstGeom xmlns:a="http://schemas.openxmlformats.org/drawingml/2006/main" prst="rect">
+            <a:avLst/>
+          </a:prstGeom>
+          <a:noFill xmlns:a="http://schemas.openxmlformats.org/drawingml/2006/main"/>
+          <a:ln xmlns:a="http://schemas.openxmlformats.org/drawingml/2006/main" w="0">
+            <a:noFill/>
+          </a:ln>
+        </p:spPr>
+        <p:txBody>
+          <a:bodyPr xmlns:a="http://schemas.openxmlformats.org/drawingml/2006/main">
+            <a:noAutofit/>
+          </a:bodyPr>
+          <a:lstStyle xmlns:a="http://schemas.openxmlformats.org/drawingml/2006/main"/>
+          <a:p xmlns:a="http://schemas.openxmlformats.org/drawingml/2006/main">
+            <a:pPr>
+              <a:defRPr sz="2025" b="0">
+                <a:solidFill>
+                  <a:srgbClr val="EAF1FF"/>
+                </a:solidFill>
+                <a:latin typeface="Arial"/>
+                <a:ea typeface="Arial"/>
+                <a:cs typeface="Arial"/>
+              </a:defRPr>
+            </a:pPr>
+            <a:r>
+              <a:rPr sz="2025" b="0">
+                <a:solidFill>
+                  <a:srgbClr val="EAF1FF"/>
+                </a:solidFill>
+                <a:latin typeface="Arial"/>
+                <a:ea typeface="Arial"/>
+                <a:cs typeface="Arial"/>
+              </a:rPr>
+              <a:t>Udhëtimi Prishtinë–AAB ishte në 08:15. Nisja kalon në 08:25.</a:t>
+            </a:r>
+          </a:p>
+          <a:p xmlns:a="http://schemas.openxmlformats.org/drawingml/2006/main">
+            <a:r>
+              <a:t/>
+            </a:r>
+          </a:p>
+          <a:p xmlns:a="http://schemas.openxmlformats.org/drawingml/2006/main">
+            <a:pPr>
+              <a:defRPr sz="2025" b="0">
+                <a:solidFill>
+                  <a:srgbClr val="EAF1FF"/>
+                </a:solidFill>
+                <a:latin typeface="Arial"/>
+                <a:ea typeface="Arial"/>
+                <a:cs typeface="Arial"/>
+              </a:defRPr>
+            </a:pPr>
+            <a:r>
+              <a:rPr sz="2025" b="0">
+                <a:solidFill>
+                  <a:srgbClr val="EAF1FF"/>
+                </a:solidFill>
+                <a:latin typeface="Arial"/>
+                <a:ea typeface="Arial"/>
+                <a:cs typeface="Arial"/>
+              </a:rPr>
+              <a:t>Sot bëjmë që lista dhe detajet të tregojnë të njëjtën orë të re.</a:t>
+            </a:r>
+          </a:p>
+        </p:txBody>
+      </p:sp>
+      <p:sp>
+        <p:nvSpPr>
           <p:cNvPr id="6" name="">
             <a:extLst xmlns:a="http://schemas.openxmlformats.org/drawingml/2006/main">
               <a:ext uri="{FF2B5EF4-FFF2-40B4-BE49-F238E27FC236}">
-                <a16:creationId xmlns:a16="http://schemas.microsoft.com/office/drawing/2014/main" id="{17F57B7F-A1A6-49D8-82EC-535634866DD5}"/>
-              </a:ext>
-            </a:extLst>
-          </p:cNvPr>
-          <p:cNvSpPr>
-            <a:spLocks xmlns:a="http://schemas.openxmlformats.org/drawingml/2006/main" noGrp="1"/>
-          </p:cNvSpPr>
-          <p:nvPr/>
-        </p:nvSpPr>
-        <p:spPr>
-          <a:xfrm xmlns:a="http://schemas.openxmlformats.org/drawingml/2006/main">
-            <a:off x="609600" y="5667375"/>
-            <a:ext cx="10953750" cy="619125"/>
-          </a:xfrm>
-          <a:prstGeom xmlns:a="http://schemas.openxmlformats.org/drawingml/2006/main" prst="rect">
-            <a:avLst/>
-          </a:prstGeom>
-          <a:noFill xmlns:a="http://schemas.openxmlformats.org/drawingml/2006/main"/>
-          <a:ln xmlns:a="http://schemas.openxmlformats.org/drawingml/2006/main" w="0">
-            <a:noFill/>
-          </a:ln>
-        </p:spPr>
-        <p:txBody>
-          <a:bodyPr xmlns:a="http://schemas.openxmlformats.org/drawingml/2006/main">
-            <a:noAutofit/>
-          </a:bodyPr>
-          <a:lstStyle xmlns:a="http://schemas.openxmlformats.org/drawingml/2006/main"/>
-          <a:p xmlns:a="http://schemas.openxmlformats.org/drawingml/2006/main">
-            <a:pPr>
-              <a:defRPr sz="1725" b="0">
-                <a:solidFill>
-                  <a:srgbClr val="EAF1FF"/>
-                </a:solidFill>
-                <a:latin typeface="Arial"/>
-                <a:ea typeface="Arial"/>
-                <a:cs typeface="Arial"/>
-              </a:defRPr>
-            </a:pPr>
-            <a:r>
-              <a:rPr sz="1725" b="0">
-                <a:solidFill>
-                  <a:srgbClr val="EAF1FF"/>
-                </a:solidFill>
-                <a:latin typeface="Arial"/>
-                <a:ea typeface="Arial"/>
-                <a:cs typeface="Arial"/>
-              </a:rPr>
-              <a:t>Telefoni kërkon faqen. Next.js lexon udhëtimet në Neon dhe kthen pamjen.</a:t>
-            </a:r>
-          </a:p>
-          <a:p xmlns:a="http://schemas.openxmlformats.org/drawingml/2006/main">
-            <a:pPr>
-              <a:defRPr sz="1725" b="0">
-                <a:solidFill>
-                  <a:srgbClr val="EAF1FF"/>
-                </a:solidFill>
-                <a:latin typeface="Arial"/>
-                <a:ea typeface="Arial"/>
-                <a:cs typeface="Arial"/>
-              </a:defRPr>
-            </a:pPr>
-            <a:r>
-              <a:rPr sz="1725" b="0">
-                <a:solidFill>
-                  <a:srgbClr val="EAF1FF"/>
-                </a:solidFill>
-                <a:latin typeface="Arial"/>
-                <a:ea typeface="Arial"/>
-                <a:cs typeface="Arial"/>
-              </a:rPr>
-              <a:t>GitHub ruan kodin. Vercel ekzekuton aplikacionin. Neon ruan të dhënat.</a:t>
+                <a16:creationId xmlns:a16="http://schemas.microsoft.com/office/drawing/2014/main" id="{C2B0A692-AE2D-40A3-BC33-C889EAFD777F}"/>
+              </a:ext>
+            </a:extLst>
+          </p:cNvPr>
+          <p:cNvSpPr>
+            <a:spLocks xmlns:a="http://schemas.openxmlformats.org/drawingml/2006/main" noGrp="1"/>
+          </p:cNvSpPr>
+          <p:nvPr/>
+        </p:nvSpPr>
+        <p:spPr>
+          <a:xfrm xmlns:a="http://schemas.openxmlformats.org/drawingml/2006/main">
+            <a:off x="609600" y="3714750"/>
+            <a:ext cx="10953750" cy="666750"/>
+          </a:xfrm>
+          <a:prstGeom xmlns:a="http://schemas.openxmlformats.org/drawingml/2006/main" prst="rect">
+            <a:avLst/>
+          </a:prstGeom>
+          <a:noFill xmlns:a="http://schemas.openxmlformats.org/drawingml/2006/main"/>
+          <a:ln xmlns:a="http://schemas.openxmlformats.org/drawingml/2006/main" w="0">
+            <a:noFill/>
+          </a:ln>
+        </p:spPr>
+        <p:txBody>
+          <a:bodyPr xmlns:a="http://schemas.openxmlformats.org/drawingml/2006/main">
+            <a:noAutofit/>
+          </a:bodyPr>
+          <a:lstStyle xmlns:a="http://schemas.openxmlformats.org/drawingml/2006/main"/>
+          <a:p xmlns:a="http://schemas.openxmlformats.org/drawingml/2006/main">
+            <a:pPr>
+              <a:defRPr sz="2100" b="1">
+                <a:solidFill>
+                  <a:srgbClr val="89DDFF"/>
+                </a:solidFill>
+                <a:latin typeface="Arial"/>
+                <a:ea typeface="Arial"/>
+                <a:cs typeface="Arial"/>
+              </a:defRPr>
+            </a:pPr>
+            <a:r>
+              <a:rPr sz="2100" b="1">
+                <a:solidFill>
+                  <a:srgbClr val="89DDFF"/>
+                </a:solidFill>
+                <a:latin typeface="Arial"/>
+                <a:ea typeface="Arial"/>
+                <a:cs typeface="Arial"/>
+              </a:rPr>
+              <a:t>Ku do ta ndryshonit orën që të dy ekranet të pajtohen?</a:t>
+            </a:r>
+          </a:p>
+        </p:txBody>
+      </p:sp>
+      <p:sp>
+        <p:nvSpPr>
+          <p:cNvPr id="7" name="">
+            <a:extLst xmlns:a="http://schemas.openxmlformats.org/drawingml/2006/main">
+              <a:ext uri="{FF2B5EF4-FFF2-40B4-BE49-F238E27FC236}">
+                <a16:creationId xmlns:a16="http://schemas.microsoft.com/office/drawing/2014/main" id="{B9192F9B-870E-40E3-B706-E0BC59F7A956}"/>
+              </a:ext>
+            </a:extLst>
+          </p:cNvPr>
+          <p:cNvSpPr>
+            <a:spLocks xmlns:a="http://schemas.openxmlformats.org/drawingml/2006/main" noGrp="1"/>
+          </p:cNvSpPr>
+          <p:nvPr/>
+        </p:nvSpPr>
+        <p:spPr>
+          <a:xfrm xmlns:a="http://schemas.openxmlformats.org/drawingml/2006/main">
+            <a:off x="609600" y="4429125"/>
+            <a:ext cx="10953750" cy="1381125"/>
+          </a:xfrm>
+          <a:prstGeom xmlns:a="http://schemas.openxmlformats.org/drawingml/2006/main" prst="rect">
+            <a:avLst/>
+          </a:prstGeom>
+          <a:noFill xmlns:a="http://schemas.openxmlformats.org/drawingml/2006/main"/>
+          <a:ln xmlns:a="http://schemas.openxmlformats.org/drawingml/2006/main" w="0">
+            <a:noFill/>
+          </a:ln>
+        </p:spPr>
+        <p:txBody>
+          <a:bodyPr xmlns:a="http://schemas.openxmlformats.org/drawingml/2006/main">
+            <a:noAutofit/>
+          </a:bodyPr>
+          <a:lstStyle xmlns:a="http://schemas.openxmlformats.org/drawingml/2006/main"/>
+          <a:p xmlns:a="http://schemas.openxmlformats.org/drawingml/2006/main">
+            <a:pPr>
+              <a:defRPr sz="1875" b="0">
+                <a:solidFill>
+                  <a:srgbClr val="EAF1FF"/>
+                </a:solidFill>
+                <a:latin typeface="Arial"/>
+                <a:ea typeface="Arial"/>
+                <a:cs typeface="Arial"/>
+              </a:defRPr>
+            </a:pPr>
+            <a:r>
+              <a:rPr sz="1875" b="0">
+                <a:solidFill>
+                  <a:srgbClr val="EAF1FF"/>
+                </a:solidFill>
+                <a:latin typeface="Arial"/>
+                <a:ea typeface="Arial"/>
+                <a:cs typeface="Arial"/>
+              </a:rPr>
+              <a:t>A · Veçmas në kartë dhe në faqen e detajeve.</a:t>
+            </a:r>
+          </a:p>
+          <a:p xmlns:a="http://schemas.openxmlformats.org/drawingml/2006/main">
+            <a:r>
+              <a:t/>
+            </a:r>
+          </a:p>
+          <a:p xmlns:a="http://schemas.openxmlformats.org/drawingml/2006/main">
+            <a:pPr>
+              <a:defRPr sz="1875" b="0">
+                <a:solidFill>
+                  <a:srgbClr val="EAF1FF"/>
+                </a:solidFill>
+                <a:latin typeface="Arial"/>
+                <a:ea typeface="Arial"/>
+                <a:cs typeface="Arial"/>
+              </a:defRPr>
+            </a:pPr>
+            <a:r>
+              <a:rPr sz="1875" b="0">
+                <a:solidFill>
+                  <a:srgbClr val="EAF1FF"/>
+                </a:solidFill>
+                <a:latin typeface="Arial"/>
+                <a:ea typeface="Arial"/>
+                <a:cs typeface="Arial"/>
+              </a:rPr>
+              <a:t>B · Në një burim të përbashkët që e lexojnë të dy ekranet.</a:t>
+            </a:r>
+          </a:p>
+          <a:p xmlns:a="http://schemas.openxmlformats.org/drawingml/2006/main">
+            <a:r>
+              <a:t/>
+            </a:r>
+          </a:p>
+          <a:p xmlns:a="http://schemas.openxmlformats.org/drawingml/2006/main">
+            <a:pPr>
+              <a:defRPr sz="1875" b="0">
+                <a:solidFill>
+                  <a:srgbClr val="EAF1FF"/>
+                </a:solidFill>
+                <a:latin typeface="Arial"/>
+                <a:ea typeface="Arial"/>
+                <a:cs typeface="Arial"/>
+              </a:defRPr>
+            </a:pPr>
+            <a:r>
+              <a:rPr sz="1875" b="0">
+                <a:solidFill>
+                  <a:srgbClr val="EAF1FF"/>
+                </a:solidFill>
+                <a:latin typeface="Arial"/>
+                <a:ea typeface="Arial"/>
+                <a:cs typeface="Arial"/>
+              </a:rPr>
+              <a:t>C · Askund. Ora në aplikacion ndryshon vetvetiu.</a:t>
+            </a:r>
+          </a:p>
+        </p:txBody>
+      </p:sp>
+      <p:sp>
+        <p:nvSpPr>
+          <p:cNvPr id="8" name="">
+            <a:extLst xmlns:a="http://schemas.openxmlformats.org/drawingml/2006/main">
+              <a:ext uri="{FF2B5EF4-FFF2-40B4-BE49-F238E27FC236}">
+                <a16:creationId xmlns:a16="http://schemas.microsoft.com/office/drawing/2014/main" id="{F21E479E-A096-46BD-99EB-12C7E2CF1F79}"/>
+              </a:ext>
+            </a:extLst>
+          </p:cNvPr>
+          <p:cNvSpPr>
+            <a:spLocks xmlns:a="http://schemas.openxmlformats.org/drawingml/2006/main" noGrp="1"/>
+          </p:cNvSpPr>
+          <p:nvPr/>
+        </p:nvSpPr>
+        <p:spPr>
+          <a:xfrm xmlns:a="http://schemas.openxmlformats.org/drawingml/2006/main">
+            <a:off x="609600" y="5953125"/>
+            <a:ext cx="10953750" cy="381000"/>
+          </a:xfrm>
+          <a:prstGeom xmlns:a="http://schemas.openxmlformats.org/drawingml/2006/main" prst="rect">
+            <a:avLst/>
+          </a:prstGeom>
+          <a:noFill xmlns:a="http://schemas.openxmlformats.org/drawingml/2006/main"/>
+          <a:ln xmlns:a="http://schemas.openxmlformats.org/drawingml/2006/main" w="0">
+            <a:noFill/>
+          </a:ln>
+        </p:spPr>
+        <p:txBody>
+          <a:bodyPr xmlns:a="http://schemas.openxmlformats.org/drawingml/2006/main">
+            <a:noAutofit/>
+          </a:bodyPr>
+          <a:lstStyle xmlns:a="http://schemas.openxmlformats.org/drawingml/2006/main"/>
+          <a:p xmlns:a="http://schemas.openxmlformats.org/drawingml/2006/main">
+            <a:pPr>
+              <a:defRPr sz="1650" b="0">
+                <a:solidFill>
+                  <a:srgbClr val="8EE9D1"/>
+                </a:solidFill>
+                <a:latin typeface="Arial"/>
+                <a:ea typeface="Arial"/>
+                <a:cs typeface="Arial"/>
+              </a:defRPr>
+            </a:pPr>
+            <a:r>
+              <a:rPr sz="1650" b="0">
+                <a:solidFill>
+                  <a:srgbClr val="8EE9D1"/>
+                </a:solidFill>
+                <a:latin typeface="Arial"/>
+                <a:ea typeface="Arial"/>
+                <a:cs typeface="Arial"/>
+              </a:rPr>
+              <a:t>Votoni, krahasoni arsyetimet dhe hapni përgjigjen në versionin interaktiv.</a:t>
             </a:r>
           </a:p>
         </p:txBody>
@@ -912,7 +1122,7 @@
     </p:spTree>
     <p:extLst>
       <p:ext uri="{BB962C8B-B14F-4D97-AF65-F5344CB8AC3E}">
-        <p14:creationId xmlns:p14="http://schemas.microsoft.com/office/powerpoint/2010/main" val="2085737414"/>
+        <p14:creationId xmlns:p14="http://schemas.microsoft.com/office/powerpoint/2010/main" val="1615965025"/>
       </p:ext>
     </p:extLst>
   </p:cSld>
@@ -943,7 +1153,7 @@
           <p:cNvPr id="7" name="">
             <a:extLst xmlns:a="http://schemas.openxmlformats.org/drawingml/2006/main">
               <a:ext uri="{FF2B5EF4-FFF2-40B4-BE49-F238E27FC236}">
-                <a16:creationId xmlns:a16="http://schemas.microsoft.com/office/drawing/2014/main" id="{B91EC9B4-13E5-43E7-AC40-467BCA6E78F6}"/>
+                <a16:creationId xmlns:a16="http://schemas.microsoft.com/office/drawing/2014/main" id="{0294B229-D120-4D69-BDF8-03C76873B90E}"/>
               </a:ext>
             </a:extLst>
           </p:cNvPr>
@@ -1000,7 +1210,7 @@
           <p:cNvPr id="2" name="">
             <a:extLst xmlns:a="http://schemas.openxmlformats.org/drawingml/2006/main">
               <a:ext uri="{FF2B5EF4-FFF2-40B4-BE49-F238E27FC236}">
-                <a16:creationId xmlns:a16="http://schemas.microsoft.com/office/drawing/2014/main" id="{BEC26714-C599-4F7F-A609-3936EB08AF63}"/>
+                <a16:creationId xmlns:a16="http://schemas.microsoft.com/office/drawing/2014/main" id="{EDC7FE9E-E4A5-43DE-8B37-28B6E007C49E}"/>
               </a:ext>
             </a:extLst>
           </p:cNvPr>
@@ -1057,7 +1267,7 @@
           <p:cNvPr id="3" name="">
             <a:extLst xmlns:a="http://schemas.openxmlformats.org/drawingml/2006/main">
               <a:ext uri="{FF2B5EF4-FFF2-40B4-BE49-F238E27FC236}">
-                <a16:creationId xmlns:a16="http://schemas.microsoft.com/office/drawing/2014/main" id="{F37FDA31-E72B-423D-BCDF-CAFCD3E00915}"/>
+                <a16:creationId xmlns:a16="http://schemas.microsoft.com/office/drawing/2014/main" id="{6D33BBF2-E6C4-4E92-A119-BB1B9F233C0E}"/>
               </a:ext>
             </a:extLst>
           </p:cNvPr>
@@ -1114,7 +1324,7 @@
           <p:cNvPr id="4" name="">
             <a:extLst xmlns:a="http://schemas.openxmlformats.org/drawingml/2006/main">
               <a:ext uri="{FF2B5EF4-FFF2-40B4-BE49-F238E27FC236}">
-                <a16:creationId xmlns:a16="http://schemas.microsoft.com/office/drawing/2014/main" id="{9F9DE0D1-9FFF-4CD7-ACD6-DC628D718BEA}"/>
+                <a16:creationId xmlns:a16="http://schemas.microsoft.com/office/drawing/2014/main" id="{581B179F-849A-4151-9FDF-B5B6A2F9BD43}"/>
               </a:ext>
             </a:extLst>
           </p:cNvPr>
@@ -1227,7 +1437,7 @@
           <p:cNvPr id="5" name="">
             <a:extLst xmlns:a="http://schemas.openxmlformats.org/drawingml/2006/main">
               <a:ext uri="{FF2B5EF4-FFF2-40B4-BE49-F238E27FC236}">
-                <a16:creationId xmlns:a16="http://schemas.microsoft.com/office/drawing/2014/main" id="{231DDE2B-DD8A-4C98-9FD7-89ED237749FD}"/>
+                <a16:creationId xmlns:a16="http://schemas.microsoft.com/office/drawing/2014/main" id="{A2EE1CE7-B07D-4287-B522-0F9140A3F6E7}"/>
               </a:ext>
             </a:extLst>
           </p:cNvPr>
@@ -1307,7 +1517,7 @@
           <p:cNvPr id="6" name="">
             <a:extLst xmlns:a="http://schemas.openxmlformats.org/drawingml/2006/main">
               <a:ext uri="{FF2B5EF4-FFF2-40B4-BE49-F238E27FC236}">
-                <a16:creationId xmlns:a16="http://schemas.microsoft.com/office/drawing/2014/main" id="{0AEDBED3-4C05-4850-AD38-20B55C39A6FB}"/>
+                <a16:creationId xmlns:a16="http://schemas.microsoft.com/office/drawing/2014/main" id="{C0C581BE-4602-42EE-821E-5BADB2DA50A6}"/>
               </a:ext>
             </a:extLst>
           </p:cNvPr>
@@ -1362,7 +1572,7 @@
     </p:spTree>
     <p:extLst>
       <p:ext uri="{BB962C8B-B14F-4D97-AF65-F5344CB8AC3E}">
-        <p14:creationId xmlns:p14="http://schemas.microsoft.com/office/powerpoint/2010/main" val="201459801"/>
+        <p14:creationId xmlns:p14="http://schemas.microsoft.com/office/powerpoint/2010/main" val="1126929307"/>
       </p:ext>
     </p:extLst>
   </p:cSld>
@@ -1393,7 +1603,7 @@
           <p:cNvPr id="7" name="">
             <a:extLst xmlns:a="http://schemas.openxmlformats.org/drawingml/2006/main">
               <a:ext uri="{FF2B5EF4-FFF2-40B4-BE49-F238E27FC236}">
-                <a16:creationId xmlns:a16="http://schemas.microsoft.com/office/drawing/2014/main" id="{5B3A216C-84DD-4953-BFB5-EDA4A24DEC2D}"/>
+                <a16:creationId xmlns:a16="http://schemas.microsoft.com/office/drawing/2014/main" id="{A93D680C-DEBC-46DE-92CF-F926782EB982}"/>
               </a:ext>
             </a:extLst>
           </p:cNvPr>
@@ -1450,7 +1660,7 @@
           <p:cNvPr id="2" name="">
             <a:extLst xmlns:a="http://schemas.openxmlformats.org/drawingml/2006/main">
               <a:ext uri="{FF2B5EF4-FFF2-40B4-BE49-F238E27FC236}">
-                <a16:creationId xmlns:a16="http://schemas.microsoft.com/office/drawing/2014/main" id="{259F9805-AA93-4ED4-9470-08F5F97147C0}"/>
+                <a16:creationId xmlns:a16="http://schemas.microsoft.com/office/drawing/2014/main" id="{6F8D31D4-4E0E-4210-BCA3-17E70852079D}"/>
               </a:ext>
             </a:extLst>
           </p:cNvPr>
@@ -1507,7 +1717,7 @@
           <p:cNvPr id="3" name="">
             <a:extLst xmlns:a="http://schemas.openxmlformats.org/drawingml/2006/main">
               <a:ext uri="{FF2B5EF4-FFF2-40B4-BE49-F238E27FC236}">
-                <a16:creationId xmlns:a16="http://schemas.microsoft.com/office/drawing/2014/main" id="{7965922B-6DD0-4FBD-BC22-9A3027388566}"/>
+                <a16:creationId xmlns:a16="http://schemas.microsoft.com/office/drawing/2014/main" id="{7B633F57-4A11-43D8-9C20-C8C085EA17C8}"/>
               </a:ext>
             </a:extLst>
           </p:cNvPr>
@@ -1564,7 +1774,7 @@
           <p:cNvPr id="4" name="">
             <a:extLst xmlns:a="http://schemas.openxmlformats.org/drawingml/2006/main">
               <a:ext uri="{FF2B5EF4-FFF2-40B4-BE49-F238E27FC236}">
-                <a16:creationId xmlns:a16="http://schemas.microsoft.com/office/drawing/2014/main" id="{BD9FDFCF-04C2-46BB-9DD3-6F35B267F398}"/>
+                <a16:creationId xmlns:a16="http://schemas.microsoft.com/office/drawing/2014/main" id="{F0192672-3FBD-417B-BBBD-F5A073ECBCB9}"/>
               </a:ext>
             </a:extLst>
           </p:cNvPr>
@@ -1677,7 +1887,7 @@
           <p:cNvPr id="5" name="">
             <a:extLst xmlns:a="http://schemas.openxmlformats.org/drawingml/2006/main">
               <a:ext uri="{FF2B5EF4-FFF2-40B4-BE49-F238E27FC236}">
-                <a16:creationId xmlns:a16="http://schemas.microsoft.com/office/drawing/2014/main" id="{E327388E-F6DA-4521-BF02-251FEB42E10F}"/>
+                <a16:creationId xmlns:a16="http://schemas.microsoft.com/office/drawing/2014/main" id="{35F66F1A-1EB7-4F85-A256-E79020B1E293}"/>
               </a:ext>
             </a:extLst>
           </p:cNvPr>
@@ -1757,7 +1967,7 @@
           <p:cNvPr id="6" name="">
             <a:extLst xmlns:a="http://schemas.openxmlformats.org/drawingml/2006/main">
               <a:ext uri="{FF2B5EF4-FFF2-40B4-BE49-F238E27FC236}">
-                <a16:creationId xmlns:a16="http://schemas.microsoft.com/office/drawing/2014/main" id="{9C91C34A-7F2D-4F4D-B201-F3566361121C}"/>
+                <a16:creationId xmlns:a16="http://schemas.microsoft.com/office/drawing/2014/main" id="{FF8025AB-8524-431B-BD1E-8F6968706844}"/>
               </a:ext>
             </a:extLst>
           </p:cNvPr>
@@ -1812,7 +2022,7 @@
     </p:spTree>
     <p:extLst>
       <p:ext uri="{BB962C8B-B14F-4D97-AF65-F5344CB8AC3E}">
-        <p14:creationId xmlns:p14="http://schemas.microsoft.com/office/powerpoint/2010/main" val="685608923"/>
+        <p14:creationId xmlns:p14="http://schemas.microsoft.com/office/powerpoint/2010/main" val="408363311"/>
       </p:ext>
     </p:extLst>
   </p:cSld>
@@ -1843,7 +2053,7 @@
           <p:cNvPr id="7" name="">
             <a:extLst xmlns:a="http://schemas.openxmlformats.org/drawingml/2006/main">
               <a:ext uri="{FF2B5EF4-FFF2-40B4-BE49-F238E27FC236}">
-                <a16:creationId xmlns:a16="http://schemas.microsoft.com/office/drawing/2014/main" id="{4E0E7F05-FE36-4DF9-8723-AB3F62A8B7DA}"/>
+                <a16:creationId xmlns:a16="http://schemas.microsoft.com/office/drawing/2014/main" id="{DED545FB-93AC-47D7-8022-70EAF3C90B8A}"/>
               </a:ext>
             </a:extLst>
           </p:cNvPr>
@@ -1900,7 +2110,7 @@
           <p:cNvPr id="2" name="">
             <a:extLst xmlns:a="http://schemas.openxmlformats.org/drawingml/2006/main">
               <a:ext uri="{FF2B5EF4-FFF2-40B4-BE49-F238E27FC236}">
-                <a16:creationId xmlns:a16="http://schemas.microsoft.com/office/drawing/2014/main" id="{70F3E372-1C47-4DB4-9AB3-DB63732297A0}"/>
+                <a16:creationId xmlns:a16="http://schemas.microsoft.com/office/drawing/2014/main" id="{FBB1250A-3F8F-41B4-AC15-E745F674442A}"/>
               </a:ext>
             </a:extLst>
           </p:cNvPr>
@@ -1957,7 +2167,7 @@
           <p:cNvPr id="3" name="">
             <a:extLst xmlns:a="http://schemas.openxmlformats.org/drawingml/2006/main">
               <a:ext uri="{FF2B5EF4-FFF2-40B4-BE49-F238E27FC236}">
-                <a16:creationId xmlns:a16="http://schemas.microsoft.com/office/drawing/2014/main" id="{3276BB5A-C40B-4FF7-A5A5-261EEAF51EBC}"/>
+                <a16:creationId xmlns:a16="http://schemas.microsoft.com/office/drawing/2014/main" id="{BA2D7E1C-94F7-41F8-BEB9-7164853D1902}"/>
               </a:ext>
             </a:extLst>
           </p:cNvPr>
@@ -2014,7 +2224,7 @@
           <p:cNvPr id="4" name="">
             <a:extLst xmlns:a="http://schemas.openxmlformats.org/drawingml/2006/main">
               <a:ext uri="{FF2B5EF4-FFF2-40B4-BE49-F238E27FC236}">
-                <a16:creationId xmlns:a16="http://schemas.microsoft.com/office/drawing/2014/main" id="{D72631E0-B90C-4DFE-9A0E-14B358E41B19}"/>
+                <a16:creationId xmlns:a16="http://schemas.microsoft.com/office/drawing/2014/main" id="{0A8D7E30-20C3-44BD-BE51-C92D3B1A61AE}"/>
               </a:ext>
             </a:extLst>
           </p:cNvPr>
@@ -2127,7 +2337,7 @@
           <p:cNvPr id="5" name="">
             <a:extLst xmlns:a="http://schemas.openxmlformats.org/drawingml/2006/main">
               <a:ext uri="{FF2B5EF4-FFF2-40B4-BE49-F238E27FC236}">
-                <a16:creationId xmlns:a16="http://schemas.microsoft.com/office/drawing/2014/main" id="{2B5FA663-A2A5-4E19-B22C-591B00D6097A}"/>
+                <a16:creationId xmlns:a16="http://schemas.microsoft.com/office/drawing/2014/main" id="{E36AD798-4CAC-4D43-9D74-609BBC17F708}"/>
               </a:ext>
             </a:extLst>
           </p:cNvPr>
@@ -2253,7 +2463,7 @@
           <p:cNvPr id="6" name="">
             <a:extLst xmlns:a="http://schemas.openxmlformats.org/drawingml/2006/main">
               <a:ext uri="{FF2B5EF4-FFF2-40B4-BE49-F238E27FC236}">
-                <a16:creationId xmlns:a16="http://schemas.microsoft.com/office/drawing/2014/main" id="{37459226-0B9C-4387-A6EE-A290BA569891}"/>
+                <a16:creationId xmlns:a16="http://schemas.microsoft.com/office/drawing/2014/main" id="{03B39943-B17F-497B-995D-2D04CDDB0A41}"/>
               </a:ext>
             </a:extLst>
           </p:cNvPr>
@@ -2308,7 +2518,7 @@
     </p:spTree>
     <p:extLst>
       <p:ext uri="{BB962C8B-B14F-4D97-AF65-F5344CB8AC3E}">
-        <p14:creationId xmlns:p14="http://schemas.microsoft.com/office/powerpoint/2010/main" val="1996564646"/>
+        <p14:creationId xmlns:p14="http://schemas.microsoft.com/office/powerpoint/2010/main" val="1981138521"/>
       </p:ext>
     </p:extLst>
   </p:cSld>
@@ -2339,7 +2549,7 @@
           <p:cNvPr id="7" name="">
             <a:extLst xmlns:a="http://schemas.openxmlformats.org/drawingml/2006/main">
               <a:ext uri="{FF2B5EF4-FFF2-40B4-BE49-F238E27FC236}">
-                <a16:creationId xmlns:a16="http://schemas.microsoft.com/office/drawing/2014/main" id="{4CDADC29-4C8B-4F50-B2D6-1720CC3B6CC4}"/>
+                <a16:creationId xmlns:a16="http://schemas.microsoft.com/office/drawing/2014/main" id="{DE57B2B7-7F05-41AA-971C-646B02140FE7}"/>
               </a:ext>
             </a:extLst>
           </p:cNvPr>
@@ -2396,7 +2606,7 @@
           <p:cNvPr id="2" name="">
             <a:extLst xmlns:a="http://schemas.openxmlformats.org/drawingml/2006/main">
               <a:ext uri="{FF2B5EF4-FFF2-40B4-BE49-F238E27FC236}">
-                <a16:creationId xmlns:a16="http://schemas.microsoft.com/office/drawing/2014/main" id="{3ABE2951-41B8-460F-89DB-57428D3F7C93}"/>
+                <a16:creationId xmlns:a16="http://schemas.microsoft.com/office/drawing/2014/main" id="{BDEBC636-00E2-49A5-9262-88EA237E0F9A}"/>
               </a:ext>
             </a:extLst>
           </p:cNvPr>
@@ -2453,7 +2663,7 @@
           <p:cNvPr id="3" name="">
             <a:extLst xmlns:a="http://schemas.openxmlformats.org/drawingml/2006/main">
               <a:ext uri="{FF2B5EF4-FFF2-40B4-BE49-F238E27FC236}">
-                <a16:creationId xmlns:a16="http://schemas.microsoft.com/office/drawing/2014/main" id="{40C13BBE-5D79-4181-AFB6-CB37B47C6A38}"/>
+                <a16:creationId xmlns:a16="http://schemas.microsoft.com/office/drawing/2014/main" id="{54DF2DE1-86BF-41D8-90D2-6497E74CB8F6}"/>
               </a:ext>
             </a:extLst>
           </p:cNvPr>
@@ -2510,7 +2720,7 @@
           <p:cNvPr id="4" name="">
             <a:extLst xmlns:a="http://schemas.openxmlformats.org/drawingml/2006/main">
               <a:ext uri="{FF2B5EF4-FFF2-40B4-BE49-F238E27FC236}">
-                <a16:creationId xmlns:a16="http://schemas.microsoft.com/office/drawing/2014/main" id="{AEA470B9-CC22-429D-A509-056EFC0D7DF1}"/>
+                <a16:creationId xmlns:a16="http://schemas.microsoft.com/office/drawing/2014/main" id="{C38A89E8-BDA1-4AA2-9667-EAEA75D18B0E}"/>
               </a:ext>
             </a:extLst>
           </p:cNvPr>
@@ -2623,7 +2833,7 @@
           <p:cNvPr id="5" name="">
             <a:extLst xmlns:a="http://schemas.openxmlformats.org/drawingml/2006/main">
               <a:ext uri="{FF2B5EF4-FFF2-40B4-BE49-F238E27FC236}">
-                <a16:creationId xmlns:a16="http://schemas.microsoft.com/office/drawing/2014/main" id="{6C8DC2DE-A108-4A44-9378-A79C31CD9440}"/>
+                <a16:creationId xmlns:a16="http://schemas.microsoft.com/office/drawing/2014/main" id="{0213ADD6-B046-400F-BCD3-23C7608CD37B}"/>
               </a:ext>
             </a:extLst>
           </p:cNvPr>
@@ -2680,7 +2890,7 @@
           <p:cNvPr id="6" name="">
             <a:extLst xmlns:a="http://schemas.openxmlformats.org/drawingml/2006/main">
               <a:ext uri="{FF2B5EF4-FFF2-40B4-BE49-F238E27FC236}">
-                <a16:creationId xmlns:a16="http://schemas.microsoft.com/office/drawing/2014/main" id="{CC76C650-B795-4CCB-BB2C-4B9E88EB3D4B}"/>
+                <a16:creationId xmlns:a16="http://schemas.microsoft.com/office/drawing/2014/main" id="{7C4910C2-63BF-4129-891E-F2BBEE11B6BF}"/>
               </a:ext>
             </a:extLst>
           </p:cNvPr>
@@ -2735,7 +2945,7 @@
     </p:spTree>
     <p:extLst>
       <p:ext uri="{BB962C8B-B14F-4D97-AF65-F5344CB8AC3E}">
-        <p14:creationId xmlns:p14="http://schemas.microsoft.com/office/powerpoint/2010/main" val="1917532762"/>
+        <p14:creationId xmlns:p14="http://schemas.microsoft.com/office/powerpoint/2010/main" val="480808677"/>
       </p:ext>
     </p:extLst>
   </p:cSld>
@@ -2766,7 +2976,7 @@
           <p:cNvPr id="6" name="">
             <a:extLst xmlns:a="http://schemas.openxmlformats.org/drawingml/2006/main">
               <a:ext uri="{FF2B5EF4-FFF2-40B4-BE49-F238E27FC236}">
-                <a16:creationId xmlns:a16="http://schemas.microsoft.com/office/drawing/2014/main" id="{6542CF29-6867-47D2-BE24-A358E894550C}"/>
+                <a16:creationId xmlns:a16="http://schemas.microsoft.com/office/drawing/2014/main" id="{3F16F8F7-2AC2-4005-B70F-7A4850705111}"/>
               </a:ext>
             </a:extLst>
           </p:cNvPr>
@@ -2823,7 +3033,7 @@
           <p:cNvPr id="2" name="">
             <a:extLst xmlns:a="http://schemas.openxmlformats.org/drawingml/2006/main">
               <a:ext uri="{FF2B5EF4-FFF2-40B4-BE49-F238E27FC236}">
-                <a16:creationId xmlns:a16="http://schemas.microsoft.com/office/drawing/2014/main" id="{77290E2B-67D4-4735-8906-EBDF528CF7E5}"/>
+                <a16:creationId xmlns:a16="http://schemas.microsoft.com/office/drawing/2014/main" id="{D7ADD8E5-407C-4B5D-BDA7-697B9D354A59}"/>
               </a:ext>
             </a:extLst>
           </p:cNvPr>
@@ -2880,7 +3090,7 @@
           <p:cNvPr id="3" name="">
             <a:extLst xmlns:a="http://schemas.openxmlformats.org/drawingml/2006/main">
               <a:ext uri="{FF2B5EF4-FFF2-40B4-BE49-F238E27FC236}">
-                <a16:creationId xmlns:a16="http://schemas.microsoft.com/office/drawing/2014/main" id="{61A5B5D2-F155-426D-BAA3-D00B975EDDD2}"/>
+                <a16:creationId xmlns:a16="http://schemas.microsoft.com/office/drawing/2014/main" id="{A7DA59C1-946C-43CF-A166-E60A2912E386}"/>
               </a:ext>
             </a:extLst>
           </p:cNvPr>
@@ -2937,7 +3147,7 @@
           <p:cNvPr id="4" name="">
             <a:extLst xmlns:a="http://schemas.openxmlformats.org/drawingml/2006/main">
               <a:ext uri="{FF2B5EF4-FFF2-40B4-BE49-F238E27FC236}">
-                <a16:creationId xmlns:a16="http://schemas.microsoft.com/office/drawing/2014/main" id="{99C2842B-A4ED-4A99-A073-ABE34EF9DB95}"/>
+                <a16:creationId xmlns:a16="http://schemas.microsoft.com/office/drawing/2014/main" id="{FB8D8B4D-EC69-4BD7-AA97-B36EB982B13F}"/>
               </a:ext>
             </a:extLst>
           </p:cNvPr>
@@ -3078,7 +3288,7 @@
           <p:cNvPr id="5" name="">
             <a:extLst xmlns:a="http://schemas.openxmlformats.org/drawingml/2006/main">
               <a:ext uri="{FF2B5EF4-FFF2-40B4-BE49-F238E27FC236}">
-                <a16:creationId xmlns:a16="http://schemas.microsoft.com/office/drawing/2014/main" id="{8B83F6DA-E203-48D3-9473-BB98C0027C5B}"/>
+                <a16:creationId xmlns:a16="http://schemas.microsoft.com/office/drawing/2014/main" id="{B6C6176B-D4B2-4012-9CB8-D4548FE99F07}"/>
               </a:ext>
             </a:extLst>
           </p:cNvPr>
@@ -3133,7 +3343,7 @@
     </p:spTree>
     <p:extLst>
       <p:ext uri="{BB962C8B-B14F-4D97-AF65-F5344CB8AC3E}">
-        <p14:creationId xmlns:p14="http://schemas.microsoft.com/office/powerpoint/2010/main" val="1764387287"/>
+        <p14:creationId xmlns:p14="http://schemas.microsoft.com/office/powerpoint/2010/main" val="1531662947"/>
       </p:ext>
     </p:extLst>
   </p:cSld>
@@ -3164,7 +3374,7 @@
           <p:cNvPr id="7" name="">
             <a:extLst xmlns:a="http://schemas.openxmlformats.org/drawingml/2006/main">
               <a:ext uri="{FF2B5EF4-FFF2-40B4-BE49-F238E27FC236}">
-                <a16:creationId xmlns:a16="http://schemas.microsoft.com/office/drawing/2014/main" id="{0312CF54-0A3F-4D96-92F2-222BF63FA193}"/>
+                <a16:creationId xmlns:a16="http://schemas.microsoft.com/office/drawing/2014/main" id="{BAF4C656-B81E-471A-98B7-9370758D5C65}"/>
               </a:ext>
             </a:extLst>
           </p:cNvPr>
@@ -3221,7 +3431,7 @@
           <p:cNvPr id="2" name="">
             <a:extLst xmlns:a="http://schemas.openxmlformats.org/drawingml/2006/main">
               <a:ext uri="{FF2B5EF4-FFF2-40B4-BE49-F238E27FC236}">
-                <a16:creationId xmlns:a16="http://schemas.microsoft.com/office/drawing/2014/main" id="{4D254AB5-10AD-4421-A58D-C53702A4E733}"/>
+                <a16:creationId xmlns:a16="http://schemas.microsoft.com/office/drawing/2014/main" id="{371890C6-362C-4F32-BB3A-B8C41C3C44A6}"/>
               </a:ext>
             </a:extLst>
           </p:cNvPr>
@@ -3278,7 +3488,7 @@
           <p:cNvPr id="3" name="">
             <a:extLst xmlns:a="http://schemas.openxmlformats.org/drawingml/2006/main">
               <a:ext uri="{FF2B5EF4-FFF2-40B4-BE49-F238E27FC236}">
-                <a16:creationId xmlns:a16="http://schemas.microsoft.com/office/drawing/2014/main" id="{6D592CD0-DF3F-4359-8797-E0DD671B8475}"/>
+                <a16:creationId xmlns:a16="http://schemas.microsoft.com/office/drawing/2014/main" id="{9B4A7F88-D37B-493A-9A3B-A44F6E9B3DC1}"/>
               </a:ext>
             </a:extLst>
           </p:cNvPr>
@@ -3335,7 +3545,7 @@
           <p:cNvPr id="4" name="">
             <a:extLst xmlns:a="http://schemas.openxmlformats.org/drawingml/2006/main">
               <a:ext uri="{FF2B5EF4-FFF2-40B4-BE49-F238E27FC236}">
-                <a16:creationId xmlns:a16="http://schemas.microsoft.com/office/drawing/2014/main" id="{401D1DE1-5A18-4BB7-88DA-C2FB85A11CB6}"/>
+                <a16:creationId xmlns:a16="http://schemas.microsoft.com/office/drawing/2014/main" id="{7113DFAB-949F-4D4B-9A31-BB8C36807FE6}"/>
               </a:ext>
             </a:extLst>
           </p:cNvPr>
@@ -3448,7 +3658,7 @@
           <p:cNvPr id="5" name="">
             <a:extLst xmlns:a="http://schemas.openxmlformats.org/drawingml/2006/main">
               <a:ext uri="{FF2B5EF4-FFF2-40B4-BE49-F238E27FC236}">
-                <a16:creationId xmlns:a16="http://schemas.microsoft.com/office/drawing/2014/main" id="{AA4BE355-040D-47E3-9E4D-E20FB079A02B}"/>
+                <a16:creationId xmlns:a16="http://schemas.microsoft.com/office/drawing/2014/main" id="{5E312EC7-F012-4308-90C5-5F320A068397}"/>
               </a:ext>
             </a:extLst>
           </p:cNvPr>
@@ -3505,7 +3715,7 @@
           <p:cNvPr id="6" name="">
             <a:extLst xmlns:a="http://schemas.openxmlformats.org/drawingml/2006/main">
               <a:ext uri="{FF2B5EF4-FFF2-40B4-BE49-F238E27FC236}">
-                <a16:creationId xmlns:a16="http://schemas.microsoft.com/office/drawing/2014/main" id="{48C947F0-12C1-480C-A46B-23ED331B1867}"/>
+                <a16:creationId xmlns:a16="http://schemas.microsoft.com/office/drawing/2014/main" id="{A88E4318-0463-4763-9F0A-D80509B2C846}"/>
               </a:ext>
             </a:extLst>
           </p:cNvPr>
@@ -3560,7 +3770,7 @@
     </p:spTree>
     <p:extLst>
       <p:ext uri="{BB962C8B-B14F-4D97-AF65-F5344CB8AC3E}">
-        <p14:creationId xmlns:p14="http://schemas.microsoft.com/office/powerpoint/2010/main" val="341160478"/>
+        <p14:creationId xmlns:p14="http://schemas.microsoft.com/office/powerpoint/2010/main" val="1731574848"/>
       </p:ext>
     </p:extLst>
   </p:cSld>
@@ -3591,7 +3801,7 @@
           <p:cNvPr id="5" name="">
             <a:extLst xmlns:a="http://schemas.openxmlformats.org/drawingml/2006/main">
               <a:ext uri="{FF2B5EF4-FFF2-40B4-BE49-F238E27FC236}">
-                <a16:creationId xmlns:a16="http://schemas.microsoft.com/office/drawing/2014/main" id="{2855D718-3242-4A8E-887E-B2141FFC1170}"/>
+                <a16:creationId xmlns:a16="http://schemas.microsoft.com/office/drawing/2014/main" id="{646130E6-9104-4951-96FD-E0276DC4D2AC}"/>
               </a:ext>
             </a:extLst>
           </p:cNvPr>
@@ -3648,7 +3858,7 @@
           <p:cNvPr id="2" name="">
             <a:extLst xmlns:a="http://schemas.openxmlformats.org/drawingml/2006/main">
               <a:ext uri="{FF2B5EF4-FFF2-40B4-BE49-F238E27FC236}">
-                <a16:creationId xmlns:a16="http://schemas.microsoft.com/office/drawing/2014/main" id="{B2AC5046-CA56-4C51-B461-2B2C004FAEC8}"/>
+                <a16:creationId xmlns:a16="http://schemas.microsoft.com/office/drawing/2014/main" id="{6FD10870-B365-4FBC-A578-FB6F5985245B}"/>
               </a:ext>
             </a:extLst>
           </p:cNvPr>
@@ -3705,7 +3915,7 @@
           <p:cNvPr id="3" name="">
             <a:extLst xmlns:a="http://schemas.openxmlformats.org/drawingml/2006/main">
               <a:ext uri="{FF2B5EF4-FFF2-40B4-BE49-F238E27FC236}">
-                <a16:creationId xmlns:a16="http://schemas.microsoft.com/office/drawing/2014/main" id="{63803796-8A6B-4646-B3E0-38D08D1AE2B7}"/>
+                <a16:creationId xmlns:a16="http://schemas.microsoft.com/office/drawing/2014/main" id="{DA87B70F-D606-4865-A72F-78F33DD59743}"/>
               </a:ext>
             </a:extLst>
           </p:cNvPr>
@@ -3762,7 +3972,7 @@
           <p:cNvPr id="4" name="">
             <a:extLst xmlns:a="http://schemas.openxmlformats.org/drawingml/2006/main">
               <a:ext uri="{FF2B5EF4-FFF2-40B4-BE49-F238E27FC236}">
-                <a16:creationId xmlns:a16="http://schemas.microsoft.com/office/drawing/2014/main" id="{6CA50EE9-FB5C-4F34-8BE8-12EF5B836719}"/>
+                <a16:creationId xmlns:a16="http://schemas.microsoft.com/office/drawing/2014/main" id="{0FCAD625-55C4-411A-986A-1078208FF36F}"/>
               </a:ext>
             </a:extLst>
           </p:cNvPr>
@@ -3901,7 +4111,7 @@
     </p:spTree>
     <p:extLst>
       <p:ext uri="{BB962C8B-B14F-4D97-AF65-F5344CB8AC3E}">
-        <p14:creationId xmlns:p14="http://schemas.microsoft.com/office/powerpoint/2010/main" val="2009882338"/>
+        <p14:creationId xmlns:p14="http://schemas.microsoft.com/office/powerpoint/2010/main" val="1921941160"/>
       </p:ext>
     </p:extLst>
   </p:cSld>
@@ -3929,10 +4139,10 @@
       </p:grpSpPr>
       <p:sp>
         <p:nvSpPr>
-          <p:cNvPr id="7" name="">
-            <a:extLst xmlns:a="http://schemas.openxmlformats.org/drawingml/2006/main">
-              <a:ext uri="{FF2B5EF4-FFF2-40B4-BE49-F238E27FC236}">
-                <a16:creationId xmlns:a16="http://schemas.microsoft.com/office/drawing/2014/main" id="{8B1F994C-B1DB-484F-8835-490717DA8D3B}"/>
+          <p:cNvPr id="8" name="">
+            <a:extLst xmlns:a="http://schemas.openxmlformats.org/drawingml/2006/main">
+              <a:ext uri="{FF2B5EF4-FFF2-40B4-BE49-F238E27FC236}">
+                <a16:creationId xmlns:a16="http://schemas.microsoft.com/office/drawing/2014/main" id="{8FB82B62-8528-45FF-B0EA-5E33ACC3EC02}"/>
               </a:ext>
             </a:extLst>
           </p:cNvPr>
@@ -3989,7 +4199,7 @@
           <p:cNvPr id="2" name="">
             <a:extLst xmlns:a="http://schemas.openxmlformats.org/drawingml/2006/main">
               <a:ext uri="{FF2B5EF4-FFF2-40B4-BE49-F238E27FC236}">
-                <a16:creationId xmlns:a16="http://schemas.microsoft.com/office/drawing/2014/main" id="{6A6229E0-6423-465F-8EBD-AE58E32F5B0A}"/>
+                <a16:creationId xmlns:a16="http://schemas.microsoft.com/office/drawing/2014/main" id="{5C4A7BC2-89B0-40D2-9135-0F959BC98416}"/>
               </a:ext>
             </a:extLst>
           </p:cNvPr>
@@ -4046,7 +4256,7 @@
           <p:cNvPr id="3" name="">
             <a:extLst xmlns:a="http://schemas.openxmlformats.org/drawingml/2006/main">
               <a:ext uri="{FF2B5EF4-FFF2-40B4-BE49-F238E27FC236}">
-                <a16:creationId xmlns:a16="http://schemas.microsoft.com/office/drawing/2014/main" id="{AE44A3D2-E025-4F1F-9831-8DCDDD9A7C61}"/>
+                <a16:creationId xmlns:a16="http://schemas.microsoft.com/office/drawing/2014/main" id="{49BB0E80-54D6-41A5-892F-A643BACDB562}"/>
               </a:ext>
             </a:extLst>
           </p:cNvPr>
@@ -4103,46 +4313,46 @@
           <p:cNvPr id="4" name="">
             <a:extLst xmlns:a="http://schemas.openxmlformats.org/drawingml/2006/main">
               <a:ext uri="{FF2B5EF4-FFF2-40B4-BE49-F238E27FC236}">
-                <a16:creationId xmlns:a16="http://schemas.microsoft.com/office/drawing/2014/main" id="{75D4B34F-D625-40A5-AD33-B398FDA816C6}"/>
-              </a:ext>
-            </a:extLst>
-          </p:cNvPr>
-          <p:cNvSpPr>
-            <a:spLocks xmlns:a="http://schemas.openxmlformats.org/drawingml/2006/main" noGrp="1"/>
-          </p:cNvSpPr>
-          <p:nvPr/>
-        </p:nvSpPr>
-        <p:spPr>
-          <a:xfrm xmlns:a="http://schemas.openxmlformats.org/drawingml/2006/main">
-            <a:off x="609600" y="2047875"/>
-            <a:ext cx="10953750" cy="3048000"/>
-          </a:xfrm>
-          <a:prstGeom xmlns:a="http://schemas.openxmlformats.org/drawingml/2006/main" prst="rect">
-            <a:avLst/>
-          </a:prstGeom>
-          <a:noFill xmlns:a="http://schemas.openxmlformats.org/drawingml/2006/main"/>
-          <a:ln xmlns:a="http://schemas.openxmlformats.org/drawingml/2006/main" w="0">
-            <a:noFill/>
-          </a:ln>
-        </p:spPr>
-        <p:txBody>
-          <a:bodyPr xmlns:a="http://schemas.openxmlformats.org/drawingml/2006/main">
-            <a:noAutofit/>
-          </a:bodyPr>
-          <a:lstStyle xmlns:a="http://schemas.openxmlformats.org/drawingml/2006/main"/>
-          <a:p xmlns:a="http://schemas.openxmlformats.org/drawingml/2006/main">
-            <a:pPr>
-              <a:defRPr sz="2175" b="0">
-                <a:solidFill>
-                  <a:srgbClr val="EAF1FF"/>
-                </a:solidFill>
-                <a:latin typeface="Arial"/>
-                <a:ea typeface="Arial"/>
-                <a:cs typeface="Arial"/>
-              </a:defRPr>
-            </a:pPr>
-            <a:r>
-              <a:rPr sz="2175" b="0">
+                <a16:creationId xmlns:a16="http://schemas.microsoft.com/office/drawing/2014/main" id="{1A6A04FB-A72D-4FE0-8A00-7D8614511CD4}"/>
+              </a:ext>
+            </a:extLst>
+          </p:cNvPr>
+          <p:cNvSpPr>
+            <a:spLocks xmlns:a="http://schemas.openxmlformats.org/drawingml/2006/main" noGrp="1"/>
+          </p:cNvSpPr>
+          <p:nvPr/>
+        </p:nvSpPr>
+        <p:spPr>
+          <a:xfrm xmlns:a="http://schemas.openxmlformats.org/drawingml/2006/main">
+            <a:off x="609600" y="1952625"/>
+            <a:ext cx="10953750" cy="1666875"/>
+          </a:xfrm>
+          <a:prstGeom xmlns:a="http://schemas.openxmlformats.org/drawingml/2006/main" prst="rect">
+            <a:avLst/>
+          </a:prstGeom>
+          <a:noFill xmlns:a="http://schemas.openxmlformats.org/drawingml/2006/main"/>
+          <a:ln xmlns:a="http://schemas.openxmlformats.org/drawingml/2006/main" w="0">
+            <a:noFill/>
+          </a:ln>
+        </p:spPr>
+        <p:txBody>
+          <a:bodyPr xmlns:a="http://schemas.openxmlformats.org/drawingml/2006/main">
+            <a:noAutofit/>
+          </a:bodyPr>
+          <a:lstStyle xmlns:a="http://schemas.openxmlformats.org/drawingml/2006/main"/>
+          <a:p xmlns:a="http://schemas.openxmlformats.org/drawingml/2006/main">
+            <a:pPr>
+              <a:defRPr sz="2025" b="0">
+                <a:solidFill>
+                  <a:srgbClr val="EAF1FF"/>
+                </a:solidFill>
+                <a:latin typeface="Arial"/>
+                <a:ea typeface="Arial"/>
+                <a:cs typeface="Arial"/>
+              </a:defRPr>
+            </a:pPr>
+            <a:r>
+              <a:rPr sz="2025" b="0">
                 <a:solidFill>
                   <a:srgbClr val="EAF1FF"/>
                 </a:solidFill>
@@ -4160,17 +4370,17 @@
           </a:p>
           <a:p xmlns:a="http://schemas.openxmlformats.org/drawingml/2006/main">
             <a:pPr>
-              <a:defRPr sz="2175" b="0">
-                <a:solidFill>
-                  <a:srgbClr val="EAF1FF"/>
-                </a:solidFill>
-                <a:latin typeface="Arial"/>
-                <a:ea typeface="Arial"/>
-                <a:cs typeface="Arial"/>
-              </a:defRPr>
-            </a:pPr>
-            <a:r>
-              <a:rPr sz="2175" b="0">
+              <a:defRPr sz="2025" b="0">
+                <a:solidFill>
+                  <a:srgbClr val="EAF1FF"/>
+                </a:solidFill>
+                <a:latin typeface="Arial"/>
+                <a:ea typeface="Arial"/>
+                <a:cs typeface="Arial"/>
+              </a:defRPr>
+            </a:pPr>
+            <a:r>
+              <a:rPr sz="2025" b="0">
                 <a:solidFill>
                   <a:srgbClr val="EAF1FF"/>
                 </a:solidFill>
@@ -4188,19 +4398,76 @@
           <p:cNvPr id="5" name="">
             <a:extLst xmlns:a="http://schemas.openxmlformats.org/drawingml/2006/main">
               <a:ext uri="{FF2B5EF4-FFF2-40B4-BE49-F238E27FC236}">
-                <a16:creationId xmlns:a16="http://schemas.microsoft.com/office/drawing/2014/main" id="{1D0D0B61-077C-4748-B27D-D979409A0717}"/>
-              </a:ext>
-            </a:extLst>
-          </p:cNvPr>
-          <p:cNvSpPr>
-            <a:spLocks xmlns:a="http://schemas.openxmlformats.org/drawingml/2006/main" noGrp="1"/>
-          </p:cNvSpPr>
-          <p:nvPr/>
-        </p:nvSpPr>
-        <p:spPr>
-          <a:xfrm xmlns:a="http://schemas.openxmlformats.org/drawingml/2006/main">
-            <a:off x="609600" y="4048125"/>
-            <a:ext cx="10953750" cy="1095375"/>
+                <a16:creationId xmlns:a16="http://schemas.microsoft.com/office/drawing/2014/main" id="{E5659D83-7712-44AE-BD03-7A98DC68A7F6}"/>
+              </a:ext>
+            </a:extLst>
+          </p:cNvPr>
+          <p:cNvSpPr>
+            <a:spLocks xmlns:a="http://schemas.openxmlformats.org/drawingml/2006/main" noGrp="1"/>
+          </p:cNvSpPr>
+          <p:nvPr/>
+        </p:nvSpPr>
+        <p:spPr>
+          <a:xfrm xmlns:a="http://schemas.openxmlformats.org/drawingml/2006/main">
+            <a:off x="609600" y="3714750"/>
+            <a:ext cx="10953750" cy="666750"/>
+          </a:xfrm>
+          <a:prstGeom xmlns:a="http://schemas.openxmlformats.org/drawingml/2006/main" prst="rect">
+            <a:avLst/>
+          </a:prstGeom>
+          <a:noFill xmlns:a="http://schemas.openxmlformats.org/drawingml/2006/main"/>
+          <a:ln xmlns:a="http://schemas.openxmlformats.org/drawingml/2006/main" w="0">
+            <a:noFill/>
+          </a:ln>
+        </p:spPr>
+        <p:txBody>
+          <a:bodyPr xmlns:a="http://schemas.openxmlformats.org/drawingml/2006/main">
+            <a:noAutofit/>
+          </a:bodyPr>
+          <a:lstStyle xmlns:a="http://schemas.openxmlformats.org/drawingml/2006/main"/>
+          <a:p xmlns:a="http://schemas.openxmlformats.org/drawingml/2006/main">
+            <a:pPr>
+              <a:defRPr sz="2100" b="1">
+                <a:solidFill>
+                  <a:srgbClr val="89DDFF"/>
+                </a:solidFill>
+                <a:latin typeface="Arial"/>
+                <a:ea typeface="Arial"/>
+                <a:cs typeface="Arial"/>
+              </a:defRPr>
+            </a:pPr>
+            <a:r>
+              <a:rPr sz="2100" b="1">
+                <a:solidFill>
+                  <a:srgbClr val="89DDFF"/>
+                </a:solidFill>
+                <a:latin typeface="Arial"/>
+                <a:ea typeface="Arial"/>
+                <a:cs typeface="Arial"/>
+              </a:rPr>
+              <a:t>Zgjidh përgjigjen</a:t>
+            </a:r>
+          </a:p>
+        </p:txBody>
+      </p:sp>
+      <p:sp>
+        <p:nvSpPr>
+          <p:cNvPr id="6" name="">
+            <a:extLst xmlns:a="http://schemas.openxmlformats.org/drawingml/2006/main">
+              <a:ext uri="{FF2B5EF4-FFF2-40B4-BE49-F238E27FC236}">
+                <a16:creationId xmlns:a16="http://schemas.microsoft.com/office/drawing/2014/main" id="{53B1E2D1-7D58-4F35-B76F-796C96774A23}"/>
+              </a:ext>
+            </a:extLst>
+          </p:cNvPr>
+          <p:cNvSpPr>
+            <a:spLocks xmlns:a="http://schemas.openxmlformats.org/drawingml/2006/main" noGrp="1"/>
+          </p:cNvSpPr>
+          <p:nvPr/>
+        </p:nvSpPr>
+        <p:spPr>
+          <a:xfrm xmlns:a="http://schemas.openxmlformats.org/drawingml/2006/main">
+            <a:off x="609600" y="4429125"/>
+            <a:ext cx="10953750" cy="1381125"/>
           </a:xfrm>
           <a:prstGeom xmlns:a="http://schemas.openxmlformats.org/drawingml/2006/main" prst="rect">
             <a:avLst/>
@@ -4239,6 +4506,11 @@
             </a:r>
           </a:p>
           <a:p xmlns:a="http://schemas.openxmlformats.org/drawingml/2006/main">
+            <a:r>
+              <a:t/>
+            </a:r>
+          </a:p>
+          <a:p xmlns:a="http://schemas.openxmlformats.org/drawingml/2006/main">
             <a:pPr>
               <a:defRPr sz="1875" b="0">
                 <a:solidFill>
@@ -4262,6 +4534,11 @@
             </a:r>
           </a:p>
           <a:p xmlns:a="http://schemas.openxmlformats.org/drawingml/2006/main">
+            <a:r>
+              <a:t/>
+            </a:r>
+          </a:p>
+          <a:p xmlns:a="http://schemas.openxmlformats.org/drawingml/2006/main">
             <a:pPr>
               <a:defRPr sz="1875" b="0">
                 <a:solidFill>
@@ -4288,39 +4565,39 @@
       </p:sp>
       <p:sp>
         <p:nvSpPr>
-          <p:cNvPr id="6" name="">
-            <a:extLst xmlns:a="http://schemas.openxmlformats.org/drawingml/2006/main">
-              <a:ext uri="{FF2B5EF4-FFF2-40B4-BE49-F238E27FC236}">
-                <a16:creationId xmlns:a16="http://schemas.microsoft.com/office/drawing/2014/main" id="{32BF32CF-F025-4EA4-8381-B007F8A786B3}"/>
-              </a:ext>
-            </a:extLst>
-          </p:cNvPr>
-          <p:cNvSpPr>
-            <a:spLocks xmlns:a="http://schemas.openxmlformats.org/drawingml/2006/main" noGrp="1"/>
-          </p:cNvSpPr>
-          <p:nvPr/>
-        </p:nvSpPr>
-        <p:spPr>
-          <a:xfrm xmlns:a="http://schemas.openxmlformats.org/drawingml/2006/main">
-            <a:off x="609600" y="5476875"/>
-            <a:ext cx="10953750" cy="904875"/>
-          </a:xfrm>
-          <a:prstGeom xmlns:a="http://schemas.openxmlformats.org/drawingml/2006/main" prst="rect">
-            <a:avLst/>
-          </a:prstGeom>
-          <a:noFill xmlns:a="http://schemas.openxmlformats.org/drawingml/2006/main"/>
-          <a:ln xmlns:a="http://schemas.openxmlformats.org/drawingml/2006/main" w="0">
-            <a:noFill/>
-          </a:ln>
-        </p:spPr>
-        <p:txBody>
-          <a:bodyPr xmlns:a="http://schemas.openxmlformats.org/drawingml/2006/main">
-            <a:noAutofit/>
-          </a:bodyPr>
-          <a:lstStyle xmlns:a="http://schemas.openxmlformats.org/drawingml/2006/main"/>
-          <a:p xmlns:a="http://schemas.openxmlformats.org/drawingml/2006/main">
-            <a:pPr>
-              <a:defRPr sz="1800" b="0">
+          <p:cNvPr id="7" name="">
+            <a:extLst xmlns:a="http://schemas.openxmlformats.org/drawingml/2006/main">
+              <a:ext uri="{FF2B5EF4-FFF2-40B4-BE49-F238E27FC236}">
+                <a16:creationId xmlns:a16="http://schemas.microsoft.com/office/drawing/2014/main" id="{CCBA4719-7E75-43D6-9439-14D05C271D40}"/>
+              </a:ext>
+            </a:extLst>
+          </p:cNvPr>
+          <p:cNvSpPr>
+            <a:spLocks xmlns:a="http://schemas.openxmlformats.org/drawingml/2006/main" noGrp="1"/>
+          </p:cNvSpPr>
+          <p:nvPr/>
+        </p:nvSpPr>
+        <p:spPr>
+          <a:xfrm xmlns:a="http://schemas.openxmlformats.org/drawingml/2006/main">
+            <a:off x="609600" y="5905500"/>
+            <a:ext cx="10953750" cy="714375"/>
+          </a:xfrm>
+          <a:prstGeom xmlns:a="http://schemas.openxmlformats.org/drawingml/2006/main" prst="rect">
+            <a:avLst/>
+          </a:prstGeom>
+          <a:noFill xmlns:a="http://schemas.openxmlformats.org/drawingml/2006/main"/>
+          <a:ln xmlns:a="http://schemas.openxmlformats.org/drawingml/2006/main" w="0">
+            <a:noFill/>
+          </a:ln>
+        </p:spPr>
+        <p:txBody>
+          <a:bodyPr xmlns:a="http://schemas.openxmlformats.org/drawingml/2006/main">
+            <a:noAutofit/>
+          </a:bodyPr>
+          <a:lstStyle xmlns:a="http://schemas.openxmlformats.org/drawingml/2006/main"/>
+          <a:p xmlns:a="http://schemas.openxmlformats.org/drawingml/2006/main">
+            <a:pPr>
+              <a:defRPr sz="1650" b="0">
                 <a:solidFill>
                   <a:srgbClr val="8EE9D1"/>
                 </a:solidFill>
@@ -4330,7 +4607,7 @@
               </a:defRPr>
             </a:pPr>
             <a:r>
-              <a:rPr sz="1800" b="0">
+              <a:rPr sz="1650" b="0">
                 <a:solidFill>
                   <a:srgbClr val="8EE9D1"/>
                 </a:solidFill>
@@ -4346,7 +4623,7 @@
     </p:spTree>
     <p:extLst>
       <p:ext uri="{BB962C8B-B14F-4D97-AF65-F5344CB8AC3E}">
-        <p14:creationId xmlns:p14="http://schemas.microsoft.com/office/powerpoint/2010/main" val="1234658242"/>
+        <p14:creationId xmlns:p14="http://schemas.microsoft.com/office/powerpoint/2010/main" val="1336204240"/>
       </p:ext>
     </p:extLst>
   </p:cSld>
@@ -4377,7 +4654,7 @@
           <p:cNvPr id="6" name="">
             <a:extLst xmlns:a="http://schemas.openxmlformats.org/drawingml/2006/main">
               <a:ext uri="{FF2B5EF4-FFF2-40B4-BE49-F238E27FC236}">
-                <a16:creationId xmlns:a16="http://schemas.microsoft.com/office/drawing/2014/main" id="{4E885CD0-A97E-45E0-8E79-0887A4B0A0FB}"/>
+                <a16:creationId xmlns:a16="http://schemas.microsoft.com/office/drawing/2014/main" id="{37FB457C-6595-4162-B01D-68D7CE3FD0D2}"/>
               </a:ext>
             </a:extLst>
           </p:cNvPr>
@@ -4434,7 +4711,7 @@
           <p:cNvPr id="2" name="">
             <a:extLst xmlns:a="http://schemas.openxmlformats.org/drawingml/2006/main">
               <a:ext uri="{FF2B5EF4-FFF2-40B4-BE49-F238E27FC236}">
-                <a16:creationId xmlns:a16="http://schemas.microsoft.com/office/drawing/2014/main" id="{CBD403FB-EC82-4683-9B90-B890C3AF63E8}"/>
+                <a16:creationId xmlns:a16="http://schemas.microsoft.com/office/drawing/2014/main" id="{6AEDCE2F-CE9B-4EF1-B2CC-570FF3A72F8F}"/>
               </a:ext>
             </a:extLst>
           </p:cNvPr>
@@ -4491,7 +4768,7 @@
           <p:cNvPr id="3" name="">
             <a:extLst xmlns:a="http://schemas.openxmlformats.org/drawingml/2006/main">
               <a:ext uri="{FF2B5EF4-FFF2-40B4-BE49-F238E27FC236}">
-                <a16:creationId xmlns:a16="http://schemas.microsoft.com/office/drawing/2014/main" id="{55086546-0C7E-4764-A691-A0829A3BC150}"/>
+                <a16:creationId xmlns:a16="http://schemas.microsoft.com/office/drawing/2014/main" id="{3DD6D139-5924-447F-9984-EE40EB2F8644}"/>
               </a:ext>
             </a:extLst>
           </p:cNvPr>
@@ -4548,7 +4825,7 @@
           <p:cNvPr id="4" name="">
             <a:extLst xmlns:a="http://schemas.openxmlformats.org/drawingml/2006/main">
               <a:ext uri="{FF2B5EF4-FFF2-40B4-BE49-F238E27FC236}">
-                <a16:creationId xmlns:a16="http://schemas.microsoft.com/office/drawing/2014/main" id="{49577D90-C537-455E-9AC9-16B37884E130}"/>
+                <a16:creationId xmlns:a16="http://schemas.microsoft.com/office/drawing/2014/main" id="{9CEFFFF9-837D-4914-B5B5-FEB6E4B6A217}"/>
               </a:ext>
             </a:extLst>
           </p:cNvPr>
@@ -4689,7 +4966,7 @@
           <p:cNvPr id="5" name="">
             <a:extLst xmlns:a="http://schemas.openxmlformats.org/drawingml/2006/main">
               <a:ext uri="{FF2B5EF4-FFF2-40B4-BE49-F238E27FC236}">
-                <a16:creationId xmlns:a16="http://schemas.microsoft.com/office/drawing/2014/main" id="{A593FA69-7F0C-4123-8F5B-52D079DD8E05}"/>
+                <a16:creationId xmlns:a16="http://schemas.microsoft.com/office/drawing/2014/main" id="{94B92799-9667-4D3A-B4E0-1DBC3521E15A}"/>
               </a:ext>
             </a:extLst>
           </p:cNvPr>
@@ -4744,7 +5021,7 @@
     </p:spTree>
     <p:extLst>
       <p:ext uri="{BB962C8B-B14F-4D97-AF65-F5344CB8AC3E}">
-        <p14:creationId xmlns:p14="http://schemas.microsoft.com/office/powerpoint/2010/main" val="1436891095"/>
+        <p14:creationId xmlns:p14="http://schemas.microsoft.com/office/powerpoint/2010/main" val="1165277424"/>
       </p:ext>
     </p:extLst>
   </p:cSld>
@@ -4775,7 +5052,7 @@
           <p:cNvPr id="5" name="">
             <a:extLst xmlns:a="http://schemas.openxmlformats.org/drawingml/2006/main">
               <a:ext uri="{FF2B5EF4-FFF2-40B4-BE49-F238E27FC236}">
-                <a16:creationId xmlns:a16="http://schemas.microsoft.com/office/drawing/2014/main" id="{3BDD66FE-6F39-4179-8532-D70D00EFC805}"/>
+                <a16:creationId xmlns:a16="http://schemas.microsoft.com/office/drawing/2014/main" id="{75BF7304-5E49-45EA-8597-87DFA6E008A0}"/>
               </a:ext>
             </a:extLst>
           </p:cNvPr>
@@ -4832,7 +5109,7 @@
           <p:cNvPr id="2" name="">
             <a:extLst xmlns:a="http://schemas.openxmlformats.org/drawingml/2006/main">
               <a:ext uri="{FF2B5EF4-FFF2-40B4-BE49-F238E27FC236}">
-                <a16:creationId xmlns:a16="http://schemas.microsoft.com/office/drawing/2014/main" id="{B4D9A819-212D-46A5-AF15-69158AA40C48}"/>
+                <a16:creationId xmlns:a16="http://schemas.microsoft.com/office/drawing/2014/main" id="{C4FEE152-F971-4BA9-9257-CA6D6FB6CD7F}"/>
               </a:ext>
             </a:extLst>
           </p:cNvPr>
@@ -4889,7 +5166,7 @@
           <p:cNvPr id="3" name="">
             <a:extLst xmlns:a="http://schemas.openxmlformats.org/drawingml/2006/main">
               <a:ext uri="{FF2B5EF4-FFF2-40B4-BE49-F238E27FC236}">
-                <a16:creationId xmlns:a16="http://schemas.microsoft.com/office/drawing/2014/main" id="{80F852C1-A0F1-48AD-BB09-CCFA4089F71F}"/>
+                <a16:creationId xmlns:a16="http://schemas.microsoft.com/office/drawing/2014/main" id="{9BE8BB21-9725-4B7C-91E8-06C285DF3D1C}"/>
               </a:ext>
             </a:extLst>
           </p:cNvPr>
@@ -4946,7 +5223,7 @@
           <p:cNvPr id="4" name="">
             <a:extLst xmlns:a="http://schemas.openxmlformats.org/drawingml/2006/main">
               <a:ext uri="{FF2B5EF4-FFF2-40B4-BE49-F238E27FC236}">
-                <a16:creationId xmlns:a16="http://schemas.microsoft.com/office/drawing/2014/main" id="{51BE5D98-E072-4C3F-9B93-02B3DD4887D0}"/>
+                <a16:creationId xmlns:a16="http://schemas.microsoft.com/office/drawing/2014/main" id="{AFAD5CB0-8C38-4CF3-9F6E-ECB765C446B0}"/>
               </a:ext>
             </a:extLst>
           </p:cNvPr>
@@ -5085,7 +5362,7 @@
     </p:spTree>
     <p:extLst>
       <p:ext uri="{BB962C8B-B14F-4D97-AF65-F5344CB8AC3E}">
-        <p14:creationId xmlns:p14="http://schemas.microsoft.com/office/powerpoint/2010/main" val="1544480383"/>
+        <p14:creationId xmlns:p14="http://schemas.microsoft.com/office/powerpoint/2010/main" val="135406597"/>
       </p:ext>
     </p:extLst>
   </p:cSld>
@@ -5113,10 +5390,10 @@
       </p:grpSpPr>
       <p:sp>
         <p:nvSpPr>
-          <p:cNvPr id="6" name="">
-            <a:extLst xmlns:a="http://schemas.openxmlformats.org/drawingml/2006/main">
-              <a:ext uri="{FF2B5EF4-FFF2-40B4-BE49-F238E27FC236}">
-                <a16:creationId xmlns:a16="http://schemas.microsoft.com/office/drawing/2014/main" id="{5A79F09B-DFDD-493B-A532-2A0AAFABE6EE}"/>
+          <p:cNvPr id="8" name="">
+            <a:extLst xmlns:a="http://schemas.openxmlformats.org/drawingml/2006/main">
+              <a:ext uri="{FF2B5EF4-FFF2-40B4-BE49-F238E27FC236}">
+                <a16:creationId xmlns:a16="http://schemas.microsoft.com/office/drawing/2014/main" id="{2D0C2B6C-F74C-46E9-9E31-6C12DC0E17E3}"/>
               </a:ext>
             </a:extLst>
           </p:cNvPr>
@@ -5163,7 +5440,7 @@
                 <a:ea typeface="Arial"/>
                 <a:cs typeface="Arial"/>
               </a:rPr>
-              <a:t>PROBLEMI · 0–5 MIN</a:t>
+              <a:t>RIKUJTIM NË ÇIFT · 2–4 MIN</a:t>
             </a:r>
           </a:p>
         </p:txBody>
@@ -5173,7 +5450,7 @@
           <p:cNvPr id="2" name="">
             <a:extLst xmlns:a="http://schemas.openxmlformats.org/drawingml/2006/main">
               <a:ext uri="{FF2B5EF4-FFF2-40B4-BE49-F238E27FC236}">
-                <a16:creationId xmlns:a16="http://schemas.microsoft.com/office/drawing/2014/main" id="{EC65AE90-35AB-43EB-932A-939659AE5BEE}"/>
+                <a16:creationId xmlns:a16="http://schemas.microsoft.com/office/drawing/2014/main" id="{4C01D2FA-BAFF-46BE-91E7-87F98F843731}"/>
               </a:ext>
             </a:extLst>
           </p:cNvPr>
@@ -5230,7 +5507,7 @@
           <p:cNvPr id="3" name="">
             <a:extLst xmlns:a="http://schemas.openxmlformats.org/drawingml/2006/main">
               <a:ext uri="{FF2B5EF4-FFF2-40B4-BE49-F238E27FC236}">
-                <a16:creationId xmlns:a16="http://schemas.microsoft.com/office/drawing/2014/main" id="{1F3F8DAB-5ED7-4123-880B-C0C684339BD8}"/>
+                <a16:creationId xmlns:a16="http://schemas.microsoft.com/office/drawing/2014/main" id="{E1EF9082-F241-4343-A1D4-4082DC3684F1}"/>
               </a:ext>
             </a:extLst>
           </p:cNvPr>
@@ -5277,7 +5554,7 @@
                 <a:ea typeface="Arial"/>
                 <a:cs typeface="Arial"/>
               </a:rPr>
-              <a:t>Shoferi ndryshon orën</a:t>
+              <a:t>Çfarë kemi tashmë nga Java 3?</a:t>
             </a:r>
           </a:p>
         </p:txBody>
@@ -5287,54 +5564,54 @@
           <p:cNvPr id="4" name="">
             <a:extLst xmlns:a="http://schemas.openxmlformats.org/drawingml/2006/main">
               <a:ext uri="{FF2B5EF4-FFF2-40B4-BE49-F238E27FC236}">
-                <a16:creationId xmlns:a16="http://schemas.microsoft.com/office/drawing/2014/main" id="{0FAACD14-520A-4272-BE4C-2B8219168873}"/>
-              </a:ext>
-            </a:extLst>
-          </p:cNvPr>
-          <p:cNvSpPr>
-            <a:spLocks xmlns:a="http://schemas.openxmlformats.org/drawingml/2006/main" noGrp="1"/>
-          </p:cNvSpPr>
-          <p:nvPr/>
-        </p:nvSpPr>
-        <p:spPr>
-          <a:xfrm xmlns:a="http://schemas.openxmlformats.org/drawingml/2006/main">
-            <a:off x="609600" y="2047875"/>
-            <a:ext cx="10953750" cy="3048000"/>
-          </a:xfrm>
-          <a:prstGeom xmlns:a="http://schemas.openxmlformats.org/drawingml/2006/main" prst="rect">
-            <a:avLst/>
-          </a:prstGeom>
-          <a:noFill xmlns:a="http://schemas.openxmlformats.org/drawingml/2006/main"/>
-          <a:ln xmlns:a="http://schemas.openxmlformats.org/drawingml/2006/main" w="0">
-            <a:noFill/>
-          </a:ln>
-        </p:spPr>
-        <p:txBody>
-          <a:bodyPr xmlns:a="http://schemas.openxmlformats.org/drawingml/2006/main">
-            <a:noAutofit/>
-          </a:bodyPr>
-          <a:lstStyle xmlns:a="http://schemas.openxmlformats.org/drawingml/2006/main"/>
-          <a:p xmlns:a="http://schemas.openxmlformats.org/drawingml/2006/main">
-            <a:pPr>
-              <a:defRPr sz="2175" b="0">
-                <a:solidFill>
-                  <a:srgbClr val="EAF1FF"/>
-                </a:solidFill>
-                <a:latin typeface="Arial"/>
-                <a:ea typeface="Arial"/>
-                <a:cs typeface="Arial"/>
-              </a:defRPr>
-            </a:pPr>
-            <a:r>
-              <a:rPr sz="2175" b="0">
-                <a:solidFill>
-                  <a:srgbClr val="EAF1FF"/>
-                </a:solidFill>
-                <a:latin typeface="Arial"/>
-                <a:ea typeface="Arial"/>
-                <a:cs typeface="Arial"/>
-              </a:rPr>
-              <a:t>Arta zgjodhi udhëtimin e orës 08:15. Shoferi e ndryshon nisjen në 08:25.</a:t>
+                <a16:creationId xmlns:a16="http://schemas.microsoft.com/office/drawing/2014/main" id="{585EBA06-D073-4BBE-B2F6-DA3546A109C7}"/>
+              </a:ext>
+            </a:extLst>
+          </p:cNvPr>
+          <p:cNvSpPr>
+            <a:spLocks xmlns:a="http://schemas.openxmlformats.org/drawingml/2006/main" noGrp="1"/>
+          </p:cNvSpPr>
+          <p:nvPr/>
+        </p:nvSpPr>
+        <p:spPr>
+          <a:xfrm xmlns:a="http://schemas.openxmlformats.org/drawingml/2006/main">
+            <a:off x="609600" y="1952625"/>
+            <a:ext cx="10953750" cy="1666875"/>
+          </a:xfrm>
+          <a:prstGeom xmlns:a="http://schemas.openxmlformats.org/drawingml/2006/main" prst="rect">
+            <a:avLst/>
+          </a:prstGeom>
+          <a:noFill xmlns:a="http://schemas.openxmlformats.org/drawingml/2006/main"/>
+          <a:ln xmlns:a="http://schemas.openxmlformats.org/drawingml/2006/main" w="0">
+            <a:noFill/>
+          </a:ln>
+        </p:spPr>
+        <p:txBody>
+          <a:bodyPr xmlns:a="http://schemas.openxmlformats.org/drawingml/2006/main">
+            <a:noAutofit/>
+          </a:bodyPr>
+          <a:lstStyle xmlns:a="http://schemas.openxmlformats.org/drawingml/2006/main"/>
+          <a:p xmlns:a="http://schemas.openxmlformats.org/drawingml/2006/main">
+            <a:pPr>
+              <a:defRPr sz="2025" b="0">
+                <a:solidFill>
+                  <a:srgbClr val="EAF1FF"/>
+                </a:solidFill>
+                <a:latin typeface="Arial"/>
+                <a:ea typeface="Arial"/>
+                <a:cs typeface="Arial"/>
+              </a:defRPr>
+            </a:pPr>
+            <a:r>
+              <a:rPr sz="2025" b="0">
+                <a:solidFill>
+                  <a:srgbClr val="EAF1FF"/>
+                </a:solidFill>
+                <a:latin typeface="Arial"/>
+                <a:ea typeface="Arial"/>
+                <a:cs typeface="Arial"/>
+              </a:rPr>
+              <a:t>KartaUdhetimi shfaq udhëtimin. Lista hap detajet dhe simulimin e kërkesës.</a:t>
             </a:r>
           </a:p>
           <a:p xmlns:a="http://schemas.openxmlformats.org/drawingml/2006/main">
@@ -5344,25 +5621,139 @@
           </a:p>
           <a:p xmlns:a="http://schemas.openxmlformats.org/drawingml/2006/main">
             <a:pPr>
-              <a:defRPr sz="2175" b="0">
-                <a:solidFill>
-                  <a:srgbClr val="EAF1FF"/>
-                </a:solidFill>
-                <a:latin typeface="Arial"/>
-                <a:ea typeface="Arial"/>
-                <a:cs typeface="Arial"/>
-              </a:defRPr>
-            </a:pPr>
-            <a:r>
-              <a:rPr sz="2175" b="0">
-                <a:solidFill>
-                  <a:srgbClr val="EAF1FF"/>
-                </a:solidFill>
-                <a:latin typeface="Arial"/>
-                <a:ea typeface="Arial"/>
-                <a:cs typeface="Arial"/>
-              </a:rPr>
-              <a:t>Parashiko: ku duhet të shihet ora e re — në kartë, në detaje apo në të dyja?</a:t>
+              <a:defRPr sz="2025" b="0">
+                <a:solidFill>
+                  <a:srgbClr val="EAF1FF"/>
+                </a:solidFill>
+                <a:latin typeface="Arial"/>
+                <a:ea typeface="Arial"/>
+                <a:cs typeface="Arial"/>
+              </a:defRPr>
+            </a:pPr>
+            <a:r>
+              <a:rPr sz="2025" b="0">
+                <a:solidFill>
+                  <a:srgbClr val="EAF1FF"/>
+                </a:solidFill>
+                <a:latin typeface="Arial"/>
+                <a:ea typeface="Arial"/>
+                <a:cs typeface="Arial"/>
+              </a:rPr>
+              <a:t>Njëri shpjegon rrugën mes ekraneve, tjetri kujton burimin e të dhënave. Pastaj ndërroni rolet.</a:t>
+            </a:r>
+          </a:p>
+        </p:txBody>
+      </p:sp>
+      <p:sp>
+        <p:nvSpPr>
+          <p:cNvPr id="5" name="">
+            <a:extLst xmlns:a="http://schemas.openxmlformats.org/drawingml/2006/main">
+              <a:ext uri="{FF2B5EF4-FFF2-40B4-BE49-F238E27FC236}">
+                <a16:creationId xmlns:a16="http://schemas.microsoft.com/office/drawing/2014/main" id="{1A23E905-C2C3-4018-B821-80D3A86F3A7E}"/>
+              </a:ext>
+            </a:extLst>
+          </p:cNvPr>
+          <p:cNvSpPr>
+            <a:spLocks xmlns:a="http://schemas.openxmlformats.org/drawingml/2006/main" noGrp="1"/>
+          </p:cNvSpPr>
+          <p:nvPr/>
+        </p:nvSpPr>
+        <p:spPr>
+          <a:xfrm xmlns:a="http://schemas.openxmlformats.org/drawingml/2006/main">
+            <a:off x="609600" y="3714750"/>
+            <a:ext cx="10953750" cy="666750"/>
+          </a:xfrm>
+          <a:prstGeom xmlns:a="http://schemas.openxmlformats.org/drawingml/2006/main" prst="rect">
+            <a:avLst/>
+          </a:prstGeom>
+          <a:noFill xmlns:a="http://schemas.openxmlformats.org/drawingml/2006/main"/>
+          <a:ln xmlns:a="http://schemas.openxmlformats.org/drawingml/2006/main" w="0">
+            <a:noFill/>
+          </a:ln>
+        </p:spPr>
+        <p:txBody>
+          <a:bodyPr xmlns:a="http://schemas.openxmlformats.org/drawingml/2006/main">
+            <a:noAutofit/>
+          </a:bodyPr>
+          <a:lstStyle xmlns:a="http://schemas.openxmlformats.org/drawingml/2006/main"/>
+          <a:p xmlns:a="http://schemas.openxmlformats.org/drawingml/2006/main">
+            <a:pPr>
+              <a:defRPr sz="2100" b="1">
+                <a:solidFill>
+                  <a:srgbClr val="89DDFF"/>
+                </a:solidFill>
+                <a:latin typeface="Arial"/>
+                <a:ea typeface="Arial"/>
+                <a:cs typeface="Arial"/>
+              </a:defRPr>
+            </a:pPr>
+            <a:r>
+              <a:rPr sz="2100" b="1">
+                <a:solidFill>
+                  <a:srgbClr val="89DDFF"/>
+                </a:solidFill>
+                <a:latin typeface="Arial"/>
+                <a:ea typeface="Arial"/>
+                <a:cs typeface="Arial"/>
+              </a:rPr>
+              <a:t>Ku ruheshin udhëtimet në shembullin e Javës 3?</a:t>
+            </a:r>
+          </a:p>
+        </p:txBody>
+      </p:sp>
+      <p:sp>
+        <p:nvSpPr>
+          <p:cNvPr id="6" name="">
+            <a:extLst xmlns:a="http://schemas.openxmlformats.org/drawingml/2006/main">
+              <a:ext uri="{FF2B5EF4-FFF2-40B4-BE49-F238E27FC236}">
+                <a16:creationId xmlns:a16="http://schemas.microsoft.com/office/drawing/2014/main" id="{41383627-44AE-43A4-BCEC-6AB038DC8504}"/>
+              </a:ext>
+            </a:extLst>
+          </p:cNvPr>
+          <p:cNvSpPr>
+            <a:spLocks xmlns:a="http://schemas.openxmlformats.org/drawingml/2006/main" noGrp="1"/>
+          </p:cNvSpPr>
+          <p:nvPr/>
+        </p:nvSpPr>
+        <p:spPr>
+          <a:xfrm xmlns:a="http://schemas.openxmlformats.org/drawingml/2006/main">
+            <a:off x="609600" y="4429125"/>
+            <a:ext cx="10953750" cy="1381125"/>
+          </a:xfrm>
+          <a:prstGeom xmlns:a="http://schemas.openxmlformats.org/drawingml/2006/main" prst="rect">
+            <a:avLst/>
+          </a:prstGeom>
+          <a:noFill xmlns:a="http://schemas.openxmlformats.org/drawingml/2006/main"/>
+          <a:ln xmlns:a="http://schemas.openxmlformats.org/drawingml/2006/main" w="0">
+            <a:noFill/>
+          </a:ln>
+        </p:spPr>
+        <p:txBody>
+          <a:bodyPr xmlns:a="http://schemas.openxmlformats.org/drawingml/2006/main">
+            <a:noAutofit/>
+          </a:bodyPr>
+          <a:lstStyle xmlns:a="http://schemas.openxmlformats.org/drawingml/2006/main"/>
+          <a:p xmlns:a="http://schemas.openxmlformats.org/drawingml/2006/main">
+            <a:pPr>
+              <a:defRPr sz="1875" b="0">
+                <a:solidFill>
+                  <a:srgbClr val="EAF1FF"/>
+                </a:solidFill>
+                <a:latin typeface="Arial"/>
+                <a:ea typeface="Arial"/>
+                <a:cs typeface="Arial"/>
+              </a:defRPr>
+            </a:pPr>
+            <a:r>
+              <a:rPr sz="1875" b="0">
+                <a:solidFill>
+                  <a:srgbClr val="EAF1FF"/>
+                </a:solidFill>
+                <a:latin typeface="Arial"/>
+                <a:ea typeface="Arial"/>
+                <a:cs typeface="Arial"/>
+              </a:rPr>
+              <a:t>A · Në një varg të të dhënave brenda kodit.</a:t>
             </a:r>
           </a:p>
           <a:p xmlns:a="http://schemas.openxmlformats.org/drawingml/2006/main">
@@ -5372,64 +5763,92 @@
           </a:p>
           <a:p xmlns:a="http://schemas.openxmlformats.org/drawingml/2006/main">
             <a:pPr>
-              <a:defRPr sz="2175" b="0">
-                <a:solidFill>
-                  <a:srgbClr val="EAF1FF"/>
-                </a:solidFill>
-                <a:latin typeface="Arial"/>
-                <a:ea typeface="Arial"/>
-                <a:cs typeface="Arial"/>
-              </a:defRPr>
-            </a:pPr>
-            <a:r>
-              <a:rPr sz="2175" b="0">
-                <a:solidFill>
-                  <a:srgbClr val="EAF1FF"/>
-                </a:solidFill>
-                <a:latin typeface="Arial"/>
-                <a:ea typeface="Arial"/>
-                <a:cs typeface="Arial"/>
-              </a:rPr>
-              <a:t>Diskuto me personin pranë teje për 20 sekonda; pastaj zbulojmë përgjigjen.</a:t>
-            </a:r>
-          </a:p>
-        </p:txBody>
-      </p:sp>
-      <p:sp>
-        <p:nvSpPr>
-          <p:cNvPr id="5" name="">
-            <a:extLst xmlns:a="http://schemas.openxmlformats.org/drawingml/2006/main">
-              <a:ext uri="{FF2B5EF4-FFF2-40B4-BE49-F238E27FC236}">
-                <a16:creationId xmlns:a16="http://schemas.microsoft.com/office/drawing/2014/main" id="{9A04E0D6-CC71-4754-9839-FEEA49D76CF1}"/>
-              </a:ext>
-            </a:extLst>
-          </p:cNvPr>
-          <p:cNvSpPr>
-            <a:spLocks xmlns:a="http://schemas.openxmlformats.org/drawingml/2006/main" noGrp="1"/>
-          </p:cNvSpPr>
-          <p:nvPr/>
-        </p:nvSpPr>
-        <p:spPr>
-          <a:xfrm xmlns:a="http://schemas.openxmlformats.org/drawingml/2006/main">
-            <a:off x="609600" y="5334000"/>
-            <a:ext cx="10953750" cy="1095375"/>
-          </a:xfrm>
-          <a:prstGeom xmlns:a="http://schemas.openxmlformats.org/drawingml/2006/main" prst="rect">
-            <a:avLst/>
-          </a:prstGeom>
-          <a:noFill xmlns:a="http://schemas.openxmlformats.org/drawingml/2006/main"/>
-          <a:ln xmlns:a="http://schemas.openxmlformats.org/drawingml/2006/main" w="0">
-            <a:noFill/>
-          </a:ln>
-        </p:spPr>
-        <p:txBody>
-          <a:bodyPr xmlns:a="http://schemas.openxmlformats.org/drawingml/2006/main">
-            <a:noAutofit/>
-          </a:bodyPr>
-          <a:lstStyle xmlns:a="http://schemas.openxmlformats.org/drawingml/2006/main"/>
-          <a:p xmlns:a="http://schemas.openxmlformats.org/drawingml/2006/main">
-            <a:pPr>
-              <a:defRPr sz="1800" b="0">
+              <a:defRPr sz="1875" b="0">
+                <a:solidFill>
+                  <a:srgbClr val="EAF1FF"/>
+                </a:solidFill>
+                <a:latin typeface="Arial"/>
+                <a:ea typeface="Arial"/>
+                <a:cs typeface="Arial"/>
+              </a:defRPr>
+            </a:pPr>
+            <a:r>
+              <a:rPr sz="1875" b="0">
+                <a:solidFill>
+                  <a:srgbClr val="EAF1FF"/>
+                </a:solidFill>
+                <a:latin typeface="Arial"/>
+                <a:ea typeface="Arial"/>
+                <a:cs typeface="Arial"/>
+              </a:rPr>
+              <a:t>B · Në databazën Neon.</a:t>
+            </a:r>
+          </a:p>
+          <a:p xmlns:a="http://schemas.openxmlformats.org/drawingml/2006/main">
+            <a:r>
+              <a:t/>
+            </a:r>
+          </a:p>
+          <a:p xmlns:a="http://schemas.openxmlformats.org/drawingml/2006/main">
+            <a:pPr>
+              <a:defRPr sz="1875" b="0">
+                <a:solidFill>
+                  <a:srgbClr val="EAF1FF"/>
+                </a:solidFill>
+                <a:latin typeface="Arial"/>
+                <a:ea typeface="Arial"/>
+                <a:cs typeface="Arial"/>
+              </a:defRPr>
+            </a:pPr>
+            <a:r>
+              <a:rPr sz="1875" b="0">
+                <a:solidFill>
+                  <a:srgbClr val="EAF1FF"/>
+                </a:solidFill>
+                <a:latin typeface="Arial"/>
+                <a:ea typeface="Arial"/>
+                <a:cs typeface="Arial"/>
+              </a:rPr>
+              <a:t>C · Te GitHub Issues.</a:t>
+            </a:r>
+          </a:p>
+        </p:txBody>
+      </p:sp>
+      <p:sp>
+        <p:nvSpPr>
+          <p:cNvPr id="7" name="">
+            <a:extLst xmlns:a="http://schemas.openxmlformats.org/drawingml/2006/main">
+              <a:ext uri="{FF2B5EF4-FFF2-40B4-BE49-F238E27FC236}">
+                <a16:creationId xmlns:a16="http://schemas.microsoft.com/office/drawing/2014/main" id="{CDF1EB9D-1D14-47AD-A5C3-35B0C30AEA1B}"/>
+              </a:ext>
+            </a:extLst>
+          </p:cNvPr>
+          <p:cNvSpPr>
+            <a:spLocks xmlns:a="http://schemas.openxmlformats.org/drawingml/2006/main" noGrp="1"/>
+          </p:cNvSpPr>
+          <p:nvPr/>
+        </p:nvSpPr>
+        <p:spPr>
+          <a:xfrm xmlns:a="http://schemas.openxmlformats.org/drawingml/2006/main">
+            <a:off x="609600" y="5953125"/>
+            <a:ext cx="10953750" cy="381000"/>
+          </a:xfrm>
+          <a:prstGeom xmlns:a="http://schemas.openxmlformats.org/drawingml/2006/main" prst="rect">
+            <a:avLst/>
+          </a:prstGeom>
+          <a:noFill xmlns:a="http://schemas.openxmlformats.org/drawingml/2006/main"/>
+          <a:ln xmlns:a="http://schemas.openxmlformats.org/drawingml/2006/main" w="0">
+            <a:noFill/>
+          </a:ln>
+        </p:spPr>
+        <p:txBody>
+          <a:bodyPr xmlns:a="http://schemas.openxmlformats.org/drawingml/2006/main">
+            <a:noAutofit/>
+          </a:bodyPr>
+          <a:lstStyle xmlns:a="http://schemas.openxmlformats.org/drawingml/2006/main"/>
+          <a:p xmlns:a="http://schemas.openxmlformats.org/drawingml/2006/main">
+            <a:pPr>
+              <a:defRPr sz="1650" b="0">
                 <a:solidFill>
                   <a:srgbClr val="8EE9D1"/>
                 </a:solidFill>
@@ -5439,7 +5858,7 @@
               </a:defRPr>
             </a:pPr>
             <a:r>
-              <a:rPr sz="1800" b="0">
+              <a:rPr sz="1650" b="0">
                 <a:solidFill>
                   <a:srgbClr val="8EE9D1"/>
                 </a:solidFill>
@@ -5447,7 +5866,7 @@
                 <a:ea typeface="Arial"/>
                 <a:cs typeface="Arial"/>
               </a:rPr>
-              <a:t>Përgjigjja: Në të dyja. Ora është e dhënë: e ndryshojmë një herë në databazë dhe të dy ekranet e lexojnë përsëri.</a:t>
+              <a:t>Votoni, krahasoni arsyetimet dhe hapni përgjigjen në versionin interaktiv.</a:t>
             </a:r>
           </a:p>
         </p:txBody>
@@ -5455,7 +5874,7 @@
     </p:spTree>
     <p:extLst>
       <p:ext uri="{BB962C8B-B14F-4D97-AF65-F5344CB8AC3E}">
-        <p14:creationId xmlns:p14="http://schemas.microsoft.com/office/powerpoint/2010/main" val="1356938526"/>
+        <p14:creationId xmlns:p14="http://schemas.microsoft.com/office/powerpoint/2010/main" val="1449631613"/>
       </p:ext>
     </p:extLst>
   </p:cSld>
@@ -5483,10 +5902,10 @@
       </p:grpSpPr>
       <p:sp>
         <p:nvSpPr>
-          <p:cNvPr id="6" name="">
-            <a:extLst xmlns:a="http://schemas.openxmlformats.org/drawingml/2006/main">
-              <a:ext uri="{FF2B5EF4-FFF2-40B4-BE49-F238E27FC236}">
-                <a16:creationId xmlns:a16="http://schemas.microsoft.com/office/drawing/2014/main" id="{66F01156-58D7-4974-B21F-5D6E08E638E0}"/>
+          <p:cNvPr id="7" name="">
+            <a:extLst xmlns:a="http://schemas.openxmlformats.org/drawingml/2006/main">
+              <a:ext uri="{FF2B5EF4-FFF2-40B4-BE49-F238E27FC236}">
+                <a16:creationId xmlns:a16="http://schemas.microsoft.com/office/drawing/2014/main" id="{23B75887-EEB9-4961-B602-CCAF47B994D7}"/>
               </a:ext>
             </a:extLst>
           </p:cNvPr>
@@ -5533,7 +5952,7 @@
                 <a:ea typeface="Arial"/>
                 <a:cs typeface="Arial"/>
               </a:rPr>
-              <a:t>VAZHDIMI</a:t>
+              <a:t>SYNIMI I JAVËS 4 · HARTA E APLIKACIONIT</a:t>
             </a:r>
           </a:p>
         </p:txBody>
@@ -5543,7 +5962,7 @@
           <p:cNvPr id="2" name="">
             <a:extLst xmlns:a="http://schemas.openxmlformats.org/drawingml/2006/main">
               <a:ext uri="{FF2B5EF4-FFF2-40B4-BE49-F238E27FC236}">
-                <a16:creationId xmlns:a16="http://schemas.microsoft.com/office/drawing/2014/main" id="{FA0D1CDD-4D61-48FE-8463-080362EFCDBF}"/>
+                <a16:creationId xmlns:a16="http://schemas.microsoft.com/office/drawing/2014/main" id="{BB3DE64C-D787-49FF-9202-F9BF145D1046}"/>
               </a:ext>
             </a:extLst>
           </p:cNvPr>
@@ -5595,24 +6014,46 @@
           </a:p>
         </p:txBody>
       </p:sp>
-      <p:sp>
-        <p:nvSpPr>
-          <p:cNvPr id="3" name="">
-            <a:extLst xmlns:a="http://schemas.openxmlformats.org/drawingml/2006/main">
-              <a:ext uri="{FF2B5EF4-FFF2-40B4-BE49-F238E27FC236}">
-                <a16:creationId xmlns:a16="http://schemas.microsoft.com/office/drawing/2014/main" id="{B93BD3CD-C46F-4328-BC48-A74BAE2FB25B}"/>
-              </a:ext>
-            </a:extLst>
-          </p:cNvPr>
-          <p:cNvSpPr>
-            <a:spLocks xmlns:a="http://schemas.openxmlformats.org/drawingml/2006/main" noGrp="1"/>
-          </p:cNvSpPr>
-          <p:nvPr/>
-        </p:nvSpPr>
-        <p:spPr>
-          <a:xfrm xmlns:a="http://schemas.openxmlformats.org/drawingml/2006/main">
-            <a:off x="609600" y="933450"/>
-            <a:ext cx="10953750" cy="952500"/>
+      <p:pic>
+        <p:nvPicPr>
+          <p:cNvPr id="9" name=""/>
+          <p:cNvPicPr>
+            <a:picLocks xmlns:a="http://schemas.openxmlformats.org/drawingml/2006/main" noChangeAspect="1"/>
+          </p:cNvPicPr>
+          <p:nvPr/>
+        </p:nvPicPr>
+        <p:blipFill>
+          <a:blip xmlns:r="http://schemas.openxmlformats.org/officeDocument/2006/relationships" xmlns:a="http://schemas.openxmlformats.org/drawingml/2006/main" r:embed="Rd383b8d15d204db9"/>
+          <a:stretch xmlns:a="http://schemas.openxmlformats.org/drawingml/2006/main"/>
+        </p:blipFill>
+        <p:spPr>
+          <a:xfrm xmlns:a="http://schemas.openxmlformats.org/drawingml/2006/main">
+            <a:off x="10287000" y="925435"/>
+            <a:ext cx="1238250" cy="244630"/>
+          </a:xfrm>
+          <a:prstGeom xmlns:a="http://schemas.openxmlformats.org/drawingml/2006/main" prst="rect">
+            <a:avLst/>
+          </a:prstGeom>
+        </p:spPr>
+      </p:pic>
+      <p:sp>
+        <p:nvSpPr>
+          <p:cNvPr id="4" name="">
+            <a:extLst xmlns:a="http://schemas.openxmlformats.org/drawingml/2006/main">
+              <a:ext uri="{FF2B5EF4-FFF2-40B4-BE49-F238E27FC236}">
+                <a16:creationId xmlns:a16="http://schemas.microsoft.com/office/drawing/2014/main" id="{DA58086E-DEF6-4C08-8185-4EBA6D44F98B}"/>
+              </a:ext>
+            </a:extLst>
+          </p:cNvPr>
+          <p:cNvSpPr>
+            <a:spLocks xmlns:a="http://schemas.openxmlformats.org/drawingml/2006/main" noGrp="1"/>
+          </p:cNvSpPr>
+          <p:nvPr/>
+        </p:nvSpPr>
+        <p:spPr>
+          <a:xfrm xmlns:a="http://schemas.openxmlformats.org/drawingml/2006/main">
+            <a:off x="609600" y="857250"/>
+            <a:ext cx="9429750" cy="714375"/>
           </a:xfrm>
           <a:prstGeom xmlns:a="http://schemas.openxmlformats.org/drawingml/2006/main" prst="rect">
             <a:avLst/>
@@ -5647,200 +6088,109 @@
                 <a:ea typeface="Arial"/>
                 <a:cs typeface="Arial"/>
               </a:rPr>
-              <a:t>Çfarë mbajmë nga Java 3</a:t>
-            </a:r>
-          </a:p>
-        </p:txBody>
-      </p:sp>
-      <p:sp>
-        <p:nvSpPr>
-          <p:cNvPr id="4" name="">
-            <a:extLst xmlns:a="http://schemas.openxmlformats.org/drawingml/2006/main">
-              <a:ext uri="{FF2B5EF4-FFF2-40B4-BE49-F238E27FC236}">
-                <a16:creationId xmlns:a16="http://schemas.microsoft.com/office/drawing/2014/main" id="{1B189C31-7981-4390-9DCD-88E20DA50359}"/>
-              </a:ext>
-            </a:extLst>
-          </p:cNvPr>
-          <p:cNvSpPr>
-            <a:spLocks xmlns:a="http://schemas.openxmlformats.org/drawingml/2006/main" noGrp="1"/>
-          </p:cNvSpPr>
-          <p:nvPr/>
-        </p:nvSpPr>
-        <p:spPr>
-          <a:xfrm xmlns:a="http://schemas.openxmlformats.org/drawingml/2006/main">
-            <a:off x="609600" y="2047875"/>
-            <a:ext cx="10953750" cy="2333625"/>
-          </a:xfrm>
-          <a:prstGeom xmlns:a="http://schemas.openxmlformats.org/drawingml/2006/main" prst="rect">
-            <a:avLst/>
-          </a:prstGeom>
-          <a:noFill xmlns:a="http://schemas.openxmlformats.org/drawingml/2006/main"/>
-          <a:ln xmlns:a="http://schemas.openxmlformats.org/drawingml/2006/main" w="0">
-            <a:noFill/>
-          </a:ln>
-        </p:spPr>
-        <p:txBody>
-          <a:bodyPr xmlns:a="http://schemas.openxmlformats.org/drawingml/2006/main">
-            <a:noAutofit/>
-          </a:bodyPr>
-          <a:lstStyle xmlns:a="http://schemas.openxmlformats.org/drawingml/2006/main"/>
-          <a:p xmlns:a="http://schemas.openxmlformats.org/drawingml/2006/main">
-            <a:pPr>
-              <a:defRPr sz="1950" b="0">
-                <a:solidFill>
-                  <a:srgbClr val="EAF1FF"/>
-                </a:solidFill>
-                <a:latin typeface="Arial"/>
-                <a:ea typeface="Arial"/>
-                <a:cs typeface="Arial"/>
-              </a:defRPr>
-            </a:pPr>
-            <a:r>
-              <a:rPr sz="1950" b="0">
-                <a:solidFill>
-                  <a:srgbClr val="EAF1FF"/>
-                </a:solidFill>
-                <a:latin typeface="Arial"/>
-                <a:ea typeface="Arial"/>
-                <a:cs typeface="Arial"/>
-              </a:rPr>
-              <a:t>Tri kartat, komponenti KartaUdhetimi dhe adresat mbeten.</a:t>
-            </a:r>
-          </a:p>
-          <a:p xmlns:a="http://schemas.openxmlformats.org/drawingml/2006/main">
-            <a:r>
-              <a:t/>
-            </a:r>
-          </a:p>
-          <a:p xmlns:a="http://schemas.openxmlformats.org/drawingml/2006/main">
-            <a:pPr>
-              <a:defRPr sz="1950" b="0">
-                <a:solidFill>
-                  <a:srgbClr val="EAF1FF"/>
-                </a:solidFill>
-                <a:latin typeface="Arial"/>
-                <a:ea typeface="Arial"/>
-                <a:cs typeface="Arial"/>
-              </a:defRPr>
-            </a:pPr>
-            <a:r>
-              <a:rPr sz="1950" b="0">
-                <a:solidFill>
-                  <a:srgbClr val="EAF1FF"/>
-                </a:solidFill>
-                <a:latin typeface="Arial"/>
-                <a:ea typeface="Arial"/>
-                <a:cs typeface="Arial"/>
-              </a:rPr>
-              <a:t>Lista → /udhetimi/2 → /udhetimi/2/kerkesa</a:t>
-            </a:r>
-          </a:p>
-          <a:p xmlns:a="http://schemas.openxmlformats.org/drawingml/2006/main">
-            <a:r>
-              <a:t/>
-            </a:r>
-          </a:p>
-          <a:p xmlns:a="http://schemas.openxmlformats.org/drawingml/2006/main">
-            <a:pPr>
-              <a:defRPr sz="1950" b="0">
-                <a:solidFill>
-                  <a:srgbClr val="EAF1FF"/>
-                </a:solidFill>
-                <a:latin typeface="Arial"/>
-                <a:ea typeface="Arial"/>
-                <a:cs typeface="Arial"/>
-              </a:defRPr>
-            </a:pPr>
-            <a:r>
-              <a:rPr sz="1950" b="0">
-                <a:solidFill>
-                  <a:srgbClr val="EAF1FF"/>
-                </a:solidFill>
-                <a:latin typeface="Arial"/>
-                <a:ea typeface="Arial"/>
-                <a:cs typeface="Arial"/>
-              </a:rPr>
-              <a:t>Ndryshon burimi: vargu në kod zëvendësohet me një pyetje te Neon.</a:t>
-            </a:r>
-          </a:p>
-        </p:txBody>
-      </p:sp>
-      <p:sp>
-        <p:nvSpPr>
-          <p:cNvPr id="5" name="">
-            <a:extLst xmlns:a="http://schemas.openxmlformats.org/drawingml/2006/main">
-              <a:ext uri="{FF2B5EF4-FFF2-40B4-BE49-F238E27FC236}">
-                <a16:creationId xmlns:a16="http://schemas.microsoft.com/office/drawing/2014/main" id="{8C3FBB15-DFCB-4274-B077-7F120E584E15}"/>
-              </a:ext>
-            </a:extLst>
-          </p:cNvPr>
-          <p:cNvSpPr>
-            <a:spLocks xmlns:a="http://schemas.openxmlformats.org/drawingml/2006/main" noGrp="1"/>
-          </p:cNvSpPr>
-          <p:nvPr/>
-        </p:nvSpPr>
-        <p:spPr>
-          <a:xfrm xmlns:a="http://schemas.openxmlformats.org/drawingml/2006/main">
-            <a:off x="609600" y="4514850"/>
-            <a:ext cx="10953750" cy="1333500"/>
-          </a:xfrm>
-          <a:prstGeom xmlns:a="http://schemas.openxmlformats.org/drawingml/2006/main" prst="rect">
-            <a:avLst/>
-          </a:prstGeom>
-          <a:noFill xmlns:a="http://schemas.openxmlformats.org/drawingml/2006/main"/>
-          <a:ln xmlns:a="http://schemas.openxmlformats.org/drawingml/2006/main" w="0">
-            <a:noFill/>
-          </a:ln>
-        </p:spPr>
-        <p:txBody>
-          <a:bodyPr xmlns:a="http://schemas.openxmlformats.org/drawingml/2006/main">
-            <a:noAutofit/>
-          </a:bodyPr>
-          <a:lstStyle xmlns:a="http://schemas.openxmlformats.org/drawingml/2006/main"/>
-          <a:p xmlns:a="http://schemas.openxmlformats.org/drawingml/2006/main">
-            <a:pPr>
-              <a:defRPr sz="1875" b="0">
-                <a:solidFill>
-                  <a:srgbClr val="8EE9D1"/>
-                </a:solidFill>
-                <a:latin typeface="Arial"/>
-                <a:ea typeface="Arial"/>
-                <a:cs typeface="Arial"/>
-              </a:defRPr>
-            </a:pPr>
-            <a:r>
-              <a:rPr sz="1875" b="0">
-                <a:solidFill>
-                  <a:srgbClr val="8EE9D1"/>
-                </a:solidFill>
-                <a:latin typeface="Arial"/>
-                <a:ea typeface="Arial"/>
-                <a:cs typeface="Arial"/>
-              </a:rPr>
-              <a:t>Java 3: udhetimet.find(...)</a:t>
-            </a:r>
-          </a:p>
-          <a:p xmlns:a="http://schemas.openxmlformats.org/drawingml/2006/main">
-            <a:pPr>
-              <a:defRPr sz="1875" b="0">
-                <a:solidFill>
-                  <a:srgbClr val="8EE9D1"/>
-                </a:solidFill>
-                <a:latin typeface="Arial"/>
-                <a:ea typeface="Arial"/>
-                <a:cs typeface="Arial"/>
-              </a:defRPr>
-            </a:pPr>
-            <a:r>
-              <a:rPr sz="1875" b="0">
-                <a:solidFill>
-                  <a:srgbClr val="8EE9D1"/>
-                </a:solidFill>
-                <a:latin typeface="Arial"/>
-                <a:ea typeface="Arial"/>
-                <a:cs typeface="Arial"/>
-              </a:rPr>
-              <a:t>Java 4: await gjejUdhetimin(id)</a:t>
+              <a:t>Sot ekranet lexojnë nga një burim</a:t>
+            </a:r>
+          </a:p>
+        </p:txBody>
+      </p:sp>
+      <p:pic>
+        <p:nvPicPr>
+          <p:cNvPr id="11" name=""/>
+          <p:cNvPicPr>
+            <a:picLocks xmlns:a="http://schemas.openxmlformats.org/drawingml/2006/main" noChangeAspect="1"/>
+          </p:cNvPicPr>
+          <p:nvPr/>
+        </p:nvPicPr>
+        <p:blipFill>
+          <a:blip xmlns:r="http://schemas.openxmlformats.org/officeDocument/2006/relationships" xmlns:a="http://schemas.openxmlformats.org/drawingml/2006/main" r:embed="Reb45c9c614ca406c"/>
+          <a:stretch xmlns:a="http://schemas.openxmlformats.org/drawingml/2006/main"/>
+        </p:blipFill>
+        <p:spPr>
+          <a:xfrm xmlns:a="http://schemas.openxmlformats.org/drawingml/2006/main">
+            <a:off x="609600" y="1770063"/>
+            <a:ext cx="10953750" cy="3651250"/>
+          </a:xfrm>
+          <a:prstGeom xmlns:a="http://schemas.openxmlformats.org/drawingml/2006/main" prst="rect">
+            <a:avLst/>
+          </a:prstGeom>
+        </p:spPr>
+      </p:pic>
+      <p:sp>
+        <p:nvSpPr>
+          <p:cNvPr id="6" name="">
+            <a:extLst xmlns:a="http://schemas.openxmlformats.org/drawingml/2006/main">
+              <a:ext uri="{FF2B5EF4-FFF2-40B4-BE49-F238E27FC236}">
+                <a16:creationId xmlns:a16="http://schemas.microsoft.com/office/drawing/2014/main" id="{D7B20F84-9940-4B3F-87B8-620EAF94325D}"/>
+              </a:ext>
+            </a:extLst>
+          </p:cNvPr>
+          <p:cNvSpPr>
+            <a:spLocks xmlns:a="http://schemas.openxmlformats.org/drawingml/2006/main" noGrp="1"/>
+          </p:cNvSpPr>
+          <p:nvPr/>
+        </p:nvSpPr>
+        <p:spPr>
+          <a:xfrm xmlns:a="http://schemas.openxmlformats.org/drawingml/2006/main">
+            <a:off x="609600" y="5667375"/>
+            <a:ext cx="10953750" cy="619125"/>
+          </a:xfrm>
+          <a:prstGeom xmlns:a="http://schemas.openxmlformats.org/drawingml/2006/main" prst="rect">
+            <a:avLst/>
+          </a:prstGeom>
+          <a:noFill xmlns:a="http://schemas.openxmlformats.org/drawingml/2006/main"/>
+          <a:ln xmlns:a="http://schemas.openxmlformats.org/drawingml/2006/main" w="0">
+            <a:noFill/>
+          </a:ln>
+        </p:spPr>
+        <p:txBody>
+          <a:bodyPr xmlns:a="http://schemas.openxmlformats.org/drawingml/2006/main">
+            <a:noAutofit/>
+          </a:bodyPr>
+          <a:lstStyle xmlns:a="http://schemas.openxmlformats.org/drawingml/2006/main"/>
+          <a:p xmlns:a="http://schemas.openxmlformats.org/drawingml/2006/main">
+            <a:pPr>
+              <a:defRPr sz="1725" b="0">
+                <a:solidFill>
+                  <a:srgbClr val="EAF1FF"/>
+                </a:solidFill>
+                <a:latin typeface="Arial"/>
+                <a:ea typeface="Arial"/>
+                <a:cs typeface="Arial"/>
+              </a:defRPr>
+            </a:pPr>
+            <a:r>
+              <a:rPr sz="1725" b="0">
+                <a:solidFill>
+                  <a:srgbClr val="EAF1FF"/>
+                </a:solidFill>
+                <a:latin typeface="Arial"/>
+                <a:ea typeface="Arial"/>
+                <a:cs typeface="Arial"/>
+              </a:rPr>
+              <a:t>Neon ruan udhëtimet. Next.js i lexon dhe ndërton listën e detajet.</a:t>
+            </a:r>
+          </a:p>
+          <a:p xmlns:a="http://schemas.openxmlformats.org/drawingml/2006/main">
+            <a:pPr>
+              <a:defRPr sz="1725" b="0">
+                <a:solidFill>
+                  <a:srgbClr val="EAF1FF"/>
+                </a:solidFill>
+                <a:latin typeface="Arial"/>
+                <a:ea typeface="Arial"/>
+                <a:cs typeface="Arial"/>
+              </a:defRPr>
+            </a:pPr>
+            <a:r>
+              <a:rPr sz="1725" b="0">
+                <a:solidFill>
+                  <a:srgbClr val="EAF1FF"/>
+                </a:solidFill>
+                <a:latin typeface="Arial"/>
+                <a:ea typeface="Arial"/>
+                <a:cs typeface="Arial"/>
+              </a:rPr>
+              <a:t>Në fund shpjegon ku ndryshon ora, kush e lexon dhe pse duhet rifreskimi.</a:t>
             </a:r>
           </a:p>
         </p:txBody>
@@ -5848,7 +6198,7 @@
     </p:spTree>
     <p:extLst>
       <p:ext uri="{BB962C8B-B14F-4D97-AF65-F5344CB8AC3E}">
-        <p14:creationId xmlns:p14="http://schemas.microsoft.com/office/powerpoint/2010/main" val="1743364757"/>
+        <p14:creationId xmlns:p14="http://schemas.microsoft.com/office/powerpoint/2010/main" val="1796133305"/>
       </p:ext>
     </p:extLst>
   </p:cSld>
@@ -5879,7 +6229,7 @@
           <p:cNvPr id="6" name="">
             <a:extLst xmlns:a="http://schemas.openxmlformats.org/drawingml/2006/main">
               <a:ext uri="{FF2B5EF4-FFF2-40B4-BE49-F238E27FC236}">
-                <a16:creationId xmlns:a16="http://schemas.microsoft.com/office/drawing/2014/main" id="{EB18CE52-E026-47F4-958D-083C8E37FCD4}"/>
+                <a16:creationId xmlns:a16="http://schemas.microsoft.com/office/drawing/2014/main" id="{4CE6A477-1283-4C79-A107-F72408E7D1F0}"/>
               </a:ext>
             </a:extLst>
           </p:cNvPr>
@@ -5936,7 +6286,7 @@
           <p:cNvPr id="2" name="">
             <a:extLst xmlns:a="http://schemas.openxmlformats.org/drawingml/2006/main">
               <a:ext uri="{FF2B5EF4-FFF2-40B4-BE49-F238E27FC236}">
-                <a16:creationId xmlns:a16="http://schemas.microsoft.com/office/drawing/2014/main" id="{A939D080-25AB-417A-81F4-91270A035F1B}"/>
+                <a16:creationId xmlns:a16="http://schemas.microsoft.com/office/drawing/2014/main" id="{9E873886-0BF9-4299-82FD-E3D81DAA1CB0}"/>
               </a:ext>
             </a:extLst>
           </p:cNvPr>
@@ -5993,7 +6343,7 @@
           <p:cNvPr id="3" name="">
             <a:extLst xmlns:a="http://schemas.openxmlformats.org/drawingml/2006/main">
               <a:ext uri="{FF2B5EF4-FFF2-40B4-BE49-F238E27FC236}">
-                <a16:creationId xmlns:a16="http://schemas.microsoft.com/office/drawing/2014/main" id="{C3945234-1D1C-4FFA-AAE1-DF05003EDADC}"/>
+                <a16:creationId xmlns:a16="http://schemas.microsoft.com/office/drawing/2014/main" id="{64462B1B-4D04-459A-9AF0-7B60050A96C2}"/>
               </a:ext>
             </a:extLst>
           </p:cNvPr>
@@ -6050,7 +6400,7 @@
           <p:cNvPr id="4" name="">
             <a:extLst xmlns:a="http://schemas.openxmlformats.org/drawingml/2006/main">
               <a:ext uri="{FF2B5EF4-FFF2-40B4-BE49-F238E27FC236}">
-                <a16:creationId xmlns:a16="http://schemas.microsoft.com/office/drawing/2014/main" id="{140C4096-128B-41D5-9FF6-06272E5437FC}"/>
+                <a16:creationId xmlns:a16="http://schemas.microsoft.com/office/drawing/2014/main" id="{6311E85F-C161-4B78-BD6D-0785F436A6E7}"/>
               </a:ext>
             </a:extLst>
           </p:cNvPr>
@@ -6163,7 +6513,7 @@
           <p:cNvPr id="5" name="">
             <a:extLst xmlns:a="http://schemas.openxmlformats.org/drawingml/2006/main">
               <a:ext uri="{FF2B5EF4-FFF2-40B4-BE49-F238E27FC236}">
-                <a16:creationId xmlns:a16="http://schemas.microsoft.com/office/drawing/2014/main" id="{DD3A7FBA-C054-4FC5-82B9-2EFADD8406EA}"/>
+                <a16:creationId xmlns:a16="http://schemas.microsoft.com/office/drawing/2014/main" id="{0EEAE42E-0F1E-42D7-91E8-887FD670C4A4}"/>
               </a:ext>
             </a:extLst>
           </p:cNvPr>
@@ -6218,7 +6568,7 @@
     </p:spTree>
     <p:extLst>
       <p:ext uri="{BB962C8B-B14F-4D97-AF65-F5344CB8AC3E}">
-        <p14:creationId xmlns:p14="http://schemas.microsoft.com/office/powerpoint/2010/main" val="2110094228"/>
+        <p14:creationId xmlns:p14="http://schemas.microsoft.com/office/powerpoint/2010/main" val="742125346"/>
       </p:ext>
     </p:extLst>
   </p:cSld>
@@ -6249,7 +6599,7 @@
           <p:cNvPr id="7" name="">
             <a:extLst xmlns:a="http://schemas.openxmlformats.org/drawingml/2006/main">
               <a:ext uri="{FF2B5EF4-FFF2-40B4-BE49-F238E27FC236}">
-                <a16:creationId xmlns:a16="http://schemas.microsoft.com/office/drawing/2014/main" id="{BD8683C2-8902-47BA-ACE1-A7F4DF9FB793}"/>
+                <a16:creationId xmlns:a16="http://schemas.microsoft.com/office/drawing/2014/main" id="{1BD99406-F1E4-4393-AFF5-4AA25DE724B2}"/>
               </a:ext>
             </a:extLst>
           </p:cNvPr>
@@ -6306,7 +6656,7 @@
           <p:cNvPr id="2" name="">
             <a:extLst xmlns:a="http://schemas.openxmlformats.org/drawingml/2006/main">
               <a:ext uri="{FF2B5EF4-FFF2-40B4-BE49-F238E27FC236}">
-                <a16:creationId xmlns:a16="http://schemas.microsoft.com/office/drawing/2014/main" id="{570140A7-D266-4DEF-9AD7-449C4DF17345}"/>
+                <a16:creationId xmlns:a16="http://schemas.microsoft.com/office/drawing/2014/main" id="{DE12073C-DC22-49ED-A389-E886A88CAF3D}"/>
               </a:ext>
             </a:extLst>
           </p:cNvPr>
@@ -6363,7 +6713,7 @@
           <p:cNvPr id="3" name="">
             <a:extLst xmlns:a="http://schemas.openxmlformats.org/drawingml/2006/main">
               <a:ext uri="{FF2B5EF4-FFF2-40B4-BE49-F238E27FC236}">
-                <a16:creationId xmlns:a16="http://schemas.microsoft.com/office/drawing/2014/main" id="{9B247B6E-779C-42E6-81CC-A7936102E516}"/>
+                <a16:creationId xmlns:a16="http://schemas.microsoft.com/office/drawing/2014/main" id="{F488C42D-B397-403A-9687-EFEE37DF659F}"/>
               </a:ext>
             </a:extLst>
           </p:cNvPr>
@@ -6836,7 +7186,7 @@
           <p:cNvPr id="5" name="">
             <a:extLst xmlns:a="http://schemas.openxmlformats.org/drawingml/2006/main">
               <a:ext uri="{FF2B5EF4-FFF2-40B4-BE49-F238E27FC236}">
-                <a16:creationId xmlns:a16="http://schemas.microsoft.com/office/drawing/2014/main" id="{21FE0A07-C5D4-41BF-BCE4-8CF2C760B212}"/>
+                <a16:creationId xmlns:a16="http://schemas.microsoft.com/office/drawing/2014/main" id="{66405DDD-D4A8-455E-BBF0-084EC78F05CE}"/>
               </a:ext>
             </a:extLst>
           </p:cNvPr>
@@ -6921,7 +7271,7 @@
           <p:cNvPr id="6" name="">
             <a:extLst xmlns:a="http://schemas.openxmlformats.org/drawingml/2006/main">
               <a:ext uri="{FF2B5EF4-FFF2-40B4-BE49-F238E27FC236}">
-                <a16:creationId xmlns:a16="http://schemas.microsoft.com/office/drawing/2014/main" id="{4FE8459D-823B-4ED6-8B14-4E274FFA8478}"/>
+                <a16:creationId xmlns:a16="http://schemas.microsoft.com/office/drawing/2014/main" id="{1823C564-0B57-4A97-85CF-63676DB7EACE}"/>
               </a:ext>
             </a:extLst>
           </p:cNvPr>
@@ -6976,7 +7326,7 @@
     </p:spTree>
     <p:extLst>
       <p:ext uri="{BB962C8B-B14F-4D97-AF65-F5344CB8AC3E}">
-        <p14:creationId xmlns:p14="http://schemas.microsoft.com/office/powerpoint/2010/main" val="567590007"/>
+        <p14:creationId xmlns:p14="http://schemas.microsoft.com/office/powerpoint/2010/main" val="1798374231"/>
       </p:ext>
     </p:extLst>
   </p:cSld>
@@ -7007,7 +7357,7 @@
           <p:cNvPr id="7" name="">
             <a:extLst xmlns:a="http://schemas.openxmlformats.org/drawingml/2006/main">
               <a:ext uri="{FF2B5EF4-FFF2-40B4-BE49-F238E27FC236}">
-                <a16:creationId xmlns:a16="http://schemas.microsoft.com/office/drawing/2014/main" id="{7A56CA47-4BF8-4159-A699-05C1124717D2}"/>
+                <a16:creationId xmlns:a16="http://schemas.microsoft.com/office/drawing/2014/main" id="{20E3C843-7704-4946-A967-04459E06E301}"/>
               </a:ext>
             </a:extLst>
           </p:cNvPr>
@@ -7064,7 +7414,7 @@
           <p:cNvPr id="2" name="">
             <a:extLst xmlns:a="http://schemas.openxmlformats.org/drawingml/2006/main">
               <a:ext uri="{FF2B5EF4-FFF2-40B4-BE49-F238E27FC236}">
-                <a16:creationId xmlns:a16="http://schemas.microsoft.com/office/drawing/2014/main" id="{AFF113A7-4918-49C3-B14D-CF3799599A47}"/>
+                <a16:creationId xmlns:a16="http://schemas.microsoft.com/office/drawing/2014/main" id="{DAB0F5E3-9D5A-4247-A0B1-EFA491627A07}"/>
               </a:ext>
             </a:extLst>
           </p:cNvPr>
@@ -7121,7 +7471,7 @@
           <p:cNvPr id="3" name="">
             <a:extLst xmlns:a="http://schemas.openxmlformats.org/drawingml/2006/main">
               <a:ext uri="{FF2B5EF4-FFF2-40B4-BE49-F238E27FC236}">
-                <a16:creationId xmlns:a16="http://schemas.microsoft.com/office/drawing/2014/main" id="{A28F80F0-BBD9-4FE6-A36B-EC9AB438C09B}"/>
+                <a16:creationId xmlns:a16="http://schemas.microsoft.com/office/drawing/2014/main" id="{BE44538D-224D-4F91-B434-B655ADE22C36}"/>
               </a:ext>
             </a:extLst>
           </p:cNvPr>
@@ -7178,7 +7528,7 @@
           <p:cNvPr id="4" name="">
             <a:extLst xmlns:a="http://schemas.openxmlformats.org/drawingml/2006/main">
               <a:ext uri="{FF2B5EF4-FFF2-40B4-BE49-F238E27FC236}">
-                <a16:creationId xmlns:a16="http://schemas.microsoft.com/office/drawing/2014/main" id="{3F6B693C-CBD9-4B86-8426-0970F20BE0EE}"/>
+                <a16:creationId xmlns:a16="http://schemas.microsoft.com/office/drawing/2014/main" id="{18AABB9E-CBF9-4E22-B8F8-7A9BC6F5CCFB}"/>
               </a:ext>
             </a:extLst>
           </p:cNvPr>
@@ -7319,7 +7669,7 @@
           <p:cNvPr id="5" name="">
             <a:extLst xmlns:a="http://schemas.openxmlformats.org/drawingml/2006/main">
               <a:ext uri="{FF2B5EF4-FFF2-40B4-BE49-F238E27FC236}">
-                <a16:creationId xmlns:a16="http://schemas.microsoft.com/office/drawing/2014/main" id="{A1446670-385B-46FC-B2FD-D5B75FED6128}"/>
+                <a16:creationId xmlns:a16="http://schemas.microsoft.com/office/drawing/2014/main" id="{4F50200C-CBC7-47E4-8788-7458E7A9034B}"/>
               </a:ext>
             </a:extLst>
           </p:cNvPr>
@@ -7422,7 +7772,7 @@
           <p:cNvPr id="6" name="">
             <a:extLst xmlns:a="http://schemas.openxmlformats.org/drawingml/2006/main">
               <a:ext uri="{FF2B5EF4-FFF2-40B4-BE49-F238E27FC236}">
-                <a16:creationId xmlns:a16="http://schemas.microsoft.com/office/drawing/2014/main" id="{D74E583E-9E43-47C4-8958-530DF5A2CB43}"/>
+                <a16:creationId xmlns:a16="http://schemas.microsoft.com/office/drawing/2014/main" id="{5D0612AE-D0E8-4EFD-89A1-EC49DFFF4EB3}"/>
               </a:ext>
             </a:extLst>
           </p:cNvPr>
@@ -7477,7 +7827,7 @@
     </p:spTree>
     <p:extLst>
       <p:ext uri="{BB962C8B-B14F-4D97-AF65-F5344CB8AC3E}">
-        <p14:creationId xmlns:p14="http://schemas.microsoft.com/office/powerpoint/2010/main" val="1229558058"/>
+        <p14:creationId xmlns:p14="http://schemas.microsoft.com/office/powerpoint/2010/main" val="739383253"/>
       </p:ext>
     </p:extLst>
   </p:cSld>
@@ -7508,7 +7858,7 @@
           <p:cNvPr id="6" name="">
             <a:extLst xmlns:a="http://schemas.openxmlformats.org/drawingml/2006/main">
               <a:ext uri="{FF2B5EF4-FFF2-40B4-BE49-F238E27FC236}">
-                <a16:creationId xmlns:a16="http://schemas.microsoft.com/office/drawing/2014/main" id="{CBD13E73-9223-4268-AD0E-95C02E1810A0}"/>
+                <a16:creationId xmlns:a16="http://schemas.microsoft.com/office/drawing/2014/main" id="{36419DED-9C56-4851-9EDE-7A8EB43C1DA4}"/>
               </a:ext>
             </a:extLst>
           </p:cNvPr>
@@ -7565,7 +7915,7 @@
           <p:cNvPr id="2" name="">
             <a:extLst xmlns:a="http://schemas.openxmlformats.org/drawingml/2006/main">
               <a:ext uri="{FF2B5EF4-FFF2-40B4-BE49-F238E27FC236}">
-                <a16:creationId xmlns:a16="http://schemas.microsoft.com/office/drawing/2014/main" id="{B99D2ED9-18A5-4D9E-9C03-AE53A5F64B08}"/>
+                <a16:creationId xmlns:a16="http://schemas.microsoft.com/office/drawing/2014/main" id="{D7DD5365-932A-4086-BD8C-899B72E34E6E}"/>
               </a:ext>
             </a:extLst>
           </p:cNvPr>
@@ -7622,7 +7972,7 @@
           <p:cNvPr id="3" name="">
             <a:extLst xmlns:a="http://schemas.openxmlformats.org/drawingml/2006/main">
               <a:ext uri="{FF2B5EF4-FFF2-40B4-BE49-F238E27FC236}">
-                <a16:creationId xmlns:a16="http://schemas.microsoft.com/office/drawing/2014/main" id="{B80E32FC-CB54-43EE-901C-ADD7C44B1BD9}"/>
+                <a16:creationId xmlns:a16="http://schemas.microsoft.com/office/drawing/2014/main" id="{38E56D23-0A34-4A3B-A85B-F09575E5D066}"/>
               </a:ext>
             </a:extLst>
           </p:cNvPr>
@@ -7679,7 +8029,7 @@
           <p:cNvPr id="4" name="">
             <a:extLst xmlns:a="http://schemas.openxmlformats.org/drawingml/2006/main">
               <a:ext uri="{FF2B5EF4-FFF2-40B4-BE49-F238E27FC236}">
-                <a16:creationId xmlns:a16="http://schemas.microsoft.com/office/drawing/2014/main" id="{DDB79063-9754-4CF6-8F7D-58E7BF13A463}"/>
+                <a16:creationId xmlns:a16="http://schemas.microsoft.com/office/drawing/2014/main" id="{AE7978BB-7C26-4387-B589-27C27A130A34}"/>
               </a:ext>
             </a:extLst>
           </p:cNvPr>
@@ -7792,7 +8142,7 @@
           <p:cNvPr id="5" name="">
             <a:extLst xmlns:a="http://schemas.openxmlformats.org/drawingml/2006/main">
               <a:ext uri="{FF2B5EF4-FFF2-40B4-BE49-F238E27FC236}">
-                <a16:creationId xmlns:a16="http://schemas.microsoft.com/office/drawing/2014/main" id="{6CB3C2C4-D83F-4E9C-86F1-40430A48D470}"/>
+                <a16:creationId xmlns:a16="http://schemas.microsoft.com/office/drawing/2014/main" id="{F87EBD07-616D-475B-9608-CCD99BD38512}"/>
               </a:ext>
             </a:extLst>
           </p:cNvPr>
@@ -7893,7 +8243,7 @@
     </p:spTree>
     <p:extLst>
       <p:ext uri="{BB962C8B-B14F-4D97-AF65-F5344CB8AC3E}">
-        <p14:creationId xmlns:p14="http://schemas.microsoft.com/office/powerpoint/2010/main" val="334347254"/>
+        <p14:creationId xmlns:p14="http://schemas.microsoft.com/office/powerpoint/2010/main" val="368498341"/>
       </p:ext>
     </p:extLst>
   </p:cSld>
@@ -7924,7 +8274,7 @@
           <p:cNvPr id="7" name="">
             <a:extLst xmlns:a="http://schemas.openxmlformats.org/drawingml/2006/main">
               <a:ext uri="{FF2B5EF4-FFF2-40B4-BE49-F238E27FC236}">
-                <a16:creationId xmlns:a16="http://schemas.microsoft.com/office/drawing/2014/main" id="{E7B8D03E-5FA7-4859-BB2C-E4DE01B83D7A}"/>
+                <a16:creationId xmlns:a16="http://schemas.microsoft.com/office/drawing/2014/main" id="{0A120F4D-40AE-4F5C-9E06-4EC59E8B74E4}"/>
               </a:ext>
             </a:extLst>
           </p:cNvPr>
@@ -7981,7 +8331,7 @@
           <p:cNvPr id="2" name="">
             <a:extLst xmlns:a="http://schemas.openxmlformats.org/drawingml/2006/main">
               <a:ext uri="{FF2B5EF4-FFF2-40B4-BE49-F238E27FC236}">
-                <a16:creationId xmlns:a16="http://schemas.microsoft.com/office/drawing/2014/main" id="{C91AE3DA-02A1-41CF-8C1A-236F28F43D48}"/>
+                <a16:creationId xmlns:a16="http://schemas.microsoft.com/office/drawing/2014/main" id="{131B96FE-F32E-43AE-9E20-C5D413C6E80D}"/>
               </a:ext>
             </a:extLst>
           </p:cNvPr>
@@ -8038,7 +8388,7 @@
           <p:cNvPr id="3" name="">
             <a:extLst xmlns:a="http://schemas.openxmlformats.org/drawingml/2006/main">
               <a:ext uri="{FF2B5EF4-FFF2-40B4-BE49-F238E27FC236}">
-                <a16:creationId xmlns:a16="http://schemas.microsoft.com/office/drawing/2014/main" id="{22B15E07-C8D2-42AA-AE3F-A040AD7F0E37}"/>
+                <a16:creationId xmlns:a16="http://schemas.microsoft.com/office/drawing/2014/main" id="{1DC6F4C8-F087-4FEA-BF1C-88881C88ED07}"/>
               </a:ext>
             </a:extLst>
           </p:cNvPr>
@@ -8095,7 +8445,7 @@
           <p:cNvPr id="4" name="">
             <a:extLst xmlns:a="http://schemas.openxmlformats.org/drawingml/2006/main">
               <a:ext uri="{FF2B5EF4-FFF2-40B4-BE49-F238E27FC236}">
-                <a16:creationId xmlns:a16="http://schemas.microsoft.com/office/drawing/2014/main" id="{A52A84F4-5C18-4E4A-A818-52F4F00D354A}"/>
+                <a16:creationId xmlns:a16="http://schemas.microsoft.com/office/drawing/2014/main" id="{46336534-0080-4942-8AD6-1D84AD622E44}"/>
               </a:ext>
             </a:extLst>
           </p:cNvPr>
@@ -8180,7 +8530,7 @@
           <p:cNvPr id="5" name="">
             <a:extLst xmlns:a="http://schemas.openxmlformats.org/drawingml/2006/main">
               <a:ext uri="{FF2B5EF4-FFF2-40B4-BE49-F238E27FC236}">
-                <a16:creationId xmlns:a16="http://schemas.microsoft.com/office/drawing/2014/main" id="{EFC5C609-B701-46A9-AC82-ECCFED5C0B33}"/>
+                <a16:creationId xmlns:a16="http://schemas.microsoft.com/office/drawing/2014/main" id="{C532EC24-981D-48A6-89C8-B2583ED40C20}"/>
               </a:ext>
             </a:extLst>
           </p:cNvPr>
@@ -8283,7 +8633,7 @@
           <p:cNvPr id="6" name="">
             <a:extLst xmlns:a="http://schemas.openxmlformats.org/drawingml/2006/main">
               <a:ext uri="{FF2B5EF4-FFF2-40B4-BE49-F238E27FC236}">
-                <a16:creationId xmlns:a16="http://schemas.microsoft.com/office/drawing/2014/main" id="{398744DC-4521-4AB8-B79E-1E647749D198}"/>
+                <a16:creationId xmlns:a16="http://schemas.microsoft.com/office/drawing/2014/main" id="{D6A3CD4F-EEFE-4FEC-8F53-D1571D1487D2}"/>
               </a:ext>
             </a:extLst>
           </p:cNvPr>
@@ -8338,7 +8688,7 @@
     </p:spTree>
     <p:extLst>
       <p:ext uri="{BB962C8B-B14F-4D97-AF65-F5344CB8AC3E}">
-        <p14:creationId xmlns:p14="http://schemas.microsoft.com/office/powerpoint/2010/main" val="1781508192"/>
+        <p14:creationId xmlns:p14="http://schemas.microsoft.com/office/powerpoint/2010/main" val="1103593455"/>
       </p:ext>
     </p:extLst>
   </p:cSld>
@@ -8369,7 +8719,7 @@
           <p:cNvPr id="7" name="">
             <a:extLst xmlns:a="http://schemas.openxmlformats.org/drawingml/2006/main">
               <a:ext uri="{FF2B5EF4-FFF2-40B4-BE49-F238E27FC236}">
-                <a16:creationId xmlns:a16="http://schemas.microsoft.com/office/drawing/2014/main" id="{4562F9B2-F638-4E76-A483-33E66FD6245E}"/>
+                <a16:creationId xmlns:a16="http://schemas.microsoft.com/office/drawing/2014/main" id="{15FF2CC6-A333-4475-AB5A-C74306626ED1}"/>
               </a:ext>
             </a:extLst>
           </p:cNvPr>
@@ -8426,7 +8776,7 @@
           <p:cNvPr id="2" name="">
             <a:extLst xmlns:a="http://schemas.openxmlformats.org/drawingml/2006/main">
               <a:ext uri="{FF2B5EF4-FFF2-40B4-BE49-F238E27FC236}">
-                <a16:creationId xmlns:a16="http://schemas.microsoft.com/office/drawing/2014/main" id="{FEF2B515-5173-4B85-86AD-E8B4BADF0F91}"/>
+                <a16:creationId xmlns:a16="http://schemas.microsoft.com/office/drawing/2014/main" id="{75605991-0394-4319-9749-131A2FB2919B}"/>
               </a:ext>
             </a:extLst>
           </p:cNvPr>
@@ -8483,7 +8833,7 @@
           <p:cNvPr id="3" name="">
             <a:extLst xmlns:a="http://schemas.openxmlformats.org/drawingml/2006/main">
               <a:ext uri="{FF2B5EF4-FFF2-40B4-BE49-F238E27FC236}">
-                <a16:creationId xmlns:a16="http://schemas.microsoft.com/office/drawing/2014/main" id="{AA868AC3-9493-4B5A-8AF2-91D404C2C0E9}"/>
+                <a16:creationId xmlns:a16="http://schemas.microsoft.com/office/drawing/2014/main" id="{FF763B87-3461-407F-BB13-00B55330861B}"/>
               </a:ext>
             </a:extLst>
           </p:cNvPr>
@@ -8544,7 +8894,7 @@
           <p:nvPr/>
         </p:nvPicPr>
         <p:blipFill>
-          <a:blip xmlns:r="http://schemas.openxmlformats.org/officeDocument/2006/relationships" xmlns:a="http://schemas.openxmlformats.org/drawingml/2006/main" r:embed="R02daadb73a384a44"/>
+          <a:blip xmlns:r="http://schemas.openxmlformats.org/officeDocument/2006/relationships" xmlns:a="http://schemas.openxmlformats.org/drawingml/2006/main" r:embed="Rd127ba89976c4fab"/>
           <a:stretch xmlns:a="http://schemas.openxmlformats.org/drawingml/2006/main"/>
         </p:blipFill>
         <p:spPr>
@@ -8562,7 +8912,7 @@
           <p:cNvPr id="5" name="">
             <a:extLst xmlns:a="http://schemas.openxmlformats.org/drawingml/2006/main">
               <a:ext uri="{FF2B5EF4-FFF2-40B4-BE49-F238E27FC236}">
-                <a16:creationId xmlns:a16="http://schemas.microsoft.com/office/drawing/2014/main" id="{AAB277D1-7128-40FD-8839-9145F9ACDFFE}"/>
+                <a16:creationId xmlns:a16="http://schemas.microsoft.com/office/drawing/2014/main" id="{01D9EA02-E24F-414B-B9FE-67DE9307EE20}"/>
               </a:ext>
             </a:extLst>
           </p:cNvPr>
@@ -8619,7 +8969,7 @@
           <p:cNvPr id="6" name="">
             <a:extLst xmlns:a="http://schemas.openxmlformats.org/drawingml/2006/main">
               <a:ext uri="{FF2B5EF4-FFF2-40B4-BE49-F238E27FC236}">
-                <a16:creationId xmlns:a16="http://schemas.microsoft.com/office/drawing/2014/main" id="{A3F2BD95-23F8-45E7-98C1-FD3ABA86E899}"/>
+                <a16:creationId xmlns:a16="http://schemas.microsoft.com/office/drawing/2014/main" id="{FE55AEC7-7265-4AA6-AFD2-ABC66D58EEDC}"/>
               </a:ext>
             </a:extLst>
           </p:cNvPr>
@@ -8674,7 +9024,7 @@
     </p:spTree>
     <p:extLst>
       <p:ext uri="{BB962C8B-B14F-4D97-AF65-F5344CB8AC3E}">
-        <p14:creationId xmlns:p14="http://schemas.microsoft.com/office/powerpoint/2010/main" val="1255033957"/>
+        <p14:creationId xmlns:p14="http://schemas.microsoft.com/office/powerpoint/2010/main" val="1290065969"/>
       </p:ext>
     </p:extLst>
   </p:cSld>

</xml_diff>